<commit_message>
Slide 3: compare SSVEP, P300 and aVEP paradigms
Three schematic panels show each paradigm's stimuli over the same
robotic-arm workspace, followed by aVEP coding and the application.

Co-Authored-By: Claude Opus 5.5 <noreply@anthropic.com>
Claude-Session: https://claude.ai/code/session_01M2N1FL6JrZz8kTbkaY5rZ8
</commit_message>
<xml_diff>
--- a/presentation/midterm_defense_sample.pptx
+++ b/presentation/midterm_defense_sample.pptx
@@ -113,12 +113,12 @@
   <p:extLst>
     <p:ext uri="{521415D9-36F7-43E2-AB2F-B90AF26B5E84}">
       <p14:sectionLst xmlns:p14="http://schemas.microsoft.com/office/powerpoint/2010/main">
-        <p14:section name="Opening" id="{4ebf33c1-5792-1569-c610-3761caa616e9}">
+        <p14:section name="Opening" id="{863af77d-12e5-93ab-f6fb-2b1bd5c5c033}">
           <p14:sldIdLst>
             <p14:sldId id="256"/>
           </p14:sldIdLst>
         </p14:section>
-        <p14:section name="Research Background and Objectives" id="{7e5569b8-7e01-3228-cc78-8573f60adc8e}">
+        <p14:section name="Research Background and Objectives" id="{a76d45ef-2183-a0e3-23c9-082df9432902}">
           <p14:sldIdLst>
             <p14:sldId id="257"/>
             <p14:sldId id="258"/>
@@ -126,7 +126,7 @@
             <p14:sldId id="260"/>
           </p14:sldIdLst>
         </p14:section>
-        <p14:section name="Research Progress and Stage Achievements" id="{5d3b28fb-b2b4-1b03-b8c3-baeecd1bd461}">
+        <p14:section name="Research Progress and Stage Achievements" id="{1b0e7695-4a05-f8d1-636b-3380704403ea}">
           <p14:sldIdLst>
             <p14:sldId id="261"/>
             <p14:sldId id="262"/>
@@ -1136,7 +1136,7 @@
           <a:p>
             <a:r>
               <a:rPr lang="en-US" dirty="0"/>
-              <a:t>~45 s. Visual BCIs are fast, but large flashing stimuli are tiring. Miniature lateral stimuli are comfortable, but the response is tiny. Each trial is a pair of stimuli; the task is to decode whether it went left→right or right→left from a single trial. (One sentence on the topic change, if needed.)</a:t>
+              <a:t>~50 s. Traditional visual BCIs use large stimuli: SSVEP needs big flickering targets, the P300 speller a flashing symbol matrix. Both cover most of the view, so the user cannot watch the robot or the road. aVEP uses tiny stimuli beside each command: a left→right pair is code 0, right→left code 1. The scene stays visible, which is what device control needs; this is the goal of Chapter 3. The cost is a very weak signal, shown next.</a:t>
             </a:r>
             <a:endParaRPr lang="en-US" dirty="0"/>
           </a:p>
@@ -2873,14 +2873,2620 @@
       </p:sp>
       <p:sp>
         <p:nvSpPr>
-          <p:cNvPr id="3" name="Screen"/>
+          <p:cNvPr id="3" name="Panel 0 head"/>
+          <p:cNvSpPr txBox="1"/>
+          <p:nvPr/>
+        </p:nvSpPr>
+        <p:spPr>
+          <a:xfrm>
+            <a:off x="502920" y="1161288"/>
+            <a:ext cx="3611880" cy="365760"/>
+          </a:xfrm>
+          <a:prstGeom prst="rect">
+            <a:avLst/>
+          </a:prstGeom>
+          <a:noFill/>
+          <a:ln/>
+        </p:spPr>
+        <p:txBody>
+          <a:bodyPr wrap="square" lIns="0" tIns="0" rIns="0" bIns="0" rtlCol="0" anchor="ctr"/>
+          <a:lstStyle/>
+          <a:p>
+            <a:pPr algn="ctr" indent="0" marL="0">
+              <a:buNone/>
+            </a:pPr>
+            <a:r>
+              <a:rPr lang="en-US" sz="1600" b="1" dirty="0">
+                <a:solidFill>
+                  <a:schemeClr val="tx1"/>
+                </a:solidFill>
+              </a:rPr>
+              <a:t>(a) SSVEP [1]</a:t>
+            </a:r>
+            <a:endParaRPr lang="en-US" sz="1600" dirty="0"/>
+          </a:p>
+        </p:txBody>
+      </p:sp>
+      <p:pic>
+        <p:nvPicPr>
+          <p:cNvPr id="4" name="Panel 0 scene" descr="Schematic workspace: robotic arm and objects on a table">    </p:cNvPr>
+          <p:cNvPicPr>
+            <a:picLocks noChangeAspect="1"/>
+          </p:cNvPicPr>
+          <p:nvPr/>
+        </p:nvPicPr>
+        <p:blipFill>
+          <a:blip r:embed="rId1"/>
+          <a:stretch>
+            <a:fillRect/>
+          </a:stretch>
+        </p:blipFill>
+        <p:spPr>
+          <a:xfrm>
+            <a:off x="502920" y="1572768"/>
+            <a:ext cx="3611880" cy="2258568"/>
+          </a:xfrm>
+          <a:prstGeom prst="rect">
+            <a:avLst/>
+          </a:prstGeom>
+        </p:spPr>
+      </p:pic>
+      <p:sp>
+        <p:nvSpPr>
+          <p:cNvPr id="5" name="Panel 1 head"/>
+          <p:cNvSpPr txBox="1"/>
+          <p:nvPr/>
+        </p:nvSpPr>
+        <p:spPr>
+          <a:xfrm>
+            <a:off x="4297680" y="1161288"/>
+            <a:ext cx="3611880" cy="365760"/>
+          </a:xfrm>
+          <a:prstGeom prst="rect">
+            <a:avLst/>
+          </a:prstGeom>
+          <a:noFill/>
+          <a:ln/>
+        </p:spPr>
+        <p:txBody>
+          <a:bodyPr wrap="square" lIns="0" tIns="0" rIns="0" bIns="0" rtlCol="0" anchor="ctr"/>
+          <a:lstStyle/>
+          <a:p>
+            <a:pPr algn="ctr" indent="0" marL="0">
+              <a:buNone/>
+            </a:pPr>
+            <a:r>
+              <a:rPr lang="en-US" sz="1600" b="1" dirty="0">
+                <a:solidFill>
+                  <a:schemeClr val="tx1"/>
+                </a:solidFill>
+              </a:rPr>
+              <a:t>(b) Oddball (P300) [2]</a:t>
+            </a:r>
+            <a:endParaRPr lang="en-US" sz="1600" dirty="0"/>
+          </a:p>
+        </p:txBody>
+      </p:sp>
+      <p:pic>
+        <p:nvPicPr>
+          <p:cNvPr id="6" name="Panel 1 scene" descr="Schematic workspace: robotic arm and objects on a table">    </p:cNvPr>
+          <p:cNvPicPr>
+            <a:picLocks noChangeAspect="1"/>
+          </p:cNvPicPr>
+          <p:nvPr/>
+        </p:nvPicPr>
+        <p:blipFill>
+          <a:blip r:embed="rId2"/>
+          <a:stretch>
+            <a:fillRect/>
+          </a:stretch>
+        </p:blipFill>
+        <p:spPr>
+          <a:xfrm>
+            <a:off x="4297680" y="1572768"/>
+            <a:ext cx="3611880" cy="2258568"/>
+          </a:xfrm>
+          <a:prstGeom prst="rect">
+            <a:avLst/>
+          </a:prstGeom>
+        </p:spPr>
+      </p:pic>
+      <p:sp>
+        <p:nvSpPr>
+          <p:cNvPr id="7" name="Panel 2 head"/>
+          <p:cNvSpPr txBox="1"/>
+          <p:nvPr/>
+        </p:nvSpPr>
+        <p:spPr>
+          <a:xfrm>
+            <a:off x="8092440" y="1161288"/>
+            <a:ext cx="3611880" cy="365760"/>
+          </a:xfrm>
+          <a:prstGeom prst="rect">
+            <a:avLst/>
+          </a:prstGeom>
+          <a:noFill/>
+          <a:ln/>
+        </p:spPr>
+        <p:txBody>
+          <a:bodyPr wrap="square" lIns="0" tIns="0" rIns="0" bIns="0" rtlCol="0" anchor="ctr"/>
+          <a:lstStyle/>
+          <a:p>
+            <a:pPr algn="ctr" indent="0" marL="0">
+              <a:buNone/>
+            </a:pPr>
+            <a:r>
+              <a:rPr lang="en-US" sz="1600" b="1" dirty="0">
+                <a:solidFill>
+                  <a:schemeClr val="tx1"/>
+                </a:solidFill>
+              </a:rPr>
+              <a:t>(c) aVEP [3]</a:t>
+            </a:r>
+            <a:endParaRPr lang="en-US" sz="1600" dirty="0"/>
+          </a:p>
+        </p:txBody>
+      </p:sp>
+      <p:pic>
+        <p:nvPicPr>
+          <p:cNvPr id="8" name="Panel 2 scene" descr="Schematic workspace: robotic arm and objects on a table">    </p:cNvPr>
+          <p:cNvPicPr>
+            <a:picLocks noChangeAspect="1"/>
+          </p:cNvPicPr>
+          <p:nvPr/>
+        </p:nvPicPr>
+        <p:blipFill>
+          <a:blip r:embed="rId3"/>
+          <a:stretch>
+            <a:fillRect/>
+          </a:stretch>
+        </p:blipFill>
+        <p:spPr>
+          <a:xfrm>
+            <a:off x="8092440" y="1572768"/>
+            <a:ext cx="3611880" cy="2258568"/>
+          </a:xfrm>
+          <a:prstGeom prst="rect">
+            <a:avLst/>
+          </a:prstGeom>
+        </p:spPr>
+      </p:pic>
+      <p:sp>
+        <p:nvSpPr>
+          <p:cNvPr id="9" name="SSVEP target 0"/>
           <p:cNvSpPr/>
           <p:nvPr/>
         </p:nvSpPr>
         <p:spPr>
           <a:xfrm>
-            <a:off x="548640" y="1508760"/>
-            <a:ext cx="3291840" cy="2194560"/>
+            <a:off x="698602" y="1753362"/>
+            <a:ext cx="658368" cy="512064"/>
+          </a:xfrm>
+          <a:prstGeom prst="rect">
+            <a:avLst/>
+          </a:prstGeom>
+          <a:solidFill>
+            <a:srgbClr val="FFFFFF"/>
+          </a:solidFill>
+          <a:ln w="9525">
+            <a:solidFill>
+              <a:srgbClr val="A6A6A6"/>
+            </a:solidFill>
+          </a:ln>
+        </p:spPr>
+        <p:txBody>
+          <a:bodyPr wrap="square" lIns="0" tIns="0" rIns="0" bIns="0" rtlCol="0" anchor="ctr"/>
+          <a:lstStyle/>
+          <a:p>
+            <a:pPr algn="ctr" indent="0" marL="0">
+              <a:buNone/>
+            </a:pPr>
+            <a:r>
+              <a:rPr lang="en-US" sz="1100" dirty="0">
+                <a:solidFill>
+                  <a:schemeClr val="tx1"/>
+                </a:solidFill>
+              </a:rPr>
+              <a:t>8.0 Hz</a:t>
+            </a:r>
+            <a:endParaRPr lang="en-US" sz="1100" dirty="0"/>
+          </a:p>
+        </p:txBody>
+      </p:sp>
+      <p:sp>
+        <p:nvSpPr>
+          <p:cNvPr id="10" name="SSVEP target 1"/>
+          <p:cNvSpPr/>
+          <p:nvPr/>
+        </p:nvSpPr>
+        <p:spPr>
+          <a:xfrm>
+            <a:off x="1552651" y="1753362"/>
+            <a:ext cx="658368" cy="512064"/>
+          </a:xfrm>
+          <a:prstGeom prst="rect">
+            <a:avLst/>
+          </a:prstGeom>
+          <a:solidFill>
+            <a:srgbClr val="FFFFFF"/>
+          </a:solidFill>
+          <a:ln w="9525">
+            <a:solidFill>
+              <a:srgbClr val="A6A6A6"/>
+            </a:solidFill>
+          </a:ln>
+        </p:spPr>
+        <p:txBody>
+          <a:bodyPr wrap="square" lIns="0" tIns="0" rIns="0" bIns="0" rtlCol="0" anchor="ctr"/>
+          <a:lstStyle/>
+          <a:p>
+            <a:pPr algn="ctr" indent="0" marL="0">
+              <a:buNone/>
+            </a:pPr>
+            <a:r>
+              <a:rPr lang="en-US" sz="1100" dirty="0">
+                <a:solidFill>
+                  <a:schemeClr val="tx1"/>
+                </a:solidFill>
+              </a:rPr>
+              <a:t>8.5 Hz</a:t>
+            </a:r>
+            <a:endParaRPr lang="en-US" sz="1100" dirty="0"/>
+          </a:p>
+        </p:txBody>
+      </p:sp>
+      <p:sp>
+        <p:nvSpPr>
+          <p:cNvPr id="11" name="SSVEP target 2"/>
+          <p:cNvSpPr/>
+          <p:nvPr/>
+        </p:nvSpPr>
+        <p:spPr>
+          <a:xfrm>
+            <a:off x="2406701" y="1753362"/>
+            <a:ext cx="658368" cy="512064"/>
+          </a:xfrm>
+          <a:prstGeom prst="rect">
+            <a:avLst/>
+          </a:prstGeom>
+          <a:solidFill>
+            <a:srgbClr val="FFFFFF"/>
+          </a:solidFill>
+          <a:ln w="9525">
+            <a:solidFill>
+              <a:srgbClr val="A6A6A6"/>
+            </a:solidFill>
+          </a:ln>
+        </p:spPr>
+        <p:txBody>
+          <a:bodyPr wrap="square" lIns="0" tIns="0" rIns="0" bIns="0" rtlCol="0" anchor="ctr"/>
+          <a:lstStyle/>
+          <a:p>
+            <a:pPr algn="ctr" indent="0" marL="0">
+              <a:buNone/>
+            </a:pPr>
+            <a:r>
+              <a:rPr lang="en-US" sz="1100" dirty="0">
+                <a:solidFill>
+                  <a:schemeClr val="tx1"/>
+                </a:solidFill>
+              </a:rPr>
+              <a:t>9.0 Hz</a:t>
+            </a:r>
+            <a:endParaRPr lang="en-US" sz="1100" dirty="0"/>
+          </a:p>
+        </p:txBody>
+      </p:sp>
+      <p:sp>
+        <p:nvSpPr>
+          <p:cNvPr id="12" name="SSVEP target 3"/>
+          <p:cNvSpPr/>
+          <p:nvPr/>
+        </p:nvSpPr>
+        <p:spPr>
+          <a:xfrm>
+            <a:off x="3260750" y="1753362"/>
+            <a:ext cx="658368" cy="512064"/>
+          </a:xfrm>
+          <a:prstGeom prst="rect">
+            <a:avLst/>
+          </a:prstGeom>
+          <a:solidFill>
+            <a:srgbClr val="FFFFFF"/>
+          </a:solidFill>
+          <a:ln w="9525">
+            <a:solidFill>
+              <a:srgbClr val="A6A6A6"/>
+            </a:solidFill>
+          </a:ln>
+        </p:spPr>
+        <p:txBody>
+          <a:bodyPr wrap="square" lIns="0" tIns="0" rIns="0" bIns="0" rtlCol="0" anchor="ctr"/>
+          <a:lstStyle/>
+          <a:p>
+            <a:pPr algn="ctr" indent="0" marL="0">
+              <a:buNone/>
+            </a:pPr>
+            <a:r>
+              <a:rPr lang="en-US" sz="1100" dirty="0">
+                <a:solidFill>
+                  <a:schemeClr val="tx1"/>
+                </a:solidFill>
+              </a:rPr>
+              <a:t>9.5 Hz</a:t>
+            </a:r>
+            <a:endParaRPr lang="en-US" sz="1100" dirty="0"/>
+          </a:p>
+        </p:txBody>
+      </p:sp>
+      <p:sp>
+        <p:nvSpPr>
+          <p:cNvPr id="13" name="SSVEP target 4"/>
+          <p:cNvSpPr/>
+          <p:nvPr/>
+        </p:nvSpPr>
+        <p:spPr>
+          <a:xfrm>
+            <a:off x="698602" y="2446020"/>
+            <a:ext cx="658368" cy="512064"/>
+          </a:xfrm>
+          <a:prstGeom prst="rect">
+            <a:avLst/>
+          </a:prstGeom>
+          <a:solidFill>
+            <a:srgbClr val="FFFFFF"/>
+          </a:solidFill>
+          <a:ln w="9525">
+            <a:solidFill>
+              <a:srgbClr val="A6A6A6"/>
+            </a:solidFill>
+          </a:ln>
+        </p:spPr>
+        <p:txBody>
+          <a:bodyPr wrap="square" lIns="0" tIns="0" rIns="0" bIns="0" rtlCol="0" anchor="ctr"/>
+          <a:lstStyle/>
+          <a:p>
+            <a:pPr algn="ctr" indent="0" marL="0">
+              <a:buNone/>
+            </a:pPr>
+            <a:r>
+              <a:rPr lang="en-US" sz="1100" dirty="0">
+                <a:solidFill>
+                  <a:schemeClr val="tx1"/>
+                </a:solidFill>
+              </a:rPr>
+              <a:t>10.0 Hz</a:t>
+            </a:r>
+            <a:endParaRPr lang="en-US" sz="1100" dirty="0"/>
+          </a:p>
+        </p:txBody>
+      </p:sp>
+      <p:sp>
+        <p:nvSpPr>
+          <p:cNvPr id="14" name="SSVEP target 5"/>
+          <p:cNvSpPr/>
+          <p:nvPr/>
+        </p:nvSpPr>
+        <p:spPr>
+          <a:xfrm>
+            <a:off x="1552651" y="2446020"/>
+            <a:ext cx="658368" cy="512064"/>
+          </a:xfrm>
+          <a:prstGeom prst="rect">
+            <a:avLst/>
+          </a:prstGeom>
+          <a:solidFill>
+            <a:srgbClr val="FFFFFF"/>
+          </a:solidFill>
+          <a:ln w="9525">
+            <a:solidFill>
+              <a:srgbClr val="A6A6A6"/>
+            </a:solidFill>
+          </a:ln>
+        </p:spPr>
+        <p:txBody>
+          <a:bodyPr wrap="square" lIns="0" tIns="0" rIns="0" bIns="0" rtlCol="0" anchor="ctr"/>
+          <a:lstStyle/>
+          <a:p>
+            <a:pPr algn="ctr" indent="0" marL="0">
+              <a:buNone/>
+            </a:pPr>
+            <a:r>
+              <a:rPr lang="en-US" sz="1100" dirty="0">
+                <a:solidFill>
+                  <a:schemeClr val="tx1"/>
+                </a:solidFill>
+              </a:rPr>
+              <a:t>10.5 Hz</a:t>
+            </a:r>
+            <a:endParaRPr lang="en-US" sz="1100" dirty="0"/>
+          </a:p>
+        </p:txBody>
+      </p:sp>
+      <p:sp>
+        <p:nvSpPr>
+          <p:cNvPr id="15" name="SSVEP target 6"/>
+          <p:cNvSpPr/>
+          <p:nvPr/>
+        </p:nvSpPr>
+        <p:spPr>
+          <a:xfrm>
+            <a:off x="2406701" y="2446020"/>
+            <a:ext cx="658368" cy="512064"/>
+          </a:xfrm>
+          <a:prstGeom prst="rect">
+            <a:avLst/>
+          </a:prstGeom>
+          <a:solidFill>
+            <a:srgbClr val="FFFFFF"/>
+          </a:solidFill>
+          <a:ln w="9525">
+            <a:solidFill>
+              <a:srgbClr val="A6A6A6"/>
+            </a:solidFill>
+          </a:ln>
+        </p:spPr>
+        <p:txBody>
+          <a:bodyPr wrap="square" lIns="0" tIns="0" rIns="0" bIns="0" rtlCol="0" anchor="ctr"/>
+          <a:lstStyle/>
+          <a:p>
+            <a:pPr algn="ctr" indent="0" marL="0">
+              <a:buNone/>
+            </a:pPr>
+            <a:r>
+              <a:rPr lang="en-US" sz="1100" dirty="0">
+                <a:solidFill>
+                  <a:schemeClr val="tx1"/>
+                </a:solidFill>
+              </a:rPr>
+              <a:t>11.0 Hz</a:t>
+            </a:r>
+            <a:endParaRPr lang="en-US" sz="1100" dirty="0"/>
+          </a:p>
+        </p:txBody>
+      </p:sp>
+      <p:sp>
+        <p:nvSpPr>
+          <p:cNvPr id="16" name="SSVEP target 7"/>
+          <p:cNvSpPr/>
+          <p:nvPr/>
+        </p:nvSpPr>
+        <p:spPr>
+          <a:xfrm>
+            <a:off x="3260750" y="2446020"/>
+            <a:ext cx="658368" cy="512064"/>
+          </a:xfrm>
+          <a:prstGeom prst="rect">
+            <a:avLst/>
+          </a:prstGeom>
+          <a:solidFill>
+            <a:srgbClr val="FFFFFF"/>
+          </a:solidFill>
+          <a:ln w="9525">
+            <a:solidFill>
+              <a:srgbClr val="A6A6A6"/>
+            </a:solidFill>
+          </a:ln>
+        </p:spPr>
+        <p:txBody>
+          <a:bodyPr wrap="square" lIns="0" tIns="0" rIns="0" bIns="0" rtlCol="0" anchor="ctr"/>
+          <a:lstStyle/>
+          <a:p>
+            <a:pPr algn="ctr" indent="0" marL="0">
+              <a:buNone/>
+            </a:pPr>
+            <a:r>
+              <a:rPr lang="en-US" sz="1100" dirty="0">
+                <a:solidFill>
+                  <a:schemeClr val="tx1"/>
+                </a:solidFill>
+              </a:rPr>
+              <a:t>11.5 Hz</a:t>
+            </a:r>
+            <a:endParaRPr lang="en-US" sz="1100" dirty="0"/>
+          </a:p>
+        </p:txBody>
+      </p:sp>
+      <p:sp>
+        <p:nvSpPr>
+          <p:cNvPr id="17" name="SSVEP target 8"/>
+          <p:cNvSpPr/>
+          <p:nvPr/>
+        </p:nvSpPr>
+        <p:spPr>
+          <a:xfrm>
+            <a:off x="698602" y="3138678"/>
+            <a:ext cx="658368" cy="512064"/>
+          </a:xfrm>
+          <a:prstGeom prst="rect">
+            <a:avLst/>
+          </a:prstGeom>
+          <a:solidFill>
+            <a:srgbClr val="FFFFFF"/>
+          </a:solidFill>
+          <a:ln w="9525">
+            <a:solidFill>
+              <a:srgbClr val="A6A6A6"/>
+            </a:solidFill>
+          </a:ln>
+        </p:spPr>
+        <p:txBody>
+          <a:bodyPr wrap="square" lIns="0" tIns="0" rIns="0" bIns="0" rtlCol="0" anchor="ctr"/>
+          <a:lstStyle/>
+          <a:p>
+            <a:pPr algn="ctr" indent="0" marL="0">
+              <a:buNone/>
+            </a:pPr>
+            <a:r>
+              <a:rPr lang="en-US" sz="1100" dirty="0">
+                <a:solidFill>
+                  <a:schemeClr val="tx1"/>
+                </a:solidFill>
+              </a:rPr>
+              <a:t>12.0 Hz</a:t>
+            </a:r>
+            <a:endParaRPr lang="en-US" sz="1100" dirty="0"/>
+          </a:p>
+        </p:txBody>
+      </p:sp>
+      <p:sp>
+        <p:nvSpPr>
+          <p:cNvPr id="18" name="SSVEP target 9"/>
+          <p:cNvSpPr/>
+          <p:nvPr/>
+        </p:nvSpPr>
+        <p:spPr>
+          <a:xfrm>
+            <a:off x="1552651" y="3138678"/>
+            <a:ext cx="658368" cy="512064"/>
+          </a:xfrm>
+          <a:prstGeom prst="rect">
+            <a:avLst/>
+          </a:prstGeom>
+          <a:solidFill>
+            <a:srgbClr val="FFFFFF"/>
+          </a:solidFill>
+          <a:ln w="9525">
+            <a:solidFill>
+              <a:srgbClr val="A6A6A6"/>
+            </a:solidFill>
+          </a:ln>
+        </p:spPr>
+        <p:txBody>
+          <a:bodyPr wrap="square" lIns="0" tIns="0" rIns="0" bIns="0" rtlCol="0" anchor="ctr"/>
+          <a:lstStyle/>
+          <a:p>
+            <a:pPr algn="ctr" indent="0" marL="0">
+              <a:buNone/>
+            </a:pPr>
+            <a:r>
+              <a:rPr lang="en-US" sz="1100" dirty="0">
+                <a:solidFill>
+                  <a:schemeClr val="tx1"/>
+                </a:solidFill>
+              </a:rPr>
+              <a:t>12.5 Hz</a:t>
+            </a:r>
+            <a:endParaRPr lang="en-US" sz="1100" dirty="0"/>
+          </a:p>
+        </p:txBody>
+      </p:sp>
+      <p:sp>
+        <p:nvSpPr>
+          <p:cNvPr id="19" name="SSVEP target 10"/>
+          <p:cNvSpPr/>
+          <p:nvPr/>
+        </p:nvSpPr>
+        <p:spPr>
+          <a:xfrm>
+            <a:off x="2406701" y="3138678"/>
+            <a:ext cx="658368" cy="512064"/>
+          </a:xfrm>
+          <a:prstGeom prst="rect">
+            <a:avLst/>
+          </a:prstGeom>
+          <a:solidFill>
+            <a:srgbClr val="FFFFFF"/>
+          </a:solidFill>
+          <a:ln w="9525">
+            <a:solidFill>
+              <a:srgbClr val="A6A6A6"/>
+            </a:solidFill>
+          </a:ln>
+        </p:spPr>
+        <p:txBody>
+          <a:bodyPr wrap="square" lIns="0" tIns="0" rIns="0" bIns="0" rtlCol="0" anchor="ctr"/>
+          <a:lstStyle/>
+          <a:p>
+            <a:pPr algn="ctr" indent="0" marL="0">
+              <a:buNone/>
+            </a:pPr>
+            <a:r>
+              <a:rPr lang="en-US" sz="1100" dirty="0">
+                <a:solidFill>
+                  <a:schemeClr val="tx1"/>
+                </a:solidFill>
+              </a:rPr>
+              <a:t>13.0 Hz</a:t>
+            </a:r>
+            <a:endParaRPr lang="en-US" sz="1100" dirty="0"/>
+          </a:p>
+        </p:txBody>
+      </p:sp>
+      <p:sp>
+        <p:nvSpPr>
+          <p:cNvPr id="20" name="SSVEP target 11"/>
+          <p:cNvSpPr/>
+          <p:nvPr/>
+        </p:nvSpPr>
+        <p:spPr>
+          <a:xfrm>
+            <a:off x="3260750" y="3138678"/>
+            <a:ext cx="658368" cy="512064"/>
+          </a:xfrm>
+          <a:prstGeom prst="rect">
+            <a:avLst/>
+          </a:prstGeom>
+          <a:solidFill>
+            <a:srgbClr val="FFFFFF"/>
+          </a:solidFill>
+          <a:ln w="9525">
+            <a:solidFill>
+              <a:srgbClr val="A6A6A6"/>
+            </a:solidFill>
+          </a:ln>
+        </p:spPr>
+        <p:txBody>
+          <a:bodyPr wrap="square" lIns="0" tIns="0" rIns="0" bIns="0" rtlCol="0" anchor="ctr"/>
+          <a:lstStyle/>
+          <a:p>
+            <a:pPr algn="ctr" indent="0" marL="0">
+              <a:buNone/>
+            </a:pPr>
+            <a:r>
+              <a:rPr lang="en-US" sz="1100" dirty="0">
+                <a:solidFill>
+                  <a:schemeClr val="tx1"/>
+                </a:solidFill>
+              </a:rPr>
+              <a:t>13.5 Hz</a:t>
+            </a:r>
+            <a:endParaRPr lang="en-US" sz="1100" dirty="0"/>
+          </a:p>
+        </p:txBody>
+      </p:sp>
+      <p:sp>
+        <p:nvSpPr>
+          <p:cNvPr id="21" name="P300 matrix bg"/>
+          <p:cNvSpPr/>
+          <p:nvPr/>
+        </p:nvSpPr>
+        <p:spPr>
+          <a:xfrm>
+            <a:off x="4617720" y="1682496"/>
+            <a:ext cx="2971800" cy="2039112"/>
+          </a:xfrm>
+          <a:prstGeom prst="rect">
+            <a:avLst/>
+          </a:prstGeom>
+          <a:solidFill>
+            <a:srgbClr val="1A1A1A"/>
+          </a:solidFill>
+          <a:ln/>
+        </p:spPr>
+      </p:sp>
+      <p:sp>
+        <p:nvSpPr>
+          <p:cNvPr id="22" name="P300 flashed row"/>
+          <p:cNvSpPr/>
+          <p:nvPr/>
+        </p:nvSpPr>
+        <p:spPr>
+          <a:xfrm>
+            <a:off x="4617720" y="2362200"/>
+            <a:ext cx="2971800" cy="339852"/>
+          </a:xfrm>
+          <a:prstGeom prst="rect">
+            <a:avLst/>
+          </a:prstGeom>
+          <a:solidFill>
+            <a:srgbClr val="595959"/>
+          </a:solidFill>
+          <a:ln/>
+        </p:spPr>
+      </p:sp>
+      <p:sp>
+        <p:nvSpPr>
+          <p:cNvPr id="23" name="P300 cell 0"/>
+          <p:cNvSpPr txBox="1"/>
+          <p:nvPr/>
+        </p:nvSpPr>
+        <p:spPr>
+          <a:xfrm>
+            <a:off x="4617720" y="1682496"/>
+            <a:ext cx="495300" cy="339852"/>
+          </a:xfrm>
+          <a:prstGeom prst="rect">
+            <a:avLst/>
+          </a:prstGeom>
+          <a:noFill/>
+          <a:ln/>
+        </p:spPr>
+        <p:txBody>
+          <a:bodyPr wrap="square" lIns="0" tIns="0" rIns="0" bIns="0" rtlCol="0" anchor="ctr"/>
+          <a:lstStyle/>
+          <a:p>
+            <a:pPr algn="ctr" indent="0" marL="0">
+              <a:buNone/>
+            </a:pPr>
+            <a:r>
+              <a:rPr lang="en-US" sz="1300" dirty="0">
+                <a:solidFill>
+                  <a:srgbClr val="8C8C8C"/>
+                </a:solidFill>
+              </a:rPr>
+              <a:t>A</a:t>
+            </a:r>
+            <a:endParaRPr lang="en-US" sz="1300" dirty="0"/>
+          </a:p>
+        </p:txBody>
+      </p:sp>
+      <p:sp>
+        <p:nvSpPr>
+          <p:cNvPr id="24" name="P300 cell 1"/>
+          <p:cNvSpPr txBox="1"/>
+          <p:nvPr/>
+        </p:nvSpPr>
+        <p:spPr>
+          <a:xfrm>
+            <a:off x="5113020" y="1682496"/>
+            <a:ext cx="495300" cy="339852"/>
+          </a:xfrm>
+          <a:prstGeom prst="rect">
+            <a:avLst/>
+          </a:prstGeom>
+          <a:noFill/>
+          <a:ln/>
+        </p:spPr>
+        <p:txBody>
+          <a:bodyPr wrap="square" lIns="0" tIns="0" rIns="0" bIns="0" rtlCol="0" anchor="ctr"/>
+          <a:lstStyle/>
+          <a:p>
+            <a:pPr algn="ctr" indent="0" marL="0">
+              <a:buNone/>
+            </a:pPr>
+            <a:r>
+              <a:rPr lang="en-US" sz="1300" dirty="0">
+                <a:solidFill>
+                  <a:srgbClr val="8C8C8C"/>
+                </a:solidFill>
+              </a:rPr>
+              <a:t>B</a:t>
+            </a:r>
+            <a:endParaRPr lang="en-US" sz="1300" dirty="0"/>
+          </a:p>
+        </p:txBody>
+      </p:sp>
+      <p:sp>
+        <p:nvSpPr>
+          <p:cNvPr id="25" name="P300 cell 2"/>
+          <p:cNvSpPr txBox="1"/>
+          <p:nvPr/>
+        </p:nvSpPr>
+        <p:spPr>
+          <a:xfrm>
+            <a:off x="5608320" y="1682496"/>
+            <a:ext cx="495300" cy="339852"/>
+          </a:xfrm>
+          <a:prstGeom prst="rect">
+            <a:avLst/>
+          </a:prstGeom>
+          <a:noFill/>
+          <a:ln/>
+        </p:spPr>
+        <p:txBody>
+          <a:bodyPr wrap="square" lIns="0" tIns="0" rIns="0" bIns="0" rtlCol="0" anchor="ctr"/>
+          <a:lstStyle/>
+          <a:p>
+            <a:pPr algn="ctr" indent="0" marL="0">
+              <a:buNone/>
+            </a:pPr>
+            <a:r>
+              <a:rPr lang="en-US" sz="1300" dirty="0">
+                <a:solidFill>
+                  <a:srgbClr val="8C8C8C"/>
+                </a:solidFill>
+              </a:rPr>
+              <a:t>C</a:t>
+            </a:r>
+            <a:endParaRPr lang="en-US" sz="1300" dirty="0"/>
+          </a:p>
+        </p:txBody>
+      </p:sp>
+      <p:sp>
+        <p:nvSpPr>
+          <p:cNvPr id="26" name="P300 cell 3"/>
+          <p:cNvSpPr txBox="1"/>
+          <p:nvPr/>
+        </p:nvSpPr>
+        <p:spPr>
+          <a:xfrm>
+            <a:off x="6103620" y="1682496"/>
+            <a:ext cx="495300" cy="339852"/>
+          </a:xfrm>
+          <a:prstGeom prst="rect">
+            <a:avLst/>
+          </a:prstGeom>
+          <a:noFill/>
+          <a:ln/>
+        </p:spPr>
+        <p:txBody>
+          <a:bodyPr wrap="square" lIns="0" tIns="0" rIns="0" bIns="0" rtlCol="0" anchor="ctr"/>
+          <a:lstStyle/>
+          <a:p>
+            <a:pPr algn="ctr" indent="0" marL="0">
+              <a:buNone/>
+            </a:pPr>
+            <a:r>
+              <a:rPr lang="en-US" sz="1300" dirty="0">
+                <a:solidFill>
+                  <a:srgbClr val="8C8C8C"/>
+                </a:solidFill>
+              </a:rPr>
+              <a:t>D</a:t>
+            </a:r>
+            <a:endParaRPr lang="en-US" sz="1300" dirty="0"/>
+          </a:p>
+        </p:txBody>
+      </p:sp>
+      <p:sp>
+        <p:nvSpPr>
+          <p:cNvPr id="27" name="P300 cell 4"/>
+          <p:cNvSpPr txBox="1"/>
+          <p:nvPr/>
+        </p:nvSpPr>
+        <p:spPr>
+          <a:xfrm>
+            <a:off x="6598920" y="1682496"/>
+            <a:ext cx="495300" cy="339852"/>
+          </a:xfrm>
+          <a:prstGeom prst="rect">
+            <a:avLst/>
+          </a:prstGeom>
+          <a:noFill/>
+          <a:ln/>
+        </p:spPr>
+        <p:txBody>
+          <a:bodyPr wrap="square" lIns="0" tIns="0" rIns="0" bIns="0" rtlCol="0" anchor="ctr"/>
+          <a:lstStyle/>
+          <a:p>
+            <a:pPr algn="ctr" indent="0" marL="0">
+              <a:buNone/>
+            </a:pPr>
+            <a:r>
+              <a:rPr lang="en-US" sz="1300" dirty="0">
+                <a:solidFill>
+                  <a:srgbClr val="8C8C8C"/>
+                </a:solidFill>
+              </a:rPr>
+              <a:t>E</a:t>
+            </a:r>
+            <a:endParaRPr lang="en-US" sz="1300" dirty="0"/>
+          </a:p>
+        </p:txBody>
+      </p:sp>
+      <p:sp>
+        <p:nvSpPr>
+          <p:cNvPr id="28" name="P300 cell 5"/>
+          <p:cNvSpPr txBox="1"/>
+          <p:nvPr/>
+        </p:nvSpPr>
+        <p:spPr>
+          <a:xfrm>
+            <a:off x="7094220" y="1682496"/>
+            <a:ext cx="495300" cy="339852"/>
+          </a:xfrm>
+          <a:prstGeom prst="rect">
+            <a:avLst/>
+          </a:prstGeom>
+          <a:noFill/>
+          <a:ln/>
+        </p:spPr>
+        <p:txBody>
+          <a:bodyPr wrap="square" lIns="0" tIns="0" rIns="0" bIns="0" rtlCol="0" anchor="ctr"/>
+          <a:lstStyle/>
+          <a:p>
+            <a:pPr algn="ctr" indent="0" marL="0">
+              <a:buNone/>
+            </a:pPr>
+            <a:r>
+              <a:rPr lang="en-US" sz="1300" dirty="0">
+                <a:solidFill>
+                  <a:srgbClr val="8C8C8C"/>
+                </a:solidFill>
+              </a:rPr>
+              <a:t>F</a:t>
+            </a:r>
+            <a:endParaRPr lang="en-US" sz="1300" dirty="0"/>
+          </a:p>
+        </p:txBody>
+      </p:sp>
+      <p:sp>
+        <p:nvSpPr>
+          <p:cNvPr id="29" name="P300 cell 6"/>
+          <p:cNvSpPr txBox="1"/>
+          <p:nvPr/>
+        </p:nvSpPr>
+        <p:spPr>
+          <a:xfrm>
+            <a:off x="4617720" y="2022348"/>
+            <a:ext cx="495300" cy="339852"/>
+          </a:xfrm>
+          <a:prstGeom prst="rect">
+            <a:avLst/>
+          </a:prstGeom>
+          <a:noFill/>
+          <a:ln/>
+        </p:spPr>
+        <p:txBody>
+          <a:bodyPr wrap="square" lIns="0" tIns="0" rIns="0" bIns="0" rtlCol="0" anchor="ctr"/>
+          <a:lstStyle/>
+          <a:p>
+            <a:pPr algn="ctr" indent="0" marL="0">
+              <a:buNone/>
+            </a:pPr>
+            <a:r>
+              <a:rPr lang="en-US" sz="1300" dirty="0">
+                <a:solidFill>
+                  <a:srgbClr val="8C8C8C"/>
+                </a:solidFill>
+              </a:rPr>
+              <a:t>G</a:t>
+            </a:r>
+            <a:endParaRPr lang="en-US" sz="1300" dirty="0"/>
+          </a:p>
+        </p:txBody>
+      </p:sp>
+      <p:sp>
+        <p:nvSpPr>
+          <p:cNvPr id="30" name="P300 cell 7"/>
+          <p:cNvSpPr txBox="1"/>
+          <p:nvPr/>
+        </p:nvSpPr>
+        <p:spPr>
+          <a:xfrm>
+            <a:off x="5113020" y="2022348"/>
+            <a:ext cx="495300" cy="339852"/>
+          </a:xfrm>
+          <a:prstGeom prst="rect">
+            <a:avLst/>
+          </a:prstGeom>
+          <a:noFill/>
+          <a:ln/>
+        </p:spPr>
+        <p:txBody>
+          <a:bodyPr wrap="square" lIns="0" tIns="0" rIns="0" bIns="0" rtlCol="0" anchor="ctr"/>
+          <a:lstStyle/>
+          <a:p>
+            <a:pPr algn="ctr" indent="0" marL="0">
+              <a:buNone/>
+            </a:pPr>
+            <a:r>
+              <a:rPr lang="en-US" sz="1300" dirty="0">
+                <a:solidFill>
+                  <a:srgbClr val="8C8C8C"/>
+                </a:solidFill>
+              </a:rPr>
+              <a:t>H</a:t>
+            </a:r>
+            <a:endParaRPr lang="en-US" sz="1300" dirty="0"/>
+          </a:p>
+        </p:txBody>
+      </p:sp>
+      <p:sp>
+        <p:nvSpPr>
+          <p:cNvPr id="31" name="P300 cell 8"/>
+          <p:cNvSpPr txBox="1"/>
+          <p:nvPr/>
+        </p:nvSpPr>
+        <p:spPr>
+          <a:xfrm>
+            <a:off x="5608320" y="2022348"/>
+            <a:ext cx="495300" cy="339852"/>
+          </a:xfrm>
+          <a:prstGeom prst="rect">
+            <a:avLst/>
+          </a:prstGeom>
+          <a:noFill/>
+          <a:ln/>
+        </p:spPr>
+        <p:txBody>
+          <a:bodyPr wrap="square" lIns="0" tIns="0" rIns="0" bIns="0" rtlCol="0" anchor="ctr"/>
+          <a:lstStyle/>
+          <a:p>
+            <a:pPr algn="ctr" indent="0" marL="0">
+              <a:buNone/>
+            </a:pPr>
+            <a:r>
+              <a:rPr lang="en-US" sz="1300" dirty="0">
+                <a:solidFill>
+                  <a:srgbClr val="8C8C8C"/>
+                </a:solidFill>
+              </a:rPr>
+              <a:t>I</a:t>
+            </a:r>
+            <a:endParaRPr lang="en-US" sz="1300" dirty="0"/>
+          </a:p>
+        </p:txBody>
+      </p:sp>
+      <p:sp>
+        <p:nvSpPr>
+          <p:cNvPr id="32" name="P300 cell 9"/>
+          <p:cNvSpPr txBox="1"/>
+          <p:nvPr/>
+        </p:nvSpPr>
+        <p:spPr>
+          <a:xfrm>
+            <a:off x="6103620" y="2022348"/>
+            <a:ext cx="495300" cy="339852"/>
+          </a:xfrm>
+          <a:prstGeom prst="rect">
+            <a:avLst/>
+          </a:prstGeom>
+          <a:noFill/>
+          <a:ln/>
+        </p:spPr>
+        <p:txBody>
+          <a:bodyPr wrap="square" lIns="0" tIns="0" rIns="0" bIns="0" rtlCol="0" anchor="ctr"/>
+          <a:lstStyle/>
+          <a:p>
+            <a:pPr algn="ctr" indent="0" marL="0">
+              <a:buNone/>
+            </a:pPr>
+            <a:r>
+              <a:rPr lang="en-US" sz="1300" dirty="0">
+                <a:solidFill>
+                  <a:srgbClr val="8C8C8C"/>
+                </a:solidFill>
+              </a:rPr>
+              <a:t>J</a:t>
+            </a:r>
+            <a:endParaRPr lang="en-US" sz="1300" dirty="0"/>
+          </a:p>
+        </p:txBody>
+      </p:sp>
+      <p:sp>
+        <p:nvSpPr>
+          <p:cNvPr id="33" name="P300 cell 10"/>
+          <p:cNvSpPr txBox="1"/>
+          <p:nvPr/>
+        </p:nvSpPr>
+        <p:spPr>
+          <a:xfrm>
+            <a:off x="6598920" y="2022348"/>
+            <a:ext cx="495300" cy="339852"/>
+          </a:xfrm>
+          <a:prstGeom prst="rect">
+            <a:avLst/>
+          </a:prstGeom>
+          <a:noFill/>
+          <a:ln/>
+        </p:spPr>
+        <p:txBody>
+          <a:bodyPr wrap="square" lIns="0" tIns="0" rIns="0" bIns="0" rtlCol="0" anchor="ctr"/>
+          <a:lstStyle/>
+          <a:p>
+            <a:pPr algn="ctr" indent="0" marL="0">
+              <a:buNone/>
+            </a:pPr>
+            <a:r>
+              <a:rPr lang="en-US" sz="1300" dirty="0">
+                <a:solidFill>
+                  <a:srgbClr val="8C8C8C"/>
+                </a:solidFill>
+              </a:rPr>
+              <a:t>K</a:t>
+            </a:r>
+            <a:endParaRPr lang="en-US" sz="1300" dirty="0"/>
+          </a:p>
+        </p:txBody>
+      </p:sp>
+      <p:sp>
+        <p:nvSpPr>
+          <p:cNvPr id="34" name="P300 cell 11"/>
+          <p:cNvSpPr txBox="1"/>
+          <p:nvPr/>
+        </p:nvSpPr>
+        <p:spPr>
+          <a:xfrm>
+            <a:off x="7094220" y="2022348"/>
+            <a:ext cx="495300" cy="339852"/>
+          </a:xfrm>
+          <a:prstGeom prst="rect">
+            <a:avLst/>
+          </a:prstGeom>
+          <a:noFill/>
+          <a:ln/>
+        </p:spPr>
+        <p:txBody>
+          <a:bodyPr wrap="square" lIns="0" tIns="0" rIns="0" bIns="0" rtlCol="0" anchor="ctr"/>
+          <a:lstStyle/>
+          <a:p>
+            <a:pPr algn="ctr" indent="0" marL="0">
+              <a:buNone/>
+            </a:pPr>
+            <a:r>
+              <a:rPr lang="en-US" sz="1300" dirty="0">
+                <a:solidFill>
+                  <a:srgbClr val="8C8C8C"/>
+                </a:solidFill>
+              </a:rPr>
+              <a:t>L</a:t>
+            </a:r>
+            <a:endParaRPr lang="en-US" sz="1300" dirty="0"/>
+          </a:p>
+        </p:txBody>
+      </p:sp>
+      <p:sp>
+        <p:nvSpPr>
+          <p:cNvPr id="35" name="P300 cell 12"/>
+          <p:cNvSpPr txBox="1"/>
+          <p:nvPr/>
+        </p:nvSpPr>
+        <p:spPr>
+          <a:xfrm>
+            <a:off x="4617720" y="2362200"/>
+            <a:ext cx="495300" cy="339852"/>
+          </a:xfrm>
+          <a:prstGeom prst="rect">
+            <a:avLst/>
+          </a:prstGeom>
+          <a:noFill/>
+          <a:ln/>
+        </p:spPr>
+        <p:txBody>
+          <a:bodyPr wrap="square" lIns="0" tIns="0" rIns="0" bIns="0" rtlCol="0" anchor="ctr"/>
+          <a:lstStyle/>
+          <a:p>
+            <a:pPr algn="ctr" indent="0" marL="0">
+              <a:buNone/>
+            </a:pPr>
+            <a:r>
+              <a:rPr lang="en-US" sz="1300" b="1" dirty="0">
+                <a:solidFill>
+                  <a:srgbClr val="FFFFFF"/>
+                </a:solidFill>
+              </a:rPr>
+              <a:t>M</a:t>
+            </a:r>
+            <a:endParaRPr lang="en-US" sz="1300" dirty="0"/>
+          </a:p>
+        </p:txBody>
+      </p:sp>
+      <p:sp>
+        <p:nvSpPr>
+          <p:cNvPr id="36" name="P300 cell 13"/>
+          <p:cNvSpPr txBox="1"/>
+          <p:nvPr/>
+        </p:nvSpPr>
+        <p:spPr>
+          <a:xfrm>
+            <a:off x="5113020" y="2362200"/>
+            <a:ext cx="495300" cy="339852"/>
+          </a:xfrm>
+          <a:prstGeom prst="rect">
+            <a:avLst/>
+          </a:prstGeom>
+          <a:noFill/>
+          <a:ln/>
+        </p:spPr>
+        <p:txBody>
+          <a:bodyPr wrap="square" lIns="0" tIns="0" rIns="0" bIns="0" rtlCol="0" anchor="ctr"/>
+          <a:lstStyle/>
+          <a:p>
+            <a:pPr algn="ctr" indent="0" marL="0">
+              <a:buNone/>
+            </a:pPr>
+            <a:r>
+              <a:rPr lang="en-US" sz="1300" b="1" dirty="0">
+                <a:solidFill>
+                  <a:srgbClr val="FFFFFF"/>
+                </a:solidFill>
+              </a:rPr>
+              <a:t>N</a:t>
+            </a:r>
+            <a:endParaRPr lang="en-US" sz="1300" dirty="0"/>
+          </a:p>
+        </p:txBody>
+      </p:sp>
+      <p:sp>
+        <p:nvSpPr>
+          <p:cNvPr id="37" name="P300 cell 14"/>
+          <p:cNvSpPr txBox="1"/>
+          <p:nvPr/>
+        </p:nvSpPr>
+        <p:spPr>
+          <a:xfrm>
+            <a:off x="5608320" y="2362200"/>
+            <a:ext cx="495300" cy="339852"/>
+          </a:xfrm>
+          <a:prstGeom prst="rect">
+            <a:avLst/>
+          </a:prstGeom>
+          <a:noFill/>
+          <a:ln/>
+        </p:spPr>
+        <p:txBody>
+          <a:bodyPr wrap="square" lIns="0" tIns="0" rIns="0" bIns="0" rtlCol="0" anchor="ctr"/>
+          <a:lstStyle/>
+          <a:p>
+            <a:pPr algn="ctr" indent="0" marL="0">
+              <a:buNone/>
+            </a:pPr>
+            <a:r>
+              <a:rPr lang="en-US" sz="1300" b="1" dirty="0">
+                <a:solidFill>
+                  <a:srgbClr val="FFFFFF"/>
+                </a:solidFill>
+              </a:rPr>
+              <a:t>O</a:t>
+            </a:r>
+            <a:endParaRPr lang="en-US" sz="1300" dirty="0"/>
+          </a:p>
+        </p:txBody>
+      </p:sp>
+      <p:sp>
+        <p:nvSpPr>
+          <p:cNvPr id="38" name="P300 cell 15"/>
+          <p:cNvSpPr txBox="1"/>
+          <p:nvPr/>
+        </p:nvSpPr>
+        <p:spPr>
+          <a:xfrm>
+            <a:off x="6103620" y="2362200"/>
+            <a:ext cx="495300" cy="339852"/>
+          </a:xfrm>
+          <a:prstGeom prst="rect">
+            <a:avLst/>
+          </a:prstGeom>
+          <a:noFill/>
+          <a:ln/>
+        </p:spPr>
+        <p:txBody>
+          <a:bodyPr wrap="square" lIns="0" tIns="0" rIns="0" bIns="0" rtlCol="0" anchor="ctr"/>
+          <a:lstStyle/>
+          <a:p>
+            <a:pPr algn="ctr" indent="0" marL="0">
+              <a:buNone/>
+            </a:pPr>
+            <a:r>
+              <a:rPr lang="en-US" sz="1300" b="1" dirty="0">
+                <a:solidFill>
+                  <a:srgbClr val="FFFFFF"/>
+                </a:solidFill>
+              </a:rPr>
+              <a:t>P</a:t>
+            </a:r>
+            <a:endParaRPr lang="en-US" sz="1300" dirty="0"/>
+          </a:p>
+        </p:txBody>
+      </p:sp>
+      <p:sp>
+        <p:nvSpPr>
+          <p:cNvPr id="39" name="P300 cell 16"/>
+          <p:cNvSpPr txBox="1"/>
+          <p:nvPr/>
+        </p:nvSpPr>
+        <p:spPr>
+          <a:xfrm>
+            <a:off x="6598920" y="2362200"/>
+            <a:ext cx="495300" cy="339852"/>
+          </a:xfrm>
+          <a:prstGeom prst="rect">
+            <a:avLst/>
+          </a:prstGeom>
+          <a:noFill/>
+          <a:ln/>
+        </p:spPr>
+        <p:txBody>
+          <a:bodyPr wrap="square" lIns="0" tIns="0" rIns="0" bIns="0" rtlCol="0" anchor="ctr"/>
+          <a:lstStyle/>
+          <a:p>
+            <a:pPr algn="ctr" indent="0" marL="0">
+              <a:buNone/>
+            </a:pPr>
+            <a:r>
+              <a:rPr lang="en-US" sz="1300" b="1" dirty="0">
+                <a:solidFill>
+                  <a:srgbClr val="FFFFFF"/>
+                </a:solidFill>
+              </a:rPr>
+              <a:t>Q</a:t>
+            </a:r>
+            <a:endParaRPr lang="en-US" sz="1300" dirty="0"/>
+          </a:p>
+        </p:txBody>
+      </p:sp>
+      <p:sp>
+        <p:nvSpPr>
+          <p:cNvPr id="40" name="P300 cell 17"/>
+          <p:cNvSpPr txBox="1"/>
+          <p:nvPr/>
+        </p:nvSpPr>
+        <p:spPr>
+          <a:xfrm>
+            <a:off x="7094220" y="2362200"/>
+            <a:ext cx="495300" cy="339852"/>
+          </a:xfrm>
+          <a:prstGeom prst="rect">
+            <a:avLst/>
+          </a:prstGeom>
+          <a:noFill/>
+          <a:ln/>
+        </p:spPr>
+        <p:txBody>
+          <a:bodyPr wrap="square" lIns="0" tIns="0" rIns="0" bIns="0" rtlCol="0" anchor="ctr"/>
+          <a:lstStyle/>
+          <a:p>
+            <a:pPr algn="ctr" indent="0" marL="0">
+              <a:buNone/>
+            </a:pPr>
+            <a:r>
+              <a:rPr lang="en-US" sz="1300" b="1" dirty="0">
+                <a:solidFill>
+                  <a:srgbClr val="FFFFFF"/>
+                </a:solidFill>
+              </a:rPr>
+              <a:t>R</a:t>
+            </a:r>
+            <a:endParaRPr lang="en-US" sz="1300" dirty="0"/>
+          </a:p>
+        </p:txBody>
+      </p:sp>
+      <p:sp>
+        <p:nvSpPr>
+          <p:cNvPr id="41" name="P300 cell 18"/>
+          <p:cNvSpPr txBox="1"/>
+          <p:nvPr/>
+        </p:nvSpPr>
+        <p:spPr>
+          <a:xfrm>
+            <a:off x="4617720" y="2702052"/>
+            <a:ext cx="495300" cy="339852"/>
+          </a:xfrm>
+          <a:prstGeom prst="rect">
+            <a:avLst/>
+          </a:prstGeom>
+          <a:noFill/>
+          <a:ln/>
+        </p:spPr>
+        <p:txBody>
+          <a:bodyPr wrap="square" lIns="0" tIns="0" rIns="0" bIns="0" rtlCol="0" anchor="ctr"/>
+          <a:lstStyle/>
+          <a:p>
+            <a:pPr algn="ctr" indent="0" marL="0">
+              <a:buNone/>
+            </a:pPr>
+            <a:r>
+              <a:rPr lang="en-US" sz="1300" dirty="0">
+                <a:solidFill>
+                  <a:srgbClr val="8C8C8C"/>
+                </a:solidFill>
+              </a:rPr>
+              <a:t>S</a:t>
+            </a:r>
+            <a:endParaRPr lang="en-US" sz="1300" dirty="0"/>
+          </a:p>
+        </p:txBody>
+      </p:sp>
+      <p:sp>
+        <p:nvSpPr>
+          <p:cNvPr id="42" name="P300 cell 19"/>
+          <p:cNvSpPr txBox="1"/>
+          <p:nvPr/>
+        </p:nvSpPr>
+        <p:spPr>
+          <a:xfrm>
+            <a:off x="5113020" y="2702052"/>
+            <a:ext cx="495300" cy="339852"/>
+          </a:xfrm>
+          <a:prstGeom prst="rect">
+            <a:avLst/>
+          </a:prstGeom>
+          <a:noFill/>
+          <a:ln/>
+        </p:spPr>
+        <p:txBody>
+          <a:bodyPr wrap="square" lIns="0" tIns="0" rIns="0" bIns="0" rtlCol="0" anchor="ctr"/>
+          <a:lstStyle/>
+          <a:p>
+            <a:pPr algn="ctr" indent="0" marL="0">
+              <a:buNone/>
+            </a:pPr>
+            <a:r>
+              <a:rPr lang="en-US" sz="1300" dirty="0">
+                <a:solidFill>
+                  <a:srgbClr val="8C8C8C"/>
+                </a:solidFill>
+              </a:rPr>
+              <a:t>T</a:t>
+            </a:r>
+            <a:endParaRPr lang="en-US" sz="1300" dirty="0"/>
+          </a:p>
+        </p:txBody>
+      </p:sp>
+      <p:sp>
+        <p:nvSpPr>
+          <p:cNvPr id="43" name="P300 cell 20"/>
+          <p:cNvSpPr txBox="1"/>
+          <p:nvPr/>
+        </p:nvSpPr>
+        <p:spPr>
+          <a:xfrm>
+            <a:off x="5608320" y="2702052"/>
+            <a:ext cx="495300" cy="339852"/>
+          </a:xfrm>
+          <a:prstGeom prst="rect">
+            <a:avLst/>
+          </a:prstGeom>
+          <a:noFill/>
+          <a:ln/>
+        </p:spPr>
+        <p:txBody>
+          <a:bodyPr wrap="square" lIns="0" tIns="0" rIns="0" bIns="0" rtlCol="0" anchor="ctr"/>
+          <a:lstStyle/>
+          <a:p>
+            <a:pPr algn="ctr" indent="0" marL="0">
+              <a:buNone/>
+            </a:pPr>
+            <a:r>
+              <a:rPr lang="en-US" sz="1300" dirty="0">
+                <a:solidFill>
+                  <a:srgbClr val="8C8C8C"/>
+                </a:solidFill>
+              </a:rPr>
+              <a:t>U</a:t>
+            </a:r>
+            <a:endParaRPr lang="en-US" sz="1300" dirty="0"/>
+          </a:p>
+        </p:txBody>
+      </p:sp>
+      <p:sp>
+        <p:nvSpPr>
+          <p:cNvPr id="44" name="P300 cell 21"/>
+          <p:cNvSpPr txBox="1"/>
+          <p:nvPr/>
+        </p:nvSpPr>
+        <p:spPr>
+          <a:xfrm>
+            <a:off x="6103620" y="2702052"/>
+            <a:ext cx="495300" cy="339852"/>
+          </a:xfrm>
+          <a:prstGeom prst="rect">
+            <a:avLst/>
+          </a:prstGeom>
+          <a:noFill/>
+          <a:ln/>
+        </p:spPr>
+        <p:txBody>
+          <a:bodyPr wrap="square" lIns="0" tIns="0" rIns="0" bIns="0" rtlCol="0" anchor="ctr"/>
+          <a:lstStyle/>
+          <a:p>
+            <a:pPr algn="ctr" indent="0" marL="0">
+              <a:buNone/>
+            </a:pPr>
+            <a:r>
+              <a:rPr lang="en-US" sz="1300" dirty="0">
+                <a:solidFill>
+                  <a:srgbClr val="8C8C8C"/>
+                </a:solidFill>
+              </a:rPr>
+              <a:t>V</a:t>
+            </a:r>
+            <a:endParaRPr lang="en-US" sz="1300" dirty="0"/>
+          </a:p>
+        </p:txBody>
+      </p:sp>
+      <p:sp>
+        <p:nvSpPr>
+          <p:cNvPr id="45" name="P300 cell 22"/>
+          <p:cNvSpPr txBox="1"/>
+          <p:nvPr/>
+        </p:nvSpPr>
+        <p:spPr>
+          <a:xfrm>
+            <a:off x="6598920" y="2702052"/>
+            <a:ext cx="495300" cy="339852"/>
+          </a:xfrm>
+          <a:prstGeom prst="rect">
+            <a:avLst/>
+          </a:prstGeom>
+          <a:noFill/>
+          <a:ln/>
+        </p:spPr>
+        <p:txBody>
+          <a:bodyPr wrap="square" lIns="0" tIns="0" rIns="0" bIns="0" rtlCol="0" anchor="ctr"/>
+          <a:lstStyle/>
+          <a:p>
+            <a:pPr algn="ctr" indent="0" marL="0">
+              <a:buNone/>
+            </a:pPr>
+            <a:r>
+              <a:rPr lang="en-US" sz="1300" dirty="0">
+                <a:solidFill>
+                  <a:srgbClr val="8C8C8C"/>
+                </a:solidFill>
+              </a:rPr>
+              <a:t>W</a:t>
+            </a:r>
+            <a:endParaRPr lang="en-US" sz="1300" dirty="0"/>
+          </a:p>
+        </p:txBody>
+      </p:sp>
+      <p:sp>
+        <p:nvSpPr>
+          <p:cNvPr id="46" name="P300 cell 23"/>
+          <p:cNvSpPr txBox="1"/>
+          <p:nvPr/>
+        </p:nvSpPr>
+        <p:spPr>
+          <a:xfrm>
+            <a:off x="7094220" y="2702052"/>
+            <a:ext cx="495300" cy="339852"/>
+          </a:xfrm>
+          <a:prstGeom prst="rect">
+            <a:avLst/>
+          </a:prstGeom>
+          <a:noFill/>
+          <a:ln/>
+        </p:spPr>
+        <p:txBody>
+          <a:bodyPr wrap="square" lIns="0" tIns="0" rIns="0" bIns="0" rtlCol="0" anchor="ctr"/>
+          <a:lstStyle/>
+          <a:p>
+            <a:pPr algn="ctr" indent="0" marL="0">
+              <a:buNone/>
+            </a:pPr>
+            <a:r>
+              <a:rPr lang="en-US" sz="1300" dirty="0">
+                <a:solidFill>
+                  <a:srgbClr val="8C8C8C"/>
+                </a:solidFill>
+              </a:rPr>
+              <a:t>X</a:t>
+            </a:r>
+            <a:endParaRPr lang="en-US" sz="1300" dirty="0"/>
+          </a:p>
+        </p:txBody>
+      </p:sp>
+      <p:sp>
+        <p:nvSpPr>
+          <p:cNvPr id="47" name="P300 cell 24"/>
+          <p:cNvSpPr txBox="1"/>
+          <p:nvPr/>
+        </p:nvSpPr>
+        <p:spPr>
+          <a:xfrm>
+            <a:off x="4617720" y="3041904"/>
+            <a:ext cx="495300" cy="339852"/>
+          </a:xfrm>
+          <a:prstGeom prst="rect">
+            <a:avLst/>
+          </a:prstGeom>
+          <a:noFill/>
+          <a:ln/>
+        </p:spPr>
+        <p:txBody>
+          <a:bodyPr wrap="square" lIns="0" tIns="0" rIns="0" bIns="0" rtlCol="0" anchor="ctr"/>
+          <a:lstStyle/>
+          <a:p>
+            <a:pPr algn="ctr" indent="0" marL="0">
+              <a:buNone/>
+            </a:pPr>
+            <a:r>
+              <a:rPr lang="en-US" sz="1300" dirty="0">
+                <a:solidFill>
+                  <a:srgbClr val="8C8C8C"/>
+                </a:solidFill>
+              </a:rPr>
+              <a:t>Y</a:t>
+            </a:r>
+            <a:endParaRPr lang="en-US" sz="1300" dirty="0"/>
+          </a:p>
+        </p:txBody>
+      </p:sp>
+      <p:sp>
+        <p:nvSpPr>
+          <p:cNvPr id="48" name="P300 cell 25"/>
+          <p:cNvSpPr txBox="1"/>
+          <p:nvPr/>
+        </p:nvSpPr>
+        <p:spPr>
+          <a:xfrm>
+            <a:off x="5113020" y="3041904"/>
+            <a:ext cx="495300" cy="339852"/>
+          </a:xfrm>
+          <a:prstGeom prst="rect">
+            <a:avLst/>
+          </a:prstGeom>
+          <a:noFill/>
+          <a:ln/>
+        </p:spPr>
+        <p:txBody>
+          <a:bodyPr wrap="square" lIns="0" tIns="0" rIns="0" bIns="0" rtlCol="0" anchor="ctr"/>
+          <a:lstStyle/>
+          <a:p>
+            <a:pPr algn="ctr" indent="0" marL="0">
+              <a:buNone/>
+            </a:pPr>
+            <a:r>
+              <a:rPr lang="en-US" sz="1300" dirty="0">
+                <a:solidFill>
+                  <a:srgbClr val="8C8C8C"/>
+                </a:solidFill>
+              </a:rPr>
+              <a:t>Z</a:t>
+            </a:r>
+            <a:endParaRPr lang="en-US" sz="1300" dirty="0"/>
+          </a:p>
+        </p:txBody>
+      </p:sp>
+      <p:sp>
+        <p:nvSpPr>
+          <p:cNvPr id="49" name="P300 cell 26"/>
+          <p:cNvSpPr txBox="1"/>
+          <p:nvPr/>
+        </p:nvSpPr>
+        <p:spPr>
+          <a:xfrm>
+            <a:off x="5608320" y="3041904"/>
+            <a:ext cx="495300" cy="339852"/>
+          </a:xfrm>
+          <a:prstGeom prst="rect">
+            <a:avLst/>
+          </a:prstGeom>
+          <a:noFill/>
+          <a:ln/>
+        </p:spPr>
+        <p:txBody>
+          <a:bodyPr wrap="square" lIns="0" tIns="0" rIns="0" bIns="0" rtlCol="0" anchor="ctr"/>
+          <a:lstStyle/>
+          <a:p>
+            <a:pPr algn="ctr" indent="0" marL="0">
+              <a:buNone/>
+            </a:pPr>
+            <a:r>
+              <a:rPr lang="en-US" sz="1300" dirty="0">
+                <a:solidFill>
+                  <a:srgbClr val="8C8C8C"/>
+                </a:solidFill>
+              </a:rPr>
+              <a:t>1</a:t>
+            </a:r>
+            <a:endParaRPr lang="en-US" sz="1300" dirty="0"/>
+          </a:p>
+        </p:txBody>
+      </p:sp>
+      <p:sp>
+        <p:nvSpPr>
+          <p:cNvPr id="50" name="P300 cell 27"/>
+          <p:cNvSpPr txBox="1"/>
+          <p:nvPr/>
+        </p:nvSpPr>
+        <p:spPr>
+          <a:xfrm>
+            <a:off x="6103620" y="3041904"/>
+            <a:ext cx="495300" cy="339852"/>
+          </a:xfrm>
+          <a:prstGeom prst="rect">
+            <a:avLst/>
+          </a:prstGeom>
+          <a:noFill/>
+          <a:ln/>
+        </p:spPr>
+        <p:txBody>
+          <a:bodyPr wrap="square" lIns="0" tIns="0" rIns="0" bIns="0" rtlCol="0" anchor="ctr"/>
+          <a:lstStyle/>
+          <a:p>
+            <a:pPr algn="ctr" indent="0" marL="0">
+              <a:buNone/>
+            </a:pPr>
+            <a:r>
+              <a:rPr lang="en-US" sz="1300" dirty="0">
+                <a:solidFill>
+                  <a:srgbClr val="8C8C8C"/>
+                </a:solidFill>
+              </a:rPr>
+              <a:t>2</a:t>
+            </a:r>
+            <a:endParaRPr lang="en-US" sz="1300" dirty="0"/>
+          </a:p>
+        </p:txBody>
+      </p:sp>
+      <p:sp>
+        <p:nvSpPr>
+          <p:cNvPr id="51" name="P300 cell 28"/>
+          <p:cNvSpPr txBox="1"/>
+          <p:nvPr/>
+        </p:nvSpPr>
+        <p:spPr>
+          <a:xfrm>
+            <a:off x="6598920" y="3041904"/>
+            <a:ext cx="495300" cy="339852"/>
+          </a:xfrm>
+          <a:prstGeom prst="rect">
+            <a:avLst/>
+          </a:prstGeom>
+          <a:noFill/>
+          <a:ln/>
+        </p:spPr>
+        <p:txBody>
+          <a:bodyPr wrap="square" lIns="0" tIns="0" rIns="0" bIns="0" rtlCol="0" anchor="ctr"/>
+          <a:lstStyle/>
+          <a:p>
+            <a:pPr algn="ctr" indent="0" marL="0">
+              <a:buNone/>
+            </a:pPr>
+            <a:r>
+              <a:rPr lang="en-US" sz="1300" dirty="0">
+                <a:solidFill>
+                  <a:srgbClr val="8C8C8C"/>
+                </a:solidFill>
+              </a:rPr>
+              <a:t>3</a:t>
+            </a:r>
+            <a:endParaRPr lang="en-US" sz="1300" dirty="0"/>
+          </a:p>
+        </p:txBody>
+      </p:sp>
+      <p:sp>
+        <p:nvSpPr>
+          <p:cNvPr id="52" name="P300 cell 29"/>
+          <p:cNvSpPr txBox="1"/>
+          <p:nvPr/>
+        </p:nvSpPr>
+        <p:spPr>
+          <a:xfrm>
+            <a:off x="7094220" y="3041904"/>
+            <a:ext cx="495300" cy="339852"/>
+          </a:xfrm>
+          <a:prstGeom prst="rect">
+            <a:avLst/>
+          </a:prstGeom>
+          <a:noFill/>
+          <a:ln/>
+        </p:spPr>
+        <p:txBody>
+          <a:bodyPr wrap="square" lIns="0" tIns="0" rIns="0" bIns="0" rtlCol="0" anchor="ctr"/>
+          <a:lstStyle/>
+          <a:p>
+            <a:pPr algn="ctr" indent="0" marL="0">
+              <a:buNone/>
+            </a:pPr>
+            <a:r>
+              <a:rPr lang="en-US" sz="1300" dirty="0">
+                <a:solidFill>
+                  <a:srgbClr val="8C8C8C"/>
+                </a:solidFill>
+              </a:rPr>
+              <a:t>4</a:t>
+            </a:r>
+            <a:endParaRPr lang="en-US" sz="1300" dirty="0"/>
+          </a:p>
+        </p:txBody>
+      </p:sp>
+      <p:sp>
+        <p:nvSpPr>
+          <p:cNvPr id="53" name="P300 cell 30"/>
+          <p:cNvSpPr txBox="1"/>
+          <p:nvPr/>
+        </p:nvSpPr>
+        <p:spPr>
+          <a:xfrm>
+            <a:off x="4617720" y="3381756"/>
+            <a:ext cx="495300" cy="339852"/>
+          </a:xfrm>
+          <a:prstGeom prst="rect">
+            <a:avLst/>
+          </a:prstGeom>
+          <a:noFill/>
+          <a:ln/>
+        </p:spPr>
+        <p:txBody>
+          <a:bodyPr wrap="square" lIns="0" tIns="0" rIns="0" bIns="0" rtlCol="0" anchor="ctr"/>
+          <a:lstStyle/>
+          <a:p>
+            <a:pPr algn="ctr" indent="0" marL="0">
+              <a:buNone/>
+            </a:pPr>
+            <a:r>
+              <a:rPr lang="en-US" sz="1300" dirty="0">
+                <a:solidFill>
+                  <a:srgbClr val="8C8C8C"/>
+                </a:solidFill>
+              </a:rPr>
+              <a:t>5</a:t>
+            </a:r>
+            <a:endParaRPr lang="en-US" sz="1300" dirty="0"/>
+          </a:p>
+        </p:txBody>
+      </p:sp>
+      <p:sp>
+        <p:nvSpPr>
+          <p:cNvPr id="54" name="P300 cell 31"/>
+          <p:cNvSpPr txBox="1"/>
+          <p:nvPr/>
+        </p:nvSpPr>
+        <p:spPr>
+          <a:xfrm>
+            <a:off x="5113020" y="3381756"/>
+            <a:ext cx="495300" cy="339852"/>
+          </a:xfrm>
+          <a:prstGeom prst="rect">
+            <a:avLst/>
+          </a:prstGeom>
+          <a:noFill/>
+          <a:ln/>
+        </p:spPr>
+        <p:txBody>
+          <a:bodyPr wrap="square" lIns="0" tIns="0" rIns="0" bIns="0" rtlCol="0" anchor="ctr"/>
+          <a:lstStyle/>
+          <a:p>
+            <a:pPr algn="ctr" indent="0" marL="0">
+              <a:buNone/>
+            </a:pPr>
+            <a:r>
+              <a:rPr lang="en-US" sz="1300" dirty="0">
+                <a:solidFill>
+                  <a:srgbClr val="8C8C8C"/>
+                </a:solidFill>
+              </a:rPr>
+              <a:t>6</a:t>
+            </a:r>
+            <a:endParaRPr lang="en-US" sz="1300" dirty="0"/>
+          </a:p>
+        </p:txBody>
+      </p:sp>
+      <p:sp>
+        <p:nvSpPr>
+          <p:cNvPr id="55" name="P300 cell 32"/>
+          <p:cNvSpPr txBox="1"/>
+          <p:nvPr/>
+        </p:nvSpPr>
+        <p:spPr>
+          <a:xfrm>
+            <a:off x="5608320" y="3381756"/>
+            <a:ext cx="495300" cy="339852"/>
+          </a:xfrm>
+          <a:prstGeom prst="rect">
+            <a:avLst/>
+          </a:prstGeom>
+          <a:noFill/>
+          <a:ln/>
+        </p:spPr>
+        <p:txBody>
+          <a:bodyPr wrap="square" lIns="0" tIns="0" rIns="0" bIns="0" rtlCol="0" anchor="ctr"/>
+          <a:lstStyle/>
+          <a:p>
+            <a:pPr algn="ctr" indent="0" marL="0">
+              <a:buNone/>
+            </a:pPr>
+            <a:r>
+              <a:rPr lang="en-US" sz="1300" dirty="0">
+                <a:solidFill>
+                  <a:srgbClr val="8C8C8C"/>
+                </a:solidFill>
+              </a:rPr>
+              <a:t>7</a:t>
+            </a:r>
+            <a:endParaRPr lang="en-US" sz="1300" dirty="0"/>
+          </a:p>
+        </p:txBody>
+      </p:sp>
+      <p:sp>
+        <p:nvSpPr>
+          <p:cNvPr id="56" name="P300 cell 33"/>
+          <p:cNvSpPr txBox="1"/>
+          <p:nvPr/>
+        </p:nvSpPr>
+        <p:spPr>
+          <a:xfrm>
+            <a:off x="6103620" y="3381756"/>
+            <a:ext cx="495300" cy="339852"/>
+          </a:xfrm>
+          <a:prstGeom prst="rect">
+            <a:avLst/>
+          </a:prstGeom>
+          <a:noFill/>
+          <a:ln/>
+        </p:spPr>
+        <p:txBody>
+          <a:bodyPr wrap="square" lIns="0" tIns="0" rIns="0" bIns="0" rtlCol="0" anchor="ctr"/>
+          <a:lstStyle/>
+          <a:p>
+            <a:pPr algn="ctr" indent="0" marL="0">
+              <a:buNone/>
+            </a:pPr>
+            <a:r>
+              <a:rPr lang="en-US" sz="1300" dirty="0">
+                <a:solidFill>
+                  <a:srgbClr val="8C8C8C"/>
+                </a:solidFill>
+              </a:rPr>
+              <a:t>8</a:t>
+            </a:r>
+            <a:endParaRPr lang="en-US" sz="1300" dirty="0"/>
+          </a:p>
+        </p:txBody>
+      </p:sp>
+      <p:sp>
+        <p:nvSpPr>
+          <p:cNvPr id="57" name="P300 cell 34"/>
+          <p:cNvSpPr txBox="1"/>
+          <p:nvPr/>
+        </p:nvSpPr>
+        <p:spPr>
+          <a:xfrm>
+            <a:off x="6598920" y="3381756"/>
+            <a:ext cx="495300" cy="339852"/>
+          </a:xfrm>
+          <a:prstGeom prst="rect">
+            <a:avLst/>
+          </a:prstGeom>
+          <a:noFill/>
+          <a:ln/>
+        </p:spPr>
+        <p:txBody>
+          <a:bodyPr wrap="square" lIns="0" tIns="0" rIns="0" bIns="0" rtlCol="0" anchor="ctr"/>
+          <a:lstStyle/>
+          <a:p>
+            <a:pPr algn="ctr" indent="0" marL="0">
+              <a:buNone/>
+            </a:pPr>
+            <a:r>
+              <a:rPr lang="en-US" sz="1300" dirty="0">
+                <a:solidFill>
+                  <a:srgbClr val="8C8C8C"/>
+                </a:solidFill>
+              </a:rPr>
+              <a:t>9</a:t>
+            </a:r>
+            <a:endParaRPr lang="en-US" sz="1300" dirty="0"/>
+          </a:p>
+        </p:txBody>
+      </p:sp>
+      <p:sp>
+        <p:nvSpPr>
+          <p:cNvPr id="58" name="P300 cell 35"/>
+          <p:cNvSpPr txBox="1"/>
+          <p:nvPr/>
+        </p:nvSpPr>
+        <p:spPr>
+          <a:xfrm>
+            <a:off x="7094220" y="3381756"/>
+            <a:ext cx="495300" cy="339852"/>
+          </a:xfrm>
+          <a:prstGeom prst="rect">
+            <a:avLst/>
+          </a:prstGeom>
+          <a:noFill/>
+          <a:ln/>
+        </p:spPr>
+        <p:txBody>
+          <a:bodyPr wrap="square" lIns="0" tIns="0" rIns="0" bIns="0" rtlCol="0" anchor="ctr"/>
+          <a:lstStyle/>
+          <a:p>
+            <a:pPr algn="ctr" indent="0" marL="0">
+              <a:buNone/>
+            </a:pPr>
+            <a:r>
+              <a:rPr lang="en-US" sz="1300" dirty="0">
+                <a:solidFill>
+                  <a:srgbClr val="8C8C8C"/>
+                </a:solidFill>
+              </a:rPr>
+              <a:t>_</a:t>
+            </a:r>
+            <a:endParaRPr lang="en-US" sz="1300" dirty="0"/>
+          </a:p>
+        </p:txBody>
+      </p:sp>
+      <p:sp>
+        <p:nvSpPr>
+          <p:cNvPr id="59" name="aVEP command 0"/>
+          <p:cNvSpPr txBox="1"/>
+          <p:nvPr/>
+        </p:nvSpPr>
+        <p:spPr>
+          <a:xfrm>
+            <a:off x="8229600" y="3538728"/>
+            <a:ext cx="667512" cy="219456"/>
+          </a:xfrm>
+          <a:prstGeom prst="rect">
+            <a:avLst/>
+          </a:prstGeom>
+          <a:noFill/>
+          <a:ln/>
+        </p:spPr>
+        <p:txBody>
+          <a:bodyPr wrap="square" lIns="0" tIns="0" rIns="0" bIns="0" rtlCol="0" anchor="ctr"/>
+          <a:lstStyle/>
+          <a:p>
+            <a:pPr algn="ctr" indent="0" marL="0">
+              <a:buNone/>
+            </a:pPr>
+            <a:r>
+              <a:rPr lang="en-US" sz="1100" dirty="0">
+                <a:solidFill>
+                  <a:schemeClr val="tx1"/>
+                </a:solidFill>
+              </a:rPr>
+              <a:t>↑</a:t>
+            </a:r>
+            <a:endParaRPr lang="en-US" sz="1100" dirty="0"/>
+          </a:p>
+        </p:txBody>
+      </p:sp>
+      <p:sp>
+        <p:nvSpPr>
+          <p:cNvPr id="60" name="aVEP stimulus 0L"/>
+          <p:cNvSpPr/>
+          <p:nvPr/>
+        </p:nvSpPr>
+        <p:spPr>
+          <a:xfrm>
+            <a:off x="8417052" y="3625596"/>
+            <a:ext cx="45720" cy="45720"/>
+          </a:xfrm>
+          <a:prstGeom prst="rect">
+            <a:avLst/>
+          </a:prstGeom>
+          <a:solidFill>
+            <a:srgbClr val="A00000"/>
+          </a:solidFill>
+          <a:ln/>
+        </p:spPr>
+      </p:sp>
+      <p:sp>
+        <p:nvSpPr>
+          <p:cNvPr id="61" name="aVEP stimulus 0R"/>
+          <p:cNvSpPr/>
+          <p:nvPr/>
+        </p:nvSpPr>
+        <p:spPr>
+          <a:xfrm>
+            <a:off x="8663940" y="3625596"/>
+            <a:ext cx="45720" cy="45720"/>
+          </a:xfrm>
+          <a:prstGeom prst="rect">
+            <a:avLst/>
+          </a:prstGeom>
+          <a:solidFill>
+            <a:srgbClr val="A00000"/>
+          </a:solidFill>
+          <a:ln/>
+        </p:spPr>
+      </p:sp>
+      <p:sp>
+        <p:nvSpPr>
+          <p:cNvPr id="62" name="aVEP command 1"/>
+          <p:cNvSpPr txBox="1"/>
+          <p:nvPr/>
+        </p:nvSpPr>
+        <p:spPr>
+          <a:xfrm>
+            <a:off x="8897112" y="3538728"/>
+            <a:ext cx="667512" cy="219456"/>
+          </a:xfrm>
+          <a:prstGeom prst="rect">
+            <a:avLst/>
+          </a:prstGeom>
+          <a:noFill/>
+          <a:ln/>
+        </p:spPr>
+        <p:txBody>
+          <a:bodyPr wrap="square" lIns="0" tIns="0" rIns="0" bIns="0" rtlCol="0" anchor="ctr"/>
+          <a:lstStyle/>
+          <a:p>
+            <a:pPr algn="ctr" indent="0" marL="0">
+              <a:buNone/>
+            </a:pPr>
+            <a:r>
+              <a:rPr lang="en-US" sz="1100" dirty="0">
+                <a:solidFill>
+                  <a:schemeClr val="tx1"/>
+                </a:solidFill>
+              </a:rPr>
+              <a:t>↓</a:t>
+            </a:r>
+            <a:endParaRPr lang="en-US" sz="1100" dirty="0"/>
+          </a:p>
+        </p:txBody>
+      </p:sp>
+      <p:sp>
+        <p:nvSpPr>
+          <p:cNvPr id="63" name="aVEP stimulus 1L"/>
+          <p:cNvSpPr/>
+          <p:nvPr/>
+        </p:nvSpPr>
+        <p:spPr>
+          <a:xfrm>
+            <a:off x="9084564" y="3625596"/>
+            <a:ext cx="45720" cy="45720"/>
+          </a:xfrm>
+          <a:prstGeom prst="rect">
+            <a:avLst/>
+          </a:prstGeom>
+          <a:solidFill>
+            <a:srgbClr val="A00000"/>
+          </a:solidFill>
+          <a:ln/>
+        </p:spPr>
+      </p:sp>
+      <p:sp>
+        <p:nvSpPr>
+          <p:cNvPr id="64" name="aVEP stimulus 1R"/>
+          <p:cNvSpPr/>
+          <p:nvPr/>
+        </p:nvSpPr>
+        <p:spPr>
+          <a:xfrm>
+            <a:off x="9331452" y="3625596"/>
+            <a:ext cx="45720" cy="45720"/>
+          </a:xfrm>
+          <a:prstGeom prst="rect">
+            <a:avLst/>
+          </a:prstGeom>
+          <a:solidFill>
+            <a:srgbClr val="A00000"/>
+          </a:solidFill>
+          <a:ln/>
+        </p:spPr>
+      </p:sp>
+      <p:sp>
+        <p:nvSpPr>
+          <p:cNvPr id="65" name="aVEP command 2"/>
+          <p:cNvSpPr txBox="1"/>
+          <p:nvPr/>
+        </p:nvSpPr>
+        <p:spPr>
+          <a:xfrm>
+            <a:off x="9564624" y="3538728"/>
+            <a:ext cx="667512" cy="219456"/>
+          </a:xfrm>
+          <a:prstGeom prst="rect">
+            <a:avLst/>
+          </a:prstGeom>
+          <a:noFill/>
+          <a:ln/>
+        </p:spPr>
+        <p:txBody>
+          <a:bodyPr wrap="square" lIns="0" tIns="0" rIns="0" bIns="0" rtlCol="0" anchor="ctr"/>
+          <a:lstStyle/>
+          <a:p>
+            <a:pPr algn="ctr" indent="0" marL="0">
+              <a:buNone/>
+            </a:pPr>
+            <a:r>
+              <a:rPr lang="en-US" sz="1100" dirty="0">
+                <a:solidFill>
+                  <a:schemeClr val="tx1"/>
+                </a:solidFill>
+              </a:rPr>
+              <a:t>←</a:t>
+            </a:r>
+            <a:endParaRPr lang="en-US" sz="1100" dirty="0"/>
+          </a:p>
+        </p:txBody>
+      </p:sp>
+      <p:sp>
+        <p:nvSpPr>
+          <p:cNvPr id="66" name="aVEP stimulus 2L"/>
+          <p:cNvSpPr/>
+          <p:nvPr/>
+        </p:nvSpPr>
+        <p:spPr>
+          <a:xfrm>
+            <a:off x="9752076" y="3625596"/>
+            <a:ext cx="45720" cy="45720"/>
+          </a:xfrm>
+          <a:prstGeom prst="rect">
+            <a:avLst/>
+          </a:prstGeom>
+          <a:solidFill>
+            <a:srgbClr val="A00000"/>
+          </a:solidFill>
+          <a:ln/>
+        </p:spPr>
+      </p:sp>
+      <p:sp>
+        <p:nvSpPr>
+          <p:cNvPr id="67" name="aVEP stimulus 2R"/>
+          <p:cNvSpPr/>
+          <p:nvPr/>
+        </p:nvSpPr>
+        <p:spPr>
+          <a:xfrm>
+            <a:off x="9998964" y="3625596"/>
+            <a:ext cx="45720" cy="45720"/>
+          </a:xfrm>
+          <a:prstGeom prst="rect">
+            <a:avLst/>
+          </a:prstGeom>
+          <a:solidFill>
+            <a:srgbClr val="A00000"/>
+          </a:solidFill>
+          <a:ln/>
+        </p:spPr>
+      </p:sp>
+      <p:sp>
+        <p:nvSpPr>
+          <p:cNvPr id="68" name="aVEP command 3"/>
+          <p:cNvSpPr txBox="1"/>
+          <p:nvPr/>
+        </p:nvSpPr>
+        <p:spPr>
+          <a:xfrm>
+            <a:off x="10232136" y="3538728"/>
+            <a:ext cx="667512" cy="219456"/>
+          </a:xfrm>
+          <a:prstGeom prst="rect">
+            <a:avLst/>
+          </a:prstGeom>
+          <a:noFill/>
+          <a:ln/>
+        </p:spPr>
+        <p:txBody>
+          <a:bodyPr wrap="square" lIns="0" tIns="0" rIns="0" bIns="0" rtlCol="0" anchor="ctr"/>
+          <a:lstStyle/>
+          <a:p>
+            <a:pPr algn="ctr" indent="0" marL="0">
+              <a:buNone/>
+            </a:pPr>
+            <a:r>
+              <a:rPr lang="en-US" sz="1100" dirty="0">
+                <a:solidFill>
+                  <a:schemeClr val="tx1"/>
+                </a:solidFill>
+              </a:rPr>
+              <a:t>→</a:t>
+            </a:r>
+            <a:endParaRPr lang="en-US" sz="1100" dirty="0"/>
+          </a:p>
+        </p:txBody>
+      </p:sp>
+      <p:sp>
+        <p:nvSpPr>
+          <p:cNvPr id="69" name="aVEP stimulus 3L"/>
+          <p:cNvSpPr/>
+          <p:nvPr/>
+        </p:nvSpPr>
+        <p:spPr>
+          <a:xfrm>
+            <a:off x="10419588" y="3625596"/>
+            <a:ext cx="45720" cy="45720"/>
+          </a:xfrm>
+          <a:prstGeom prst="rect">
+            <a:avLst/>
+          </a:prstGeom>
+          <a:solidFill>
+            <a:srgbClr val="A00000"/>
+          </a:solidFill>
+          <a:ln/>
+        </p:spPr>
+      </p:sp>
+      <p:sp>
+        <p:nvSpPr>
+          <p:cNvPr id="70" name="aVEP stimulus 3R"/>
+          <p:cNvSpPr/>
+          <p:nvPr/>
+        </p:nvSpPr>
+        <p:spPr>
+          <a:xfrm>
+            <a:off x="10666476" y="3625596"/>
+            <a:ext cx="45720" cy="45720"/>
+          </a:xfrm>
+          <a:prstGeom prst="rect">
+            <a:avLst/>
+          </a:prstGeom>
+          <a:solidFill>
+            <a:srgbClr val="A00000"/>
+          </a:solidFill>
+          <a:ln/>
+        </p:spPr>
+      </p:sp>
+      <p:sp>
+        <p:nvSpPr>
+          <p:cNvPr id="71" name="aVEP command 4"/>
+          <p:cNvSpPr txBox="1"/>
+          <p:nvPr/>
+        </p:nvSpPr>
+        <p:spPr>
+          <a:xfrm>
+            <a:off x="10899648" y="3538728"/>
+            <a:ext cx="667512" cy="219456"/>
+          </a:xfrm>
+          <a:prstGeom prst="rect">
+            <a:avLst/>
+          </a:prstGeom>
+          <a:noFill/>
+          <a:ln/>
+        </p:spPr>
+        <p:txBody>
+          <a:bodyPr wrap="square" lIns="0" tIns="0" rIns="0" bIns="0" rtlCol="0" anchor="ctr"/>
+          <a:lstStyle/>
+          <a:p>
+            <a:pPr algn="ctr" indent="0" marL="0">
+              <a:buNone/>
+            </a:pPr>
+            <a:r>
+              <a:rPr lang="en-US" sz="1100" dirty="0">
+                <a:solidFill>
+                  <a:schemeClr val="tx1"/>
+                </a:solidFill>
+              </a:rPr>
+              <a:t>Grasp</a:t>
+            </a:r>
+            <a:endParaRPr lang="en-US" sz="1100" dirty="0"/>
+          </a:p>
+        </p:txBody>
+      </p:sp>
+      <p:sp>
+        <p:nvSpPr>
+          <p:cNvPr id="72" name="aVEP stimulus 4L"/>
+          <p:cNvSpPr/>
+          <p:nvPr/>
+        </p:nvSpPr>
+        <p:spPr>
+          <a:xfrm>
+            <a:off x="10968228" y="3625596"/>
+            <a:ext cx="45720" cy="45720"/>
+          </a:xfrm>
+          <a:prstGeom prst="rect">
+            <a:avLst/>
+          </a:prstGeom>
+          <a:solidFill>
+            <a:srgbClr val="A00000"/>
+          </a:solidFill>
+          <a:ln/>
+        </p:spPr>
+      </p:sp>
+      <p:sp>
+        <p:nvSpPr>
+          <p:cNvPr id="73" name="aVEP stimulus 4R"/>
+          <p:cNvSpPr/>
+          <p:nvPr/>
+        </p:nvSpPr>
+        <p:spPr>
+          <a:xfrm>
+            <a:off x="11452860" y="3625596"/>
+            <a:ext cx="45720" cy="45720"/>
+          </a:xfrm>
+          <a:prstGeom prst="rect">
+            <a:avLst/>
+          </a:prstGeom>
+          <a:solidFill>
+            <a:srgbClr val="A00000"/>
+          </a:solidFill>
+          <a:ln/>
+        </p:spPr>
+      </p:sp>
+      <p:sp>
+        <p:nvSpPr>
+          <p:cNvPr id="74" name="Panel 0 caption"/>
+          <p:cNvSpPr txBox="1"/>
+          <p:nvPr/>
+        </p:nvSpPr>
+        <p:spPr>
+          <a:xfrm>
+            <a:off x="502920" y="3886200"/>
+            <a:ext cx="3611880" cy="566928"/>
+          </a:xfrm>
+          <a:prstGeom prst="rect">
+            <a:avLst/>
+          </a:prstGeom>
+          <a:noFill/>
+          <a:ln/>
+        </p:spPr>
+        <p:txBody>
+          <a:bodyPr wrap="square" lIns="0" tIns="0" rIns="0" bIns="0" rtlCol="0" anchor="t"/>
+          <a:lstStyle/>
+          <a:p>
+            <a:pPr algn="ctr" indent="0" marL="0">
+              <a:buNone/>
+            </a:pPr>
+            <a:r>
+              <a:rPr lang="en-US" sz="1400" dirty="0">
+                <a:solidFill>
+                  <a:schemeClr val="tx1"/>
+                </a:solidFill>
+              </a:rPr>
+              <a:t>Large flickering targets, one frequency each</a:t>
+            </a:r>
+            <a:endParaRPr lang="en-US" sz="1400" dirty="0"/>
+          </a:p>
+          <a:p>
+            <a:pPr algn="ctr" indent="0" marL="0">
+              <a:buNone/>
+            </a:pPr>
+            <a:r>
+              <a:rPr lang="en-US" sz="1400" b="1" dirty="0">
+                <a:solidFill>
+                  <a:srgbClr val="A00000"/>
+                </a:solidFill>
+              </a:rPr>
+              <a:t>High visual burden: view largely occluded</a:t>
+            </a:r>
+            <a:endParaRPr lang="en-US" sz="1400" dirty="0"/>
+          </a:p>
+        </p:txBody>
+      </p:sp>
+      <p:sp>
+        <p:nvSpPr>
+          <p:cNvPr id="75" name="Panel 1 caption"/>
+          <p:cNvSpPr txBox="1"/>
+          <p:nvPr/>
+        </p:nvSpPr>
+        <p:spPr>
+          <a:xfrm>
+            <a:off x="4297680" y="3886200"/>
+            <a:ext cx="3611880" cy="566928"/>
+          </a:xfrm>
+          <a:prstGeom prst="rect">
+            <a:avLst/>
+          </a:prstGeom>
+          <a:noFill/>
+          <a:ln/>
+        </p:spPr>
+        <p:txBody>
+          <a:bodyPr wrap="square" lIns="0" tIns="0" rIns="0" bIns="0" rtlCol="0" anchor="t"/>
+          <a:lstStyle/>
+          <a:p>
+            <a:pPr algn="ctr" indent="0" marL="0">
+              <a:buNone/>
+            </a:pPr>
+            <a:r>
+              <a:rPr lang="en-US" sz="1400" dirty="0">
+                <a:solidFill>
+                  <a:schemeClr val="tx1"/>
+                </a:solidFill>
+              </a:rPr>
+              <a:t>Flashing rows / columns of a symbol matrix</a:t>
+            </a:r>
+            <a:endParaRPr lang="en-US" sz="1400" dirty="0"/>
+          </a:p>
+          <a:p>
+            <a:pPr algn="ctr" indent="0" marL="0">
+              <a:buNone/>
+            </a:pPr>
+            <a:r>
+              <a:rPr lang="en-US" sz="1400" b="1" dirty="0">
+                <a:solidFill>
+                  <a:srgbClr val="A00000"/>
+                </a:solidFill>
+              </a:rPr>
+              <a:t>High visual burden: view largely occluded</a:t>
+            </a:r>
+            <a:endParaRPr lang="en-US" sz="1400" dirty="0"/>
+          </a:p>
+        </p:txBody>
+      </p:sp>
+      <p:sp>
+        <p:nvSpPr>
+          <p:cNvPr id="76" name="Panel 2 caption"/>
+          <p:cNvSpPr txBox="1"/>
+          <p:nvPr/>
+        </p:nvSpPr>
+        <p:spPr>
+          <a:xfrm>
+            <a:off x="8092440" y="3886200"/>
+            <a:ext cx="3611880" cy="566928"/>
+          </a:xfrm>
+          <a:prstGeom prst="rect">
+            <a:avLst/>
+          </a:prstGeom>
+          <a:noFill/>
+          <a:ln/>
+        </p:spPr>
+        <p:txBody>
+          <a:bodyPr wrap="square" lIns="0" tIns="0" rIns="0" bIns="0" rtlCol="0" anchor="t"/>
+          <a:lstStyle/>
+          <a:p>
+            <a:pPr algn="ctr" indent="0" marL="0">
+              <a:buNone/>
+            </a:pPr>
+            <a:r>
+              <a:rPr lang="en-US" sz="1400" dirty="0">
+                <a:solidFill>
+                  <a:schemeClr val="tx1"/>
+                </a:solidFill>
+              </a:rPr>
+              <a:t>Miniature stimuli beside each command</a:t>
+            </a:r>
+            <a:endParaRPr lang="en-US" sz="1400" dirty="0"/>
+          </a:p>
+          <a:p>
+            <a:pPr algn="ctr" indent="0" marL="0">
+              <a:buNone/>
+            </a:pPr>
+            <a:r>
+              <a:rPr lang="en-US" sz="1400" b="1" dirty="0">
+                <a:solidFill>
+                  <a:srgbClr val="1E7B34"/>
+                </a:solidFill>
+              </a:rPr>
+              <a:t>Low visual burden: environment stays visible</a:t>
+            </a:r>
+            <a:endParaRPr lang="en-US" sz="1400" dirty="0"/>
+          </a:p>
+        </p:txBody>
+      </p:sp>
+      <p:sp>
+        <p:nvSpPr>
+          <p:cNvPr id="77" name="Coding panel"/>
+          <p:cNvSpPr/>
+          <p:nvPr/>
+        </p:nvSpPr>
+        <p:spPr>
+          <a:xfrm>
+            <a:off x="502920" y="4553712"/>
+            <a:ext cx="5486400" cy="1344168"/>
+          </a:xfrm>
+          <a:prstGeom prst="rect">
+            <a:avLst/>
+          </a:prstGeom>
+          <a:solidFill>
+            <a:srgbClr val="F2F2F2"/>
+          </a:solidFill>
+          <a:ln/>
+        </p:spPr>
+      </p:sp>
+      <p:sp>
+        <p:nvSpPr>
+          <p:cNvPr id="78" name="Coding head"/>
+          <p:cNvSpPr txBox="1"/>
+          <p:nvPr/>
+        </p:nvSpPr>
+        <p:spPr>
+          <a:xfrm>
+            <a:off x="685800" y="4645152"/>
+            <a:ext cx="5120640" cy="320040"/>
+          </a:xfrm>
+          <a:prstGeom prst="rect">
+            <a:avLst/>
+          </a:prstGeom>
+          <a:noFill/>
+          <a:ln/>
+        </p:spPr>
+        <p:txBody>
+          <a:bodyPr wrap="square" lIns="0" tIns="0" rIns="0" bIns="0" rtlCol="0" anchor="t"/>
+          <a:lstStyle/>
+          <a:p>
+            <a:pPr indent="0" marL="0">
+              <a:buNone/>
+            </a:pPr>
+            <a:r>
+              <a:rPr lang="en-US" sz="1600" b="1" dirty="0">
+                <a:solidFill>
+                  <a:schemeClr val="tx1"/>
+                </a:solidFill>
+              </a:rPr>
+              <a:t>aVEP coding [3]: stimulus order = code</a:t>
+            </a:r>
+            <a:endParaRPr lang="en-US" sz="1600" dirty="0"/>
+          </a:p>
+        </p:txBody>
+      </p:sp>
+      <p:sp>
+        <p:nvSpPr>
+          <p:cNvPr id="79" name="Code 0 first"/>
+          <p:cNvSpPr/>
+          <p:nvPr/>
+        </p:nvSpPr>
+        <p:spPr>
+          <a:xfrm>
+            <a:off x="685800" y="4965192"/>
+            <a:ext cx="548640" cy="365760"/>
           </a:xfrm>
           <a:prstGeom prst="rect">
             <a:avLst/>
@@ -2893,13 +5499,13 @@
       </p:sp>
       <p:sp>
         <p:nvSpPr>
-          <p:cNvPr id="4" name="Screen fixation"/>
+          <p:cNvPr id="80" name="Code 0 first fixation"/>
           <p:cNvSpPr txBox="1"/>
           <p:nvPr/>
         </p:nvSpPr>
         <p:spPr>
           <a:xfrm>
-            <a:off x="2011680" y="2423160"/>
+            <a:off x="777240" y="4965192"/>
             <a:ext cx="365760" cy="365760"/>
           </a:xfrm>
           <a:prstGeom prst="rect">
@@ -2916,27 +5522,27 @@
               <a:buNone/>
             </a:pPr>
             <a:r>
-              <a:rPr lang="en-US" sz="5300" b="1" dirty="0">
+              <a:rPr lang="en-US" sz="1000" b="1" dirty="0">
                 <a:solidFill>
                   <a:schemeClr val="bg1"/>
                 </a:solidFill>
               </a:rPr>
               <a:t>+</a:t>
             </a:r>
-            <a:endParaRPr lang="en-US" sz="5300" dirty="0"/>
-          </a:p>
-        </p:txBody>
-      </p:sp>
-      <p:sp>
-        <p:nvSpPr>
-          <p:cNvPr id="5" name="Screen L stimulus"/>
+            <a:endParaRPr lang="en-US" sz="1000" dirty="0"/>
+          </a:p>
+        </p:txBody>
+      </p:sp>
+      <p:sp>
+        <p:nvSpPr>
+          <p:cNvPr id="81" name="Code 0 first L stimulus"/>
           <p:cNvSpPr/>
           <p:nvPr/>
         </p:nvSpPr>
         <p:spPr>
           <a:xfrm>
-            <a:off x="1481328" y="2529230"/>
-            <a:ext cx="153619" cy="153619"/>
+            <a:off x="811987" y="5120640"/>
+            <a:ext cx="54864" cy="54864"/>
           </a:xfrm>
           <a:prstGeom prst="rect">
             <a:avLst/>
@@ -2949,182 +5555,14 @@
       </p:sp>
       <p:sp>
         <p:nvSpPr>
-          <p:cNvPr id="6" name="Screen R stimulus"/>
+          <p:cNvPr id="82" name="Code 0 arrow"/>
           <p:cNvSpPr/>
           <p:nvPr/>
         </p:nvSpPr>
         <p:spPr>
           <a:xfrm>
-            <a:off x="2754173" y="2529230"/>
-            <a:ext cx="153619" cy="153619"/>
-          </a:xfrm>
-          <a:prstGeom prst="rect">
-            <a:avLst/>
-          </a:prstGeom>
-          <a:solidFill>
-            <a:srgbClr val="FFFFFF"/>
-          </a:solidFill>
-          <a:ln/>
-        </p:spPr>
-      </p:sp>
-      <p:sp>
-        <p:nvSpPr>
-          <p:cNvPr id="7" name="Caption a"/>
-          <p:cNvSpPr txBox="1"/>
-          <p:nvPr/>
-        </p:nvSpPr>
-        <p:spPr>
-          <a:xfrm>
-            <a:off x="548640" y="3794760"/>
-            <a:ext cx="3291840" cy="320040"/>
-          </a:xfrm>
-          <a:prstGeom prst="rect">
-            <a:avLst/>
-          </a:prstGeom>
-          <a:noFill/>
-          <a:ln/>
-        </p:spPr>
-        <p:txBody>
-          <a:bodyPr wrap="square" lIns="0" tIns="0" rIns="0" bIns="0" rtlCol="0" anchor="t"/>
-          <a:lstStyle/>
-          <a:p>
-            <a:pPr algn="ctr" indent="0" marL="0">
-              <a:buNone/>
-            </a:pPr>
-            <a:r>
-              <a:rPr lang="en-US" sz="1400" dirty="0">
-                <a:solidFill>
-                  <a:schemeClr val="tx1"/>
-                </a:solidFill>
-              </a:rPr>
-              <a:t>(a) Miniature stimuli flank the fixation point</a:t>
-            </a:r>
-            <a:endParaRPr lang="en-US" sz="1400" dirty="0"/>
-          </a:p>
-        </p:txBody>
-      </p:sp>
-      <p:sp>
-        <p:nvSpPr>
-          <p:cNvPr id="8" name="Caption b head"/>
-          <p:cNvSpPr txBox="1"/>
-          <p:nvPr/>
-        </p:nvSpPr>
-        <p:spPr>
-          <a:xfrm>
-            <a:off x="4160520" y="1463040"/>
-            <a:ext cx="3291840" cy="320040"/>
-          </a:xfrm>
-          <a:prstGeom prst="rect">
-            <a:avLst/>
-          </a:prstGeom>
-          <a:noFill/>
-          <a:ln/>
-        </p:spPr>
-        <p:txBody>
-          <a:bodyPr wrap="square" lIns="0" tIns="0" rIns="0" bIns="0" rtlCol="0" anchor="t"/>
-          <a:lstStyle/>
-          <a:p>
-            <a:pPr algn="ctr" indent="0" marL="0">
-              <a:buNone/>
-            </a:pPr>
-            <a:r>
-              <a:rPr lang="en-US" sz="1400" dirty="0">
-                <a:solidFill>
-                  <a:schemeClr val="tx1"/>
-                </a:solidFill>
-              </a:rPr>
-              <a:t>(b) One trial = one stimulus pair</a:t>
-            </a:r>
-            <a:endParaRPr lang="en-US" sz="1400" dirty="0"/>
-          </a:p>
-        </p:txBody>
-      </p:sp>
-      <p:sp>
-        <p:nvSpPr>
-          <p:cNvPr id="9" name="Class 0 first"/>
-          <p:cNvSpPr/>
-          <p:nvPr/>
-        </p:nvSpPr>
-        <p:spPr>
-          <a:xfrm>
-            <a:off x="4297680" y="1874520"/>
-            <a:ext cx="1097280" cy="731520"/>
-          </a:xfrm>
-          <a:prstGeom prst="rect">
-            <a:avLst/>
-          </a:prstGeom>
-          <a:solidFill>
-            <a:srgbClr val="262626"/>
-          </a:solidFill>
-          <a:ln/>
-        </p:spPr>
-      </p:sp>
-      <p:sp>
-        <p:nvSpPr>
-          <p:cNvPr id="10" name="Class 0 first fixation"/>
-          <p:cNvSpPr txBox="1"/>
-          <p:nvPr/>
-        </p:nvSpPr>
-        <p:spPr>
-          <a:xfrm>
-            <a:off x="4663440" y="2057400"/>
-            <a:ext cx="365760" cy="365760"/>
-          </a:xfrm>
-          <a:prstGeom prst="rect">
-            <a:avLst/>
-          </a:prstGeom>
-          <a:noFill/>
-          <a:ln/>
-        </p:spPr>
-        <p:txBody>
-          <a:bodyPr wrap="square" lIns="0" tIns="0" rIns="0" bIns="0" rtlCol="0" anchor="ctr"/>
-          <a:lstStyle/>
-          <a:p>
-            <a:pPr algn="ctr" indent="0" marL="0">
-              <a:buNone/>
-            </a:pPr>
-            <a:r>
-              <a:rPr lang="en-US" sz="1800" b="1" dirty="0">
-                <a:solidFill>
-                  <a:schemeClr val="bg1"/>
-                </a:solidFill>
-              </a:rPr>
-              <a:t>+</a:t>
-            </a:r>
-            <a:endParaRPr lang="en-US" sz="1800" dirty="0"/>
-          </a:p>
-        </p:txBody>
-      </p:sp>
-      <p:sp>
-        <p:nvSpPr>
-          <p:cNvPr id="11" name="Class 0 first L stimulus"/>
-          <p:cNvSpPr/>
-          <p:nvPr/>
-        </p:nvSpPr>
-        <p:spPr>
-          <a:xfrm>
-            <a:off x="4604918" y="2212848"/>
-            <a:ext cx="54864" cy="54864"/>
-          </a:xfrm>
-          <a:prstGeom prst="rect">
-            <a:avLst/>
-          </a:prstGeom>
-          <a:solidFill>
-            <a:srgbClr val="FFFFFF"/>
-          </a:solidFill>
-          <a:ln/>
-        </p:spPr>
-      </p:sp>
-      <p:sp>
-        <p:nvSpPr>
-          <p:cNvPr id="12" name="Class 0 arrow"/>
-          <p:cNvSpPr/>
-          <p:nvPr/>
-        </p:nvSpPr>
-        <p:spPr>
-          <a:xfrm>
-            <a:off x="5486400" y="2240280"/>
-            <a:ext cx="502920" cy="0"/>
+            <a:off x="1280160" y="5148072"/>
+            <a:ext cx="274320" cy="0"/>
           </a:xfrm>
           <a:prstGeom prst="line">
             <a:avLst/>
@@ -3141,14 +5579,14 @@
       </p:sp>
       <p:sp>
         <p:nvSpPr>
-          <p:cNvPr id="13" name="Class 0 second"/>
+          <p:cNvPr id="83" name="Code 0 second"/>
           <p:cNvSpPr/>
           <p:nvPr/>
         </p:nvSpPr>
         <p:spPr>
           <a:xfrm>
-            <a:off x="6080760" y="1874520"/>
-            <a:ext cx="1097280" cy="731520"/>
+            <a:off x="1600200" y="4965192"/>
+            <a:ext cx="548640" cy="365760"/>
           </a:xfrm>
           <a:prstGeom prst="rect">
             <a:avLst/>
@@ -3161,13 +5599,13 @@
       </p:sp>
       <p:sp>
         <p:nvSpPr>
-          <p:cNvPr id="14" name="Class 0 second fixation"/>
+          <p:cNvPr id="84" name="Code 0 second fixation"/>
           <p:cNvSpPr txBox="1"/>
           <p:nvPr/>
         </p:nvSpPr>
         <p:spPr>
           <a:xfrm>
-            <a:off x="6446520" y="2057400"/>
+            <a:off x="1691640" y="4965192"/>
             <a:ext cx="365760" cy="365760"/>
           </a:xfrm>
           <a:prstGeom prst="rect">
@@ -3184,26 +5622,26 @@
               <a:buNone/>
             </a:pPr>
             <a:r>
-              <a:rPr lang="en-US" sz="1800" b="1" dirty="0">
+              <a:rPr lang="en-US" sz="1000" b="1" dirty="0">
                 <a:solidFill>
                   <a:schemeClr val="bg1"/>
                 </a:solidFill>
               </a:rPr>
               <a:t>+</a:t>
             </a:r>
-            <a:endParaRPr lang="en-US" sz="1800" dirty="0"/>
-          </a:p>
-        </p:txBody>
-      </p:sp>
-      <p:sp>
-        <p:nvSpPr>
-          <p:cNvPr id="15" name="Class 0 second R stimulus"/>
+            <a:endParaRPr lang="en-US" sz="1000" dirty="0"/>
+          </a:p>
+        </p:txBody>
+      </p:sp>
+      <p:sp>
+        <p:nvSpPr>
+          <p:cNvPr id="85" name="Code 0 second R stimulus"/>
           <p:cNvSpPr/>
           <p:nvPr/>
         </p:nvSpPr>
         <p:spPr>
           <a:xfrm>
-            <a:off x="6815938" y="2212848"/>
+            <a:off x="1967789" y="5120640"/>
             <a:ext cx="54864" cy="54864"/>
           </a:xfrm>
           <a:prstGeom prst="rect">
@@ -3217,14 +5655,14 @@
       </p:sp>
       <p:sp>
         <p:nvSpPr>
-          <p:cNvPr id="16" name="Class 0 label"/>
+          <p:cNvPr id="86" name="Code 0 label"/>
           <p:cNvSpPr txBox="1"/>
           <p:nvPr/>
         </p:nvSpPr>
         <p:spPr>
           <a:xfrm>
-            <a:off x="4297680" y="2651760"/>
-            <a:ext cx="2880360" cy="274320"/>
+            <a:off x="2240280" y="4965192"/>
+            <a:ext cx="1097280" cy="365760"/>
           </a:xfrm>
           <a:prstGeom prst="rect">
             <a:avLst/>
@@ -3236,7 +5674,7 @@
           <a:bodyPr wrap="square" lIns="0" tIns="0" rIns="0" bIns="0" rtlCol="0" anchor="ctr"/>
           <a:lstStyle/>
           <a:p>
-            <a:pPr algn="ctr" indent="0" marL="0">
+            <a:pPr indent="0" marL="0">
               <a:buNone/>
             </a:pPr>
             <a:r>
@@ -3245,7 +5683,7 @@
                   <a:schemeClr val="tx1"/>
                 </a:solidFill>
               </a:rPr>
-              <a:t>Class 0:  left → right</a:t>
+              <a:t>= code 0</a:t>
             </a:r>
             <a:endParaRPr lang="en-US" sz="1400" dirty="0"/>
           </a:p>
@@ -3253,14 +5691,14 @@
       </p:sp>
       <p:sp>
         <p:nvSpPr>
-          <p:cNvPr id="17" name="Class 1 first"/>
+          <p:cNvPr id="87" name="Code 1 first"/>
           <p:cNvSpPr/>
           <p:nvPr/>
         </p:nvSpPr>
         <p:spPr>
           <a:xfrm>
-            <a:off x="4297680" y="3017520"/>
-            <a:ext cx="1097280" cy="731520"/>
+            <a:off x="3383280" y="4965192"/>
+            <a:ext cx="548640" cy="365760"/>
           </a:xfrm>
           <a:prstGeom prst="rect">
             <a:avLst/>
@@ -3273,13 +5711,13 @@
       </p:sp>
       <p:sp>
         <p:nvSpPr>
-          <p:cNvPr id="18" name="Class 1 first fixation"/>
+          <p:cNvPr id="88" name="Code 1 first fixation"/>
           <p:cNvSpPr txBox="1"/>
           <p:nvPr/>
         </p:nvSpPr>
         <p:spPr>
           <a:xfrm>
-            <a:off x="4663440" y="3200400"/>
+            <a:off x="3474720" y="4965192"/>
             <a:ext cx="365760" cy="365760"/>
           </a:xfrm>
           <a:prstGeom prst="rect">
@@ -3296,26 +5734,26 @@
               <a:buNone/>
             </a:pPr>
             <a:r>
-              <a:rPr lang="en-US" sz="1800" b="1" dirty="0">
+              <a:rPr lang="en-US" sz="1000" b="1" dirty="0">
                 <a:solidFill>
                   <a:schemeClr val="bg1"/>
                 </a:solidFill>
               </a:rPr>
               <a:t>+</a:t>
             </a:r>
-            <a:endParaRPr lang="en-US" sz="1800" dirty="0"/>
-          </a:p>
-        </p:txBody>
-      </p:sp>
-      <p:sp>
-        <p:nvSpPr>
-          <p:cNvPr id="19" name="Class 1 first R stimulus"/>
+            <a:endParaRPr lang="en-US" sz="1000" dirty="0"/>
+          </a:p>
+        </p:txBody>
+      </p:sp>
+      <p:sp>
+        <p:nvSpPr>
+          <p:cNvPr id="89" name="Code 1 first R stimulus"/>
           <p:cNvSpPr/>
           <p:nvPr/>
         </p:nvSpPr>
         <p:spPr>
           <a:xfrm>
-            <a:off x="5032858" y="3355848"/>
+            <a:off x="3750869" y="5120640"/>
             <a:ext cx="54864" cy="54864"/>
           </a:xfrm>
           <a:prstGeom prst="rect">
@@ -3329,14 +5767,14 @@
       </p:sp>
       <p:sp>
         <p:nvSpPr>
-          <p:cNvPr id="20" name="Class 1 arrow"/>
+          <p:cNvPr id="90" name="Code 1 arrow"/>
           <p:cNvSpPr/>
           <p:nvPr/>
         </p:nvSpPr>
         <p:spPr>
           <a:xfrm>
-            <a:off x="5486400" y="3383280"/>
-            <a:ext cx="502920" cy="0"/>
+            <a:off x="3977640" y="5148072"/>
+            <a:ext cx="274320" cy="0"/>
           </a:xfrm>
           <a:prstGeom prst="line">
             <a:avLst/>
@@ -3353,14 +5791,14 @@
       </p:sp>
       <p:sp>
         <p:nvSpPr>
-          <p:cNvPr id="21" name="Class 1 second"/>
+          <p:cNvPr id="91" name="Code 1 second"/>
           <p:cNvSpPr/>
           <p:nvPr/>
         </p:nvSpPr>
         <p:spPr>
           <a:xfrm>
-            <a:off x="6080760" y="3017520"/>
-            <a:ext cx="1097280" cy="731520"/>
+            <a:off x="4297680" y="4965192"/>
+            <a:ext cx="548640" cy="365760"/>
           </a:xfrm>
           <a:prstGeom prst="rect">
             <a:avLst/>
@@ -3373,13 +5811,13 @@
       </p:sp>
       <p:sp>
         <p:nvSpPr>
-          <p:cNvPr id="22" name="Class 1 second fixation"/>
+          <p:cNvPr id="92" name="Code 1 second fixation"/>
           <p:cNvSpPr txBox="1"/>
           <p:nvPr/>
         </p:nvSpPr>
         <p:spPr>
           <a:xfrm>
-            <a:off x="6446520" y="3200400"/>
+            <a:off x="4389120" y="4965192"/>
             <a:ext cx="365760" cy="365760"/>
           </a:xfrm>
           <a:prstGeom prst="rect">
@@ -3396,26 +5834,26 @@
               <a:buNone/>
             </a:pPr>
             <a:r>
-              <a:rPr lang="en-US" sz="1800" b="1" dirty="0">
+              <a:rPr lang="en-US" sz="1000" b="1" dirty="0">
                 <a:solidFill>
                   <a:schemeClr val="bg1"/>
                 </a:solidFill>
               </a:rPr>
               <a:t>+</a:t>
             </a:r>
-            <a:endParaRPr lang="en-US" sz="1800" dirty="0"/>
-          </a:p>
-        </p:txBody>
-      </p:sp>
-      <p:sp>
-        <p:nvSpPr>
-          <p:cNvPr id="23" name="Class 1 second L stimulus"/>
+            <a:endParaRPr lang="en-US" sz="1000" dirty="0"/>
+          </a:p>
+        </p:txBody>
+      </p:sp>
+      <p:sp>
+        <p:nvSpPr>
+          <p:cNvPr id="93" name="Code 1 second L stimulus"/>
           <p:cNvSpPr/>
           <p:nvPr/>
         </p:nvSpPr>
         <p:spPr>
           <a:xfrm>
-            <a:off x="6387998" y="3355848"/>
+            <a:off x="4423867" y="5120640"/>
             <a:ext cx="54864" cy="54864"/>
           </a:xfrm>
           <a:prstGeom prst="rect">
@@ -3429,14 +5867,14 @@
       </p:sp>
       <p:sp>
         <p:nvSpPr>
-          <p:cNvPr id="24" name="Class 1 label"/>
+          <p:cNvPr id="94" name="Code 1 label"/>
           <p:cNvSpPr txBox="1"/>
           <p:nvPr/>
         </p:nvSpPr>
         <p:spPr>
           <a:xfrm>
-            <a:off x="4297680" y="3794760"/>
-            <a:ext cx="2880360" cy="274320"/>
+            <a:off x="4937760" y="4965192"/>
+            <a:ext cx="1097280" cy="365760"/>
           </a:xfrm>
           <a:prstGeom prst="rect">
             <a:avLst/>
@@ -3448,7 +5886,7 @@
           <a:bodyPr wrap="square" lIns="0" tIns="0" rIns="0" bIns="0" rtlCol="0" anchor="ctr"/>
           <a:lstStyle/>
           <a:p>
-            <a:pPr algn="ctr" indent="0" marL="0">
+            <a:pPr indent="0" marL="0">
               <a:buNone/>
             </a:pPr>
             <a:r>
@@ -3457,7 +5895,7 @@
                   <a:schemeClr val="tx1"/>
                 </a:solidFill>
               </a:rPr>
-              <a:t>Class 1:  right → left</a:t>
+              <a:t>= code 1</a:t>
             </a:r>
             <a:endParaRPr lang="en-US" sz="1400" dirty="0"/>
           </a:p>
@@ -3465,14 +5903,14 @@
       </p:sp>
       <p:sp>
         <p:nvSpPr>
-          <p:cNvPr id="25" name="Dataset"/>
+          <p:cNvPr id="95" name="Coding task"/>
           <p:cNvSpPr txBox="1"/>
           <p:nvPr/>
         </p:nvSpPr>
         <p:spPr>
           <a:xfrm>
-            <a:off x="548640" y="4434840"/>
-            <a:ext cx="6858000" cy="731520"/>
+            <a:off x="685800" y="5559552"/>
+            <a:ext cx="5120640" cy="274320"/>
           </a:xfrm>
           <a:prstGeom prst="rect">
             <a:avLst/>
@@ -3488,14 +5926,79 @@
               <a:buNone/>
             </a:pPr>
             <a:r>
+              <a:rPr lang="en-US" sz="1400" i="1" dirty="0">
+                <a:solidFill>
+                  <a:schemeClr val="tx1"/>
+                </a:solidFill>
+              </a:rPr>
+              <a:t>Task: decode each pair (one every 200 ms) from single-trial EEG</a:t>
+            </a:r>
+            <a:endParaRPr lang="en-US" sz="1400" dirty="0"/>
+          </a:p>
+        </p:txBody>
+      </p:sp>
+      <p:sp>
+        <p:nvSpPr>
+          <p:cNvPr id="96" name="Application panel"/>
+          <p:cNvSpPr/>
+          <p:nvPr/>
+        </p:nvSpPr>
+        <p:spPr>
+          <a:xfrm>
+            <a:off x="6172200" y="4553712"/>
+            <a:ext cx="5486400" cy="1344168"/>
+          </a:xfrm>
+          <a:prstGeom prst="rect">
+            <a:avLst/>
+          </a:prstGeom>
+          <a:solidFill>
+            <a:srgbClr val="F2F2F2"/>
+          </a:solidFill>
+          <a:ln/>
+        </p:spPr>
+      </p:sp>
+      <p:sp>
+        <p:nvSpPr>
+          <p:cNvPr id="97" name="Application"/>
+          <p:cNvSpPr txBox="1"/>
+          <p:nvPr/>
+        </p:nvSpPr>
+        <p:spPr>
+          <a:xfrm>
+            <a:off x="6355080" y="4645152"/>
+            <a:ext cx="5120640" cy="1161288"/>
+          </a:xfrm>
+          <a:prstGeom prst="rect">
+            <a:avLst/>
+          </a:prstGeom>
+          <a:noFill/>
+          <a:ln/>
+        </p:spPr>
+        <p:txBody>
+          <a:bodyPr wrap="square" lIns="0" tIns="0" rIns="0" bIns="0" rtlCol="0" anchor="t"/>
+          <a:lstStyle/>
+          <a:p>
+            <a:pPr indent="0" marL="0">
+              <a:spcAft>
+                <a:spcPts val="200"/>
+              </a:spcAft>
+              <a:buNone/>
+            </a:pPr>
+            <a:r>
               <a:rPr lang="en-US" sz="1600" b="1" dirty="0">
                 <a:solidFill>
                   <a:schemeClr val="tx1"/>
                 </a:solidFill>
               </a:rPr>
-              <a:t>Dataset: </a:t>
-            </a:r>
+              <a:t>Application</a:t>
+            </a:r>
+            <a:endParaRPr lang="en-US" sz="1600" dirty="0"/>
+          </a:p>
+          <a:p>
             <a:pPr indent="0" marL="0">
+              <a:spcAft>
+                <a:spcPts val="200"/>
+              </a:spcAft>
               <a:buNone/>
             </a:pPr>
             <a:r>
@@ -3504,219 +6007,74 @@
                   <a:schemeClr val="tx1"/>
                 </a:solidFill>
               </a:rPr>
-              <a:t>28 subjects × 6 sessions × 480 trials; 21 parieto-occipital channels, 200 Hz; stimulus pairs presented every 200 ms</a:t>
+              <a:t>Robotic arms, unmanned vehicles: the user must keep watching the environment while issuing commands</a:t>
             </a:r>
             <a:endParaRPr lang="en-US" sz="1600" dirty="0"/>
           </a:p>
-        </p:txBody>
-      </p:sp>
-      <p:sp>
-        <p:nvSpPr>
-          <p:cNvPr id="26" name="Background points"/>
+          <a:p>
+            <a:pPr indent="0" marL="0">
+              <a:spcAft>
+                <a:spcPts val="200"/>
+              </a:spcAft>
+              <a:buNone/>
+            </a:pPr>
+            <a:r>
+              <a:rPr lang="en-US" sz="1600" b="1" dirty="0">
+                <a:solidFill>
+                  <a:schemeClr val="accent1"/>
+                </a:solidFill>
+              </a:rPr>
+              <a:t>→ Chapter 3: online aVEP-based robotic arm</a:t>
+            </a:r>
+            <a:endParaRPr lang="en-US" sz="1600" dirty="0"/>
+          </a:p>
+        </p:txBody>
+      </p:sp>
+      <p:sp>
+        <p:nvSpPr>
+          <p:cNvPr id="98" name="Reference"/>
           <p:cNvSpPr txBox="1"/>
           <p:nvPr/>
         </p:nvSpPr>
         <p:spPr>
           <a:xfrm>
-            <a:off x="7726680" y="1508760"/>
-            <a:ext cx="4114800" cy="4206240"/>
-          </a:xfrm>
-          <a:prstGeom prst="rect">
-            <a:avLst/>
-          </a:prstGeom>
-          <a:noFill/>
-          <a:ln/>
-        </p:spPr>
-        <p:txBody>
-          <a:bodyPr wrap="square" lIns="0" tIns="0" rIns="0" bIns="0" rtlCol="0" anchor="t"/>
+            <a:off x="320040" y="5989320"/>
+            <a:ext cx="10881360" cy="731520"/>
+          </a:xfrm>
+          <a:prstGeom prst="rect">
+            <a:avLst/>
+          </a:prstGeom>
+          <a:noFill/>
+          <a:ln/>
+        </p:spPr>
+        <p:txBody>
+          <a:bodyPr wrap="square" lIns="0" tIns="0" rIns="0" bIns="0" rtlCol="0" anchor="b"/>
           <a:lstStyle/>
           <a:p>
             <a:pPr indent="0" marL="0">
               <a:buNone/>
             </a:pPr>
             <a:r>
-              <a:rPr lang="en-US" sz="1800" b="1" dirty="0">
-                <a:solidFill>
-                  <a:schemeClr val="tx1"/>
-                </a:solidFill>
-              </a:rPr>
-              <a:t>Visual BCIs</a:t>
-            </a:r>
-            <a:endParaRPr lang="en-US" sz="1800" dirty="0"/>
+              <a:rPr lang="en-US" sz="1200" dirty="0">
+                <a:solidFill>
+                  <a:schemeClr val="accent3"/>
+                </a:solidFill>
+              </a:rPr>
+              <a:t>[1] X. Chen et al., PNAS, 2015.   [2] L. A. Farwell, E. Donchin, Electroencephalogr. Clin. Neurophysiol., 1988.</a:t>
+            </a:r>
+            <a:endParaRPr lang="en-US" sz="1200" dirty="0"/>
           </a:p>
           <a:p>
             <a:pPr indent="0" marL="0">
               <a:buNone/>
             </a:pPr>
             <a:r>
-              <a:rPr lang="en-US" sz="1800" dirty="0">
-                <a:solidFill>
-                  <a:schemeClr val="tx1"/>
-                </a:solidFill>
-              </a:rPr>
-              <a:t>High speed, but large flashing stimuli cause visual fatigue</a:t>
-            </a:r>
-            <a:endParaRPr lang="en-US" sz="1800" dirty="0"/>
-          </a:p>
-          <a:p>
-            <a:pPr indent="0" marL="0">
-              <a:buNone/>
-            </a:pPr>
-            <a:r>
-              <a:rPr lang="en-US" sz="800" dirty="0">
-                <a:solidFill>
-                  <a:schemeClr val="tx1"/>
-                </a:solidFill>
-              </a:rPr>
-              <a:t> </a:t>
-            </a:r>
-            <a:endParaRPr lang="en-US" sz="1800" dirty="0"/>
-          </a:p>
-          <a:p>
-            <a:pPr indent="0" marL="0">
-              <a:buNone/>
-            </a:pPr>
-            <a:r>
-              <a:rPr lang="en-US" sz="1800" b="1" dirty="0">
-                <a:solidFill>
-                  <a:schemeClr val="tx1"/>
-                </a:solidFill>
-              </a:rPr>
-              <a:t>Miniature lateral stimuli [1]</a:t>
-            </a:r>
-            <a:endParaRPr lang="en-US" sz="1800" dirty="0"/>
-          </a:p>
-          <a:p>
-            <a:pPr indent="0" marL="0">
-              <a:buNone/>
-            </a:pPr>
-            <a:r>
-              <a:rPr lang="en-US" sz="1800" dirty="0">
-                <a:solidFill>
-                  <a:schemeClr val="tx1"/>
-                </a:solidFill>
-              </a:rPr>
-              <a:t>Small and unobtrusive, so more comfortable to use</a:t>
-            </a:r>
-            <a:endParaRPr lang="en-US" sz="1800" dirty="0"/>
-          </a:p>
-          <a:p>
-            <a:pPr indent="0" marL="0">
-              <a:buNone/>
-            </a:pPr>
-            <a:r>
-              <a:rPr lang="en-US" sz="800" dirty="0">
-                <a:solidFill>
-                  <a:schemeClr val="tx1"/>
-                </a:solidFill>
-              </a:rPr>
-              <a:t> </a:t>
-            </a:r>
-            <a:endParaRPr lang="en-US" sz="1800" dirty="0"/>
-          </a:p>
-          <a:p>
-            <a:pPr indent="0" marL="0">
-              <a:buNone/>
-            </a:pPr>
-            <a:r>
-              <a:rPr lang="en-US" sz="1800" b="1" dirty="0">
-                <a:solidFill>
-                  <a:schemeClr val="tx1"/>
-                </a:solidFill>
-              </a:rPr>
-              <a:t>Cost</a:t>
-            </a:r>
-            <a:endParaRPr lang="en-US" sz="1800" dirty="0"/>
-          </a:p>
-          <a:p>
-            <a:pPr indent="0" marL="0">
-              <a:buNone/>
-            </a:pPr>
-            <a:r>
-              <a:rPr lang="en-US" sz="1800" dirty="0">
-                <a:solidFill>
-                  <a:schemeClr val="tx1"/>
-                </a:solidFill>
-              </a:rPr>
-              <a:t>Very weak response: class difference ≈ 1 µV</a:t>
-            </a:r>
-            <a:endParaRPr lang="en-US" sz="1800" dirty="0"/>
-          </a:p>
-          <a:p>
-            <a:pPr indent="0" marL="0">
-              <a:buNone/>
-            </a:pPr>
-            <a:r>
-              <a:rPr lang="en-US" sz="800" dirty="0">
-                <a:solidFill>
-                  <a:schemeClr val="tx1"/>
-                </a:solidFill>
-              </a:rPr>
-              <a:t> </a:t>
-            </a:r>
-            <a:endParaRPr lang="en-US" sz="1800" dirty="0"/>
-          </a:p>
-          <a:p>
-            <a:pPr indent="0" marL="0">
-              <a:buNone/>
-            </a:pPr>
-            <a:r>
-              <a:rPr lang="en-US" sz="1800" b="1" dirty="0">
-                <a:solidFill>
-                  <a:schemeClr val="tx1"/>
-                </a:solidFill>
-              </a:rPr>
-              <a:t>Task</a:t>
-            </a:r>
-            <a:endParaRPr lang="en-US" sz="1800" dirty="0"/>
-          </a:p>
-          <a:p>
-            <a:pPr indent="0" marL="0">
-              <a:buNone/>
-            </a:pPr>
-            <a:r>
-              <a:rPr lang="en-US" sz="1800" dirty="0">
-                <a:solidFill>
-                  <a:schemeClr val="tx1"/>
-                </a:solidFill>
-              </a:rPr>
-              <a:t>Decode the stimulus order (left→right vs right→left) from a single trial</a:t>
-            </a:r>
-            <a:endParaRPr lang="en-US" sz="1800" dirty="0"/>
-          </a:p>
-        </p:txBody>
-      </p:sp>
-      <p:sp>
-        <p:nvSpPr>
-          <p:cNvPr id="27" name="Reference"/>
-          <p:cNvSpPr txBox="1"/>
-          <p:nvPr/>
-        </p:nvSpPr>
-        <p:spPr>
-          <a:xfrm>
-            <a:off x="320040" y="6355080"/>
-            <a:ext cx="10607040" cy="365760"/>
-          </a:xfrm>
-          <a:prstGeom prst="rect">
-            <a:avLst/>
-          </a:prstGeom>
-          <a:noFill/>
-          <a:ln/>
-        </p:spPr>
-        <p:txBody>
-          <a:bodyPr wrap="square" lIns="0" tIns="0" rIns="0" bIns="0" rtlCol="0" anchor="b"/>
-          <a:lstStyle/>
-          <a:p>
-            <a:pPr indent="0" marL="0">
-              <a:buNone/>
-            </a:pPr>
-            <a:r>
               <a:rPr lang="en-US" sz="1200" dirty="0">
                 <a:solidFill>
                   <a:schemeClr val="accent3"/>
                 </a:solidFill>
               </a:rPr>
-              <a:t>[1] M. Xu et al. A Brain–Computer Interface Based on Miniature-Event-Related Potentials Induced by Very Small Lateral Visual Stimuli. IEEE Trans. Biomed. Eng., 2018.</a:t>
+              <a:t>[3] M. Xu et al., IEEE Trans. Biomed. Eng., 2018.   Panels (a)–(c) are schematic illustrations.</a:t>
             </a:r>
             <a:endParaRPr lang="en-US" sz="1200" dirty="0"/>
           </a:p>

</xml_diff>

<commit_message>
Slide 4: measured-data figures for the two challenges
scripts/make_slide_figures.py computes, from the preprocessed data, the
class averages vs. single trials (low SNR) and four example subjects with
per-subject mirror correlation and peak latency (inter-subject variability).

Co-Authored-By: Claude Opus 5.5 <noreply@anthropic.com>
Claude-Session: https://claude.ai/code/session_01M2N1FL6JrZz8kTbkaY5rZ8
</commit_message>
<xml_diff>
--- a/presentation/midterm_defense_sample.pptx
+++ b/presentation/midterm_defense_sample.pptx
@@ -113,12 +113,12 @@
   <p:extLst>
     <p:ext uri="{521415D9-36F7-43E2-AB2F-B90AF26B5E84}">
       <p14:sectionLst xmlns:p14="http://schemas.microsoft.com/office/powerpoint/2010/main">
-        <p14:section name="Opening" id="{863af77d-12e5-93ab-f6fb-2b1bd5c5c033}">
+        <p14:section name="Opening" id="{742fab5d-9654-6886-c39f-14f57bfd6031}">
           <p14:sldIdLst>
             <p14:sldId id="256"/>
           </p14:sldIdLst>
         </p14:section>
-        <p14:section name="Research Background and Objectives" id="{a76d45ef-2183-a0e3-23c9-082df9432902}">
+        <p14:section name="Research Background and Objectives" id="{cafdc750-5bfe-df4d-fdaf-e72c3d41edc8}">
           <p14:sldIdLst>
             <p14:sldId id="257"/>
             <p14:sldId id="258"/>
@@ -126,7 +126,7 @@
             <p14:sldId id="260"/>
           </p14:sldIdLst>
         </p14:section>
-        <p14:section name="Research Progress and Stage Achievements" id="{1b0e7695-4a05-f8d1-636b-3380704403ea}">
+        <p14:section name="Research Progress and Stage Achievements" id="{36082c95-6dbf-1fc1-024a-f89fdd4e761e}">
           <p14:sldIdLst>
             <p14:sldId id="261"/>
             <p14:sldId id="262"/>
@@ -139,430 +139,6 @@
     </p:ext>
   </p:extLst>
 </p:presentation>
-</file>
-
-<file path=ppt/charts/chart1.xml><?xml version="1.0" encoding="utf-8"?>
-<c:chartSpace xmlns:c="http://schemas.openxmlformats.org/drawingml/2006/chart" xmlns:a="http://schemas.openxmlformats.org/drawingml/2006/main" xmlns:r="http://schemas.openxmlformats.org/officeDocument/2006/relationships">
-  <c:date1904 val="0"/>
-  <c:roundedCorners val="1"/>
-  <c:chart>
-    <c:title>
-      <c:tx>
-        <c:rich>
-          <a:bodyPr/>
-          <a:lstStyle/>
-          <a:p>
-            <a:pPr>
-              <a:defRPr sz="1600" b="0" i="0" u="none" strike="noStrike">
-                <a:solidFill>
-                  <a:srgbClr val="000000"/>
-                </a:solidFill>
-                <a:latin typeface="+mn-lt"/>
-              </a:defRPr>
-            </a:pPr>
-            <a:r>
-              <a:rPr sz="1600" b="0" i="0" u="none" strike="noStrike">
-                <a:solidFill>
-                  <a:srgbClr val="000000"/>
-                </a:solidFill>
-                <a:latin typeface="+mn-lt"/>
-              </a:rPr>
-              <a:t>Grand-average lateralization (n = 28)</a:t>
-            </a:r>
-          </a:p>
-        </c:rich>
-      </c:tx>
-      <c:layout/>
-      <c:overlay val="0"/>
-    </c:title>
-    <c:autoTitleDeleted val="0"/>
-    <c:plotArea>
-      <c:layout/>
-      <c:lineChart>
-        <c:varyColors val="0"/>
-        <c:ser>
-          <c:idx val="0"/>
-          <c:order val="0"/>
-          <c:tx>
-            <c:strRef>
-              <c:f>Sheet1!$B$1</c:f>
-              <c:strCache>
-                <c:ptCount val="1"/>
-                <c:pt idx="0">
-                  <c:v>Lateralization</c:v>
-                </c:pt>
-              </c:strCache>
-            </c:strRef>
-          </c:tx>
-          <c:spPr>
-            <a:solidFill>
-              <a:srgbClr val="A00000"/>
-            </a:solidFill>
-            <a:ln w="31750" cap="flat">
-              <a:solidFill>
-                <a:srgbClr val="A00000"/>
-              </a:solidFill>
-              <a:prstDash val="solid"/>
-              <a:round/>
-            </a:ln>
-            <a:effectLst/>
-          </c:spPr>
-          <c:invertIfNegative val="0"/>
-          <c:dLbls>
-            <c:numFmt formatCode="#,##0" sourceLinked="0"/>
-            <c:txPr>
-              <a:bodyPr/>
-              <a:lstStyle/>
-              <a:p>
-                <a:pPr>
-                  <a:defRPr b="0" i="0" strike="noStrike" sz="1200" u="none">
-                    <a:solidFill>
-                      <a:srgbClr val="000000"/>
-                    </a:solidFill>
-                    <a:latin typeface="Arial"/>
-                  </a:defRPr>
-                </a:pPr>
-              </a:p>
-            </c:txPr>
-            <c:showLegendKey val="0"/>
-            <c:showVal val="0"/>
-            <c:showCatName val="0"/>
-            <c:showSerName val="0"/>
-            <c:showPercent val="0"/>
-            <c:showBubbleSize val="0"/>
-            <c:showLeaderLines val="0"/>
-          </c:dLbls>
-          <c:marker>
-            <c:symbol val="circle"/>
-            <c:size val="6"/>
-            <c:spPr>
-              <a:solidFill>
-                <a:srgbClr val="A00000"/>
-              </a:solidFill>
-              <a:ln w="9525" cap="flat">
-                <a:solidFill>
-                  <a:srgbClr val="A00000"/>
-                </a:solidFill>
-                <a:prstDash val="solid"/>
-                <a:round/>
-              </a:ln>
-              <a:effectLst/>
-            </c:spPr>
-          </c:marker>
-          <c:cat>
-            <c:multiLvlStrRef>
-              <c:f>Sheet1!$A$2:$A$16</c:f>
-              <c:multiLvlStrCache>
-                <c:ptCount val="15"/>
-                <c:lvl>
-                  <c:pt idx="0">
-                    <c:v>50</c:v>
-                  </c:pt>
-                  <c:pt idx="1">
-                    <c:v>70</c:v>
-                  </c:pt>
-                  <c:pt idx="2">
-                    <c:v>90</c:v>
-                  </c:pt>
-                  <c:pt idx="3">
-                    <c:v>110</c:v>
-                  </c:pt>
-                  <c:pt idx="4">
-                    <c:v>130</c:v>
-                  </c:pt>
-                  <c:pt idx="5">
-                    <c:v>150</c:v>
-                  </c:pt>
-                  <c:pt idx="6">
-                    <c:v>170</c:v>
-                  </c:pt>
-                  <c:pt idx="7">
-                    <c:v>190</c:v>
-                  </c:pt>
-                  <c:pt idx="8">
-                    <c:v>210</c:v>
-                  </c:pt>
-                  <c:pt idx="9">
-                    <c:v>230</c:v>
-                  </c:pt>
-                  <c:pt idx="10">
-                    <c:v>250</c:v>
-                  </c:pt>
-                  <c:pt idx="11">
-                    <c:v>270</c:v>
-                  </c:pt>
-                  <c:pt idx="12">
-                    <c:v>290</c:v>
-                  </c:pt>
-                  <c:pt idx="13">
-                    <c:v>310</c:v>
-                  </c:pt>
-                  <c:pt idx="14">
-                    <c:v>330</c:v>
-                  </c:pt>
-                </c:lvl>
-              </c:multiLvlStrCache>
-            </c:multiLvlStrRef>
-          </c:cat>
-          <c:val>
-            <c:numRef>
-              <c:f>Sheet1!$B$2:$B$16</c:f>
-              <c:numCache>
-                <c:formatCode>General</c:formatCode>
-                <c:ptCount val="15"/>
-                <c:pt idx="0">
-                  <c:v>-0.01</c:v>
-                </c:pt>
-                <c:pt idx="1">
-                  <c:v>-0.03</c:v>
-                </c:pt>
-                <c:pt idx="2">
-                  <c:v>-0.44</c:v>
-                </c:pt>
-                <c:pt idx="3">
-                  <c:v>-0.76</c:v>
-                </c:pt>
-                <c:pt idx="4">
-                  <c:v>-0.38</c:v>
-                </c:pt>
-                <c:pt idx="5">
-                  <c:v>0.04</c:v>
-                </c:pt>
-                <c:pt idx="6">
-                  <c:v>0.12</c:v>
-                </c:pt>
-                <c:pt idx="7">
-                  <c:v>0.65</c:v>
-                </c:pt>
-                <c:pt idx="8">
-                  <c:v>1.01</c:v>
-                </c:pt>
-                <c:pt idx="9">
-                  <c:v>0.32</c:v>
-                </c:pt>
-                <c:pt idx="10">
-                  <c:v>-0.3</c:v>
-                </c:pt>
-                <c:pt idx="11">
-                  <c:v>-0.42</c:v>
-                </c:pt>
-                <c:pt idx="12">
-                  <c:v>-0.39</c:v>
-                </c:pt>
-                <c:pt idx="13">
-                  <c:v>-0.18</c:v>
-                </c:pt>
-                <c:pt idx="14">
-                  <c:v>0.02</c:v>
-                </c:pt>
-              </c:numCache>
-            </c:numRef>
-          </c:val>
-          <c:smooth val="0"/>
-        </c:ser>
-        <c:dLbls>
-          <c:numFmt formatCode="#,##0" sourceLinked="0"/>
-          <c:txPr>
-            <a:bodyPr/>
-            <a:lstStyle/>
-            <a:p>
-              <a:pPr>
-                <a:defRPr b="0" i="0" strike="noStrike" sz="1200" u="none">
-                  <a:solidFill>
-                    <a:srgbClr val="000000"/>
-                  </a:solidFill>
-                  <a:latin typeface="Arial"/>
-                </a:defRPr>
-              </a:pPr>
-            </a:p>
-          </c:txPr>
-          <c:showLegendKey val="0"/>
-          <c:showVal val="0"/>
-          <c:showCatName val="0"/>
-          <c:showSerName val="0"/>
-          <c:showPercent val="0"/>
-          <c:showBubbleSize val="0"/>
-          <c:showLeaderLines val="0"/>
-        </c:dLbls>
-        <c:marker val="1"/>
-        <c:axId val="2094734554"/>
-        <c:axId val="2094734552"/>
-        <c:axId val="2094734556"/>
-      </c:lineChart>
-      <c:catAx>
-        <c:axId val="2094734554"/>
-        <c:scaling>
-          <c:orientation val="minMax"/>
-        </c:scaling>
-        <c:delete val="0"/>
-        <c:axPos val="b"/>
-        <c:title>
-          <c:tx>
-            <c:rich>
-              <a:bodyPr/>
-              <a:lstStyle/>
-              <a:p>
-                <a:pPr>
-                  <a:defRPr sz="1400" b="0" i="0" u="none" strike="noStrike">
-                    <a:solidFill>
-                      <a:srgbClr val="000000"/>
-                    </a:solidFill>
-                    <a:latin typeface="+mn-lt"/>
-                  </a:defRPr>
-                </a:pPr>
-                <a:r>
-                  <a:rPr sz="1400" b="0" i="0" u="none" strike="noStrike">
-                    <a:solidFill>
-                      <a:srgbClr val="000000"/>
-                    </a:solidFill>
-                    <a:latin typeface="+mn-lt"/>
-                  </a:rPr>
-                  <a:t>Time after pair onset (ms)</a:t>
-                </a:r>
-              </a:p>
-            </c:rich>
-          </c:tx>
-          <c:layout/>
-          <c:overlay val="0"/>
-        </c:title>
-        <c:numFmt formatCode="General" sourceLinked="1"/>
-        <c:majorTickMark val="out"/>
-        <c:minorTickMark val="none"/>
-        <c:tickLblPos val="low"/>
-        <c:spPr>
-          <a:ln w="12700" cap="flat">
-            <a:solidFill>
-              <a:srgbClr val="888888"/>
-            </a:solidFill>
-            <a:prstDash val="solid"/>
-            <a:round/>
-          </a:ln>
-        </c:spPr>
-        <c:txPr>
-          <a:bodyPr/>
-          <a:lstStyle/>
-          <a:p>
-            <a:pPr>
-              <a:defRPr sz="1200" b="0" i="0" u="none" strike="noStrike">
-                <a:solidFill>
-                  <a:srgbClr val="000000"/>
-                </a:solidFill>
-                <a:latin typeface="+mn-lt"/>
-              </a:defRPr>
-            </a:pPr>
-            <a:endParaRPr lang="en-US"/>
-          </a:p>
-        </c:txPr>
-        <c:crossAx val="2094734552"/>
-        <c:crosses val="autoZero"/>
-        <c:auto val="1"/>
-        <c:lblAlgn val="ctr"/>
-        <c:noMultiLvlLbl val="1"/>
-      </c:catAx>
-      <c:valAx>
-        <c:axId val="2094734552"/>
-        <c:scaling>
-          <c:orientation val="minMax"/>
-          <c:max val="1.2"/>
-          <c:min val="-1"/>
-        </c:scaling>
-        <c:delete val="0"/>
-        <c:axPos val="l"/>
-        <c:majorGridlines>
-          <c:spPr>
-            <a:ln w="6350" cap="flat">
-              <a:solidFill>
-                <a:srgbClr val="D9D9D9"/>
-              </a:solidFill>
-              <a:prstDash val="solid"/>
-              <a:round/>
-            </a:ln>
-          </c:spPr>
-        </c:majorGridlines>
-        <c:title>
-          <c:tx>
-            <c:rich>
-              <a:bodyPr/>
-              <a:lstStyle/>
-              <a:p>
-                <a:pPr>
-                  <a:defRPr sz="1400" b="0" i="0" u="none" strike="noStrike">
-                    <a:solidFill>
-                      <a:srgbClr val="000000"/>
-                    </a:solidFill>
-                    <a:latin typeface="+mn-lt"/>
-                  </a:defRPr>
-                </a:pPr>
-                <a:r>
-                  <a:rPr sz="1400" b="0" i="0" u="none" strike="noStrike">
-                    <a:solidFill>
-                      <a:srgbClr val="000000"/>
-                    </a:solidFill>
-                    <a:latin typeface="+mn-lt"/>
-                  </a:rPr>
-                  <a:t>Amplitude (µV)</a:t>
-                </a:r>
-              </a:p>
-            </c:rich>
-          </c:tx>
-          <c:layout/>
-          <c:overlay val="0"/>
-        </c:title>
-        <c:numFmt formatCode="0.0" sourceLinked="0"/>
-        <c:majorTickMark val="out"/>
-        <c:minorTickMark val="none"/>
-        <c:tickLblPos val="nextTo"/>
-        <c:spPr>
-          <a:ln w="12700" cap="flat">
-            <a:solidFill>
-              <a:srgbClr val="888888"/>
-            </a:solidFill>
-            <a:prstDash val="solid"/>
-            <a:round/>
-          </a:ln>
-        </c:spPr>
-        <c:txPr>
-          <a:bodyPr/>
-          <a:lstStyle/>
-          <a:p>
-            <a:pPr>
-              <a:defRPr sz="1200" b="0" i="0" u="none" strike="noStrike">
-                <a:solidFill>
-                  <a:srgbClr val="000000"/>
-                </a:solidFill>
-                <a:latin typeface="+mn-lt"/>
-              </a:defRPr>
-            </a:pPr>
-            <a:endParaRPr lang="en-US"/>
-          </a:p>
-        </c:txPr>
-        <c:crossAx val="2094734554"/>
-        <c:crosses val="autoZero"/>
-        <c:crossBetween val="between"/>
-        <c:majorUnit val="0.5"/>
-      </c:valAx>
-      <c:spPr>
-        <a:noFill/>
-        <a:ln>
-          <a:noFill/>
-        </a:ln>
-        <a:effectLst/>
-      </c:spPr>
-    </c:plotArea>
-    <c:plotVisOnly val="1"/>
-    <c:dispBlanksAs val="span"/>
-  </c:chart>
-  <c:spPr>
-    <a:noFill/>
-    <a:ln>
-      <a:noFill/>
-    </a:ln>
-    <a:effectLst/>
-  </c:spPr>
-  <c:externalData r:id="rId1">
-    <c:autoUpdate val="0"/>
-  </c:externalData>
-</c:chartSpace>
 </file>
 
 <file path=ppt/notesMasters/notesMaster1.xml><?xml version="1.0" encoding="utf-8"?>
@@ -1224,7 +800,7 @@
           <a:p>
             <a:r>
               <a:rPr lang="en-US" dirty="0"/>
-              <a:t>~40 s. Exploratory analysis of the class-averaged ERPs: the effect is about 1 µV and changes sign between ~110 and ~210 ms, matching the stimulus order. Responses to neighbouring trials overlap, and subjects differ strongly in symmetry and latency.</a:t>
+              <a:t>~45 s. Left: grey lines are real single trials; red and blue are the class averages, black dashed their difference. Single trials swing by about ten microvolts, the class difference is about one, so a single trial carries very little of the signal. Responses to neighbouring pairs also overlap, since pairs come every 200 ms. Right: four real subjects. Sub18 follows the mirror rule, Sub22 peaks early, Sub17 is inverted, Sub05 barely responds. Across 28 subjects r ranges from −0.65 to 0.86 and the peak from 150 to 300 ms, so a model trained on some subjects transfers poorly to others.</a:t>
             </a:r>
             <a:endParaRPr lang="en-US" dirty="0"/>
           </a:p>
@@ -6188,32 +5764,136 @@
           </a:p>
         </p:txBody>
       </p:sp>
-      <p:graphicFrame>
-        <p:nvGraphicFramePr>
-          <p:cNvPr id="3" name="Lateralization chart" descr=""/>
-          <p:cNvGraphicFramePr/>
-          <p:nvPr/>
-        </p:nvGraphicFramePr>
-        <p:xfrm>
-          <a:off x="411480" y="1325880"/>
-          <a:ext cx="6949440" cy="4206240"/>
-        </p:xfrm>
-        <a:graphic xmlns:a="http://schemas.openxmlformats.org/drawingml/2006/main">
-          <a:graphicData uri="http://schemas.openxmlformats.org/drawingml/2006/chart">
-            <c:chart xmlns:c="http://schemas.openxmlformats.org/drawingml/2006/chart" r:id="rId1"/>
-          </a:graphicData>
-        </a:graphic>
-      </p:graphicFrame>
-      <p:sp>
-        <p:nvSpPr>
-          <p:cNvPr id="4" name="Chart note"/>
+      <p:sp>
+        <p:nvSpPr>
+          <p:cNvPr id="3" name="Challenge 1 head"/>
           <p:cNvSpPr txBox="1"/>
           <p:nvPr/>
         </p:nvSpPr>
         <p:spPr>
           <a:xfrm>
-            <a:off x="548640" y="5577840"/>
-            <a:ext cx="6766560" cy="548640"/>
+            <a:off x="411480" y="1161288"/>
+            <a:ext cx="5577840" cy="384048"/>
+          </a:xfrm>
+          <a:prstGeom prst="rect">
+            <a:avLst/>
+          </a:prstGeom>
+          <a:noFill/>
+          <a:ln/>
+        </p:spPr>
+        <p:txBody>
+          <a:bodyPr wrap="square" lIns="0" tIns="0" rIns="0" bIns="0" rtlCol="0" anchor="ctr"/>
+          <a:lstStyle/>
+          <a:p>
+            <a:pPr algn="ctr" indent="0" marL="0">
+              <a:buNone/>
+            </a:pPr>
+            <a:r>
+              <a:rPr lang="en-US" sz="1800" b="1" dirty="0">
+                <a:solidFill>
+                  <a:schemeClr val="accent1"/>
+                </a:solidFill>
+              </a:rPr>
+              <a:t>Challenge 1: Low single-trial SNR</a:t>
+            </a:r>
+            <a:endParaRPr lang="en-US" sz="1800" dirty="0"/>
+          </a:p>
+        </p:txBody>
+      </p:sp>
+      <p:pic>
+        <p:nvPicPr>
+          <p:cNvPr id="4" name="Challenge 1 figure" descr="Measured single trials (grey) vs. class averages, all 28 subjects">    </p:cNvPr>
+          <p:cNvPicPr>
+            <a:picLocks noChangeAspect="1"/>
+          </p:cNvPicPr>
+          <p:nvPr/>
+        </p:nvPicPr>
+        <p:blipFill>
+          <a:blip r:embed="rId1"/>
+          <a:stretch>
+            <a:fillRect/>
+          </a:stretch>
+        </p:blipFill>
+        <p:spPr>
+          <a:xfrm>
+            <a:off x="411480" y="1600200"/>
+            <a:ext cx="5577840" cy="3429000"/>
+          </a:xfrm>
+          <a:prstGeom prst="rect">
+            <a:avLst/>
+          </a:prstGeom>
+        </p:spPr>
+      </p:pic>
+      <p:sp>
+        <p:nvSpPr>
+          <p:cNvPr id="5" name="Challenge 2 head"/>
+          <p:cNvSpPr txBox="1"/>
+          <p:nvPr/>
+        </p:nvSpPr>
+        <p:spPr>
+          <a:xfrm>
+            <a:off x="6217920" y="1161288"/>
+            <a:ext cx="5577840" cy="384048"/>
+          </a:xfrm>
+          <a:prstGeom prst="rect">
+            <a:avLst/>
+          </a:prstGeom>
+          <a:noFill/>
+          <a:ln/>
+        </p:spPr>
+        <p:txBody>
+          <a:bodyPr wrap="square" lIns="0" tIns="0" rIns="0" bIns="0" rtlCol="0" anchor="ctr"/>
+          <a:lstStyle/>
+          <a:p>
+            <a:pPr algn="ctr" indent="0" marL="0">
+              <a:buNone/>
+            </a:pPr>
+            <a:r>
+              <a:rPr lang="en-US" sz="1800" b="1" dirty="0">
+                <a:solidFill>
+                  <a:schemeClr val="accent1"/>
+                </a:solidFill>
+              </a:rPr>
+              <a:t>Challenge 2: High inter-subject variability</a:t>
+            </a:r>
+            <a:endParaRPr lang="en-US" sz="1800" dirty="0"/>
+          </a:p>
+        </p:txBody>
+      </p:sp>
+      <p:pic>
+        <p:nvPicPr>
+          <p:cNvPr id="6" name="Challenge 2 figure" descr="Measured class averages of four example subjects and per-subject statistics">    </p:cNvPr>
+          <p:cNvPicPr>
+            <a:picLocks noChangeAspect="1"/>
+          </p:cNvPicPr>
+          <p:nvPr/>
+        </p:nvPicPr>
+        <p:blipFill>
+          <a:blip r:embed="rId2"/>
+          <a:stretch>
+            <a:fillRect/>
+          </a:stretch>
+        </p:blipFill>
+        <p:spPr>
+          <a:xfrm>
+            <a:off x="6217920" y="1600200"/>
+            <a:ext cx="5577840" cy="3429000"/>
+          </a:xfrm>
+          <a:prstGeom prst="rect">
+            <a:avLst/>
+          </a:prstGeom>
+        </p:spPr>
+      </p:pic>
+      <p:sp>
+        <p:nvSpPr>
+          <p:cNvPr id="7" name="Challenge 1 text"/>
+          <p:cNvSpPr txBox="1"/>
+          <p:nvPr/>
+        </p:nvSpPr>
+        <p:spPr>
+          <a:xfrm>
+            <a:off x="548640" y="5120640"/>
+            <a:ext cx="5303520" cy="777240"/>
           </a:xfrm>
           <a:prstGeom prst="rect">
             <a:avLst/>
@@ -6229,190 +5909,114 @@
               <a:buNone/>
             </a:pPr>
             <a:r>
-              <a:rPr lang="en-US" sz="1200" dirty="0">
+              <a:rPr lang="en-US" sz="1500" dirty="0">
+                <a:solidFill>
+                  <a:schemeClr val="tx1"/>
+                </a:solidFill>
+              </a:rPr>
+              <a:t>Single trials fluctuate by about ±10 µV (SD 3.3 µV), while the class difference peaks at only ≈ 1 µV</a:t>
+            </a:r>
+            <a:endParaRPr lang="en-US" sz="1500" dirty="0"/>
+          </a:p>
+          <a:p>
+            <a:pPr indent="0" marL="0">
+              <a:buNone/>
+            </a:pPr>
+            <a:r>
+              <a:rPr lang="en-US" sz="1500" b="1" dirty="0">
+                <a:solidFill>
+                  <a:schemeClr val="tx1"/>
+                </a:solidFill>
+              </a:rPr>
+              <a:t>→ The task-related ERP is buried in background EEG</a:t>
+            </a:r>
+            <a:endParaRPr lang="en-US" sz="1500" dirty="0"/>
+          </a:p>
+        </p:txBody>
+      </p:sp>
+      <p:sp>
+        <p:nvSpPr>
+          <p:cNvPr id="8" name="Challenge 2 text"/>
+          <p:cNvSpPr txBox="1"/>
+          <p:nvPr/>
+        </p:nvSpPr>
+        <p:spPr>
+          <a:xfrm>
+            <a:off x="6355080" y="5120640"/>
+            <a:ext cx="5303520" cy="777240"/>
+          </a:xfrm>
+          <a:prstGeom prst="rect">
+            <a:avLst/>
+          </a:prstGeom>
+          <a:noFill/>
+          <a:ln/>
+        </p:spPr>
+        <p:txBody>
+          <a:bodyPr wrap="square" lIns="0" tIns="0" rIns="0" bIns="0" rtlCol="0" anchor="t"/>
+          <a:lstStyle/>
+          <a:p>
+            <a:pPr indent="0" marL="0">
+              <a:buNone/>
+            </a:pPr>
+            <a:r>
+              <a:rPr lang="en-US" sz="1500" dirty="0">
+                <a:solidFill>
+                  <a:schemeClr val="tx1"/>
+                </a:solidFill>
+              </a:rPr>
+              <a:t>Mirror-symmetry r: −0.65 to 0.86;  peak latency: 150–300 ms;  peak amplitude: 0.3–3.9 µV</a:t>
+            </a:r>
+            <a:endParaRPr lang="en-US" sz="1500" dirty="0"/>
+          </a:p>
+          <a:p>
+            <a:pPr indent="0" marL="0">
+              <a:buNone/>
+            </a:pPr>
+            <a:r>
+              <a:rPr lang="en-US" sz="1500" b="1" dirty="0">
+                <a:solidFill>
+                  <a:schemeClr val="tx1"/>
+                </a:solidFill>
+              </a:rPr>
+              <a:t>→ Waveform, timing and lateralization differ across subjects</a:t>
+            </a:r>
+            <a:endParaRPr lang="en-US" sz="1500" dirty="0"/>
+          </a:p>
+        </p:txBody>
+      </p:sp>
+      <p:sp>
+        <p:nvSpPr>
+          <p:cNvPr id="9" name="Reference"/>
+          <p:cNvSpPr txBox="1"/>
+          <p:nvPr/>
+        </p:nvSpPr>
+        <p:spPr>
+          <a:xfrm>
+            <a:off x="320040" y="5943600"/>
+            <a:ext cx="10881360" cy="777240"/>
+          </a:xfrm>
+          <a:prstGeom prst="rect">
+            <a:avLst/>
+          </a:prstGeom>
+          <a:noFill/>
+          <a:ln/>
+        </p:spPr>
+        <p:txBody>
+          <a:bodyPr wrap="square" lIns="0" tIns="0" rIns="0" bIns="0" rtlCol="0" anchor="b"/>
+          <a:lstStyle/>
+          <a:p>
+            <a:pPr indent="0" marL="0">
+              <a:buNone/>
+            </a:pPr>
+            <a:r>
+              <a:rPr lang="en-US" sz="1100" dirty="0">
                 <a:solidFill>
                   <a:schemeClr val="accent3"/>
                 </a:solidFill>
               </a:rPr>
-              <a:t>Class difference (left→right − right→left) of the hemispheric difference, averaged over 9 mirror channel pairs</a:t>
-            </a:r>
-            <a:endParaRPr lang="en-US" sz="1200" dirty="0"/>
-          </a:p>
-        </p:txBody>
-      </p:sp>
-      <p:sp>
-        <p:nvSpPr>
-          <p:cNvPr id="5" name="Observations"/>
-          <p:cNvSpPr txBox="1"/>
-          <p:nvPr/>
-        </p:nvSpPr>
-        <p:spPr>
-          <a:xfrm>
-            <a:off x="7726680" y="1508760"/>
-            <a:ext cx="4114800" cy="4206240"/>
-          </a:xfrm>
-          <a:prstGeom prst="rect">
-            <a:avLst/>
-          </a:prstGeom>
-          <a:noFill/>
-          <a:ln/>
-        </p:spPr>
-        <p:txBody>
-          <a:bodyPr wrap="square" lIns="0" tIns="0" rIns="0" bIns="0" rtlCol="0" anchor="t"/>
-          <a:lstStyle/>
-          <a:p>
-            <a:pPr indent="0" marL="0">
-              <a:buNone/>
-            </a:pPr>
-            <a:r>
-              <a:rPr lang="en-US" sz="1800" b="1" dirty="0">
-                <a:solidFill>
-                  <a:schemeClr val="tx1"/>
-                </a:solidFill>
-              </a:rPr>
-              <a:t>1. Very weak effect</a:t>
-            </a:r>
-            <a:endParaRPr lang="en-US" sz="1800" dirty="0"/>
-          </a:p>
-          <a:p>
-            <a:pPr indent="0" marL="0">
-              <a:buNone/>
-            </a:pPr>
-            <a:r>
-              <a:rPr lang="en-US" sz="1800" dirty="0">
-                <a:solidFill>
-                  <a:schemeClr val="tx1"/>
-                </a:solidFill>
-              </a:rPr>
-              <a:t>Class difference ≈ 1 µV</a:t>
-            </a:r>
-            <a:endParaRPr lang="en-US" sz="1800" dirty="0"/>
-          </a:p>
-          <a:p>
-            <a:pPr indent="0" marL="0">
-              <a:buNone/>
-            </a:pPr>
-            <a:r>
-              <a:rPr lang="en-US" sz="800" dirty="0">
-                <a:solidFill>
-                  <a:schemeClr val="tx1"/>
-                </a:solidFill>
-              </a:rPr>
-              <a:t> </a:t>
-            </a:r>
-            <a:endParaRPr lang="en-US" sz="1800" dirty="0"/>
-          </a:p>
-          <a:p>
-            <a:pPr indent="0" marL="0">
-              <a:buNone/>
-            </a:pPr>
-            <a:r>
-              <a:rPr lang="en-US" sz="1800" b="1" dirty="0">
-                <a:solidFill>
-                  <a:schemeClr val="tx1"/>
-                </a:solidFill>
-              </a:rPr>
-              <a:t>2. Time-varying lateralization</a:t>
-            </a:r>
-            <a:endParaRPr lang="en-US" sz="1800" dirty="0"/>
-          </a:p>
-          <a:p>
-            <a:pPr indent="0" marL="0">
-              <a:buNone/>
-            </a:pPr>
-            <a:r>
-              <a:rPr lang="en-US" sz="1800" dirty="0">
-                <a:solidFill>
-                  <a:schemeClr val="tx1"/>
-                </a:solidFill>
-              </a:rPr>
-              <a:t>Sign reverses: −0.76 µV at 110 ms, +1.01 µV at 210 ms</a:t>
-            </a:r>
-            <a:endParaRPr lang="en-US" sz="1800" dirty="0"/>
-          </a:p>
-          <a:p>
-            <a:pPr indent="0" marL="0">
-              <a:buNone/>
-            </a:pPr>
-            <a:r>
-              <a:rPr lang="en-US" sz="800" dirty="0">
-                <a:solidFill>
-                  <a:schemeClr val="tx1"/>
-                </a:solidFill>
-              </a:rPr>
-              <a:t> </a:t>
-            </a:r>
-            <a:endParaRPr lang="en-US" sz="1800" dirty="0"/>
-          </a:p>
-          <a:p>
-            <a:pPr indent="0" marL="0">
-              <a:buNone/>
-            </a:pPr>
-            <a:r>
-              <a:rPr lang="en-US" sz="1800" b="1" dirty="0">
-                <a:solidFill>
-                  <a:schemeClr val="tx1"/>
-                </a:solidFill>
-              </a:rPr>
-              <a:t>3. Overlapping responses</a:t>
-            </a:r>
-            <a:endParaRPr lang="en-US" sz="1800" dirty="0"/>
-          </a:p>
-          <a:p>
-            <a:pPr indent="0" marL="0">
-              <a:buNone/>
-            </a:pPr>
-            <a:r>
-              <a:rPr lang="en-US" sz="1800" dirty="0">
-                <a:solidFill>
-                  <a:schemeClr val="tx1"/>
-                </a:solidFill>
-              </a:rPr>
-              <a:t>Pairs every 200 ms, so each epoch also contains the next trials</a:t>
-            </a:r>
-            <a:endParaRPr lang="en-US" sz="1800" dirty="0"/>
-          </a:p>
-          <a:p>
-            <a:pPr indent="0" marL="0">
-              <a:buNone/>
-            </a:pPr>
-            <a:r>
-              <a:rPr lang="en-US" sz="800" dirty="0">
-                <a:solidFill>
-                  <a:schemeClr val="tx1"/>
-                </a:solidFill>
-              </a:rPr>
-              <a:t> </a:t>
-            </a:r>
-            <a:endParaRPr lang="en-US" sz="1800" dirty="0"/>
-          </a:p>
-          <a:p>
-            <a:pPr indent="0" marL="0">
-              <a:buNone/>
-            </a:pPr>
-            <a:r>
-              <a:rPr lang="en-US" sz="1800" b="1" dirty="0">
-                <a:solidFill>
-                  <a:schemeClr val="tx1"/>
-                </a:solidFill>
-              </a:rPr>
-              <a:t>4. Inter-subject heterogeneity</a:t>
-            </a:r>
-            <a:endParaRPr lang="en-US" sz="1800" dirty="0"/>
-          </a:p>
-          <a:p>
-            <a:pPr indent="0" marL="0">
-              <a:buNone/>
-            </a:pPr>
-            <a:r>
-              <a:rPr lang="en-US" sz="1800" dirty="0">
-                <a:solidFill>
-                  <a:schemeClr val="tx1"/>
-                </a:solidFill>
-              </a:rPr>
-              <a:t>Mirror-symmetry correlation −0.64 to 0.75; peak latency 105–245 ms</a:t>
-            </a:r>
-            <a:endParaRPr lang="en-US" sz="1800" dirty="0"/>
+              <a:t>All waveforms are measured data (28 subjects; 1–30 Hz, common average reference). Signal: left − right hemisphere, mean of 9 mirror channel pairs. r: correlation of the class-0 pattern with the sign-flipped class-1 pattern (9 pairs × time; mirror rule gives r = 1). Peak latency: largest class difference within 80–300 ms.</a:t>
+            </a:r>
+            <a:endParaRPr lang="en-US" sz="1100" dirty="0"/>
           </a:p>
         </p:txBody>
       </p:sp>

</xml_diff>

<commit_message>
Slide 4: linked x10 zoom panel for the class averages
Single trials and averages stay on one linear scale; a boxed region is
connected to a magnified panel that shows the averaged waveforms and the
peaks of the class difference.

Co-Authored-By: Claude Opus 5.5 <noreply@anthropic.com>
Claude-Session: https://claude.ai/code/session_01M2N1FL6JrZz8kTbkaY5rZ8
</commit_message>
<xml_diff>
--- a/presentation/midterm_defense_sample.pptx
+++ b/presentation/midterm_defense_sample.pptx
@@ -113,12 +113,12 @@
   <p:extLst>
     <p:ext uri="{521415D9-36F7-43E2-AB2F-B90AF26B5E84}">
       <p14:sectionLst xmlns:p14="http://schemas.microsoft.com/office/powerpoint/2010/main">
-        <p14:section name="Opening" id="{742fab5d-9654-6886-c39f-14f57bfd6031}">
+        <p14:section name="Opening" id="{a0bf1fbd-097f-b3f1-e97f-2f660a718ec3}">
           <p14:sldIdLst>
             <p14:sldId id="256"/>
           </p14:sldIdLst>
         </p14:section>
-        <p14:section name="Research Background and Objectives" id="{cafdc750-5bfe-df4d-fdaf-e72c3d41edc8}">
+        <p14:section name="Research Background and Objectives" id="{edd17cb6-7d15-4a0f-4bd2-d656d9225d49}">
           <p14:sldIdLst>
             <p14:sldId id="257"/>
             <p14:sldId id="258"/>
@@ -126,7 +126,7 @@
             <p14:sldId id="260"/>
           </p14:sldIdLst>
         </p14:section>
-        <p14:section name="Research Progress and Stage Achievements" id="{36082c95-6dbf-1fc1-024a-f89fdd4e761e}">
+        <p14:section name="Research Progress and Stage Achievements" id="{1830fa79-925c-6463-c8cf-29917d260811}">
           <p14:sldIdLst>
             <p14:sldId id="261"/>
             <p14:sldId id="262"/>

</xml_diff>

<commit_message>
Add Chapter 1 (RED) and Chapter 2 (LR-MoE) architecture slides
Native, editable diagrams: RED's two training stages, losses and
inference path (matching aved/train_red.py), and LR-MoE's hemispheric
decomposition, expert families, router and gating.

Co-Authored-By: Claude Opus 5.5 <noreply@anthropic.com>
Claude-Session: https://claude.ai/code/session_01M2N1FL6JrZz8kTbkaY5rZ8
</commit_message>
<xml_diff>
--- a/presentation/midterm_defense_sample.pptx
+++ b/presentation/midterm_defense_sample.pptx
@@ -12,9 +12,11 @@
     <p:sldId id="260" r:id="rId6"/>
     <p:sldId id="261" r:id="rId7"/>
     <p:sldId id="262" r:id="rId8"/>
+    <p:sldId id="263" r:id="rId9"/>
+    <p:sldId id="264" r:id="rId10"/>
   </p:sldIdLst>
   <p:notesMasterIdLst>
-    <p:notesMasterId r:id="rId9"/>
+    <p:notesMasterId r:id="rId11"/>
   </p:notesMasterIdLst>
   <p:sldSz cx="12192000" cy="6858000"/>
   <p:notesSz cx="6858000" cy="12192000"/>
@@ -113,12 +115,12 @@
   <p:extLst>
     <p:ext uri="{521415D9-36F7-43E2-AB2F-B90AF26B5E84}">
       <p14:sectionLst xmlns:p14="http://schemas.microsoft.com/office/powerpoint/2010/main">
-        <p14:section name="Opening" id="{a0bf1fbd-097f-b3f1-e97f-2f660a718ec3}">
+        <p14:section name="Opening" id="{85d7688c-8546-dda1-13e8-6165857311df}">
           <p14:sldIdLst>
             <p14:sldId id="256"/>
           </p14:sldIdLst>
         </p14:section>
-        <p14:section name="Research Background and Objectives" id="{edd17cb6-7d15-4a0f-4bd2-d656d9225d49}">
+        <p14:section name="Research Background and Objectives" id="{e7b14f48-b1d4-0763-28a7-e3ebd2b996a3}">
           <p14:sldIdLst>
             <p14:sldId id="257"/>
             <p14:sldId id="258"/>
@@ -126,10 +128,12 @@
             <p14:sldId id="260"/>
           </p14:sldIdLst>
         </p14:section>
-        <p14:section name="Research Progress and Stage Achievements" id="{1830fa79-925c-6463-c8cf-29917d260811}">
+        <p14:section name="Research Progress and Stage Achievements" id="{aca0614d-fb59-aacf-390f-b7eee02e8687}">
           <p14:sldIdLst>
             <p14:sldId id="261"/>
             <p14:sldId id="262"/>
+            <p14:sldId id="263"/>
+            <p14:sldId id="264"/>
           </p14:sldIdLst>
         </p14:section>
       </p14:sectionLst>
@@ -1088,6 +1092,182 @@
             <a:fld id="{F7021451-1387-4CA6-816F-3879F97B5CBC}" type="slidenum">
               <a:rPr lang="en-US"/>
               <a:t>7</a:t>
+            </a:fld>
+            <a:endParaRPr lang="en-US"/>
+          </a:p>
+        </p:txBody>
+      </p:sp>
+    </p:spTree>
+    <p:extLst>
+      <p:ext uri="{BB962C8B-B14F-4D97-AF65-F5344CB8AC3E}">
+        <p14:creationId xmlns:p14="http://schemas.microsoft.com/office/powerpoint/2010/main" val="1024086991"/>
+      </p:ext>
+    </p:extLst>
+  </p:cSld>
+  <p:clrMapOvr>
+    <a:masterClrMapping/>
+  </p:clrMapOvr>
+</p:notes>
+</file>
+
+<file path=ppt/notesSlides/notesSlide8.xml><?xml version="1.0" encoding="utf-8"?>
+<p:notes xmlns:a="http://schemas.openxmlformats.org/drawingml/2006/main" xmlns:r="http://schemas.openxmlformats.org/officeDocument/2006/relationships" xmlns:p="http://schemas.openxmlformats.org/presentationml/2006/main">
+  <p:cSld>
+    <p:spTree>
+      <p:nvGrpSpPr>
+        <p:cNvPr id="1" name=""/>
+        <p:cNvGrpSpPr/>
+        <p:nvPr/>
+      </p:nvGrpSpPr>
+      <p:grpSpPr>
+        <a:xfrm>
+          <a:off x="0" y="0"/>
+          <a:ext cx="0" cy="0"/>
+          <a:chOff x="0" y="0"/>
+          <a:chExt cx="0" cy="0"/>
+        </a:xfrm>
+      </p:grpSpPr>
+      <p:sp>
+        <p:nvSpPr>
+          <p:cNvPr id="2" name="Slide Image Placeholder 1"/>
+          <p:cNvSpPr>
+            <a:spLocks noGrp="1" noRot="1" noChangeAspect="1"/>
+          </p:cNvSpPr>
+          <p:nvPr>
+            <p:ph type="sldImg"/>
+          </p:nvPr>
+        </p:nvSpPr>
+        <p:spPr/>
+      </p:sp>
+      <p:sp>
+        <p:nvSpPr>
+          <p:cNvPr id="3" name="Notes Placeholder 2"/>
+          <p:cNvSpPr>
+            <a:spLocks noGrp="1"/>
+          </p:cNvSpPr>
+          <p:nvPr>
+            <p:ph type="body" idx="1"/>
+          </p:nvPr>
+        </p:nvSpPr>
+        <p:spPr/>
+        <p:txBody>
+          <a:bodyPr/>
+          <a:lstStyle/>
+          <a:p>
+            <a:r>
+              <a:rPr lang="en-US" dirty="0"/>
+              <a:t>~65 s. Training only: a teacher EEGNet learns from k-trial averages, which have much higher SNR. The student sees single trials. Besides the label loss, a linear decoder reconstructs the ERP and is trained against the average of the other trials in the same group; because that target never contains x, the best possible output is the expected ERP given x, i.e. only what is recoverable. The frozen teacher then classifies this reconstruction and its verdict is distilled into the student. At test time only the EEGNet remains. Expected: higher within-subject accuracy than the 74.4 % baseline; naive distillation from averages should not help.</a:t>
+            </a:r>
+            <a:endParaRPr lang="en-US" dirty="0"/>
+          </a:p>
+        </p:txBody>
+      </p:sp>
+      <p:sp>
+        <p:nvSpPr>
+          <p:cNvPr id="4" name="Slide Number Placeholder 3"/>
+          <p:cNvSpPr>
+            <a:spLocks noGrp="1"/>
+          </p:cNvSpPr>
+          <p:nvPr>
+            <p:ph type="sldNum" sz="quarter" idx="10"/>
+          </p:nvPr>
+        </p:nvSpPr>
+        <p:spPr/>
+        <p:txBody>
+          <a:bodyPr/>
+          <a:lstStyle/>
+          <a:p>
+            <a:fld id="{F7021451-1387-4CA6-816F-3879F97B5CBC}" type="slidenum">
+              <a:rPr lang="en-US"/>
+              <a:t>8</a:t>
+            </a:fld>
+            <a:endParaRPr lang="en-US"/>
+          </a:p>
+        </p:txBody>
+      </p:sp>
+    </p:spTree>
+    <p:extLst>
+      <p:ext uri="{BB962C8B-B14F-4D97-AF65-F5344CB8AC3E}">
+        <p14:creationId xmlns:p14="http://schemas.microsoft.com/office/powerpoint/2010/main" val="1024086991"/>
+      </p:ext>
+    </p:extLst>
+  </p:cSld>
+  <p:clrMapOvr>
+    <a:masterClrMapping/>
+  </p:clrMapOvr>
+</p:notes>
+</file>
+
+<file path=ppt/notesSlides/notesSlide9.xml><?xml version="1.0" encoding="utf-8"?>
+<p:notes xmlns:a="http://schemas.openxmlformats.org/drawingml/2006/main" xmlns:r="http://schemas.openxmlformats.org/officeDocument/2006/relationships" xmlns:p="http://schemas.openxmlformats.org/presentationml/2006/main">
+  <p:cSld>
+    <p:spTree>
+      <p:nvGrpSpPr>
+        <p:cNvPr id="1" name=""/>
+        <p:cNvGrpSpPr/>
+        <p:nvPr/>
+      </p:nvGrpSpPr>
+      <p:grpSpPr>
+        <a:xfrm>
+          <a:off x="0" y="0"/>
+          <a:ext cx="0" cy="0"/>
+          <a:chOff x="0" y="0"/>
+          <a:chExt cx="0" cy="0"/>
+        </a:xfrm>
+      </p:grpSpPr>
+      <p:sp>
+        <p:nvSpPr>
+          <p:cNvPr id="2" name="Slide Image Placeholder 1"/>
+          <p:cNvSpPr>
+            <a:spLocks noGrp="1" noRot="1" noChangeAspect="1"/>
+          </p:cNvSpPr>
+          <p:nvPr>
+            <p:ph type="sldImg"/>
+          </p:nvPr>
+        </p:nvSpPr>
+        <p:spPr/>
+      </p:sp>
+      <p:sp>
+        <p:nvSpPr>
+          <p:cNvPr id="3" name="Notes Placeholder 2"/>
+          <p:cNvSpPr>
+            <a:spLocks noGrp="1"/>
+          </p:cNvSpPr>
+          <p:nvPr>
+            <p:ph type="body" idx="1"/>
+          </p:nvPr>
+        </p:nvSpPr>
+        <p:spPr/>
+        <p:txBody>
+          <a:bodyPr/>
+          <a:lstStyle/>
+          <a:p>
+            <a:r>
+              <a:rPr lang="en-US" dirty="0"/>
+              <a:t>~65 s. Subjects differ in how symmetric and how fast their response is, so one model does not fit all. The trial is split by the mirror operator into an antisymmetric, lateralized part and a symmetric part. After a shared temporal convolution, three expert families process them: mirror-equivariant experts for strong lateralizers, hemisphere-dominant experts for asymmetric responders, and symmetric experts for the shared response; each has early, middle and late latency variants. A small router reads interpretable descriptors of the trial and weights the experts. Test: leave-one-subject-out without target data. Expected: above the 62.3 % EEGNet LOSO baseline, with router choices that agree with each subject's measured symmetry and latency.</a:t>
+            </a:r>
+            <a:endParaRPr lang="en-US" dirty="0"/>
+          </a:p>
+        </p:txBody>
+      </p:sp>
+      <p:sp>
+        <p:nvSpPr>
+          <p:cNvPr id="4" name="Slide Number Placeholder 3"/>
+          <p:cNvSpPr>
+            <a:spLocks noGrp="1"/>
+          </p:cNvSpPr>
+          <p:nvPr>
+            <p:ph type="sldNum" sz="quarter" idx="10"/>
+          </p:nvPr>
+        </p:nvSpPr>
+        <p:spPr/>
+        <p:txBody>
+          <a:bodyPr/>
+          <a:lstStyle/>
+          <a:p>
+            <a:fld id="{F7021451-1387-4CA6-816F-3879F97B5CBC}" type="slidenum">
+              <a:rPr lang="en-US"/>
+              <a:t>9</a:t>
             </a:fld>
             <a:endParaRPr lang="en-US"/>
           </a:p>
@@ -8267,6 +8447,3499 @@
 </p:sld>
 </file>
 
+<file path=ppt/slides/slide8.xml><?xml version="1.0" encoding="utf-8"?>
+<p:sld xmlns:a="http://schemas.openxmlformats.org/drawingml/2006/main" xmlns:r="http://schemas.openxmlformats.org/officeDocument/2006/relationships" xmlns:p="http://schemas.openxmlformats.org/presentationml/2006/main">
+  <p:cSld name="Slide 8">
+    <p:spTree>
+      <p:nvGrpSpPr>
+        <p:cNvPr id="1" name=""/>
+        <p:cNvGrpSpPr/>
+        <p:nvPr/>
+      </p:nvGrpSpPr>
+      <p:grpSpPr>
+        <a:xfrm>
+          <a:off x="0" y="0"/>
+          <a:ext cx="0" cy="0"/>
+          <a:chOff x="0" y="0"/>
+          <a:chExt cx="0" cy="0"/>
+        </a:xfrm>
+      </p:grpSpPr>
+      <p:sp>
+        <p:nvSpPr>
+          <p:cNvPr id="2" name="Text 4"/>
+          <p:cNvSpPr/>
+          <p:nvPr>
+            <p:ph idx="104" type="title" hasCustomPrompt="1"/>
+          </p:nvPr>
+        </p:nvSpPr>
+        <p:spPr>
+          <a:xfrm>
+            <a:off x="457200" y="274320"/>
+            <a:ext cx="8001000" cy="749808"/>
+          </a:xfrm>
+          <a:prstGeom prst="rect">
+            <a:avLst/>
+          </a:prstGeom>
+          <a:noFill/>
+          <a:ln/>
+        </p:spPr>
+        <p:txBody>
+          <a:bodyPr wrap="square" lIns="0" tIns="0" rIns="0" bIns="0" rtlCol="0" anchor="ctr"/>
+          <a:lstStyle/>
+          <a:p>
+            <a:pPr algn="l" indent="0" marL="0">
+              <a:buNone/>
+            </a:pPr>
+            <a:r>
+              <a:rPr lang="en-US" sz="2800" b="1" dirty="0">
+                <a:solidFill>
+                  <a:schemeClr val="bg1"/>
+                </a:solidFill>
+              </a:rPr>
+              <a:t>2 Research Progress and Stage Achievements</a:t>
+            </a:r>
+            <a:endParaRPr lang="en-US" sz="2800" dirty="0"/>
+          </a:p>
+        </p:txBody>
+      </p:sp>
+      <p:sp>
+        <p:nvSpPr>
+          <p:cNvPr id="3" name="Lead"/>
+          <p:cNvSpPr txBox="1"/>
+          <p:nvPr/>
+        </p:nvSpPr>
+        <p:spPr>
+          <a:xfrm>
+            <a:off x="548640" y="1161288"/>
+            <a:ext cx="11338560" cy="365760"/>
+          </a:xfrm>
+          <a:prstGeom prst="rect">
+            <a:avLst/>
+          </a:prstGeom>
+          <a:noFill/>
+          <a:ln/>
+        </p:spPr>
+        <p:txBody>
+          <a:bodyPr wrap="square" lIns="0" tIns="0" rIns="0" bIns="0" rtlCol="0" anchor="ctr"/>
+          <a:lstStyle/>
+          <a:p>
+            <a:pPr indent="0" marL="0">
+              <a:buNone/>
+            </a:pPr>
+            <a:r>
+              <a:rPr lang="en-US" sz="1700" dirty="0">
+                <a:solidFill>
+                  <a:schemeClr val="tx1"/>
+                </a:solidFill>
+              </a:rPr>
+              <a:t>Chapter 1 · RED: learn from multi-trial averages during training; a plain EEGNet at inference</a:t>
+            </a:r>
+            <a:endParaRPr lang="en-US" sz="1700" dirty="0"/>
+          </a:p>
+        </p:txBody>
+      </p:sp>
+      <p:sp>
+        <p:nvSpPr>
+          <p:cNvPr id="4" name="Stage 1"/>
+          <p:cNvSpPr/>
+          <p:nvPr/>
+        </p:nvSpPr>
+        <p:spPr>
+          <a:xfrm>
+            <a:off x="411480" y="1600200"/>
+            <a:ext cx="8092440" cy="1097280"/>
+          </a:xfrm>
+          <a:prstGeom prst="rect">
+            <a:avLst/>
+          </a:prstGeom>
+          <a:solidFill>
+            <a:srgbClr val="F2F2F2"/>
+          </a:solidFill>
+          <a:ln/>
+        </p:spPr>
+      </p:sp>
+      <p:sp>
+        <p:nvSpPr>
+          <p:cNvPr id="5" name="Stage 1 label"/>
+          <p:cNvSpPr txBox="1"/>
+          <p:nvPr/>
+        </p:nvSpPr>
+        <p:spPr>
+          <a:xfrm>
+            <a:off x="521208" y="1645920"/>
+            <a:ext cx="7872984" cy="274320"/>
+          </a:xfrm>
+          <a:prstGeom prst="rect">
+            <a:avLst/>
+          </a:prstGeom>
+          <a:noFill/>
+          <a:ln/>
+        </p:spPr>
+        <p:txBody>
+          <a:bodyPr wrap="square" lIns="0" tIns="0" rIns="0" bIns="0" rtlCol="0" anchor="ctr"/>
+          <a:lstStyle/>
+          <a:p>
+            <a:pPr indent="0" marL="0">
+              <a:buNone/>
+            </a:pPr>
+            <a:r>
+              <a:rPr lang="en-US" sz="1300" b="1" dirty="0">
+                <a:solidFill>
+                  <a:schemeClr val="tx1"/>
+                </a:solidFill>
+              </a:rPr>
+              <a:t>Stage 1 · Averaged-input teacher (training only)</a:t>
+            </a:r>
+            <a:endParaRPr lang="en-US" sz="1300" dirty="0"/>
+          </a:p>
+        </p:txBody>
+      </p:sp>
+      <p:sp>
+        <p:nvSpPr>
+          <p:cNvPr id="6" name="Averaging group"/>
+          <p:cNvSpPr/>
+          <p:nvPr/>
+        </p:nvSpPr>
+        <p:spPr>
+          <a:xfrm>
+            <a:off x="548640" y="1984248"/>
+            <a:ext cx="1828800" cy="594360"/>
+          </a:xfrm>
+          <a:prstGeom prst="rect">
+            <a:avLst/>
+          </a:prstGeom>
+          <a:solidFill>
+            <a:srgbClr val="FFFFFF"/>
+          </a:solidFill>
+          <a:ln w="12700">
+            <a:solidFill>
+              <a:srgbClr val="000000"/>
+            </a:solidFill>
+            <a:prstDash val="solid"/>
+          </a:ln>
+        </p:spPr>
+        <p:txBody>
+          <a:bodyPr wrap="square" lIns="25400" tIns="25400" rIns="25400" bIns="25400" rtlCol="0" anchor="ctr"/>
+          <a:lstStyle/>
+          <a:p>
+            <a:pPr algn="ctr" indent="0" marL="0">
+              <a:buNone/>
+            </a:pPr>
+            <a:r>
+              <a:rPr lang="en-US" sz="1300" b="1" dirty="0">
+                <a:solidFill>
+                  <a:srgbClr val="000000"/>
+                </a:solidFill>
+              </a:rPr>
+              <a:t>Averaging group</a:t>
+            </a:r>
+            <a:endParaRPr lang="en-US" sz="1300" dirty="0"/>
+          </a:p>
+          <a:p>
+            <a:pPr algn="ctr" indent="0" marL="0">
+              <a:buNone/>
+            </a:pPr>
+            <a:r>
+              <a:rPr lang="en-US" sz="1150" dirty="0">
+                <a:solidFill>
+                  <a:srgbClr val="262626"/>
+                </a:solidFill>
+              </a:rPr>
+              <a:t>same subject, session,</a:t>
+            </a:r>
+            <a:endParaRPr lang="en-US" sz="1300" dirty="0"/>
+          </a:p>
+          <a:p>
+            <a:pPr algn="ctr" indent="0" marL="0">
+              <a:buNone/>
+            </a:pPr>
+            <a:r>
+              <a:rPr lang="en-US" sz="1150" dirty="0">
+                <a:solidFill>
+                  <a:srgbClr val="262626"/>
+                </a:solidFill>
+              </a:rPr>
+              <a:t>character and bit</a:t>
+            </a:r>
+            <a:endParaRPr lang="en-US" sz="1300" dirty="0"/>
+          </a:p>
+        </p:txBody>
+      </p:sp>
+      <p:sp>
+        <p:nvSpPr>
+          <p:cNvPr id="7" name="k-trial average"/>
+          <p:cNvSpPr/>
+          <p:nvPr/>
+        </p:nvSpPr>
+        <p:spPr>
+          <a:xfrm>
+            <a:off x="2697480" y="1984248"/>
+            <a:ext cx="1828800" cy="594360"/>
+          </a:xfrm>
+          <a:prstGeom prst="rect">
+            <a:avLst/>
+          </a:prstGeom>
+          <a:solidFill>
+            <a:srgbClr val="FFFFFF"/>
+          </a:solidFill>
+          <a:ln w="12700">
+            <a:solidFill>
+              <a:srgbClr val="000000"/>
+            </a:solidFill>
+            <a:prstDash val="solid"/>
+          </a:ln>
+        </p:spPr>
+        <p:txBody>
+          <a:bodyPr wrap="square" lIns="25400" tIns="25400" rIns="25400" bIns="25400" rtlCol="0" anchor="ctr"/>
+          <a:lstStyle/>
+          <a:p>
+            <a:pPr algn="ctr" indent="0" marL="0">
+              <a:buNone/>
+            </a:pPr>
+            <a:r>
+              <a:rPr lang="en-US" sz="1300" b="1" dirty="0">
+                <a:solidFill>
+                  <a:srgbClr val="000000"/>
+                </a:solidFill>
+              </a:rPr>
+              <a:t>k-trial average a</a:t>
+            </a:r>
+            <a:endParaRPr lang="en-US" sz="1300" dirty="0"/>
+          </a:p>
+          <a:p>
+            <a:pPr algn="ctr" indent="0" marL="0">
+              <a:buNone/>
+            </a:pPr>
+            <a:r>
+              <a:rPr lang="en-US" sz="1150" dirty="0">
+                <a:solidFill>
+                  <a:srgbClr val="262626"/>
+                </a:solidFill>
+              </a:rPr>
+              <a:t>k ∈ {2, 3, 6}</a:t>
+            </a:r>
+            <a:endParaRPr lang="en-US" sz="1300" dirty="0"/>
+          </a:p>
+        </p:txBody>
+      </p:sp>
+      <p:sp>
+        <p:nvSpPr>
+          <p:cNvPr id="8" name="Teacher"/>
+          <p:cNvSpPr/>
+          <p:nvPr/>
+        </p:nvSpPr>
+        <p:spPr>
+          <a:xfrm>
+            <a:off x="4846320" y="1984248"/>
+            <a:ext cx="1508760" cy="594360"/>
+          </a:xfrm>
+          <a:prstGeom prst="rect">
+            <a:avLst/>
+          </a:prstGeom>
+          <a:solidFill>
+            <a:srgbClr val="FFFFFF"/>
+          </a:solidFill>
+          <a:ln w="12700">
+            <a:solidFill>
+              <a:srgbClr val="000000"/>
+            </a:solidFill>
+            <a:prstDash val="solid"/>
+          </a:ln>
+        </p:spPr>
+        <p:txBody>
+          <a:bodyPr wrap="square" lIns="25400" tIns="25400" rIns="25400" bIns="25400" rtlCol="0" anchor="ctr"/>
+          <a:lstStyle/>
+          <a:p>
+            <a:pPr algn="ctr" indent="0" marL="0">
+              <a:buNone/>
+            </a:pPr>
+            <a:r>
+              <a:rPr lang="en-US" sz="1300" b="1" dirty="0">
+                <a:solidFill>
+                  <a:srgbClr val="000000"/>
+                </a:solidFill>
+              </a:rPr>
+              <a:t>Teacher EEGNet</a:t>
+            </a:r>
+            <a:endParaRPr lang="en-US" sz="1300" dirty="0"/>
+          </a:p>
+          <a:p>
+            <a:pPr algn="ctr" indent="0" marL="0">
+              <a:buNone/>
+            </a:pPr>
+            <a:r>
+              <a:rPr lang="en-US" sz="1150" dirty="0">
+                <a:solidFill>
+                  <a:srgbClr val="262626"/>
+                </a:solidFill>
+              </a:rPr>
+              <a:t>trained on averages</a:t>
+            </a:r>
+            <a:endParaRPr lang="en-US" sz="1300" dirty="0"/>
+          </a:p>
+        </p:txBody>
+      </p:sp>
+      <p:sp>
+        <p:nvSpPr>
+          <p:cNvPr id="9" name="Frozen teacher"/>
+          <p:cNvSpPr/>
+          <p:nvPr/>
+        </p:nvSpPr>
+        <p:spPr>
+          <a:xfrm>
+            <a:off x="6675120" y="1984248"/>
+            <a:ext cx="1691640" cy="594360"/>
+          </a:xfrm>
+          <a:prstGeom prst="rect">
+            <a:avLst/>
+          </a:prstGeom>
+          <a:solidFill>
+            <a:srgbClr val="FFFFFF"/>
+          </a:solidFill>
+          <a:ln w="12700">
+            <a:solidFill>
+              <a:srgbClr val="A00000"/>
+            </a:solidFill>
+            <a:prstDash val="solid"/>
+          </a:ln>
+        </p:spPr>
+        <p:txBody>
+          <a:bodyPr wrap="square" lIns="25400" tIns="25400" rIns="25400" bIns="25400" rtlCol="0" anchor="ctr"/>
+          <a:lstStyle/>
+          <a:p>
+            <a:pPr algn="ctr" indent="0" marL="0">
+              <a:buNone/>
+            </a:pPr>
+            <a:r>
+              <a:rPr lang="en-US" sz="1300" b="1" dirty="0">
+                <a:solidFill>
+                  <a:srgbClr val="000000"/>
+                </a:solidFill>
+              </a:rPr>
+              <a:t>Frozen teacher T</a:t>
+            </a:r>
+            <a:endParaRPr lang="en-US" sz="1300" dirty="0"/>
+          </a:p>
+          <a:p>
+            <a:pPr algn="ctr" indent="0" marL="0">
+              <a:buNone/>
+            </a:pPr>
+            <a:r>
+              <a:rPr lang="en-US" sz="1150" dirty="0">
+                <a:solidFill>
+                  <a:srgbClr val="262626"/>
+                </a:solidFill>
+              </a:rPr>
+              <a:t>reused in Stage 2</a:t>
+            </a:r>
+            <a:endParaRPr lang="en-US" sz="1300" dirty="0"/>
+          </a:p>
+        </p:txBody>
+      </p:sp>
+      <p:sp>
+        <p:nvSpPr>
+          <p:cNvPr id="10" name="S1 arrow 1"/>
+          <p:cNvSpPr/>
+          <p:nvPr/>
+        </p:nvSpPr>
+        <p:spPr>
+          <a:xfrm>
+            <a:off x="2377440" y="2281428"/>
+            <a:ext cx="320040" cy="0"/>
+          </a:xfrm>
+          <a:prstGeom prst="line">
+            <a:avLst/>
+          </a:prstGeom>
+          <a:noFill/>
+          <a:ln w="15875">
+            <a:solidFill>
+              <a:srgbClr val="000000"/>
+            </a:solidFill>
+            <a:prstDash val="solid"/>
+            <a:tailEnd type="triangle"/>
+          </a:ln>
+        </p:spPr>
+      </p:sp>
+      <p:sp>
+        <p:nvSpPr>
+          <p:cNvPr id="11" name="S1 arrow 2"/>
+          <p:cNvSpPr/>
+          <p:nvPr/>
+        </p:nvSpPr>
+        <p:spPr>
+          <a:xfrm>
+            <a:off x="4526280" y="2281428"/>
+            <a:ext cx="320040" cy="0"/>
+          </a:xfrm>
+          <a:prstGeom prst="line">
+            <a:avLst/>
+          </a:prstGeom>
+          <a:noFill/>
+          <a:ln w="15875">
+            <a:solidFill>
+              <a:srgbClr val="000000"/>
+            </a:solidFill>
+            <a:prstDash val="solid"/>
+            <a:tailEnd type="triangle"/>
+          </a:ln>
+        </p:spPr>
+      </p:sp>
+      <p:sp>
+        <p:nvSpPr>
+          <p:cNvPr id="12" name="S1 arrow 3"/>
+          <p:cNvSpPr/>
+          <p:nvPr/>
+        </p:nvSpPr>
+        <p:spPr>
+          <a:xfrm>
+            <a:off x="6355080" y="2281428"/>
+            <a:ext cx="320040" cy="0"/>
+          </a:xfrm>
+          <a:prstGeom prst="line">
+            <a:avLst/>
+          </a:prstGeom>
+          <a:noFill/>
+          <a:ln w="15875">
+            <a:solidFill>
+              <a:srgbClr val="000000"/>
+            </a:solidFill>
+            <a:prstDash val="solid"/>
+            <a:tailEnd type="triangle"/>
+          </a:ln>
+        </p:spPr>
+      </p:sp>
+      <p:sp>
+        <p:nvSpPr>
+          <p:cNvPr id="13" name="Stage 2"/>
+          <p:cNvSpPr/>
+          <p:nvPr/>
+        </p:nvSpPr>
+        <p:spPr>
+          <a:xfrm>
+            <a:off x="411480" y="2816352"/>
+            <a:ext cx="8092440" cy="2441448"/>
+          </a:xfrm>
+          <a:prstGeom prst="rect">
+            <a:avLst/>
+          </a:prstGeom>
+          <a:solidFill>
+            <a:srgbClr val="F2F2F2"/>
+          </a:solidFill>
+          <a:ln/>
+        </p:spPr>
+      </p:sp>
+      <p:sp>
+        <p:nvSpPr>
+          <p:cNvPr id="14" name="Stage 2 label"/>
+          <p:cNvSpPr txBox="1"/>
+          <p:nvPr/>
+        </p:nvSpPr>
+        <p:spPr>
+          <a:xfrm>
+            <a:off x="521208" y="2862072"/>
+            <a:ext cx="7872984" cy="274320"/>
+          </a:xfrm>
+          <a:prstGeom prst="rect">
+            <a:avLst/>
+          </a:prstGeom>
+          <a:noFill/>
+          <a:ln/>
+        </p:spPr>
+        <p:txBody>
+          <a:bodyPr wrap="square" lIns="0" tIns="0" rIns="0" bIns="0" rtlCol="0" anchor="ctr"/>
+          <a:lstStyle/>
+          <a:p>
+            <a:pPr indent="0" marL="0">
+              <a:buNone/>
+            </a:pPr>
+            <a:r>
+              <a:rPr lang="en-US" sz="1300" b="1" dirty="0">
+                <a:solidFill>
+                  <a:schemeClr val="tx1"/>
+                </a:solidFill>
+              </a:rPr>
+              <a:t>Stage 2 · Student training on single trials</a:t>
+            </a:r>
+            <a:endParaRPr lang="en-US" sz="1300" dirty="0"/>
+          </a:p>
+        </p:txBody>
+      </p:sp>
+      <p:sp>
+        <p:nvSpPr>
+          <p:cNvPr id="15" name="Single trial"/>
+          <p:cNvSpPr/>
+          <p:nvPr/>
+        </p:nvSpPr>
+        <p:spPr>
+          <a:xfrm>
+            <a:off x="548640" y="3172968"/>
+            <a:ext cx="1828800" cy="548640"/>
+          </a:xfrm>
+          <a:prstGeom prst="rect">
+            <a:avLst/>
+          </a:prstGeom>
+          <a:solidFill>
+            <a:srgbClr val="FFFFFF"/>
+          </a:solidFill>
+          <a:ln w="12700">
+            <a:solidFill>
+              <a:srgbClr val="000000"/>
+            </a:solidFill>
+            <a:prstDash val="solid"/>
+          </a:ln>
+        </p:spPr>
+        <p:txBody>
+          <a:bodyPr wrap="square" lIns="25400" tIns="25400" rIns="25400" bIns="25400" rtlCol="0" anchor="ctr"/>
+          <a:lstStyle/>
+          <a:p>
+            <a:pPr algn="ctr" indent="0" marL="0">
+              <a:buNone/>
+            </a:pPr>
+            <a:r>
+              <a:rPr lang="en-US" sz="1300" b="1" dirty="0">
+                <a:solidFill>
+                  <a:srgbClr val="000000"/>
+                </a:solidFill>
+              </a:rPr>
+              <a:t>Single trial x</a:t>
+            </a:r>
+            <a:endParaRPr lang="en-US" sz="1300" dirty="0"/>
+          </a:p>
+          <a:p>
+            <a:pPr algn="ctr" indent="0" marL="0">
+              <a:buNone/>
+            </a:pPr>
+            <a:r>
+              <a:rPr lang="en-US" sz="1150" dirty="0">
+                <a:solidFill>
+                  <a:srgbClr val="262626"/>
+                </a:solidFill>
+              </a:rPr>
+              <a:t>21 channels × 58 samples</a:t>
+            </a:r>
+            <a:endParaRPr lang="en-US" sz="1300" dirty="0"/>
+          </a:p>
+        </p:txBody>
+      </p:sp>
+      <p:sp>
+        <p:nvSpPr>
+          <p:cNvPr id="16" name="Encoder"/>
+          <p:cNvSpPr/>
+          <p:nvPr/>
+        </p:nvSpPr>
+        <p:spPr>
+          <a:xfrm>
+            <a:off x="2697480" y="3172968"/>
+            <a:ext cx="1828800" cy="548640"/>
+          </a:xfrm>
+          <a:prstGeom prst="rect">
+            <a:avLst/>
+          </a:prstGeom>
+          <a:solidFill>
+            <a:srgbClr val="FFFFFF"/>
+          </a:solidFill>
+          <a:ln w="12700">
+            <a:solidFill>
+              <a:srgbClr val="000000"/>
+            </a:solidFill>
+            <a:prstDash val="solid"/>
+          </a:ln>
+        </p:spPr>
+        <p:txBody>
+          <a:bodyPr wrap="square" lIns="25400" tIns="25400" rIns="25400" bIns="25400" rtlCol="0" anchor="ctr"/>
+          <a:lstStyle/>
+          <a:p>
+            <a:pPr algn="ctr" indent="0" marL="0">
+              <a:buNone/>
+            </a:pPr>
+            <a:r>
+              <a:rPr lang="en-US" sz="1300" b="1" dirty="0">
+                <a:solidFill>
+                  <a:srgbClr val="000000"/>
+                </a:solidFill>
+              </a:rPr>
+              <a:t>EEGNet encoder</a:t>
+            </a:r>
+            <a:endParaRPr lang="en-US" sz="1300" dirty="0"/>
+          </a:p>
+          <a:p>
+            <a:pPr algn="ctr" indent="0" marL="0">
+              <a:buNone/>
+            </a:pPr>
+            <a:r>
+              <a:rPr lang="en-US" sz="1150" dirty="0">
+                <a:solidFill>
+                  <a:srgbClr val="262626"/>
+                </a:solidFill>
+              </a:rPr>
+              <a:t>temporal + spatial filters</a:t>
+            </a:r>
+            <a:endParaRPr lang="en-US" sz="1300" dirty="0"/>
+          </a:p>
+        </p:txBody>
+      </p:sp>
+      <p:sp>
+        <p:nvSpPr>
+          <p:cNvPr id="17" name="Classifier"/>
+          <p:cNvSpPr/>
+          <p:nvPr/>
+        </p:nvSpPr>
+        <p:spPr>
+          <a:xfrm>
+            <a:off x="4846320" y="3172968"/>
+            <a:ext cx="1508760" cy="548640"/>
+          </a:xfrm>
+          <a:prstGeom prst="rect">
+            <a:avLst/>
+          </a:prstGeom>
+          <a:solidFill>
+            <a:srgbClr val="FFFFFF"/>
+          </a:solidFill>
+          <a:ln w="12700">
+            <a:solidFill>
+              <a:srgbClr val="000000"/>
+            </a:solidFill>
+            <a:prstDash val="solid"/>
+          </a:ln>
+        </p:spPr>
+        <p:txBody>
+          <a:bodyPr wrap="square" lIns="25400" tIns="25400" rIns="25400" bIns="25400" rtlCol="0" anchor="ctr"/>
+          <a:lstStyle/>
+          <a:p>
+            <a:pPr algn="ctr" indent="0" marL="0">
+              <a:buNone/>
+            </a:pPr>
+            <a:r>
+              <a:rPr lang="en-US" sz="1300" b="1" dirty="0">
+                <a:solidFill>
+                  <a:srgbClr val="000000"/>
+                </a:solidFill>
+              </a:rPr>
+              <a:t>Classifier</a:t>
+            </a:r>
+            <a:endParaRPr lang="en-US" sz="1300" dirty="0"/>
+          </a:p>
+          <a:p>
+            <a:pPr algn="ctr" indent="0" marL="0">
+              <a:buNone/>
+            </a:pPr>
+            <a:r>
+              <a:rPr lang="en-US" sz="1150" dirty="0">
+                <a:solidFill>
+                  <a:srgbClr val="262626"/>
+                </a:solidFill>
+              </a:rPr>
+              <a:t>student logits</a:t>
+            </a:r>
+            <a:endParaRPr lang="en-US" sz="1300" dirty="0"/>
+          </a:p>
+        </p:txBody>
+      </p:sp>
+      <p:sp>
+        <p:nvSpPr>
+          <p:cNvPr id="18" name="L_CE"/>
+          <p:cNvSpPr/>
+          <p:nvPr/>
+        </p:nvSpPr>
+        <p:spPr>
+          <a:xfrm>
+            <a:off x="6675120" y="3172968"/>
+            <a:ext cx="1691640" cy="548640"/>
+          </a:xfrm>
+          <a:prstGeom prst="rect">
+            <a:avLst/>
+          </a:prstGeom>
+          <a:solidFill>
+            <a:srgbClr val="FBEDED"/>
+          </a:solidFill>
+          <a:ln w="12700">
+            <a:solidFill>
+              <a:srgbClr val="A00000"/>
+            </a:solidFill>
+            <a:prstDash val="solid"/>
+          </a:ln>
+        </p:spPr>
+        <p:txBody>
+          <a:bodyPr wrap="square" lIns="25400" tIns="25400" rIns="25400" bIns="25400" rtlCol="0" anchor="ctr"/>
+          <a:lstStyle/>
+          <a:p>
+            <a:pPr algn="ctr" indent="0" marL="0">
+              <a:buNone/>
+            </a:pPr>
+            <a:r>
+              <a:rPr lang="en-US" sz="1300" b="1" dirty="0">
+                <a:solidFill>
+                  <a:srgbClr val="000000"/>
+                </a:solidFill>
+              </a:rPr>
+              <a:t>L</a:t>
+            </a:r>
+            <a:pPr algn="ctr" indent="0" marL="0">
+              <a:buNone/>
+            </a:pPr>
+            <a:r>
+              <a:rPr lang="en-US" sz="1300" b="1" baseline="-40000" dirty="0">
+                <a:solidFill>
+                  <a:srgbClr val="000000"/>
+                </a:solidFill>
+              </a:rPr>
+              <a:t>CE</a:t>
+            </a:r>
+            <a:endParaRPr lang="en-US" sz="1300" dirty="0"/>
+          </a:p>
+          <a:p>
+            <a:pPr algn="ctr" indent="0" marL="0">
+              <a:buNone/>
+            </a:pPr>
+            <a:r>
+              <a:rPr lang="en-US" sz="1150" dirty="0">
+                <a:solidFill>
+                  <a:srgbClr val="262626"/>
+                </a:solidFill>
+              </a:rPr>
+              <a:t>single-trial label y</a:t>
+            </a:r>
+            <a:endParaRPr lang="en-US" sz="1300" dirty="0"/>
+          </a:p>
+        </p:txBody>
+      </p:sp>
+      <p:sp>
+        <p:nvSpPr>
+          <p:cNvPr id="19" name="Decoder"/>
+          <p:cNvSpPr/>
+          <p:nvPr/>
+        </p:nvSpPr>
+        <p:spPr>
+          <a:xfrm>
+            <a:off x="2697480" y="3904488"/>
+            <a:ext cx="1828800" cy="548640"/>
+          </a:xfrm>
+          <a:prstGeom prst="rect">
+            <a:avLst/>
+          </a:prstGeom>
+          <a:solidFill>
+            <a:srgbClr val="FFFFFF"/>
+          </a:solidFill>
+          <a:ln w="12700">
+            <a:solidFill>
+              <a:srgbClr val="000000"/>
+            </a:solidFill>
+            <a:prstDash val="dash"/>
+          </a:ln>
+        </p:spPr>
+        <p:txBody>
+          <a:bodyPr wrap="square" lIns="25400" tIns="25400" rIns="25400" bIns="25400" rtlCol="0" anchor="ctr"/>
+          <a:lstStyle/>
+          <a:p>
+            <a:pPr algn="ctr" indent="0" marL="0">
+              <a:buNone/>
+            </a:pPr>
+            <a:r>
+              <a:rPr lang="en-US" sz="1300" b="1" dirty="0">
+                <a:solidFill>
+                  <a:srgbClr val="000000"/>
+                </a:solidFill>
+              </a:rPr>
+              <a:t>Linear ERP decoder</a:t>
+            </a:r>
+            <a:endParaRPr lang="en-US" sz="1300" dirty="0"/>
+          </a:p>
+          <a:p>
+            <a:pPr algn="ctr" indent="0" marL="0">
+              <a:buNone/>
+            </a:pPr>
+            <a:r>
+              <a:rPr lang="en-US" sz="1150" dirty="0">
+                <a:solidFill>
+                  <a:srgbClr val="262626"/>
+                </a:solidFill>
+              </a:rPr>
+              <a:t>training only</a:t>
+            </a:r>
+            <a:endParaRPr lang="en-US" sz="1300" dirty="0"/>
+          </a:p>
+        </p:txBody>
+      </p:sp>
+      <p:sp>
+        <p:nvSpPr>
+          <p:cNvPr id="20" name="Reconstruction"/>
+          <p:cNvSpPr/>
+          <p:nvPr/>
+        </p:nvSpPr>
+        <p:spPr>
+          <a:xfrm>
+            <a:off x="4846320" y="3904488"/>
+            <a:ext cx="1508760" cy="548640"/>
+          </a:xfrm>
+          <a:prstGeom prst="rect">
+            <a:avLst/>
+          </a:prstGeom>
+          <a:solidFill>
+            <a:srgbClr val="FFFFFF"/>
+          </a:solidFill>
+          <a:ln w="12700">
+            <a:solidFill>
+              <a:srgbClr val="000000"/>
+            </a:solidFill>
+            <a:prstDash val="solid"/>
+          </a:ln>
+        </p:spPr>
+        <p:txBody>
+          <a:bodyPr wrap="square" lIns="25400" tIns="25400" rIns="25400" bIns="25400" rtlCol="0" anchor="ctr"/>
+          <a:lstStyle/>
+          <a:p>
+            <a:pPr algn="ctr" indent="0" marL="0">
+              <a:buNone/>
+            </a:pPr>
+            <a:r>
+              <a:rPr lang="en-US" sz="1300" b="1" dirty="0">
+                <a:solidFill>
+                  <a:srgbClr val="000000"/>
+                </a:solidFill>
+              </a:rPr>
+              <a:t>Reconstruction x̂</a:t>
+            </a:r>
+            <a:endParaRPr lang="en-US" sz="1300" dirty="0"/>
+          </a:p>
+          <a:p>
+            <a:pPr algn="ctr" indent="0" marL="0">
+              <a:buNone/>
+            </a:pPr>
+            <a:r>
+              <a:rPr lang="en-US" sz="1150" dirty="0">
+                <a:solidFill>
+                  <a:srgbClr val="262626"/>
+                </a:solidFill>
+              </a:rPr>
+              <a:t>channels × time</a:t>
+            </a:r>
+            <a:endParaRPr lang="en-US" sz="1300" dirty="0"/>
+          </a:p>
+        </p:txBody>
+      </p:sp>
+      <p:sp>
+        <p:nvSpPr>
+          <p:cNvPr id="21" name="L_N2N"/>
+          <p:cNvSpPr/>
+          <p:nvPr/>
+        </p:nvSpPr>
+        <p:spPr>
+          <a:xfrm>
+            <a:off x="6675120" y="3904488"/>
+            <a:ext cx="1691640" cy="548640"/>
+          </a:xfrm>
+          <a:prstGeom prst="rect">
+            <a:avLst/>
+          </a:prstGeom>
+          <a:solidFill>
+            <a:srgbClr val="FBEDED"/>
+          </a:solidFill>
+          <a:ln w="12700">
+            <a:solidFill>
+              <a:srgbClr val="A00000"/>
+            </a:solidFill>
+            <a:prstDash val="solid"/>
+          </a:ln>
+        </p:spPr>
+        <p:txBody>
+          <a:bodyPr wrap="square" lIns="25400" tIns="25400" rIns="25400" bIns="25400" rtlCol="0" anchor="ctr"/>
+          <a:lstStyle/>
+          <a:p>
+            <a:pPr algn="ctr" indent="0" marL="0">
+              <a:buNone/>
+            </a:pPr>
+            <a:r>
+              <a:rPr lang="en-US" sz="1300" b="1" dirty="0">
+                <a:solidFill>
+                  <a:srgbClr val="000000"/>
+                </a:solidFill>
+              </a:rPr>
+              <a:t>L</a:t>
+            </a:r>
+            <a:pPr algn="ctr" indent="0" marL="0">
+              <a:buNone/>
+            </a:pPr>
+            <a:r>
+              <a:rPr lang="en-US" sz="1300" b="1" baseline="-40000" dirty="0">
+                <a:solidFill>
+                  <a:srgbClr val="000000"/>
+                </a:solidFill>
+              </a:rPr>
+              <a:t>N2N</a:t>
+            </a:r>
+            <a:pPr algn="ctr" indent="0" marL="0">
+              <a:buNone/>
+            </a:pPr>
+            <a:r>
+              <a:rPr lang="en-US" sz="1300" b="1" dirty="0">
+                <a:solidFill>
+                  <a:srgbClr val="000000"/>
+                </a:solidFill>
+              </a:rPr>
+              <a:t> = ‖x̂ − ā‖</a:t>
+            </a:r>
+            <a:pPr algn="ctr" indent="0" marL="0">
+              <a:buNone/>
+            </a:pPr>
+            <a:r>
+              <a:rPr lang="en-US" sz="1300" b="1" baseline="30000" dirty="0">
+                <a:solidFill>
+                  <a:srgbClr val="000000"/>
+                </a:solidFill>
+              </a:rPr>
+              <a:t>2</a:t>
+            </a:r>
+            <a:endParaRPr lang="en-US" sz="1300" dirty="0"/>
+          </a:p>
+          <a:p>
+            <a:pPr algn="ctr" indent="0" marL="0">
+              <a:buNone/>
+            </a:pPr>
+            <a:r>
+              <a:rPr lang="en-US" sz="1150" dirty="0">
+                <a:solidFill>
+                  <a:srgbClr val="262626"/>
+                </a:solidFill>
+              </a:rPr>
+              <a:t>ā: group average without x</a:t>
+            </a:r>
+            <a:endParaRPr lang="en-US" sz="1300" dirty="0"/>
+          </a:p>
+        </p:txBody>
+      </p:sp>
+      <p:sp>
+        <p:nvSpPr>
+          <p:cNvPr id="22" name="Frozen teacher 2"/>
+          <p:cNvSpPr/>
+          <p:nvPr/>
+        </p:nvSpPr>
+        <p:spPr>
+          <a:xfrm>
+            <a:off x="4846320" y="4617720"/>
+            <a:ext cx="1508760" cy="548640"/>
+          </a:xfrm>
+          <a:prstGeom prst="rect">
+            <a:avLst/>
+          </a:prstGeom>
+          <a:solidFill>
+            <a:srgbClr val="FFFFFF"/>
+          </a:solidFill>
+          <a:ln w="12700">
+            <a:solidFill>
+              <a:srgbClr val="A00000"/>
+            </a:solidFill>
+            <a:prstDash val="solid"/>
+          </a:ln>
+        </p:spPr>
+        <p:txBody>
+          <a:bodyPr wrap="square" lIns="25400" tIns="25400" rIns="25400" bIns="25400" rtlCol="0" anchor="ctr"/>
+          <a:lstStyle/>
+          <a:p>
+            <a:pPr algn="ctr" indent="0" marL="0">
+              <a:buNone/>
+            </a:pPr>
+            <a:r>
+              <a:rPr lang="en-US" sz="1300" b="1" dirty="0">
+                <a:solidFill>
+                  <a:srgbClr val="000000"/>
+                </a:solidFill>
+              </a:rPr>
+              <a:t>Frozen teacher T</a:t>
+            </a:r>
+            <a:endParaRPr lang="en-US" sz="1300" dirty="0"/>
+          </a:p>
+          <a:p>
+            <a:pPr algn="ctr" indent="0" marL="0">
+              <a:buNone/>
+            </a:pPr>
+            <a:r>
+              <a:rPr lang="en-US" sz="1150" dirty="0">
+                <a:solidFill>
+                  <a:srgbClr val="262626"/>
+                </a:solidFill>
+              </a:rPr>
+              <a:t>judges x̂</a:t>
+            </a:r>
+            <a:endParaRPr lang="en-US" sz="1300" dirty="0"/>
+          </a:p>
+        </p:txBody>
+      </p:sp>
+      <p:sp>
+        <p:nvSpPr>
+          <p:cNvPr id="23" name="L_critic"/>
+          <p:cNvSpPr/>
+          <p:nvPr/>
+        </p:nvSpPr>
+        <p:spPr>
+          <a:xfrm>
+            <a:off x="6675120" y="4617720"/>
+            <a:ext cx="1691640" cy="548640"/>
+          </a:xfrm>
+          <a:prstGeom prst="rect">
+            <a:avLst/>
+          </a:prstGeom>
+          <a:solidFill>
+            <a:srgbClr val="FBEDED"/>
+          </a:solidFill>
+          <a:ln w="12700">
+            <a:solidFill>
+              <a:srgbClr val="A00000"/>
+            </a:solidFill>
+            <a:prstDash val="solid"/>
+          </a:ln>
+        </p:spPr>
+        <p:txBody>
+          <a:bodyPr wrap="square" lIns="25400" tIns="25400" rIns="25400" bIns="25400" rtlCol="0" anchor="ctr"/>
+          <a:lstStyle/>
+          <a:p>
+            <a:pPr algn="ctr" indent="0" marL="0">
+              <a:buNone/>
+            </a:pPr>
+            <a:r>
+              <a:rPr lang="en-US" sz="1300" b="1" dirty="0">
+                <a:solidFill>
+                  <a:srgbClr val="000000"/>
+                </a:solidFill>
+              </a:rPr>
+              <a:t>L</a:t>
+            </a:r>
+            <a:pPr algn="ctr" indent="0" marL="0">
+              <a:buNone/>
+            </a:pPr>
+            <a:r>
+              <a:rPr lang="en-US" sz="1300" b="1" baseline="-40000" dirty="0">
+                <a:solidFill>
+                  <a:srgbClr val="000000"/>
+                </a:solidFill>
+              </a:rPr>
+              <a:t>critic</a:t>
+            </a:r>
+            <a:endParaRPr lang="en-US" sz="1300" dirty="0"/>
+          </a:p>
+          <a:p>
+            <a:pPr algn="ctr" indent="0" marL="0">
+              <a:buNone/>
+            </a:pPr>
+            <a:r>
+              <a:rPr lang="en-US" sz="1150" dirty="0">
+                <a:solidFill>
+                  <a:srgbClr val="262626"/>
+                </a:solidFill>
+              </a:rPr>
+              <a:t>CE(T(x̂), y) + KL</a:t>
+            </a:r>
+            <a:endParaRPr lang="en-US" sz="1300" dirty="0"/>
+          </a:p>
+        </p:txBody>
+      </p:sp>
+      <p:sp>
+        <p:nvSpPr>
+          <p:cNvPr id="24" name="S2 x-enc"/>
+          <p:cNvSpPr/>
+          <p:nvPr/>
+        </p:nvSpPr>
+        <p:spPr>
+          <a:xfrm>
+            <a:off x="2377440" y="3447288"/>
+            <a:ext cx="320040" cy="0"/>
+          </a:xfrm>
+          <a:prstGeom prst="line">
+            <a:avLst/>
+          </a:prstGeom>
+          <a:noFill/>
+          <a:ln w="15875">
+            <a:solidFill>
+              <a:srgbClr val="000000"/>
+            </a:solidFill>
+            <a:prstDash val="solid"/>
+            <a:tailEnd type="triangle"/>
+          </a:ln>
+        </p:spPr>
+      </p:sp>
+      <p:sp>
+        <p:nvSpPr>
+          <p:cNvPr id="25" name="S2 enc-cls"/>
+          <p:cNvSpPr/>
+          <p:nvPr/>
+        </p:nvSpPr>
+        <p:spPr>
+          <a:xfrm>
+            <a:off x="4526280" y="3447288"/>
+            <a:ext cx="320040" cy="0"/>
+          </a:xfrm>
+          <a:prstGeom prst="line">
+            <a:avLst/>
+          </a:prstGeom>
+          <a:noFill/>
+          <a:ln w="15875">
+            <a:solidFill>
+              <a:srgbClr val="000000"/>
+            </a:solidFill>
+            <a:prstDash val="solid"/>
+            <a:tailEnd type="triangle"/>
+          </a:ln>
+        </p:spPr>
+      </p:sp>
+      <p:sp>
+        <p:nvSpPr>
+          <p:cNvPr id="26" name="S2 cls-ce"/>
+          <p:cNvSpPr/>
+          <p:nvPr/>
+        </p:nvSpPr>
+        <p:spPr>
+          <a:xfrm>
+            <a:off x="6355080" y="3447288"/>
+            <a:ext cx="320040" cy="0"/>
+          </a:xfrm>
+          <a:prstGeom prst="line">
+            <a:avLst/>
+          </a:prstGeom>
+          <a:noFill/>
+          <a:ln w="15875">
+            <a:solidFill>
+              <a:srgbClr val="000000"/>
+            </a:solidFill>
+            <a:prstDash val="solid"/>
+            <a:tailEnd type="triangle"/>
+          </a:ln>
+        </p:spPr>
+      </p:sp>
+      <p:sp>
+        <p:nvSpPr>
+          <p:cNvPr id="27" name="S2 enc-dec"/>
+          <p:cNvSpPr/>
+          <p:nvPr/>
+        </p:nvSpPr>
+        <p:spPr>
+          <a:xfrm>
+            <a:off x="3611880" y="3721608"/>
+            <a:ext cx="0" cy="182880"/>
+          </a:xfrm>
+          <a:prstGeom prst="line">
+            <a:avLst/>
+          </a:prstGeom>
+          <a:noFill/>
+          <a:ln w="15875">
+            <a:solidFill>
+              <a:srgbClr val="000000"/>
+            </a:solidFill>
+            <a:prstDash val="solid"/>
+            <a:tailEnd type="triangle"/>
+          </a:ln>
+        </p:spPr>
+      </p:sp>
+      <p:sp>
+        <p:nvSpPr>
+          <p:cNvPr id="28" name="S2 dec-rec"/>
+          <p:cNvSpPr/>
+          <p:nvPr/>
+        </p:nvSpPr>
+        <p:spPr>
+          <a:xfrm>
+            <a:off x="4526280" y="4178808"/>
+            <a:ext cx="320040" cy="0"/>
+          </a:xfrm>
+          <a:prstGeom prst="line">
+            <a:avLst/>
+          </a:prstGeom>
+          <a:noFill/>
+          <a:ln w="15875">
+            <a:solidFill>
+              <a:srgbClr val="000000"/>
+            </a:solidFill>
+            <a:prstDash val="solid"/>
+            <a:tailEnd type="triangle"/>
+          </a:ln>
+        </p:spPr>
+      </p:sp>
+      <p:sp>
+        <p:nvSpPr>
+          <p:cNvPr id="29" name="S2 rec-n2n"/>
+          <p:cNvSpPr/>
+          <p:nvPr/>
+        </p:nvSpPr>
+        <p:spPr>
+          <a:xfrm>
+            <a:off x="6355080" y="4178808"/>
+            <a:ext cx="320040" cy="0"/>
+          </a:xfrm>
+          <a:prstGeom prst="line">
+            <a:avLst/>
+          </a:prstGeom>
+          <a:noFill/>
+          <a:ln w="15875">
+            <a:solidFill>
+              <a:srgbClr val="000000"/>
+            </a:solidFill>
+            <a:prstDash val="solid"/>
+            <a:tailEnd type="triangle"/>
+          </a:ln>
+        </p:spPr>
+      </p:sp>
+      <p:sp>
+        <p:nvSpPr>
+          <p:cNvPr id="30" name="S2 rec-T"/>
+          <p:cNvSpPr/>
+          <p:nvPr/>
+        </p:nvSpPr>
+        <p:spPr>
+          <a:xfrm>
+            <a:off x="5600700" y="4453128"/>
+            <a:ext cx="0" cy="164592"/>
+          </a:xfrm>
+          <a:prstGeom prst="line">
+            <a:avLst/>
+          </a:prstGeom>
+          <a:noFill/>
+          <a:ln w="15875">
+            <a:solidFill>
+              <a:srgbClr val="000000"/>
+            </a:solidFill>
+            <a:prstDash val="solid"/>
+            <a:tailEnd type="triangle"/>
+          </a:ln>
+        </p:spPr>
+      </p:sp>
+      <p:sp>
+        <p:nvSpPr>
+          <p:cNvPr id="31" name="S2 T-critic"/>
+          <p:cNvSpPr/>
+          <p:nvPr/>
+        </p:nvSpPr>
+        <p:spPr>
+          <a:xfrm>
+            <a:off x="6355080" y="4892040"/>
+            <a:ext cx="320040" cy="0"/>
+          </a:xfrm>
+          <a:prstGeom prst="line">
+            <a:avLst/>
+          </a:prstGeom>
+          <a:noFill/>
+          <a:ln w="15875">
+            <a:solidFill>
+              <a:srgbClr val="000000"/>
+            </a:solidFill>
+            <a:prstDash val="solid"/>
+            <a:tailEnd type="triangle"/>
+          </a:ln>
+        </p:spPr>
+      </p:sp>
+      <p:sp>
+        <p:nvSpPr>
+          <p:cNvPr id="32" name="Total loss"/>
+          <p:cNvSpPr txBox="1"/>
+          <p:nvPr/>
+        </p:nvSpPr>
+        <p:spPr>
+          <a:xfrm>
+            <a:off x="548640" y="3904488"/>
+            <a:ext cx="1965960" cy="640080"/>
+          </a:xfrm>
+          <a:prstGeom prst="rect">
+            <a:avLst/>
+          </a:prstGeom>
+          <a:noFill/>
+          <a:ln/>
+        </p:spPr>
+        <p:txBody>
+          <a:bodyPr wrap="square" lIns="0" tIns="0" rIns="0" bIns="0" rtlCol="0" anchor="ctr"/>
+          <a:lstStyle/>
+          <a:p>
+            <a:pPr indent="0" marL="0">
+              <a:buNone/>
+            </a:pPr>
+            <a:r>
+              <a:rPr lang="en-US" sz="1400" b="1" dirty="0">
+                <a:solidFill>
+                  <a:schemeClr val="accent1"/>
+                </a:solidFill>
+              </a:rPr>
+              <a:t>L = L</a:t>
+            </a:r>
+            <a:pPr indent="0" marL="0">
+              <a:buNone/>
+            </a:pPr>
+            <a:r>
+              <a:rPr lang="en-US" sz="1400" b="1" baseline="-40000" dirty="0">
+                <a:solidFill>
+                  <a:schemeClr val="accent1"/>
+                </a:solidFill>
+              </a:rPr>
+              <a:t>CE</a:t>
+            </a:r>
+            <a:pPr indent="0" marL="0">
+              <a:buNone/>
+            </a:pPr>
+            <a:r>
+              <a:rPr lang="en-US" sz="1400" b="1" dirty="0">
+                <a:solidFill>
+                  <a:schemeClr val="accent1"/>
+                </a:solidFill>
+              </a:rPr>
+              <a:t> + λ</a:t>
+            </a:r>
+            <a:pPr indent="0" marL="0">
+              <a:buNone/>
+            </a:pPr>
+            <a:r>
+              <a:rPr lang="en-US" sz="1400" b="1" baseline="-40000" dirty="0">
+                <a:solidFill>
+                  <a:schemeClr val="accent1"/>
+                </a:solidFill>
+              </a:rPr>
+              <a:t>1</a:t>
+            </a:r>
+            <a:pPr indent="0" marL="0">
+              <a:buNone/>
+            </a:pPr>
+            <a:r>
+              <a:rPr lang="en-US" sz="1400" b="1" dirty="0">
+                <a:solidFill>
+                  <a:schemeClr val="accent1"/>
+                </a:solidFill>
+              </a:rPr>
+              <a:t> L</a:t>
+            </a:r>
+            <a:pPr indent="0" marL="0">
+              <a:buNone/>
+            </a:pPr>
+            <a:r>
+              <a:rPr lang="en-US" sz="1400" b="1" baseline="-40000" dirty="0">
+                <a:solidFill>
+                  <a:schemeClr val="accent1"/>
+                </a:solidFill>
+              </a:rPr>
+              <a:t>N2N</a:t>
+            </a:r>
+            <a:endParaRPr lang="en-US" sz="1400" dirty="0"/>
+          </a:p>
+          <a:p>
+            <a:pPr indent="0" marL="0">
+              <a:buNone/>
+            </a:pPr>
+            <a:r>
+              <a:rPr lang="en-US" sz="1400" b="1" dirty="0">
+                <a:solidFill>
+                  <a:schemeClr val="accent1"/>
+                </a:solidFill>
+              </a:rPr>
+              <a:t>      + λ</a:t>
+            </a:r>
+            <a:pPr indent="0" marL="0">
+              <a:buNone/>
+            </a:pPr>
+            <a:r>
+              <a:rPr lang="en-US" sz="1400" b="1" baseline="-40000" dirty="0">
+                <a:solidFill>
+                  <a:schemeClr val="accent1"/>
+                </a:solidFill>
+              </a:rPr>
+              <a:t>2</a:t>
+            </a:r>
+            <a:pPr indent="0" marL="0">
+              <a:buNone/>
+            </a:pPr>
+            <a:r>
+              <a:rPr lang="en-US" sz="1400" b="1" dirty="0">
+                <a:solidFill>
+                  <a:schemeClr val="accent1"/>
+                </a:solidFill>
+              </a:rPr>
+              <a:t> L</a:t>
+            </a:r>
+            <a:pPr indent="0" marL="0">
+              <a:buNone/>
+            </a:pPr>
+            <a:r>
+              <a:rPr lang="en-US" sz="1400" b="1" baseline="-40000" dirty="0">
+                <a:solidFill>
+                  <a:schemeClr val="accent1"/>
+                </a:solidFill>
+              </a:rPr>
+              <a:t>critic</a:t>
+            </a:r>
+            <a:endParaRPr lang="en-US" sz="1400" dirty="0"/>
+          </a:p>
+        </p:txBody>
+      </p:sp>
+      <p:sp>
+        <p:nvSpPr>
+          <p:cNvPr id="33" name="Total loss note"/>
+          <p:cNvSpPr txBox="1"/>
+          <p:nvPr/>
+        </p:nvSpPr>
+        <p:spPr>
+          <a:xfrm>
+            <a:off x="548640" y="4590288"/>
+            <a:ext cx="1965960" cy="274320"/>
+          </a:xfrm>
+          <a:prstGeom prst="rect">
+            <a:avLst/>
+          </a:prstGeom>
+          <a:noFill/>
+          <a:ln/>
+        </p:spPr>
+        <p:txBody>
+          <a:bodyPr wrap="square" lIns="0" tIns="0" rIns="0" bIns="0" rtlCol="0" anchor="ctr"/>
+          <a:lstStyle/>
+          <a:p>
+            <a:pPr indent="0" marL="0">
+              <a:buNone/>
+            </a:pPr>
+            <a:r>
+              <a:rPr lang="en-US" sz="1200" dirty="0">
+                <a:solidFill>
+                  <a:schemeClr val="accent3"/>
+                </a:solidFill>
+              </a:rPr>
+              <a:t>λ</a:t>
+            </a:r>
+            <a:pPr indent="0" marL="0">
+              <a:buNone/>
+            </a:pPr>
+            <a:r>
+              <a:rPr lang="en-US" sz="1200" baseline="-40000" dirty="0">
+                <a:solidFill>
+                  <a:schemeClr val="accent3"/>
+                </a:solidFill>
+              </a:rPr>
+              <a:t>1</a:t>
+            </a:r>
+            <a:pPr indent="0" marL="0">
+              <a:buNone/>
+            </a:pPr>
+            <a:r>
+              <a:rPr lang="en-US" sz="1200" dirty="0">
+                <a:solidFill>
+                  <a:schemeClr val="accent3"/>
+                </a:solidFill>
+              </a:rPr>
+              <a:t> = 1,  λ</a:t>
+            </a:r>
+            <a:pPr indent="0" marL="0">
+              <a:buNone/>
+            </a:pPr>
+            <a:r>
+              <a:rPr lang="en-US" sz="1200" baseline="-40000" dirty="0">
+                <a:solidFill>
+                  <a:schemeClr val="accent3"/>
+                </a:solidFill>
+              </a:rPr>
+              <a:t>2</a:t>
+            </a:r>
+            <a:pPr indent="0" marL="0">
+              <a:buNone/>
+            </a:pPr>
+            <a:r>
+              <a:rPr lang="en-US" sz="1200" dirty="0">
+                <a:solidFill>
+                  <a:schemeClr val="accent3"/>
+                </a:solidFill>
+              </a:rPr>
+              <a:t> = 0.5</a:t>
+            </a:r>
+            <a:endParaRPr lang="en-US" sz="1200" dirty="0"/>
+          </a:p>
+        </p:txBody>
+      </p:sp>
+      <p:sp>
+        <p:nvSpPr>
+          <p:cNvPr id="34" name="Inference"/>
+          <p:cNvSpPr/>
+          <p:nvPr/>
+        </p:nvSpPr>
+        <p:spPr>
+          <a:xfrm>
+            <a:off x="411480" y="5394960"/>
+            <a:ext cx="8092440" cy="566928"/>
+          </a:xfrm>
+          <a:prstGeom prst="rect">
+            <a:avLst/>
+          </a:prstGeom>
+          <a:solidFill>
+            <a:srgbClr val="F2F2F2"/>
+          </a:solidFill>
+          <a:ln/>
+        </p:spPr>
+      </p:sp>
+      <p:sp>
+        <p:nvSpPr>
+          <p:cNvPr id="35" name="Inference text"/>
+          <p:cNvSpPr txBox="1"/>
+          <p:nvPr/>
+        </p:nvSpPr>
+        <p:spPr>
+          <a:xfrm>
+            <a:off x="548640" y="5394960"/>
+            <a:ext cx="7863840" cy="566928"/>
+          </a:xfrm>
+          <a:prstGeom prst="rect">
+            <a:avLst/>
+          </a:prstGeom>
+          <a:noFill/>
+          <a:ln/>
+        </p:spPr>
+        <p:txBody>
+          <a:bodyPr wrap="square" lIns="0" tIns="0" rIns="0" bIns="0" rtlCol="0" anchor="ctr"/>
+          <a:lstStyle/>
+          <a:p>
+            <a:pPr indent="0" marL="0">
+              <a:buNone/>
+            </a:pPr>
+            <a:r>
+              <a:rPr lang="en-US" sz="1300" b="1" dirty="0">
+                <a:solidFill>
+                  <a:schemeClr val="tx1"/>
+                </a:solidFill>
+              </a:rPr>
+              <a:t>Inference:  </a:t>
+            </a:r>
+            <a:pPr indent="0" marL="0">
+              <a:buNone/>
+            </a:pPr>
+            <a:r>
+              <a:rPr lang="en-US" sz="1300" dirty="0">
+                <a:solidFill>
+                  <a:schemeClr val="tx1"/>
+                </a:solidFill>
+              </a:rPr>
+              <a:t>single trial x → EEGNet (student) → left→right / right→left.  </a:t>
+            </a:r>
+            <a:pPr indent="0" marL="0">
+              <a:buNone/>
+            </a:pPr>
+            <a:r>
+              <a:rPr lang="en-US" sz="1300" i="1" dirty="0">
+                <a:solidFill>
+                  <a:srgbClr val="262626"/>
+                </a:solidFill>
+              </a:rPr>
+              <a:t>Decoder and teacher are discarded: same cost as the baseline EEGNet.</a:t>
+            </a:r>
+            <a:endParaRPr lang="en-US" sz="1300" dirty="0"/>
+          </a:p>
+        </p:txBody>
+      </p:sp>
+      <p:sp>
+        <p:nvSpPr>
+          <p:cNvPr id="36" name="Key points"/>
+          <p:cNvSpPr txBox="1"/>
+          <p:nvPr/>
+        </p:nvSpPr>
+        <p:spPr>
+          <a:xfrm>
+            <a:off x="8778240" y="1600200"/>
+            <a:ext cx="3108960" cy="4434840"/>
+          </a:xfrm>
+          <a:prstGeom prst="rect">
+            <a:avLst/>
+          </a:prstGeom>
+          <a:noFill/>
+          <a:ln/>
+        </p:spPr>
+        <p:txBody>
+          <a:bodyPr wrap="square" lIns="0" tIns="0" rIns="0" bIns="0" rtlCol="0" anchor="t"/>
+          <a:lstStyle/>
+          <a:p>
+            <a:pPr indent="0" marL="0">
+              <a:buNone/>
+            </a:pPr>
+            <a:r>
+              <a:rPr lang="en-US" sz="1400" b="1" dirty="0">
+                <a:solidFill>
+                  <a:schemeClr val="tx1"/>
+                </a:solidFill>
+              </a:rPr>
+              <a:t>1. Teacher on averages</a:t>
+            </a:r>
+            <a:endParaRPr lang="en-US" sz="1400" dirty="0"/>
+          </a:p>
+          <a:p>
+            <a:pPr indent="0" marL="0">
+              <a:buNone/>
+            </a:pPr>
+            <a:r>
+              <a:rPr lang="en-US" sz="1400" dirty="0">
+                <a:solidFill>
+                  <a:srgbClr val="262626"/>
+                </a:solidFill>
+              </a:rPr>
+              <a:t>Averaging the same group raises the SNR; the teacher learns what the clean aVEP looks like</a:t>
+            </a:r>
+            <a:endParaRPr lang="en-US" sz="1400" dirty="0"/>
+          </a:p>
+          <a:p>
+            <a:pPr indent="0" marL="0">
+              <a:buNone/>
+            </a:pPr>
+            <a:r>
+              <a:rPr lang="en-US" sz="600" dirty="0">
+                <a:solidFill>
+                  <a:schemeClr val="tx1"/>
+                </a:solidFill>
+              </a:rPr>
+              <a:t> </a:t>
+            </a:r>
+            <a:endParaRPr lang="en-US" sz="1400" dirty="0"/>
+          </a:p>
+          <a:p>
+            <a:pPr indent="0" marL="0">
+              <a:buNone/>
+            </a:pPr>
+            <a:r>
+              <a:rPr lang="en-US" sz="1400" b="1" dirty="0">
+                <a:solidFill>
+                  <a:schemeClr val="tx1"/>
+                </a:solidFill>
+              </a:rPr>
+              <a:t>2. Noise2Noise reconstruction</a:t>
+            </a:r>
+            <a:endParaRPr lang="en-US" sz="1400" dirty="0"/>
+          </a:p>
+          <a:p>
+            <a:pPr indent="0" marL="0">
+              <a:buNone/>
+            </a:pPr>
+            <a:r>
+              <a:rPr lang="en-US" sz="1400" dirty="0">
+                <a:solidFill>
+                  <a:srgbClr val="262626"/>
+                </a:solidFill>
+              </a:rPr>
+              <a:t>The target ā never contains x, so the student learns E[ERP | x]: only the part a single trial can recover</a:t>
+            </a:r>
+            <a:endParaRPr lang="en-US" sz="1400" dirty="0"/>
+          </a:p>
+          <a:p>
+            <a:pPr indent="0" marL="0">
+              <a:buNone/>
+            </a:pPr>
+            <a:r>
+              <a:rPr lang="en-US" sz="600" dirty="0">
+                <a:solidFill>
+                  <a:schemeClr val="tx1"/>
+                </a:solidFill>
+              </a:rPr>
+              <a:t> </a:t>
+            </a:r>
+            <a:endParaRPr lang="en-US" sz="1400" dirty="0"/>
+          </a:p>
+          <a:p>
+            <a:pPr indent="0" marL="0">
+              <a:buNone/>
+            </a:pPr>
+            <a:r>
+              <a:rPr lang="en-US" sz="1400" b="1" dirty="0">
+                <a:solidFill>
+                  <a:schemeClr val="tx1"/>
+                </a:solidFill>
+              </a:rPr>
+              <a:t>3. Teacher as critic</a:t>
+            </a:r>
+            <a:endParaRPr lang="en-US" sz="1400" dirty="0"/>
+          </a:p>
+          <a:p>
+            <a:pPr indent="0" marL="0">
+              <a:buNone/>
+            </a:pPr>
+            <a:r>
+              <a:rPr lang="en-US" sz="1400" dirty="0">
+                <a:solidFill>
+                  <a:srgbClr val="262626"/>
+                </a:solidFill>
+              </a:rPr>
+              <a:t>T judges the student's own reconstruction, so the distilled target is always reachable</a:t>
+            </a:r>
+            <a:endParaRPr lang="en-US" sz="1400" dirty="0"/>
+          </a:p>
+          <a:p>
+            <a:pPr indent="0" marL="0">
+              <a:buNone/>
+            </a:pPr>
+            <a:r>
+              <a:rPr lang="en-US" sz="600" dirty="0">
+                <a:solidFill>
+                  <a:schemeClr val="tx1"/>
+                </a:solidFill>
+              </a:rPr>
+              <a:t> </a:t>
+            </a:r>
+            <a:endParaRPr lang="en-US" sz="1400" dirty="0"/>
+          </a:p>
+          <a:p>
+            <a:pPr indent="0" marL="0">
+              <a:buNone/>
+            </a:pPr>
+            <a:r>
+              <a:rPr lang="en-US" sz="1400" b="1" dirty="0">
+                <a:solidFill>
+                  <a:srgbClr val="A00000"/>
+                </a:solidFill>
+              </a:rPr>
+              <a:t>Research positioning</a:t>
+            </a:r>
+            <a:endParaRPr lang="en-US" sz="1400" dirty="0"/>
+          </a:p>
+          <a:p>
+            <a:pPr indent="0" marL="0">
+              <a:buNone/>
+            </a:pPr>
+            <a:r>
+              <a:rPr lang="en-US" sz="1400" b="1" dirty="0">
+                <a:solidFill>
+                  <a:srgbClr val="A00000"/>
+                </a:solidFill>
+              </a:rPr>
+              <a:t>Chapter 1 · within-subject single-trial SNR</a:t>
+            </a:r>
+            <a:endParaRPr lang="en-US" sz="1400" dirty="0"/>
+          </a:p>
+        </p:txBody>
+      </p:sp>
+      <p:sp>
+        <p:nvSpPr>
+          <p:cNvPr id="25" name="Slide Number Placeholder 0"/>
+          <p:cNvSpPr>
+            <a:spLocks noGrp="1"/>
+          </p:cNvSpPr>
+          <p:nvPr>
+            <p:ph type="sldNum" sz="quarter" idx="4294967295"/>
+          </p:nvPr>
+        </p:nvSpPr>
+        <p:spPr>
+          <a:xfrm>
+            <a:off x="11292840" y="6382512"/>
+            <a:ext cx="594360" cy="320040"/>
+          </a:xfrm>
+          <a:prstGeom prst="rect">
+            <a:avLst/>
+          </a:prstGeom>
+          <a:extLst>
+            <a:ext uri="{C572A759-6A51-4108-AA02-DFA0A04FC94B}">
+              <ma14:wrappingTextBoxFlag xmlns:ma14="http://schemas.microsoft.com/office/mac/drawingml/2011/main" val="0"/>
+            </a:ext>
+          </a:extLst>
+        </p:spPr>
+        <p:txBody>
+          <a:bodyPr/>
+          <a:lstStyle>
+            <a:lvl1pPr>
+              <a:defRPr sz="1400">
+                <a:solidFill>
+                  <a:schemeClr val="tx1"/>
+                </a:solidFill>
+              </a:defRPr>
+            </a:lvl1pPr>
+          </a:lstStyle>
+          <a:p>
+            <a:pPr algn="r"/>
+            <a:fld id="{F7021451-1387-4CA6-816F-3879F97B5CBC}" type="slidenum">
+              <a:rPr b="0" lang="en-US"/>
+              <a:t>8</a:t>
+            </a:fld>
+            <a:endParaRPr lang="en-US"/>
+          </a:p>
+        </p:txBody>
+      </p:sp>
+    </p:spTree>
+  </p:cSld>
+  <p:clrMapOvr>
+    <a:masterClrMapping/>
+  </p:clrMapOvr>
+</p:sld>
+</file>
+
+<file path=ppt/slides/slide9.xml><?xml version="1.0" encoding="utf-8"?>
+<p:sld xmlns:a="http://schemas.openxmlformats.org/drawingml/2006/main" xmlns:r="http://schemas.openxmlformats.org/officeDocument/2006/relationships" xmlns:p="http://schemas.openxmlformats.org/presentationml/2006/main">
+  <p:cSld name="Slide 9">
+    <p:spTree>
+      <p:nvGrpSpPr>
+        <p:cNvPr id="1" name=""/>
+        <p:cNvGrpSpPr/>
+        <p:nvPr/>
+      </p:nvGrpSpPr>
+      <p:grpSpPr>
+        <a:xfrm>
+          <a:off x="0" y="0"/>
+          <a:ext cx="0" cy="0"/>
+          <a:chOff x="0" y="0"/>
+          <a:chExt cx="0" cy="0"/>
+        </a:xfrm>
+      </p:grpSpPr>
+      <p:sp>
+        <p:nvSpPr>
+          <p:cNvPr id="2" name="Text 4"/>
+          <p:cNvSpPr/>
+          <p:nvPr>
+            <p:ph idx="104" type="title" hasCustomPrompt="1"/>
+          </p:nvPr>
+        </p:nvSpPr>
+        <p:spPr>
+          <a:xfrm>
+            <a:off x="457200" y="274320"/>
+            <a:ext cx="8001000" cy="749808"/>
+          </a:xfrm>
+          <a:prstGeom prst="rect">
+            <a:avLst/>
+          </a:prstGeom>
+          <a:noFill/>
+          <a:ln/>
+        </p:spPr>
+        <p:txBody>
+          <a:bodyPr wrap="square" lIns="0" tIns="0" rIns="0" bIns="0" rtlCol="0" anchor="ctr"/>
+          <a:lstStyle/>
+          <a:p>
+            <a:pPr algn="l" indent="0" marL="0">
+              <a:buNone/>
+            </a:pPr>
+            <a:r>
+              <a:rPr lang="en-US" sz="2800" b="1" dirty="0">
+                <a:solidFill>
+                  <a:schemeClr val="bg1"/>
+                </a:solidFill>
+              </a:rPr>
+              <a:t>2 Research Progress and Stage Achievements</a:t>
+            </a:r>
+            <a:endParaRPr lang="en-US" sz="2800" dirty="0"/>
+          </a:p>
+        </p:txBody>
+      </p:sp>
+      <p:sp>
+        <p:nvSpPr>
+          <p:cNvPr id="3" name="Lead"/>
+          <p:cNvSpPr txBox="1"/>
+          <p:nvPr/>
+        </p:nvSpPr>
+        <p:spPr>
+          <a:xfrm>
+            <a:off x="548640" y="1161288"/>
+            <a:ext cx="11338560" cy="365760"/>
+          </a:xfrm>
+          <a:prstGeom prst="rect">
+            <a:avLst/>
+          </a:prstGeom>
+          <a:noFill/>
+          <a:ln/>
+        </p:spPr>
+        <p:txBody>
+          <a:bodyPr wrap="square" lIns="0" tIns="0" rIns="0" bIns="0" rtlCol="0" anchor="ctr"/>
+          <a:lstStyle/>
+          <a:p>
+            <a:pPr indent="0" marL="0">
+              <a:buNone/>
+            </a:pPr>
+            <a:r>
+              <a:rPr lang="en-US" sz="1700" dirty="0">
+                <a:solidFill>
+                  <a:schemeClr val="tx1"/>
+                </a:solidFill>
+              </a:rPr>
+              <a:t>Chapter 2 · LR-MoE: experts organized by hemispheric symmetry and latency, chosen by a physiological router</a:t>
+            </a:r>
+            <a:endParaRPr lang="en-US" sz="1700" dirty="0"/>
+          </a:p>
+        </p:txBody>
+      </p:sp>
+      <p:sp>
+        <p:nvSpPr>
+          <p:cNvPr id="4" name="Diagram panel"/>
+          <p:cNvSpPr/>
+          <p:nvPr/>
+        </p:nvSpPr>
+        <p:spPr>
+          <a:xfrm>
+            <a:off x="411480" y="1600200"/>
+            <a:ext cx="8092440" cy="4361688"/>
+          </a:xfrm>
+          <a:prstGeom prst="rect">
+            <a:avLst/>
+          </a:prstGeom>
+          <a:solidFill>
+            <a:srgbClr val="F2F2F2"/>
+          </a:solidFill>
+          <a:ln/>
+        </p:spPr>
+      </p:sp>
+      <p:sp>
+        <p:nvSpPr>
+          <p:cNvPr id="5" name="Input"/>
+          <p:cNvSpPr/>
+          <p:nvPr/>
+        </p:nvSpPr>
+        <p:spPr>
+          <a:xfrm>
+            <a:off x="548640" y="2743200"/>
+            <a:ext cx="1143000" cy="731520"/>
+          </a:xfrm>
+          <a:prstGeom prst="rect">
+            <a:avLst/>
+          </a:prstGeom>
+          <a:solidFill>
+            <a:srgbClr val="FFFFFF"/>
+          </a:solidFill>
+          <a:ln w="12700">
+            <a:solidFill>
+              <a:srgbClr val="000000"/>
+            </a:solidFill>
+            <a:prstDash val="solid"/>
+          </a:ln>
+        </p:spPr>
+        <p:txBody>
+          <a:bodyPr wrap="square" lIns="25400" tIns="25400" rIns="25400" bIns="25400" rtlCol="0" anchor="ctr"/>
+          <a:lstStyle/>
+          <a:p>
+            <a:pPr algn="ctr" indent="0" marL="0">
+              <a:buNone/>
+            </a:pPr>
+            <a:r>
+              <a:rPr lang="en-US" sz="1300" b="1" dirty="0">
+                <a:solidFill>
+                  <a:srgbClr val="000000"/>
+                </a:solidFill>
+              </a:rPr>
+              <a:t>Single</a:t>
+            </a:r>
+            <a:endParaRPr lang="en-US" sz="1300" dirty="0"/>
+          </a:p>
+          <a:p>
+            <a:pPr algn="ctr" indent="0" marL="0">
+              <a:buNone/>
+            </a:pPr>
+            <a:r>
+              <a:rPr lang="en-US" sz="1300" b="1" dirty="0">
+                <a:solidFill>
+                  <a:srgbClr val="000000"/>
+                </a:solidFill>
+              </a:rPr>
+              <a:t>trial x</a:t>
+            </a:r>
+            <a:endParaRPr lang="en-US" sz="1300" dirty="0"/>
+          </a:p>
+        </p:txBody>
+      </p:sp>
+      <p:sp>
+        <p:nvSpPr>
+          <p:cNvPr id="6" name="Decomposition head"/>
+          <p:cNvSpPr txBox="1"/>
+          <p:nvPr/>
+        </p:nvSpPr>
+        <p:spPr>
+          <a:xfrm>
+            <a:off x="1783080" y="1645920"/>
+            <a:ext cx="2240280" cy="292608"/>
+          </a:xfrm>
+          <a:prstGeom prst="rect">
+            <a:avLst/>
+          </a:prstGeom>
+          <a:noFill/>
+          <a:ln/>
+        </p:spPr>
+        <p:txBody>
+          <a:bodyPr wrap="square" lIns="0" tIns="0" rIns="0" bIns="0" rtlCol="0" anchor="ctr"/>
+          <a:lstStyle/>
+          <a:p>
+            <a:pPr algn="ctr" indent="0" marL="0">
+              <a:buNone/>
+            </a:pPr>
+            <a:r>
+              <a:rPr lang="en-US" sz="1300" b="1" dirty="0">
+                <a:solidFill>
+                  <a:schemeClr val="tx1"/>
+                </a:solidFill>
+              </a:rPr>
+              <a:t>Hemispheric decomposition</a:t>
+            </a:r>
+            <a:endParaRPr lang="en-US" sz="1300" dirty="0"/>
+          </a:p>
+        </p:txBody>
+      </p:sp>
+      <p:sp>
+        <p:nvSpPr>
+          <p:cNvPr id="7" name="x_a"/>
+          <p:cNvSpPr/>
+          <p:nvPr/>
+        </p:nvSpPr>
+        <p:spPr>
+          <a:xfrm>
+            <a:off x="1965960" y="2011680"/>
+            <a:ext cx="1874520" cy="777240"/>
+          </a:xfrm>
+          <a:prstGeom prst="rect">
+            <a:avLst/>
+          </a:prstGeom>
+          <a:solidFill>
+            <a:srgbClr val="FFFFFF"/>
+          </a:solidFill>
+          <a:ln w="12700">
+            <a:solidFill>
+              <a:srgbClr val="000000"/>
+            </a:solidFill>
+            <a:prstDash val="solid"/>
+          </a:ln>
+        </p:spPr>
+        <p:txBody>
+          <a:bodyPr wrap="square" lIns="25400" tIns="25400" rIns="25400" bIns="25400" rtlCol="0" anchor="ctr"/>
+          <a:lstStyle/>
+          <a:p>
+            <a:pPr algn="ctr" indent="0" marL="0">
+              <a:buNone/>
+            </a:pPr>
+            <a:r>
+              <a:rPr lang="en-US" sz="1300" b="1" dirty="0">
+                <a:solidFill>
+                  <a:srgbClr val="000000"/>
+                </a:solidFill>
+              </a:rPr>
+              <a:t>x</a:t>
+            </a:r>
+            <a:pPr algn="ctr" indent="0" marL="0">
+              <a:buNone/>
+            </a:pPr>
+            <a:r>
+              <a:rPr lang="en-US" sz="1300" b="1" baseline="-40000" dirty="0">
+                <a:solidFill>
+                  <a:srgbClr val="000000"/>
+                </a:solidFill>
+              </a:rPr>
+              <a:t>a</a:t>
+            </a:r>
+            <a:pPr algn="ctr" indent="0" marL="0">
+              <a:buNone/>
+            </a:pPr>
+            <a:r>
+              <a:rPr lang="en-US" sz="1300" b="1" dirty="0">
+                <a:solidFill>
+                  <a:srgbClr val="000000"/>
+                </a:solidFill>
+              </a:rPr>
+              <a:t> = (x − Mx) / 2</a:t>
+            </a:r>
+            <a:endParaRPr lang="en-US" sz="1300" dirty="0"/>
+          </a:p>
+          <a:p>
+            <a:pPr algn="ctr" indent="0" marL="0">
+              <a:buNone/>
+            </a:pPr>
+            <a:r>
+              <a:rPr lang="en-US" sz="1150" dirty="0">
+                <a:solidFill>
+                  <a:srgbClr val="262626"/>
+                </a:solidFill>
+              </a:rPr>
+              <a:t>antisymmetric: lateralized</a:t>
+            </a:r>
+            <a:endParaRPr lang="en-US" sz="1300" dirty="0"/>
+          </a:p>
+        </p:txBody>
+      </p:sp>
+      <p:sp>
+        <p:nvSpPr>
+          <p:cNvPr id="8" name="x_s"/>
+          <p:cNvSpPr/>
+          <p:nvPr/>
+        </p:nvSpPr>
+        <p:spPr>
+          <a:xfrm>
+            <a:off x="1965960" y="3429000"/>
+            <a:ext cx="1874520" cy="777240"/>
+          </a:xfrm>
+          <a:prstGeom prst="rect">
+            <a:avLst/>
+          </a:prstGeom>
+          <a:solidFill>
+            <a:srgbClr val="FFFFFF"/>
+          </a:solidFill>
+          <a:ln w="12700">
+            <a:solidFill>
+              <a:srgbClr val="000000"/>
+            </a:solidFill>
+            <a:prstDash val="solid"/>
+          </a:ln>
+        </p:spPr>
+        <p:txBody>
+          <a:bodyPr wrap="square" lIns="25400" tIns="25400" rIns="25400" bIns="25400" rtlCol="0" anchor="ctr"/>
+          <a:lstStyle/>
+          <a:p>
+            <a:pPr algn="ctr" indent="0" marL="0">
+              <a:buNone/>
+            </a:pPr>
+            <a:r>
+              <a:rPr lang="en-US" sz="1300" b="1" dirty="0">
+                <a:solidFill>
+                  <a:srgbClr val="000000"/>
+                </a:solidFill>
+              </a:rPr>
+              <a:t>x</a:t>
+            </a:r>
+            <a:pPr algn="ctr" indent="0" marL="0">
+              <a:buNone/>
+            </a:pPr>
+            <a:r>
+              <a:rPr lang="en-US" sz="1300" b="1" baseline="-40000" dirty="0">
+                <a:solidFill>
+                  <a:srgbClr val="000000"/>
+                </a:solidFill>
+              </a:rPr>
+              <a:t>s</a:t>
+            </a:r>
+            <a:pPr algn="ctr" indent="0" marL="0">
+              <a:buNone/>
+            </a:pPr>
+            <a:r>
+              <a:rPr lang="en-US" sz="1300" b="1" dirty="0">
+                <a:solidFill>
+                  <a:srgbClr val="000000"/>
+                </a:solidFill>
+              </a:rPr>
+              <a:t> = (x + Mx) / 2</a:t>
+            </a:r>
+            <a:endParaRPr lang="en-US" sz="1300" dirty="0"/>
+          </a:p>
+          <a:p>
+            <a:pPr algn="ctr" indent="0" marL="0">
+              <a:buNone/>
+            </a:pPr>
+            <a:r>
+              <a:rPr lang="en-US" sz="1150" dirty="0">
+                <a:solidFill>
+                  <a:srgbClr val="262626"/>
+                </a:solidFill>
+              </a:rPr>
+              <a:t>symmetric: shared + context</a:t>
+            </a:r>
+            <a:endParaRPr lang="en-US" sz="1300" dirty="0"/>
+          </a:p>
+        </p:txBody>
+      </p:sp>
+      <p:sp>
+        <p:nvSpPr>
+          <p:cNvPr id="9" name="Mirror note"/>
+          <p:cNvSpPr txBox="1"/>
+          <p:nvPr/>
+        </p:nvSpPr>
+        <p:spPr>
+          <a:xfrm>
+            <a:off x="1554480" y="4251960"/>
+            <a:ext cx="2697480" cy="274320"/>
+          </a:xfrm>
+          <a:prstGeom prst="rect">
+            <a:avLst/>
+          </a:prstGeom>
+          <a:noFill/>
+          <a:ln/>
+        </p:spPr>
+        <p:txBody>
+          <a:bodyPr wrap="square" lIns="0" tIns="0" rIns="0" bIns="0" rtlCol="0" anchor="t"/>
+          <a:lstStyle/>
+          <a:p>
+            <a:pPr algn="ctr" indent="0" marL="0">
+              <a:buNone/>
+            </a:pPr>
+            <a:r>
+              <a:rPr lang="en-US" sz="1100" i="1" dirty="0">
+                <a:solidFill>
+                  <a:schemeClr val="accent5"/>
+                </a:solidFill>
+              </a:rPr>
+              <a:t>M: mirror P7↔P8, PO7↔PO8, O1↔O2, …</a:t>
+            </a:r>
+            <a:endParaRPr lang="en-US" sz="1100" dirty="0"/>
+          </a:p>
+        </p:txBody>
+      </p:sp>
+      <p:sp>
+        <p:nvSpPr>
+          <p:cNvPr id="10" name="Fork in h"/>
+          <p:cNvSpPr/>
+          <p:nvPr/>
+        </p:nvSpPr>
+        <p:spPr>
+          <a:xfrm>
+            <a:off x="1691640" y="3108960"/>
+            <a:ext cx="118872" cy="0"/>
+          </a:xfrm>
+          <a:prstGeom prst="line">
+            <a:avLst/>
+          </a:prstGeom>
+          <a:noFill/>
+          <a:ln w="15875">
+            <a:solidFill>
+              <a:srgbClr val="000000"/>
+            </a:solidFill>
+            <a:prstDash val="solid"/>
+          </a:ln>
+        </p:spPr>
+      </p:sp>
+      <p:sp>
+        <p:nvSpPr>
+          <p:cNvPr id="11" name="Fork in v"/>
+          <p:cNvSpPr/>
+          <p:nvPr/>
+        </p:nvSpPr>
+        <p:spPr>
+          <a:xfrm>
+            <a:off x="1810512" y="2400300"/>
+            <a:ext cx="0" cy="1417320"/>
+          </a:xfrm>
+          <a:prstGeom prst="line">
+            <a:avLst/>
+          </a:prstGeom>
+          <a:noFill/>
+          <a:ln w="15875">
+            <a:solidFill>
+              <a:srgbClr val="000000"/>
+            </a:solidFill>
+            <a:prstDash val="solid"/>
+          </a:ln>
+        </p:spPr>
+      </p:sp>
+      <p:sp>
+        <p:nvSpPr>
+          <p:cNvPr id="12" name="Fork to x_a"/>
+          <p:cNvSpPr/>
+          <p:nvPr/>
+        </p:nvSpPr>
+        <p:spPr>
+          <a:xfrm>
+            <a:off x="1810512" y="2400300"/>
+            <a:ext cx="155448" cy="0"/>
+          </a:xfrm>
+          <a:prstGeom prst="line">
+            <a:avLst/>
+          </a:prstGeom>
+          <a:noFill/>
+          <a:ln w="15875">
+            <a:solidFill>
+              <a:srgbClr val="000000"/>
+            </a:solidFill>
+            <a:prstDash val="solid"/>
+            <a:tailEnd type="triangle"/>
+          </a:ln>
+        </p:spPr>
+      </p:sp>
+      <p:sp>
+        <p:nvSpPr>
+          <p:cNvPr id="13" name="Fork to x_s"/>
+          <p:cNvSpPr/>
+          <p:nvPr/>
+        </p:nvSpPr>
+        <p:spPr>
+          <a:xfrm>
+            <a:off x="1810512" y="3817620"/>
+            <a:ext cx="155448" cy="0"/>
+          </a:xfrm>
+          <a:prstGeom prst="line">
+            <a:avLst/>
+          </a:prstGeom>
+          <a:noFill/>
+          <a:ln w="15875">
+            <a:solidFill>
+              <a:srgbClr val="000000"/>
+            </a:solidFill>
+            <a:prstDash val="solid"/>
+            <a:tailEnd type="triangle"/>
+          </a:ln>
+        </p:spPr>
+      </p:sp>
+      <p:sp>
+        <p:nvSpPr>
+          <p:cNvPr id="14" name="Trunk"/>
+          <p:cNvSpPr/>
+          <p:nvPr/>
+        </p:nvSpPr>
+        <p:spPr>
+          <a:xfrm>
+            <a:off x="4160520" y="2011680"/>
+            <a:ext cx="868680" cy="2194560"/>
+          </a:xfrm>
+          <a:prstGeom prst="rect">
+            <a:avLst/>
+          </a:prstGeom>
+          <a:solidFill>
+            <a:srgbClr val="FFFFFF"/>
+          </a:solidFill>
+          <a:ln w="12700">
+            <a:solidFill>
+              <a:srgbClr val="000000"/>
+            </a:solidFill>
+            <a:prstDash val="solid"/>
+          </a:ln>
+        </p:spPr>
+        <p:txBody>
+          <a:bodyPr wrap="square" lIns="25400" tIns="25400" rIns="25400" bIns="25400" rtlCol="0" anchor="ctr"/>
+          <a:lstStyle/>
+          <a:p>
+            <a:pPr algn="ctr" indent="0" marL="0">
+              <a:buNone/>
+            </a:pPr>
+            <a:r>
+              <a:rPr lang="en-US" sz="1300" b="1" dirty="0">
+                <a:solidFill>
+                  <a:srgbClr val="000000"/>
+                </a:solidFill>
+              </a:rPr>
+              <a:t>Shared</a:t>
+            </a:r>
+            <a:endParaRPr lang="en-US" sz="1300" dirty="0"/>
+          </a:p>
+          <a:p>
+            <a:pPr algn="ctr" indent="0" marL="0">
+              <a:buNone/>
+            </a:pPr>
+            <a:r>
+              <a:rPr lang="en-US" sz="1300" b="1" dirty="0">
+                <a:solidFill>
+                  <a:srgbClr val="000000"/>
+                </a:solidFill>
+              </a:rPr>
+              <a:t>temporal</a:t>
+            </a:r>
+            <a:endParaRPr lang="en-US" sz="1300" dirty="0"/>
+          </a:p>
+          <a:p>
+            <a:pPr algn="ctr" indent="0" marL="0">
+              <a:buNone/>
+            </a:pPr>
+            <a:r>
+              <a:rPr lang="en-US" sz="1300" b="1" dirty="0">
+                <a:solidFill>
+                  <a:srgbClr val="000000"/>
+                </a:solidFill>
+              </a:rPr>
+              <a:t>conv</a:t>
+            </a:r>
+            <a:endParaRPr lang="en-US" sz="1300" dirty="0"/>
+          </a:p>
+        </p:txBody>
+      </p:sp>
+      <p:sp>
+        <p:nvSpPr>
+          <p:cNvPr id="15" name="x_a to trunk"/>
+          <p:cNvSpPr/>
+          <p:nvPr/>
+        </p:nvSpPr>
+        <p:spPr>
+          <a:xfrm>
+            <a:off x="3840480" y="2400300"/>
+            <a:ext cx="320040" cy="0"/>
+          </a:xfrm>
+          <a:prstGeom prst="line">
+            <a:avLst/>
+          </a:prstGeom>
+          <a:noFill/>
+          <a:ln w="15875">
+            <a:solidFill>
+              <a:srgbClr val="000000"/>
+            </a:solidFill>
+            <a:prstDash val="solid"/>
+            <a:tailEnd type="triangle"/>
+          </a:ln>
+        </p:spPr>
+      </p:sp>
+      <p:sp>
+        <p:nvSpPr>
+          <p:cNvPr id="16" name="x_s to trunk"/>
+          <p:cNvSpPr/>
+          <p:nvPr/>
+        </p:nvSpPr>
+        <p:spPr>
+          <a:xfrm>
+            <a:off x="3840480" y="3817620"/>
+            <a:ext cx="320040" cy="0"/>
+          </a:xfrm>
+          <a:prstGeom prst="line">
+            <a:avLst/>
+          </a:prstGeom>
+          <a:noFill/>
+          <a:ln w="15875">
+            <a:solidFill>
+              <a:srgbClr val="000000"/>
+            </a:solidFill>
+            <a:prstDash val="solid"/>
+            <a:tailEnd type="triangle"/>
+          </a:ln>
+        </p:spPr>
+      </p:sp>
+      <p:sp>
+        <p:nvSpPr>
+          <p:cNvPr id="17" name="Experts head"/>
+          <p:cNvSpPr txBox="1"/>
+          <p:nvPr/>
+        </p:nvSpPr>
+        <p:spPr>
+          <a:xfrm>
+            <a:off x="5349240" y="1645920"/>
+            <a:ext cx="2194560" cy="292608"/>
+          </a:xfrm>
+          <a:prstGeom prst="rect">
+            <a:avLst/>
+          </a:prstGeom>
+          <a:noFill/>
+          <a:ln/>
+        </p:spPr>
+        <p:txBody>
+          <a:bodyPr wrap="square" lIns="0" tIns="0" rIns="0" bIns="0" rtlCol="0" anchor="ctr"/>
+          <a:lstStyle/>
+          <a:p>
+            <a:pPr algn="ctr" indent="0" marL="0">
+              <a:buNone/>
+            </a:pPr>
+            <a:r>
+              <a:rPr lang="en-US" sz="1300" b="1" dirty="0">
+                <a:solidFill>
+                  <a:schemeClr val="tx1"/>
+                </a:solidFill>
+              </a:rPr>
+              <a:t>Expert families</a:t>
+            </a:r>
+            <a:endParaRPr lang="en-US" sz="1300" dirty="0"/>
+          </a:p>
+        </p:txBody>
+      </p:sp>
+      <p:sp>
+        <p:nvSpPr>
+          <p:cNvPr id="18" name="Expert 1"/>
+          <p:cNvSpPr/>
+          <p:nvPr/>
+        </p:nvSpPr>
+        <p:spPr>
+          <a:xfrm>
+            <a:off x="5349240" y="2011680"/>
+            <a:ext cx="2194560" cy="685800"/>
+          </a:xfrm>
+          <a:prstGeom prst="rect">
+            <a:avLst/>
+          </a:prstGeom>
+          <a:solidFill>
+            <a:srgbClr val="FFFFFF"/>
+          </a:solidFill>
+          <a:ln w="12700">
+            <a:solidFill>
+              <a:srgbClr val="000000"/>
+            </a:solidFill>
+            <a:prstDash val="solid"/>
+          </a:ln>
+        </p:spPr>
+        <p:txBody>
+          <a:bodyPr wrap="square" lIns="25400" tIns="25400" rIns="25400" bIns="25400" rtlCol="0" anchor="ctr"/>
+          <a:lstStyle/>
+          <a:p>
+            <a:pPr algn="ctr" indent="0" marL="0">
+              <a:buNone/>
+            </a:pPr>
+            <a:r>
+              <a:rPr lang="en-US" sz="1300" b="1" dirty="0">
+                <a:solidFill>
+                  <a:srgbClr val="000000"/>
+                </a:solidFill>
+              </a:rPr>
+              <a:t>Mirror-equivariant (x</a:t>
+            </a:r>
+            <a:pPr algn="ctr" indent="0" marL="0">
+              <a:buNone/>
+            </a:pPr>
+            <a:r>
+              <a:rPr lang="en-US" sz="1300" b="1" baseline="-40000" dirty="0">
+                <a:solidFill>
+                  <a:srgbClr val="000000"/>
+                </a:solidFill>
+              </a:rPr>
+              <a:t>a</a:t>
+            </a:r>
+            <a:pPr algn="ctr" indent="0" marL="0">
+              <a:buNone/>
+            </a:pPr>
+            <a:r>
+              <a:rPr lang="en-US" sz="1300" b="1" dirty="0">
+                <a:solidFill>
+                  <a:srgbClr val="000000"/>
+                </a:solidFill>
+              </a:rPr>
+              <a:t>)</a:t>
+            </a:r>
+            <a:endParaRPr lang="en-US" sz="1300" dirty="0"/>
+          </a:p>
+          <a:p>
+            <a:pPr algn="ctr" indent="0" marL="0">
+              <a:buNone/>
+            </a:pPr>
+            <a:r>
+              <a:rPr lang="en-US" sz="1150" dirty="0">
+                <a:solidFill>
+                  <a:srgbClr val="262626"/>
+                </a:solidFill>
+              </a:rPr>
+              <a:t>logit(Mx) = −logit(x)</a:t>
+            </a:r>
+            <a:endParaRPr lang="en-US" sz="1300" dirty="0"/>
+          </a:p>
+        </p:txBody>
+      </p:sp>
+      <p:sp>
+        <p:nvSpPr>
+          <p:cNvPr id="19" name="Expert 2"/>
+          <p:cNvSpPr/>
+          <p:nvPr/>
+        </p:nvSpPr>
+        <p:spPr>
+          <a:xfrm>
+            <a:off x="5349240" y="2788920"/>
+            <a:ext cx="2194560" cy="685800"/>
+          </a:xfrm>
+          <a:prstGeom prst="rect">
+            <a:avLst/>
+          </a:prstGeom>
+          <a:solidFill>
+            <a:srgbClr val="FFFFFF"/>
+          </a:solidFill>
+          <a:ln w="12700">
+            <a:solidFill>
+              <a:srgbClr val="000000"/>
+            </a:solidFill>
+            <a:prstDash val="solid"/>
+          </a:ln>
+        </p:spPr>
+        <p:txBody>
+          <a:bodyPr wrap="square" lIns="25400" tIns="25400" rIns="25400" bIns="25400" rtlCol="0" anchor="ctr"/>
+          <a:lstStyle/>
+          <a:p>
+            <a:pPr algn="ctr" indent="0" marL="0">
+              <a:buNone/>
+            </a:pPr>
+            <a:r>
+              <a:rPr lang="en-US" sz="1300" b="1" dirty="0">
+                <a:solidFill>
+                  <a:srgbClr val="000000"/>
+                </a:solidFill>
+              </a:rPr>
+              <a:t>Hemisphere-dominant</a:t>
+            </a:r>
+            <a:endParaRPr lang="en-US" sz="1300" dirty="0"/>
+          </a:p>
+          <a:p>
+            <a:pPr algn="ctr" indent="0" marL="0">
+              <a:buNone/>
+            </a:pPr>
+            <a:r>
+              <a:rPr lang="en-US" sz="1150" dirty="0">
+                <a:solidFill>
+                  <a:srgbClr val="262626"/>
+                </a:solidFill>
+              </a:rPr>
+              <a:t>L- or R-weighted, swapped by M</a:t>
+            </a:r>
+            <a:endParaRPr lang="en-US" sz="1300" dirty="0"/>
+          </a:p>
+        </p:txBody>
+      </p:sp>
+      <p:sp>
+        <p:nvSpPr>
+          <p:cNvPr id="20" name="Expert 3"/>
+          <p:cNvSpPr/>
+          <p:nvPr/>
+        </p:nvSpPr>
+        <p:spPr>
+          <a:xfrm>
+            <a:off x="5349240" y="3566160"/>
+            <a:ext cx="2194560" cy="685800"/>
+          </a:xfrm>
+          <a:prstGeom prst="rect">
+            <a:avLst/>
+          </a:prstGeom>
+          <a:solidFill>
+            <a:srgbClr val="FFFFFF"/>
+          </a:solidFill>
+          <a:ln w="12700">
+            <a:solidFill>
+              <a:srgbClr val="000000"/>
+            </a:solidFill>
+            <a:prstDash val="solid"/>
+          </a:ln>
+        </p:spPr>
+        <p:txBody>
+          <a:bodyPr wrap="square" lIns="25400" tIns="25400" rIns="25400" bIns="25400" rtlCol="0" anchor="ctr"/>
+          <a:lstStyle/>
+          <a:p>
+            <a:pPr algn="ctr" indent="0" marL="0">
+              <a:buNone/>
+            </a:pPr>
+            <a:r>
+              <a:rPr lang="en-US" sz="1300" b="1" dirty="0">
+                <a:solidFill>
+                  <a:srgbClr val="000000"/>
+                </a:solidFill>
+              </a:rPr>
+              <a:t>Symmetric / context (x</a:t>
+            </a:r>
+            <a:pPr algn="ctr" indent="0" marL="0">
+              <a:buNone/>
+            </a:pPr>
+            <a:r>
+              <a:rPr lang="en-US" sz="1300" b="1" baseline="-40000" dirty="0">
+                <a:solidFill>
+                  <a:srgbClr val="000000"/>
+                </a:solidFill>
+              </a:rPr>
+              <a:t>s</a:t>
+            </a:r>
+            <a:pPr algn="ctr" indent="0" marL="0">
+              <a:buNone/>
+            </a:pPr>
+            <a:r>
+              <a:rPr lang="en-US" sz="1300" b="1" dirty="0">
+                <a:solidFill>
+                  <a:srgbClr val="000000"/>
+                </a:solidFill>
+              </a:rPr>
+              <a:t>)</a:t>
+            </a:r>
+            <a:endParaRPr lang="en-US" sz="1300" dirty="0"/>
+          </a:p>
+          <a:p>
+            <a:pPr algn="ctr" indent="0" marL="0">
+              <a:buNone/>
+            </a:pPr>
+            <a:r>
+              <a:rPr lang="en-US" sz="1150" dirty="0">
+                <a:solidFill>
+                  <a:srgbClr val="262626"/>
+                </a:solidFill>
+              </a:rPr>
+              <a:t>shared response and overlap</a:t>
+            </a:r>
+            <a:endParaRPr lang="en-US" sz="1300" dirty="0"/>
+          </a:p>
+        </p:txBody>
+      </p:sp>
+      <p:sp>
+        <p:nvSpPr>
+          <p:cNvPr id="21" name="Latency note"/>
+          <p:cNvSpPr txBox="1"/>
+          <p:nvPr/>
+        </p:nvSpPr>
+        <p:spPr>
+          <a:xfrm>
+            <a:off x="4937760" y="4297680"/>
+            <a:ext cx="3017520" cy="274320"/>
+          </a:xfrm>
+          <a:prstGeom prst="rect">
+            <a:avLst/>
+          </a:prstGeom>
+          <a:noFill/>
+          <a:ln/>
+        </p:spPr>
+        <p:txBody>
+          <a:bodyPr wrap="square" lIns="0" tIns="0" rIns="0" bIns="0" rtlCol="0" anchor="t"/>
+          <a:lstStyle/>
+          <a:p>
+            <a:pPr algn="ctr" indent="0" marL="0">
+              <a:buNone/>
+            </a:pPr>
+            <a:r>
+              <a:rPr lang="en-US" sz="1100" i="1" dirty="0">
+                <a:solidFill>
+                  <a:schemeClr val="accent5"/>
+                </a:solidFill>
+              </a:rPr>
+              <a:t>each × 3 latency variants (≈ 100 / 170 / 230 ms)</a:t>
+            </a:r>
+            <a:endParaRPr lang="en-US" sz="1100" dirty="0"/>
+          </a:p>
+        </p:txBody>
+      </p:sp>
+      <p:sp>
+        <p:nvSpPr>
+          <p:cNvPr id="22" name="Trunk out"/>
+          <p:cNvSpPr/>
+          <p:nvPr/>
+        </p:nvSpPr>
+        <p:spPr>
+          <a:xfrm>
+            <a:off x="5029200" y="3131820"/>
+            <a:ext cx="164592" cy="0"/>
+          </a:xfrm>
+          <a:prstGeom prst="line">
+            <a:avLst/>
+          </a:prstGeom>
+          <a:noFill/>
+          <a:ln w="15875">
+            <a:solidFill>
+              <a:srgbClr val="000000"/>
+            </a:solidFill>
+            <a:prstDash val="solid"/>
+          </a:ln>
+        </p:spPr>
+      </p:sp>
+      <p:sp>
+        <p:nvSpPr>
+          <p:cNvPr id="23" name="Expert fork"/>
+          <p:cNvSpPr/>
+          <p:nvPr/>
+        </p:nvSpPr>
+        <p:spPr>
+          <a:xfrm>
+            <a:off x="5193792" y="2354580"/>
+            <a:ext cx="0" cy="1554480"/>
+          </a:xfrm>
+          <a:prstGeom prst="line">
+            <a:avLst/>
+          </a:prstGeom>
+          <a:noFill/>
+          <a:ln w="15875">
+            <a:solidFill>
+              <a:srgbClr val="000000"/>
+            </a:solidFill>
+            <a:prstDash val="solid"/>
+          </a:ln>
+        </p:spPr>
+      </p:sp>
+      <p:sp>
+        <p:nvSpPr>
+          <p:cNvPr id="24" name="To expert 1"/>
+          <p:cNvSpPr/>
+          <p:nvPr/>
+        </p:nvSpPr>
+        <p:spPr>
+          <a:xfrm>
+            <a:off x="5193792" y="2354580"/>
+            <a:ext cx="155448" cy="0"/>
+          </a:xfrm>
+          <a:prstGeom prst="line">
+            <a:avLst/>
+          </a:prstGeom>
+          <a:noFill/>
+          <a:ln w="15875">
+            <a:solidFill>
+              <a:srgbClr val="000000"/>
+            </a:solidFill>
+            <a:prstDash val="solid"/>
+            <a:tailEnd type="triangle"/>
+          </a:ln>
+        </p:spPr>
+      </p:sp>
+      <p:sp>
+        <p:nvSpPr>
+          <p:cNvPr id="25" name="To expert 2"/>
+          <p:cNvSpPr/>
+          <p:nvPr/>
+        </p:nvSpPr>
+        <p:spPr>
+          <a:xfrm>
+            <a:off x="5193792" y="3131820"/>
+            <a:ext cx="155448" cy="0"/>
+          </a:xfrm>
+          <a:prstGeom prst="line">
+            <a:avLst/>
+          </a:prstGeom>
+          <a:noFill/>
+          <a:ln w="15875">
+            <a:solidFill>
+              <a:srgbClr val="000000"/>
+            </a:solidFill>
+            <a:prstDash val="solid"/>
+            <a:tailEnd type="triangle"/>
+          </a:ln>
+        </p:spPr>
+      </p:sp>
+      <p:sp>
+        <p:nvSpPr>
+          <p:cNvPr id="26" name="To expert 3"/>
+          <p:cNvSpPr/>
+          <p:nvPr/>
+        </p:nvSpPr>
+        <p:spPr>
+          <a:xfrm>
+            <a:off x="5193792" y="3909060"/>
+            <a:ext cx="155448" cy="0"/>
+          </a:xfrm>
+          <a:prstGeom prst="line">
+            <a:avLst/>
+          </a:prstGeom>
+          <a:noFill/>
+          <a:ln w="15875">
+            <a:solidFill>
+              <a:srgbClr val="000000"/>
+            </a:solidFill>
+            <a:prstDash val="solid"/>
+            <a:tailEnd type="triangle"/>
+          </a:ln>
+        </p:spPr>
+      </p:sp>
+      <p:sp>
+        <p:nvSpPr>
+          <p:cNvPr id="27" name="From expert 1"/>
+          <p:cNvSpPr/>
+          <p:nvPr/>
+        </p:nvSpPr>
+        <p:spPr>
+          <a:xfrm>
+            <a:off x="7543800" y="2354580"/>
+            <a:ext cx="155448" cy="0"/>
+          </a:xfrm>
+          <a:prstGeom prst="line">
+            <a:avLst/>
+          </a:prstGeom>
+          <a:noFill/>
+          <a:ln w="15875">
+            <a:solidFill>
+              <a:srgbClr val="000000"/>
+            </a:solidFill>
+            <a:prstDash val="solid"/>
+          </a:ln>
+        </p:spPr>
+      </p:sp>
+      <p:sp>
+        <p:nvSpPr>
+          <p:cNvPr id="28" name="From expert 2"/>
+          <p:cNvSpPr/>
+          <p:nvPr/>
+        </p:nvSpPr>
+        <p:spPr>
+          <a:xfrm>
+            <a:off x="7543800" y="3131820"/>
+            <a:ext cx="155448" cy="0"/>
+          </a:xfrm>
+          <a:prstGeom prst="line">
+            <a:avLst/>
+          </a:prstGeom>
+          <a:noFill/>
+          <a:ln w="15875">
+            <a:solidFill>
+              <a:srgbClr val="000000"/>
+            </a:solidFill>
+            <a:prstDash val="solid"/>
+          </a:ln>
+        </p:spPr>
+      </p:sp>
+      <p:sp>
+        <p:nvSpPr>
+          <p:cNvPr id="29" name="From expert 3"/>
+          <p:cNvSpPr/>
+          <p:nvPr/>
+        </p:nvSpPr>
+        <p:spPr>
+          <a:xfrm>
+            <a:off x="7543800" y="3909060"/>
+            <a:ext cx="155448" cy="0"/>
+          </a:xfrm>
+          <a:prstGeom prst="line">
+            <a:avLst/>
+          </a:prstGeom>
+          <a:noFill/>
+          <a:ln w="15875">
+            <a:solidFill>
+              <a:srgbClr val="000000"/>
+            </a:solidFill>
+            <a:prstDash val="solid"/>
+          </a:ln>
+        </p:spPr>
+      </p:sp>
+      <p:sp>
+        <p:nvSpPr>
+          <p:cNvPr id="30" name="Expert join"/>
+          <p:cNvSpPr/>
+          <p:nvPr/>
+        </p:nvSpPr>
+        <p:spPr>
+          <a:xfrm>
+            <a:off x="7699248" y="2354580"/>
+            <a:ext cx="0" cy="1554480"/>
+          </a:xfrm>
+          <a:prstGeom prst="line">
+            <a:avLst/>
+          </a:prstGeom>
+          <a:noFill/>
+          <a:ln w="15875">
+            <a:solidFill>
+              <a:srgbClr val="000000"/>
+            </a:solidFill>
+            <a:prstDash val="solid"/>
+          </a:ln>
+        </p:spPr>
+      </p:sp>
+      <p:sp>
+        <p:nvSpPr>
+          <p:cNvPr id="31" name="Join to sum"/>
+          <p:cNvSpPr/>
+          <p:nvPr/>
+        </p:nvSpPr>
+        <p:spPr>
+          <a:xfrm>
+            <a:off x="7699248" y="3131820"/>
+            <a:ext cx="182880" cy="0"/>
+          </a:xfrm>
+          <a:prstGeom prst="line">
+            <a:avLst/>
+          </a:prstGeom>
+          <a:noFill/>
+          <a:ln w="15875">
+            <a:solidFill>
+              <a:srgbClr val="000000"/>
+            </a:solidFill>
+            <a:prstDash val="solid"/>
+            <a:tailEnd type="triangle"/>
+          </a:ln>
+        </p:spPr>
+      </p:sp>
+      <p:sp>
+        <p:nvSpPr>
+          <p:cNvPr id="32" name="Weighted sum"/>
+          <p:cNvSpPr/>
+          <p:nvPr/>
+        </p:nvSpPr>
+        <p:spPr>
+          <a:xfrm>
+            <a:off x="7882128" y="2903220"/>
+            <a:ext cx="457200" cy="457200"/>
+          </a:xfrm>
+          <a:prstGeom prst="ellipse">
+            <a:avLst/>
+          </a:prstGeom>
+          <a:solidFill>
+            <a:srgbClr val="FFFFFF"/>
+          </a:solidFill>
+          <a:ln w="12700">
+            <a:solidFill>
+              <a:srgbClr val="000000"/>
+            </a:solidFill>
+          </a:ln>
+        </p:spPr>
+        <p:txBody>
+          <a:bodyPr wrap="square" lIns="0" tIns="0" rIns="0" bIns="0" rtlCol="0" anchor="ctr"/>
+          <a:lstStyle/>
+          <a:p>
+            <a:pPr algn="ctr" indent="0" marL="0">
+              <a:buNone/>
+            </a:pPr>
+            <a:r>
+              <a:rPr lang="en-US" sz="1800" b="1" dirty="0">
+                <a:solidFill>
+                  <a:srgbClr val="000000"/>
+                </a:solidFill>
+              </a:rPr>
+              <a:t>Σ</a:t>
+            </a:r>
+            <a:endParaRPr lang="en-US" sz="1800" dirty="0"/>
+          </a:p>
+        </p:txBody>
+      </p:sp>
+      <p:sp>
+        <p:nvSpPr>
+          <p:cNvPr id="33" name="Sum to output"/>
+          <p:cNvSpPr/>
+          <p:nvPr/>
+        </p:nvSpPr>
+        <p:spPr>
+          <a:xfrm flipV="1">
+            <a:off x="8110728" y="2331720"/>
+            <a:ext cx="0" cy="571500"/>
+          </a:xfrm>
+          <a:prstGeom prst="line">
+            <a:avLst/>
+          </a:prstGeom>
+          <a:noFill/>
+          <a:ln w="15875">
+            <a:solidFill>
+              <a:srgbClr val="000000"/>
+            </a:solidFill>
+            <a:prstDash val="solid"/>
+            <a:tailEnd type="triangle"/>
+          </a:ln>
+        </p:spPr>
+      </p:sp>
+      <p:sp>
+        <p:nvSpPr>
+          <p:cNvPr id="34" name="Output"/>
+          <p:cNvSpPr txBox="1"/>
+          <p:nvPr/>
+        </p:nvSpPr>
+        <p:spPr>
+          <a:xfrm>
+            <a:off x="7607808" y="1984248"/>
+            <a:ext cx="1005840" cy="329184"/>
+          </a:xfrm>
+          <a:prstGeom prst="rect">
+            <a:avLst/>
+          </a:prstGeom>
+          <a:noFill/>
+          <a:ln/>
+        </p:spPr>
+        <p:txBody>
+          <a:bodyPr wrap="square" lIns="0" tIns="0" rIns="0" bIns="0" rtlCol="0" anchor="ctr"/>
+          <a:lstStyle/>
+          <a:p>
+            <a:pPr algn="ctr" indent="0" marL="0">
+              <a:buNone/>
+            </a:pPr>
+            <a:r>
+              <a:rPr lang="en-US" sz="1400" b="1" dirty="0">
+                <a:solidFill>
+                  <a:schemeClr val="tx1"/>
+                </a:solidFill>
+              </a:rPr>
+              <a:t>p(y | x)</a:t>
+            </a:r>
+            <a:endParaRPr lang="en-US" sz="1400" dirty="0"/>
+          </a:p>
+        </p:txBody>
+      </p:sp>
+      <p:sp>
+        <p:nvSpPr>
+          <p:cNvPr id="35" name="Router"/>
+          <p:cNvSpPr/>
+          <p:nvPr/>
+        </p:nvSpPr>
+        <p:spPr>
+          <a:xfrm>
+            <a:off x="548640" y="4864608"/>
+            <a:ext cx="6949440" cy="868680"/>
+          </a:xfrm>
+          <a:prstGeom prst="rect">
+            <a:avLst/>
+          </a:prstGeom>
+          <a:solidFill>
+            <a:srgbClr val="FFFFFF"/>
+          </a:solidFill>
+          <a:ln w="12700">
+            <a:solidFill>
+              <a:srgbClr val="A00000"/>
+            </a:solidFill>
+            <a:prstDash val="dash"/>
+          </a:ln>
+        </p:spPr>
+        <p:txBody>
+          <a:bodyPr wrap="square" lIns="25400" tIns="25400" rIns="25400" bIns="25400" rtlCol="0" anchor="ctr"/>
+          <a:lstStyle/>
+          <a:p>
+            <a:pPr algn="ctr" indent="0" marL="0">
+              <a:buNone/>
+            </a:pPr>
+            <a:r>
+              <a:rPr lang="en-US" sz="1300" b="1" dirty="0">
+                <a:solidFill>
+                  <a:srgbClr val="A00000"/>
+                </a:solidFill>
+              </a:rPr>
+              <a:t>Physiological router: small MLP → soft top-2 expert weights g</a:t>
+            </a:r>
+            <a:endParaRPr lang="en-US" sz="1300" dirty="0"/>
+          </a:p>
+          <a:p>
+            <a:pPr algn="ctr" indent="0" marL="0">
+              <a:buNone/>
+            </a:pPr>
+            <a:r>
+              <a:rPr lang="en-US" sz="1150" dirty="0">
+                <a:solidFill>
+                  <a:srgbClr val="262626"/>
+                </a:solidFill>
+              </a:rPr>
+              <a:t>lateralization index · left/right power ratio · ~10 Hz amplitude &amp; phase (O1, Oz, O2) · antisym./sym. energy ratio</a:t>
+            </a:r>
+            <a:endParaRPr lang="en-US" sz="1300" dirty="0"/>
+          </a:p>
+        </p:txBody>
+      </p:sp>
+      <p:sp>
+        <p:nvSpPr>
+          <p:cNvPr id="36" name="Input to router"/>
+          <p:cNvSpPr/>
+          <p:nvPr/>
+        </p:nvSpPr>
+        <p:spPr>
+          <a:xfrm>
+            <a:off x="1120140" y="3474720"/>
+            <a:ext cx="0" cy="1389888"/>
+          </a:xfrm>
+          <a:prstGeom prst="line">
+            <a:avLst/>
+          </a:prstGeom>
+          <a:noFill/>
+          <a:ln w="15875">
+            <a:solidFill>
+              <a:srgbClr val="A00000"/>
+            </a:solidFill>
+            <a:prstDash val="solid"/>
+            <a:tailEnd type="triangle"/>
+          </a:ln>
+        </p:spPr>
+      </p:sp>
+      <p:sp>
+        <p:nvSpPr>
+          <p:cNvPr id="37" name="Router out h"/>
+          <p:cNvSpPr/>
+          <p:nvPr/>
+        </p:nvSpPr>
+        <p:spPr>
+          <a:xfrm>
+            <a:off x="7498080" y="5298948"/>
+            <a:ext cx="612648" cy="0"/>
+          </a:xfrm>
+          <a:prstGeom prst="line">
+            <a:avLst/>
+          </a:prstGeom>
+          <a:noFill/>
+          <a:ln w="15875">
+            <a:solidFill>
+              <a:srgbClr val="A00000"/>
+            </a:solidFill>
+            <a:prstDash val="solid"/>
+          </a:ln>
+        </p:spPr>
+      </p:sp>
+      <p:sp>
+        <p:nvSpPr>
+          <p:cNvPr id="38" name="Router to sum"/>
+          <p:cNvSpPr/>
+          <p:nvPr/>
+        </p:nvSpPr>
+        <p:spPr>
+          <a:xfrm flipV="1">
+            <a:off x="8110728" y="3360420"/>
+            <a:ext cx="0" cy="1938528"/>
+          </a:xfrm>
+          <a:prstGeom prst="line">
+            <a:avLst/>
+          </a:prstGeom>
+          <a:noFill/>
+          <a:ln w="15875">
+            <a:solidFill>
+              <a:srgbClr val="A00000"/>
+            </a:solidFill>
+            <a:prstDash val="solid"/>
+            <a:tailEnd type="triangle"/>
+          </a:ln>
+        </p:spPr>
+      </p:sp>
+      <p:sp>
+        <p:nvSpPr>
+          <p:cNvPr id="39" name="Gate label"/>
+          <p:cNvSpPr txBox="1"/>
+          <p:nvPr/>
+        </p:nvSpPr>
+        <p:spPr>
+          <a:xfrm>
+            <a:off x="8165592" y="3931920"/>
+            <a:ext cx="274320" cy="320040"/>
+          </a:xfrm>
+          <a:prstGeom prst="rect">
+            <a:avLst/>
+          </a:prstGeom>
+          <a:noFill/>
+          <a:ln/>
+        </p:spPr>
+        <p:txBody>
+          <a:bodyPr wrap="square" lIns="0" tIns="0" rIns="0" bIns="0" rtlCol="0" anchor="ctr"/>
+          <a:lstStyle/>
+          <a:p>
+            <a:pPr indent="0" marL="0">
+              <a:buNone/>
+            </a:pPr>
+            <a:r>
+              <a:rPr lang="en-US" sz="1500" b="1" i="1" dirty="0">
+                <a:solidFill>
+                  <a:schemeClr val="accent1"/>
+                </a:solidFill>
+              </a:rPr>
+              <a:t>g</a:t>
+            </a:r>
+            <a:endParaRPr lang="en-US" sz="1500" dirty="0"/>
+          </a:p>
+        </p:txBody>
+      </p:sp>
+      <p:sp>
+        <p:nvSpPr>
+          <p:cNvPr id="40" name="Key points"/>
+          <p:cNvSpPr txBox="1"/>
+          <p:nvPr/>
+        </p:nvSpPr>
+        <p:spPr>
+          <a:xfrm>
+            <a:off x="8778240" y="1600200"/>
+            <a:ext cx="3108960" cy="4434840"/>
+          </a:xfrm>
+          <a:prstGeom prst="rect">
+            <a:avLst/>
+          </a:prstGeom>
+          <a:noFill/>
+          <a:ln/>
+        </p:spPr>
+        <p:txBody>
+          <a:bodyPr wrap="square" lIns="0" tIns="0" rIns="0" bIns="0" rtlCol="0" anchor="t"/>
+          <a:lstStyle/>
+          <a:p>
+            <a:pPr indent="0" marL="0">
+              <a:buNone/>
+            </a:pPr>
+            <a:r>
+              <a:rPr lang="en-US" sz="1400" b="1" dirty="0">
+                <a:solidFill>
+                  <a:schemeClr val="tx1"/>
+                </a:solidFill>
+              </a:rPr>
+              <a:t>1. Hemispheric decomposition</a:t>
+            </a:r>
+            <a:endParaRPr lang="en-US" sz="1400" dirty="0"/>
+          </a:p>
+          <a:p>
+            <a:pPr indent="0" marL="0">
+              <a:buNone/>
+            </a:pPr>
+            <a:r>
+              <a:rPr lang="en-US" sz="1400" dirty="0">
+                <a:solidFill>
+                  <a:srgbClr val="262626"/>
+                </a:solidFill>
+              </a:rPr>
+              <a:t>Separates lateralized from shared activity; x</a:t>
+            </a:r>
+            <a:pPr indent="0" marL="0">
+              <a:buNone/>
+            </a:pPr>
+            <a:r>
+              <a:rPr lang="en-US" sz="1400" baseline="-40000" dirty="0">
+                <a:solidFill>
+                  <a:srgbClr val="262626"/>
+                </a:solidFill>
+              </a:rPr>
+              <a:t>a</a:t>
+            </a:r>
+            <a:pPr indent="0" marL="0">
+              <a:buNone/>
+            </a:pPr>
+            <a:r>
+              <a:rPr lang="en-US" sz="1400" dirty="0">
+                <a:solidFill>
+                  <a:srgbClr val="262626"/>
+                </a:solidFill>
+              </a:rPr>
+              <a:t> does not depend on the common reference</a:t>
+            </a:r>
+            <a:endParaRPr lang="en-US" sz="1400" dirty="0"/>
+          </a:p>
+          <a:p>
+            <a:pPr indent="0" marL="0">
+              <a:buNone/>
+            </a:pPr>
+            <a:r>
+              <a:rPr lang="en-US" sz="600" dirty="0">
+                <a:solidFill>
+                  <a:schemeClr val="tx1"/>
+                </a:solidFill>
+              </a:rPr>
+              <a:t> </a:t>
+            </a:r>
+            <a:endParaRPr lang="en-US" sz="1400" dirty="0"/>
+          </a:p>
+          <a:p>
+            <a:pPr indent="0" marL="0">
+              <a:buNone/>
+            </a:pPr>
+            <a:r>
+              <a:rPr lang="en-US" sz="1400" b="1" dirty="0">
+                <a:solidFill>
+                  <a:schemeClr val="tx1"/>
+                </a:solidFill>
+              </a:rPr>
+              <a:t>2. Structured experts</a:t>
+            </a:r>
+            <a:endParaRPr lang="en-US" sz="1400" dirty="0"/>
+          </a:p>
+          <a:p>
+            <a:pPr indent="0" marL="0">
+              <a:buNone/>
+            </a:pPr>
+            <a:r>
+              <a:rPr lang="en-US" sz="1400" dirty="0">
+                <a:solidFill>
+                  <a:srgbClr val="262626"/>
+                </a:solidFill>
+              </a:rPr>
+              <a:t>Symmetry type × response latency, matching the observed subject differences</a:t>
+            </a:r>
+            <a:endParaRPr lang="en-US" sz="1400" dirty="0"/>
+          </a:p>
+          <a:p>
+            <a:pPr indent="0" marL="0">
+              <a:buNone/>
+            </a:pPr>
+            <a:r>
+              <a:rPr lang="en-US" sz="600" dirty="0">
+                <a:solidFill>
+                  <a:schemeClr val="tx1"/>
+                </a:solidFill>
+              </a:rPr>
+              <a:t> </a:t>
+            </a:r>
+            <a:endParaRPr lang="en-US" sz="1400" dirty="0"/>
+          </a:p>
+          <a:p>
+            <a:pPr indent="0" marL="0">
+              <a:buNone/>
+            </a:pPr>
+            <a:r>
+              <a:rPr lang="en-US" sz="1400" b="1" dirty="0">
+                <a:solidFill>
+                  <a:schemeClr val="tx1"/>
+                </a:solidFill>
+              </a:rPr>
+              <a:t>3. Physiological router</a:t>
+            </a:r>
+            <a:endParaRPr lang="en-US" sz="1400" dirty="0"/>
+          </a:p>
+          <a:p>
+            <a:pPr indent="0" marL="0">
+              <a:buNone/>
+            </a:pPr>
+            <a:r>
+              <a:rPr lang="en-US" sz="1400" dirty="0">
+                <a:solidFill>
+                  <a:srgbClr val="262626"/>
+                </a:solidFill>
+              </a:rPr>
+              <a:t>Interpretable descriptors pick experts per trial; no target labels needed</a:t>
+            </a:r>
+            <a:endParaRPr lang="en-US" sz="1400" dirty="0"/>
+          </a:p>
+          <a:p>
+            <a:pPr indent="0" marL="0">
+              <a:buNone/>
+            </a:pPr>
+            <a:r>
+              <a:rPr lang="en-US" sz="600" dirty="0">
+                <a:solidFill>
+                  <a:schemeClr val="tx1"/>
+                </a:solidFill>
+              </a:rPr>
+              <a:t> </a:t>
+            </a:r>
+            <a:endParaRPr lang="en-US" sz="1400" dirty="0"/>
+          </a:p>
+          <a:p>
+            <a:pPr indent="0" marL="0">
+              <a:buNone/>
+            </a:pPr>
+            <a:r>
+              <a:rPr lang="en-US" sz="1400" b="1" dirty="0">
+                <a:solidFill>
+                  <a:schemeClr val="tx1"/>
+                </a:solidFill>
+              </a:rPr>
+              <a:t>Training losses</a:t>
+            </a:r>
+            <a:endParaRPr lang="en-US" sz="1400" dirty="0"/>
+          </a:p>
+          <a:p>
+            <a:pPr indent="0" marL="0">
+              <a:buNone/>
+            </a:pPr>
+            <a:r>
+              <a:rPr lang="en-US" sz="1400" dirty="0">
+                <a:solidFill>
+                  <a:srgbClr val="262626"/>
+                </a:solidFill>
+              </a:rPr>
+              <a:t>CE + load balancing + mirror consistency + subject-coherent routing</a:t>
+            </a:r>
+            <a:endParaRPr lang="en-US" sz="1400" dirty="0"/>
+          </a:p>
+          <a:p>
+            <a:pPr indent="0" marL="0">
+              <a:buNone/>
+            </a:pPr>
+            <a:r>
+              <a:rPr lang="en-US" sz="600" dirty="0">
+                <a:solidFill>
+                  <a:schemeClr val="tx1"/>
+                </a:solidFill>
+              </a:rPr>
+              <a:t> </a:t>
+            </a:r>
+            <a:endParaRPr lang="en-US" sz="1400" dirty="0"/>
+          </a:p>
+          <a:p>
+            <a:pPr indent="0" marL="0">
+              <a:buNone/>
+            </a:pPr>
+            <a:r>
+              <a:rPr lang="en-US" sz="1400" b="1" dirty="0">
+                <a:solidFill>
+                  <a:srgbClr val="A00000"/>
+                </a:solidFill>
+              </a:rPr>
+              <a:t>Research positioning</a:t>
+            </a:r>
+            <a:endParaRPr lang="en-US" sz="1400" dirty="0"/>
+          </a:p>
+          <a:p>
+            <a:pPr indent="0" marL="0">
+              <a:buNone/>
+            </a:pPr>
+            <a:r>
+              <a:rPr lang="en-US" sz="1400" b="1" dirty="0">
+                <a:solidFill>
+                  <a:srgbClr val="A00000"/>
+                </a:solidFill>
+              </a:rPr>
+              <a:t>Chapter 2 · cross-subject (LOSO) decoding</a:t>
+            </a:r>
+            <a:endParaRPr lang="en-US" sz="1400" dirty="0"/>
+          </a:p>
+        </p:txBody>
+      </p:sp>
+      <p:sp>
+        <p:nvSpPr>
+          <p:cNvPr id="25" name="Slide Number Placeholder 0"/>
+          <p:cNvSpPr>
+            <a:spLocks noGrp="1"/>
+          </p:cNvSpPr>
+          <p:nvPr>
+            <p:ph type="sldNum" sz="quarter" idx="4294967295"/>
+          </p:nvPr>
+        </p:nvSpPr>
+        <p:spPr>
+          <a:xfrm>
+            <a:off x="11292840" y="6382512"/>
+            <a:ext cx="594360" cy="320040"/>
+          </a:xfrm>
+          <a:prstGeom prst="rect">
+            <a:avLst/>
+          </a:prstGeom>
+          <a:extLst>
+            <a:ext uri="{C572A759-6A51-4108-AA02-DFA0A04FC94B}">
+              <ma14:wrappingTextBoxFlag xmlns:ma14="http://schemas.microsoft.com/office/mac/drawingml/2011/main" val="0"/>
+            </a:ext>
+          </a:extLst>
+        </p:spPr>
+        <p:txBody>
+          <a:bodyPr/>
+          <a:lstStyle>
+            <a:lvl1pPr>
+              <a:defRPr sz="1400">
+                <a:solidFill>
+                  <a:schemeClr val="tx1"/>
+                </a:solidFill>
+              </a:defRPr>
+            </a:lvl1pPr>
+          </a:lstStyle>
+          <a:p>
+            <a:pPr algn="r"/>
+            <a:fld id="{F7021451-1387-4CA6-816F-3879F97B5CBC}" type="slidenum">
+              <a:rPr b="0" lang="en-US"/>
+              <a:t>9</a:t>
+            </a:fld>
+            <a:endParaRPr lang="en-US"/>
+          </a:p>
+        </p:txBody>
+      </p:sp>
+    </p:spTree>
+  </p:cSld>
+  <p:clrMapOvr>
+    <a:masterClrMapping/>
+  </p:clrMapOvr>
+</p:sld>
+</file>
+
 <file path=ppt/theme/theme1.xml><?xml version="1.0" encoding="utf-8"?>
 <a:theme xmlns:a="http://schemas.openxmlformats.org/drawingml/2006/main" name="Thesis Defense">
   <a:themeElements>

</xml_diff>

<commit_message>
Add next-stage research plan: validation of Chapters 1-2 and online robotic arm
Outline slide for part 3, a validation-plan table for RED and LR-MoE, and
the Chapter 3 closed-loop system (aVEP interface, streaming, decoders,
continuous velocity control) with a slot for the preliminary system.

Co-Authored-By: Claude Opus 5.5 <noreply@anthropic.com>
Claude-Session: https://claude.ai/code/session_01M2N1FL6JrZz8kTbkaY5rZ8
</commit_message>
<xml_diff>
--- a/presentation/midterm_defense_sample.pptx
+++ b/presentation/midterm_defense_sample.pptx
@@ -16,9 +16,12 @@
     <p:sldId id="264" r:id="rId10"/>
     <p:sldId id="265" r:id="rId11"/>
     <p:sldId id="266" r:id="rId12"/>
+    <p:sldId id="267" r:id="rId13"/>
+    <p:sldId id="268" r:id="rId14"/>
+    <p:sldId id="269" r:id="rId15"/>
   </p:sldIdLst>
   <p:notesMasterIdLst>
-    <p:notesMasterId r:id="rId13"/>
+    <p:notesMasterId r:id="rId16"/>
   </p:notesMasterIdLst>
   <p:sldSz cx="12192000" cy="6858000"/>
   <p:notesSz cx="6858000" cy="12192000"/>
@@ -117,12 +120,12 @@
   <p:extLst>
     <p:ext uri="{521415D9-36F7-43E2-AB2F-B90AF26B5E84}">
       <p14:sectionLst xmlns:p14="http://schemas.microsoft.com/office/powerpoint/2010/main">
-        <p14:section name="Opening" id="{a3aefa53-0be2-ed51-945c-ae2439e62908}">
+        <p14:section name="Opening" id="{f65439e6-c17b-005b-3be4-4fe3f2e82916}">
           <p14:sldIdLst>
             <p14:sldId id="256"/>
           </p14:sldIdLst>
         </p14:section>
-        <p14:section name="Research Background and Objectives" id="{24114870-df3c-cc28-875b-220ea79cf4c1}">
+        <p14:section name="Research Background and Objectives" id="{d5c9c9e0-8dfe-257a-2598-948dfa2d426f}">
           <p14:sldIdLst>
             <p14:sldId id="257"/>
             <p14:sldId id="258"/>
@@ -130,7 +133,7 @@
             <p14:sldId id="260"/>
           </p14:sldIdLst>
         </p14:section>
-        <p14:section name="Research Progress and Stage Achievements" id="{76c28261-a12e-2d75-06ae-91c7474f93a6}">
+        <p14:section name="Research Progress and Stage Achievements" id="{ae354c8e-1fcd-48f0-f3e2-0d9bd0f25fae}">
           <p14:sldIdLst>
             <p14:sldId id="261"/>
             <p14:sldId id="262"/>
@@ -138,6 +141,13 @@
             <p14:sldId id="264"/>
             <p14:sldId id="265"/>
             <p14:sldId id="266"/>
+          </p14:sldIdLst>
+        </p14:section>
+        <p14:section name="Next-stage Research Plan" id="{a6249486-14aa-1818-b1b6-1ae12c56094a}">
+          <p14:sldIdLst>
+            <p14:sldId id="267"/>
+            <p14:sldId id="268"/>
+            <p14:sldId id="269"/>
           </p14:sldIdLst>
         </p14:section>
       </p14:sectionLst>
@@ -744,6 +754,270 @@
             <a:fld id="{F7021451-1387-4CA6-816F-3879F97B5CBC}" type="slidenum">
               <a:rPr lang="en-US"/>
               <a:t>11</a:t>
+            </a:fld>
+            <a:endParaRPr lang="en-US"/>
+          </a:p>
+        </p:txBody>
+      </p:sp>
+    </p:spTree>
+    <p:extLst>
+      <p:ext uri="{BB962C8B-B14F-4D97-AF65-F5344CB8AC3E}">
+        <p14:creationId xmlns:p14="http://schemas.microsoft.com/office/powerpoint/2010/main" val="1024086991"/>
+      </p:ext>
+    </p:extLst>
+  </p:cSld>
+  <p:clrMapOvr>
+    <a:masterClrMapping/>
+  </p:clrMapOvr>
+</p:notes>
+</file>
+
+<file path=ppt/notesSlides/notesSlide12.xml><?xml version="1.0" encoding="utf-8"?>
+<p:notes xmlns:a="http://schemas.openxmlformats.org/drawingml/2006/main" xmlns:r="http://schemas.openxmlformats.org/officeDocument/2006/relationships" xmlns:p="http://schemas.openxmlformats.org/presentationml/2006/main">
+  <p:cSld>
+    <p:spTree>
+      <p:nvGrpSpPr>
+        <p:cNvPr id="1" name=""/>
+        <p:cNvGrpSpPr/>
+        <p:nvPr/>
+      </p:nvGrpSpPr>
+      <p:grpSpPr>
+        <a:xfrm>
+          <a:off x="0" y="0"/>
+          <a:ext cx="0" cy="0"/>
+          <a:chOff x="0" y="0"/>
+          <a:chExt cx="0" cy="0"/>
+        </a:xfrm>
+      </p:grpSpPr>
+      <p:sp>
+        <p:nvSpPr>
+          <p:cNvPr id="2" name="Slide Image Placeholder 1"/>
+          <p:cNvSpPr>
+            <a:spLocks noGrp="1" noRot="1" noChangeAspect="1"/>
+          </p:cNvSpPr>
+          <p:nvPr>
+            <p:ph type="sldImg"/>
+          </p:nvPr>
+        </p:nvSpPr>
+        <p:spPr/>
+      </p:sp>
+      <p:sp>
+        <p:nvSpPr>
+          <p:cNvPr id="3" name="Notes Placeholder 2"/>
+          <p:cNvSpPr>
+            <a:spLocks noGrp="1"/>
+          </p:cNvSpPr>
+          <p:nvPr>
+            <p:ph type="body" idx="1"/>
+          </p:nvPr>
+        </p:nvSpPr>
+        <p:spPr/>
+        <p:txBody>
+          <a:bodyPr/>
+          <a:lstStyle/>
+          <a:p>
+            <a:r>
+              <a:rPr lang="en-US" dirty="0"/>
+              <a:t>~3 s.</a:t>
+            </a:r>
+            <a:endParaRPr lang="en-US" dirty="0"/>
+          </a:p>
+        </p:txBody>
+      </p:sp>
+      <p:sp>
+        <p:nvSpPr>
+          <p:cNvPr id="4" name="Slide Number Placeholder 3"/>
+          <p:cNvSpPr>
+            <a:spLocks noGrp="1"/>
+          </p:cNvSpPr>
+          <p:nvPr>
+            <p:ph type="sldNum" sz="quarter" idx="10"/>
+          </p:nvPr>
+        </p:nvSpPr>
+        <p:spPr/>
+        <p:txBody>
+          <a:bodyPr/>
+          <a:lstStyle/>
+          <a:p>
+            <a:fld id="{F7021451-1387-4CA6-816F-3879F97B5CBC}" type="slidenum">
+              <a:rPr lang="en-US"/>
+              <a:t>12</a:t>
+            </a:fld>
+            <a:endParaRPr lang="en-US"/>
+          </a:p>
+        </p:txBody>
+      </p:sp>
+    </p:spTree>
+    <p:extLst>
+      <p:ext uri="{BB962C8B-B14F-4D97-AF65-F5344CB8AC3E}">
+        <p14:creationId xmlns:p14="http://schemas.microsoft.com/office/powerpoint/2010/main" val="1024086991"/>
+      </p:ext>
+    </p:extLst>
+  </p:cSld>
+  <p:clrMapOvr>
+    <a:masterClrMapping/>
+  </p:clrMapOvr>
+</p:notes>
+</file>
+
+<file path=ppt/notesSlides/notesSlide13.xml><?xml version="1.0" encoding="utf-8"?>
+<p:notes xmlns:a="http://schemas.openxmlformats.org/drawingml/2006/main" xmlns:r="http://schemas.openxmlformats.org/officeDocument/2006/relationships" xmlns:p="http://schemas.openxmlformats.org/presentationml/2006/main">
+  <p:cSld>
+    <p:spTree>
+      <p:nvGrpSpPr>
+        <p:cNvPr id="1" name=""/>
+        <p:cNvGrpSpPr/>
+        <p:nvPr/>
+      </p:nvGrpSpPr>
+      <p:grpSpPr>
+        <a:xfrm>
+          <a:off x="0" y="0"/>
+          <a:ext cx="0" cy="0"/>
+          <a:chOff x="0" y="0"/>
+          <a:chExt cx="0" cy="0"/>
+        </a:xfrm>
+      </p:grpSpPr>
+      <p:sp>
+        <p:nvSpPr>
+          <p:cNvPr id="2" name="Slide Image Placeholder 1"/>
+          <p:cNvSpPr>
+            <a:spLocks noGrp="1" noRot="1" noChangeAspect="1"/>
+          </p:cNvSpPr>
+          <p:nvPr>
+            <p:ph type="sldImg"/>
+          </p:nvPr>
+        </p:nvSpPr>
+        <p:spPr/>
+      </p:sp>
+      <p:sp>
+        <p:nvSpPr>
+          <p:cNvPr id="3" name="Notes Placeholder 2"/>
+          <p:cNvSpPr>
+            <a:spLocks noGrp="1"/>
+          </p:cNvSpPr>
+          <p:nvPr>
+            <p:ph type="body" idx="1"/>
+          </p:nvPr>
+        </p:nvSpPr>
+        <p:spPr/>
+        <p:txBody>
+          <a:bodyPr/>
+          <a:lstStyle/>
+          <a:p>
+            <a:r>
+              <a:rPr lang="en-US" dirty="0"/>
+              <a:t>~35 s. Both methods still need full validation. Comparisons add standard ERP decoders and recent deep models for Chapter 1, and alignment and domain-adaptation methods for Chapter 2. Ablations remove one component at a time. All results are reported over 28 subjects and several seeds with signed-rank tests. Robustness covers less training data, fewer channels and atypical subjects. Optimization prepares the models for real-time use.</a:t>
+            </a:r>
+            <a:endParaRPr lang="en-US" dirty="0"/>
+          </a:p>
+        </p:txBody>
+      </p:sp>
+      <p:sp>
+        <p:nvSpPr>
+          <p:cNvPr id="4" name="Slide Number Placeholder 3"/>
+          <p:cNvSpPr>
+            <a:spLocks noGrp="1"/>
+          </p:cNvSpPr>
+          <p:nvPr>
+            <p:ph type="sldNum" sz="quarter" idx="10"/>
+          </p:nvPr>
+        </p:nvSpPr>
+        <p:spPr/>
+        <p:txBody>
+          <a:bodyPr/>
+          <a:lstStyle/>
+          <a:p>
+            <a:fld id="{F7021451-1387-4CA6-816F-3879F97B5CBC}" type="slidenum">
+              <a:rPr lang="en-US"/>
+              <a:t>13</a:t>
+            </a:fld>
+            <a:endParaRPr lang="en-US"/>
+          </a:p>
+        </p:txBody>
+      </p:sp>
+    </p:spTree>
+    <p:extLst>
+      <p:ext uri="{BB962C8B-B14F-4D97-AF65-F5344CB8AC3E}">
+        <p14:creationId xmlns:p14="http://schemas.microsoft.com/office/powerpoint/2010/main" val="1024086991"/>
+      </p:ext>
+    </p:extLst>
+  </p:cSld>
+  <p:clrMapOvr>
+    <a:masterClrMapping/>
+  </p:clrMapOvr>
+</p:notes>
+</file>
+
+<file path=ppt/notesSlides/notesSlide14.xml><?xml version="1.0" encoding="utf-8"?>
+<p:notes xmlns:a="http://schemas.openxmlformats.org/drawingml/2006/main" xmlns:r="http://schemas.openxmlformats.org/officeDocument/2006/relationships" xmlns:p="http://schemas.openxmlformats.org/presentationml/2006/main">
+  <p:cSld>
+    <p:spTree>
+      <p:nvGrpSpPr>
+        <p:cNvPr id="1" name=""/>
+        <p:cNvGrpSpPr/>
+        <p:nvPr/>
+      </p:nvGrpSpPr>
+      <p:grpSpPr>
+        <a:xfrm>
+          <a:off x="0" y="0"/>
+          <a:ext cx="0" cy="0"/>
+          <a:chOff x="0" y="0"/>
+          <a:chExt cx="0" cy="0"/>
+        </a:xfrm>
+      </p:grpSpPr>
+      <p:sp>
+        <p:nvSpPr>
+          <p:cNvPr id="2" name="Slide Image Placeholder 1"/>
+          <p:cNvSpPr>
+            <a:spLocks noGrp="1" noRot="1" noChangeAspect="1"/>
+          </p:cNvSpPr>
+          <p:nvPr>
+            <p:ph type="sldImg"/>
+          </p:nvPr>
+        </p:nvSpPr>
+        <p:spPr/>
+      </p:sp>
+      <p:sp>
+        <p:nvSpPr>
+          <p:cNvPr id="3" name="Notes Placeholder 2"/>
+          <p:cNvSpPr>
+            <a:spLocks noGrp="1"/>
+          </p:cNvSpPr>
+          <p:nvPr>
+            <p:ph type="body" idx="1"/>
+          </p:nvPr>
+        </p:nvSpPr>
+        <p:spPr/>
+        <p:txBody>
+          <a:bodyPr/>
+          <a:lstStyle/>
+          <a:p>
+            <a:r>
+              <a:rPr lang="en-US" dirty="0"/>
+              <a:t>~55 s. Chapter 3 closes the loop. The user watches the robot through the aVEP interface: tiny stimuli beside each command, so the workspace stays visible. EEG is streamed, filtered causally and cut into one epoch per stimulus pair, and the proposed decoders output a class probability every 200 ms. Instead of one discrete command per selection, these probabilities are accumulated into a smoothed velocity whose speed follows the decoder's confidence, so the arm moves continuously. The robot controller enforces workspace and speed limits. We evaluate online accuracy, ITR, latency, task success and workload. The starting point is our preliminary system, which won [award] at [competition]; Chapter 3 upgrades its interface, decoder and control scheme.</a:t>
+            </a:r>
+            <a:endParaRPr lang="en-US" dirty="0"/>
+          </a:p>
+        </p:txBody>
+      </p:sp>
+      <p:sp>
+        <p:nvSpPr>
+          <p:cNvPr id="4" name="Slide Number Placeholder 3"/>
+          <p:cNvSpPr>
+            <a:spLocks noGrp="1"/>
+          </p:cNvSpPr>
+          <p:nvPr>
+            <p:ph type="sldNum" sz="quarter" idx="10"/>
+          </p:nvPr>
+        </p:nvSpPr>
+        <p:spPr/>
+        <p:txBody>
+          <a:bodyPr/>
+          <a:lstStyle/>
+          <a:p>
+            <a:fld id="{F7021451-1387-4CA6-816F-3879F97B5CBC}" type="slidenum">
+              <a:rPr lang="en-US"/>
+              <a:t>14</a:t>
             </a:fld>
             <a:endParaRPr lang="en-US"/>
           </a:p>
@@ -4954,6 +5228,2352 @@
             <a:fld id="{F7021451-1387-4CA6-816F-3879F97B5CBC}" type="slidenum">
               <a:rPr b="0" lang="en-US"/>
               <a:t>11</a:t>
+            </a:fld>
+            <a:endParaRPr lang="en-US"/>
+          </a:p>
+        </p:txBody>
+      </p:sp>
+    </p:spTree>
+  </p:cSld>
+  <p:clrMapOvr>
+    <a:masterClrMapping/>
+  </p:clrMapOvr>
+</p:sld>
+</file>
+
+<file path=ppt/slides/slide12.xml><?xml version="1.0" encoding="utf-8"?>
+<p:sld xmlns:a="http://schemas.openxmlformats.org/drawingml/2006/main" xmlns:r="http://schemas.openxmlformats.org/officeDocument/2006/relationships" xmlns:p="http://schemas.openxmlformats.org/presentationml/2006/main">
+  <p:cSld name="Slide 12">
+    <p:spTree>
+      <p:nvGrpSpPr>
+        <p:cNvPr id="1" name=""/>
+        <p:cNvGrpSpPr/>
+        <p:nvPr/>
+      </p:nvGrpSpPr>
+      <p:grpSpPr>
+        <a:xfrm>
+          <a:off x="0" y="0"/>
+          <a:ext cx="0" cy="0"/>
+          <a:chOff x="0" y="0"/>
+          <a:chExt cx="0" cy="0"/>
+        </a:xfrm>
+      </p:grpSpPr>
+      <p:sp>
+        <p:nvSpPr>
+          <p:cNvPr id="2" name="Outline list"/>
+          <p:cNvSpPr txBox="1"/>
+          <p:nvPr/>
+        </p:nvSpPr>
+        <p:spPr>
+          <a:xfrm>
+            <a:off x="4389120" y="1920240"/>
+            <a:ext cx="7132320" cy="2926080"/>
+          </a:xfrm>
+          <a:prstGeom prst="rect">
+            <a:avLst/>
+          </a:prstGeom>
+          <a:noFill/>
+          <a:ln/>
+        </p:spPr>
+        <p:txBody>
+          <a:bodyPr wrap="square" lIns="0" tIns="0" rIns="0" bIns="0" rtlCol="0" anchor="ctr"/>
+          <a:lstStyle/>
+          <a:p>
+            <a:pPr marL="342900" indent="-342900">
+              <a:spcAft>
+                <a:spcPts val="1800"/>
+              </a:spcAft>
+              <a:buSzPct val="100000"/>
+              <a:buChar char="•"/>
+            </a:pPr>
+            <a:r>
+              <a:rPr lang="en-US" sz="2600" dirty="0">
+                <a:solidFill>
+                  <a:srgbClr val="000000"/>
+                </a:solidFill>
+              </a:rPr>
+              <a:t>Research Background and Objectives</a:t>
+            </a:r>
+            <a:endParaRPr lang="en-US" sz="2600" dirty="0"/>
+          </a:p>
+          <a:p>
+            <a:pPr marL="342900" indent="-342900">
+              <a:spcAft>
+                <a:spcPts val="1800"/>
+              </a:spcAft>
+              <a:buSzPct val="100000"/>
+              <a:buChar char="•"/>
+            </a:pPr>
+            <a:r>
+              <a:rPr lang="en-US" sz="2600" dirty="0">
+                <a:solidFill>
+                  <a:srgbClr val="000000"/>
+                </a:solidFill>
+              </a:rPr>
+              <a:t>Research Progress and Stage Achievements</a:t>
+            </a:r>
+            <a:endParaRPr lang="en-US" sz="2600" dirty="0"/>
+          </a:p>
+          <a:p>
+            <a:pPr marL="342900" indent="-342900">
+              <a:spcAft>
+                <a:spcPts val="1800"/>
+              </a:spcAft>
+              <a:buSzPct val="100000"/>
+              <a:buChar char="•"/>
+            </a:pPr>
+            <a:r>
+              <a:rPr lang="en-US" sz="2600" dirty="0">
+                <a:solidFill>
+                  <a:srgbClr val="A00000"/>
+                </a:solidFill>
+              </a:rPr>
+              <a:t>Next-stage Research Plan</a:t>
+            </a:r>
+            <a:endParaRPr lang="en-US" sz="2600" dirty="0"/>
+          </a:p>
+          <a:p>
+            <a:pPr marL="342900" indent="-342900">
+              <a:spcAft>
+                <a:spcPts val="1800"/>
+              </a:spcAft>
+              <a:buSzPct val="100000"/>
+              <a:buChar char="•"/>
+            </a:pPr>
+            <a:r>
+              <a:rPr lang="en-US" sz="2600" dirty="0">
+                <a:solidFill>
+                  <a:srgbClr val="000000"/>
+                </a:solidFill>
+              </a:rPr>
+              <a:t>Project Schedule</a:t>
+            </a:r>
+            <a:endParaRPr lang="en-US" sz="2600" dirty="0"/>
+          </a:p>
+        </p:txBody>
+      </p:sp>
+      <p:sp>
+        <p:nvSpPr>
+          <p:cNvPr id="25" name="Slide Number Placeholder 0"/>
+          <p:cNvSpPr>
+            <a:spLocks noGrp="1"/>
+          </p:cNvSpPr>
+          <p:nvPr>
+            <p:ph type="sldNum" sz="quarter" idx="4294967295"/>
+          </p:nvPr>
+        </p:nvSpPr>
+        <p:spPr>
+          <a:xfrm>
+            <a:off x="11292840" y="6382512"/>
+            <a:ext cx="594360" cy="320040"/>
+          </a:xfrm>
+          <a:prstGeom prst="rect">
+            <a:avLst/>
+          </a:prstGeom>
+          <a:extLst>
+            <a:ext uri="{C572A759-6A51-4108-AA02-DFA0A04FC94B}">
+              <ma14:wrappingTextBoxFlag xmlns:ma14="http://schemas.microsoft.com/office/mac/drawingml/2011/main" val="0"/>
+            </a:ext>
+          </a:extLst>
+        </p:spPr>
+        <p:txBody>
+          <a:bodyPr/>
+          <a:lstStyle>
+            <a:lvl1pPr>
+              <a:defRPr sz="1400">
+                <a:solidFill>
+                  <a:schemeClr val="tx1"/>
+                </a:solidFill>
+              </a:defRPr>
+            </a:lvl1pPr>
+          </a:lstStyle>
+          <a:p>
+            <a:pPr algn="r"/>
+            <a:fld id="{F7021451-1387-4CA6-816F-3879F97B5CBC}" type="slidenum">
+              <a:rPr b="0" lang="en-US"/>
+              <a:t>12</a:t>
+            </a:fld>
+            <a:endParaRPr lang="en-US"/>
+          </a:p>
+        </p:txBody>
+      </p:sp>
+    </p:spTree>
+  </p:cSld>
+  <p:clrMapOvr>
+    <a:masterClrMapping/>
+  </p:clrMapOvr>
+</p:sld>
+</file>
+
+<file path=ppt/slides/slide13.xml><?xml version="1.0" encoding="utf-8"?>
+<p:sld xmlns:a="http://schemas.openxmlformats.org/drawingml/2006/main" xmlns:r="http://schemas.openxmlformats.org/officeDocument/2006/relationships" xmlns:p="http://schemas.openxmlformats.org/presentationml/2006/main">
+  <p:cSld name="Slide 13">
+    <p:spTree>
+      <p:nvGrpSpPr>
+        <p:cNvPr id="1" name=""/>
+        <p:cNvGrpSpPr/>
+        <p:nvPr/>
+      </p:nvGrpSpPr>
+      <p:grpSpPr>
+        <a:xfrm>
+          <a:off x="0" y="0"/>
+          <a:ext cx="0" cy="0"/>
+          <a:chOff x="0" y="0"/>
+          <a:chExt cx="0" cy="0"/>
+        </a:xfrm>
+      </p:grpSpPr>
+      <p:sp>
+        <p:nvSpPr>
+          <p:cNvPr id="2" name="Text 4"/>
+          <p:cNvSpPr/>
+          <p:nvPr>
+            <p:ph idx="104" type="title" hasCustomPrompt="1"/>
+          </p:nvPr>
+        </p:nvSpPr>
+        <p:spPr>
+          <a:xfrm>
+            <a:off x="457200" y="274320"/>
+            <a:ext cx="8001000" cy="749808"/>
+          </a:xfrm>
+          <a:prstGeom prst="rect">
+            <a:avLst/>
+          </a:prstGeom>
+          <a:noFill/>
+          <a:ln/>
+        </p:spPr>
+        <p:txBody>
+          <a:bodyPr wrap="square" lIns="0" tIns="0" rIns="0" bIns="0" rtlCol="0" anchor="ctr"/>
+          <a:lstStyle/>
+          <a:p>
+            <a:pPr algn="l" indent="0" marL="0">
+              <a:buNone/>
+            </a:pPr>
+            <a:r>
+              <a:rPr lang="en-US" sz="2800" b="1" dirty="0">
+                <a:solidFill>
+                  <a:schemeClr val="bg1"/>
+                </a:solidFill>
+              </a:rPr>
+              <a:t>3 Next-stage Research Plan</a:t>
+            </a:r>
+            <a:endParaRPr lang="en-US" sz="2800" dirty="0"/>
+          </a:p>
+        </p:txBody>
+      </p:sp>
+      <p:sp>
+        <p:nvSpPr>
+          <p:cNvPr id="3" name="Lead"/>
+          <p:cNvSpPr txBox="1"/>
+          <p:nvPr/>
+        </p:nvSpPr>
+        <p:spPr>
+          <a:xfrm>
+            <a:off x="548640" y="1161288"/>
+            <a:ext cx="11338560" cy="365760"/>
+          </a:xfrm>
+          <a:prstGeom prst="rect">
+            <a:avLst/>
+          </a:prstGeom>
+          <a:noFill/>
+          <a:ln/>
+        </p:spPr>
+        <p:txBody>
+          <a:bodyPr wrap="square" lIns="0" tIns="0" rIns="0" bIns="0" rtlCol="0" anchor="ctr"/>
+          <a:lstStyle/>
+          <a:p>
+            <a:pPr indent="0" marL="0">
+              <a:buNone/>
+            </a:pPr>
+            <a:r>
+              <a:rPr lang="en-US" sz="1700" dirty="0">
+                <a:solidFill>
+                  <a:schemeClr val="tx1"/>
+                </a:solidFill>
+              </a:rPr>
+              <a:t>Chapters 1–2: from algorithm design to validated, complete methods</a:t>
+            </a:r>
+            <a:endParaRPr lang="en-US" sz="1700" dirty="0"/>
+          </a:p>
+        </p:txBody>
+      </p:sp>
+      <p:graphicFrame>
+        <p:nvGraphicFramePr>
+          <p:cNvPr id="14" name="Plan table"/>
+          <p:cNvGraphicFramePr>
+            <a:graphicFrameLocks noGrp="1"/>
+          </p:cNvGraphicFramePr>
+          <p:nvPr>
+            <p:extLst>
+              <p:ext uri="{D42A27DB-BD31-4B8C-83A1-F6EECF244321}">
+                <p14:modId xmlns:p14="http://schemas.microsoft.com/office/powerpoint/2010/main" val="1579011935"/>
+              </p:ext>
+            </p:extLst>
+          </p:nvPr>
+        </p:nvGraphicFramePr>
+        <p:xfrm>
+          <a:off x="548640" y="1645920"/>
+          <a:ext cx="11064240" cy="914400"/>
+        </p:xfrm>
+        <a:graphic>
+          <a:graphicData uri="http://schemas.openxmlformats.org/drawingml/2006/table">
+            <a:tbl>
+              <a:tblPr/>
+              <a:tblGrid>
+                <a:gridCol w="2103120"/>
+                <a:gridCol w="4480560"/>
+                <a:gridCol w="4480560"/>
+              </a:tblGrid>
+              <a:tr h="411480">
+                <a:tc>
+                  <a:txBody>
+                    <a:bodyPr/>
+                    <a:lstStyle/>
+                    <a:p>
+                      <a:pPr algn="l" indent="0" marL="0">
+                        <a:buNone/>
+                      </a:pPr>
+                      <a:endParaRPr lang="en-US" sz="1500" dirty="0">
+                        <a:latin typeface="Times New Roman" charset="0"/>
+                        <a:ea typeface="Times New Roman" charset="0"/>
+                        <a:cs typeface="Times New Roman" charset="0"/>
+                      </a:endParaRPr>
+                    </a:p>
+                  </a:txBody>
+                  <a:tcPr marL="101600" marR="101600" marT="38100" marB="38100" anchor="ctr">
+                    <a:lnL w="0" cap="flat" cmpd="sng" algn="ctr">
+                      <a:noFill/>
+                    </a:lnL>
+                    <a:lnR w="0" cap="flat" cmpd="sng" algn="ctr">
+                      <a:noFill/>
+                    </a:lnR>
+                    <a:lnT w="19050" cap="flat" cmpd="sng" algn="ctr">
+                      <a:solidFill>
+                        <a:srgbClr val="000000"/>
+                      </a:solidFill>
+                      <a:prstDash val="solid"/>
+                      <a:round/>
+                      <a:headEnd type="none" w="med" len="med"/>
+                      <a:tailEnd type="none" w="med" len="med"/>
+                    </a:lnT>
+                    <a:lnB w="12700" cap="flat" cmpd="sng" algn="ctr">
+                      <a:solidFill>
+                        <a:srgbClr val="000000"/>
+                      </a:solidFill>
+                      <a:prstDash val="solid"/>
+                      <a:round/>
+                      <a:headEnd type="none" w="med" len="med"/>
+                      <a:tailEnd type="none" w="med" len="med"/>
+                    </a:lnB>
+                  </a:tcPr>
+                </a:tc>
+                <a:tc>
+                  <a:txBody>
+                    <a:bodyPr/>
+                    <a:lstStyle/>
+                    <a:p>
+                      <a:pPr algn="l" indent="0" marL="0">
+                        <a:buNone/>
+                      </a:pPr>
+                      <a:r>
+                        <a:rPr lang="en-US" sz="1500" b="1" dirty="0">
+                          <a:solidFill>
+                            <a:srgbClr val="000000"/>
+                          </a:solidFill>
+                          <a:latin typeface="Times New Roman" pitchFamily="34" charset="0"/>
+                          <a:ea typeface="Times New Roman" pitchFamily="34" charset="-122"/>
+                          <a:cs typeface="Times New Roman" pitchFamily="34" charset="-120"/>
+                        </a:rPr>
+                        <a:t>Chapter 1 · RED (within-subject SNR)</a:t>
+                      </a:r>
+                      <a:endParaRPr lang="en-US" sz="1500" dirty="0">
+                        <a:latin typeface="Times New Roman" charset="0"/>
+                        <a:ea typeface="Times New Roman" charset="0"/>
+                        <a:cs typeface="Times New Roman" charset="0"/>
+                      </a:endParaRPr>
+                    </a:p>
+                  </a:txBody>
+                  <a:tcPr marL="101600" marR="101600" marT="38100" marB="38100" anchor="ctr">
+                    <a:lnL w="0" cap="flat" cmpd="sng" algn="ctr">
+                      <a:noFill/>
+                    </a:lnL>
+                    <a:lnR w="0" cap="flat" cmpd="sng" algn="ctr">
+                      <a:noFill/>
+                    </a:lnR>
+                    <a:lnT w="19050" cap="flat" cmpd="sng" algn="ctr">
+                      <a:solidFill>
+                        <a:srgbClr val="000000"/>
+                      </a:solidFill>
+                      <a:prstDash val="solid"/>
+                      <a:round/>
+                      <a:headEnd type="none" w="med" len="med"/>
+                      <a:tailEnd type="none" w="med" len="med"/>
+                    </a:lnT>
+                    <a:lnB w="12700" cap="flat" cmpd="sng" algn="ctr">
+                      <a:solidFill>
+                        <a:srgbClr val="000000"/>
+                      </a:solidFill>
+                      <a:prstDash val="solid"/>
+                      <a:round/>
+                      <a:headEnd type="none" w="med" len="med"/>
+                      <a:tailEnd type="none" w="med" len="med"/>
+                    </a:lnB>
+                  </a:tcPr>
+                </a:tc>
+                <a:tc>
+                  <a:txBody>
+                    <a:bodyPr/>
+                    <a:lstStyle/>
+                    <a:p>
+                      <a:pPr algn="l" indent="0" marL="0">
+                        <a:buNone/>
+                      </a:pPr>
+                      <a:r>
+                        <a:rPr lang="en-US" sz="1500" b="1" dirty="0">
+                          <a:solidFill>
+                            <a:srgbClr val="000000"/>
+                          </a:solidFill>
+                          <a:latin typeface="Times New Roman" pitchFamily="34" charset="0"/>
+                          <a:ea typeface="Times New Roman" pitchFamily="34" charset="-122"/>
+                          <a:cs typeface="Times New Roman" pitchFamily="34" charset="-120"/>
+                        </a:rPr>
+                        <a:t>Chapter 2 · LR-MoE (cross-subject)</a:t>
+                      </a:r>
+                      <a:endParaRPr lang="en-US" sz="1500" dirty="0">
+                        <a:latin typeface="Times New Roman" charset="0"/>
+                        <a:ea typeface="Times New Roman" charset="0"/>
+                        <a:cs typeface="Times New Roman" charset="0"/>
+                      </a:endParaRPr>
+                    </a:p>
+                  </a:txBody>
+                  <a:tcPr marL="101600" marR="101600" marT="38100" marB="38100" anchor="ctr">
+                    <a:lnL w="0" cap="flat" cmpd="sng" algn="ctr">
+                      <a:noFill/>
+                    </a:lnL>
+                    <a:lnR w="0" cap="flat" cmpd="sng" algn="ctr">
+                      <a:noFill/>
+                    </a:lnR>
+                    <a:lnT w="19050" cap="flat" cmpd="sng" algn="ctr">
+                      <a:solidFill>
+                        <a:srgbClr val="000000"/>
+                      </a:solidFill>
+                      <a:prstDash val="solid"/>
+                      <a:round/>
+                      <a:headEnd type="none" w="med" len="med"/>
+                      <a:tailEnd type="none" w="med" len="med"/>
+                    </a:lnT>
+                    <a:lnB w="12700" cap="flat" cmpd="sng" algn="ctr">
+                      <a:solidFill>
+                        <a:srgbClr val="000000"/>
+                      </a:solidFill>
+                      <a:prstDash val="solid"/>
+                      <a:round/>
+                      <a:headEnd type="none" w="med" len="med"/>
+                      <a:tailEnd type="none" w="med" len="med"/>
+                    </a:lnB>
+                  </a:tcPr>
+                </a:tc>
+              </a:tr>
+              <a:tr h="676656">
+                <a:tc>
+                  <a:txBody>
+                    <a:bodyPr/>
+                    <a:lstStyle/>
+                    <a:p>
+                      <a:pPr algn="l" indent="0" marL="0">
+                        <a:buNone/>
+                      </a:pPr>
+                      <a:r>
+                        <a:rPr lang="en-US" sz="1300" b="1" dirty="0">
+                          <a:solidFill>
+                            <a:srgbClr val="000000"/>
+                          </a:solidFill>
+                          <a:latin typeface="Times New Roman" pitchFamily="34" charset="0"/>
+                          <a:ea typeface="Times New Roman" pitchFamily="34" charset="-122"/>
+                          <a:cs typeface="Times New Roman" pitchFamily="34" charset="-120"/>
+                        </a:rPr>
+                        <a:t>Comparative experiments</a:t>
+                      </a:r>
+                      <a:endParaRPr lang="en-US" sz="1300" dirty="0">
+                        <a:latin typeface="Times New Roman" charset="0"/>
+                        <a:ea typeface="Times New Roman" charset="0"/>
+                        <a:cs typeface="Times New Roman" charset="0"/>
+                      </a:endParaRPr>
+                    </a:p>
+                  </a:txBody>
+                  <a:tcPr marL="101600" marR="101600" marT="38100" marB="38100" anchor="ctr">
+                    <a:lnL w="0" cap="flat" cmpd="sng" algn="ctr">
+                      <a:noFill/>
+                    </a:lnL>
+                    <a:lnR w="0" cap="flat" cmpd="sng" algn="ctr">
+                      <a:noFill/>
+                    </a:lnR>
+                    <a:lnT w="0" cap="flat" cmpd="sng" algn="ctr">
+                      <a:noFill/>
+                    </a:lnT>
+                    <a:lnB w="0" cap="flat" cmpd="sng" algn="ctr">
+                      <a:noFill/>
+                    </a:lnB>
+                  </a:tcPr>
+                </a:tc>
+                <a:tc>
+                  <a:txBody>
+                    <a:bodyPr/>
+                    <a:lstStyle/>
+                    <a:p>
+                      <a:pPr algn="l" indent="0" marL="0">
+                        <a:buNone/>
+                      </a:pPr>
+                      <a:r>
+                        <a:rPr lang="en-US" sz="1300" dirty="0">
+                          <a:solidFill>
+                            <a:srgbClr val="000000"/>
+                          </a:solidFill>
+                          <a:latin typeface="Times New Roman" pitchFamily="34" charset="0"/>
+                          <a:ea typeface="Times New Roman" pitchFamily="34" charset="-122"/>
+                          <a:cs typeface="Times New Roman" pitchFamily="34" charset="-120"/>
+                        </a:rPr>
+                        <a:t>EEGNet, DCPM + xDAWN-LDA, ShallowConvNet, EEG-Conformer; within-subject and pooled</a:t>
+                      </a:r>
+                      <a:endParaRPr lang="en-US" sz="1300" dirty="0">
+                        <a:latin typeface="Times New Roman" charset="0"/>
+                        <a:ea typeface="Times New Roman" charset="0"/>
+                        <a:cs typeface="Times New Roman" charset="0"/>
+                      </a:endParaRPr>
+                    </a:p>
+                  </a:txBody>
+                  <a:tcPr marL="101600" marR="101600" marT="38100" marB="38100" anchor="ctr">
+                    <a:lnL w="0" cap="flat" cmpd="sng" algn="ctr">
+                      <a:noFill/>
+                    </a:lnL>
+                    <a:lnR w="0" cap="flat" cmpd="sng" algn="ctr">
+                      <a:noFill/>
+                    </a:lnR>
+                    <a:lnT w="0" cap="flat" cmpd="sng" algn="ctr">
+                      <a:noFill/>
+                    </a:lnT>
+                    <a:lnB w="0" cap="flat" cmpd="sng" algn="ctr">
+                      <a:noFill/>
+                    </a:lnB>
+                  </a:tcPr>
+                </a:tc>
+                <a:tc>
+                  <a:txBody>
+                    <a:bodyPr/>
+                    <a:lstStyle/>
+                    <a:p>
+                      <a:pPr algn="l" indent="0" marL="0">
+                        <a:buNone/>
+                      </a:pPr>
+                      <a:r>
+                        <a:rPr lang="en-US" sz="1300" dirty="0">
+                          <a:solidFill>
+                            <a:srgbClr val="000000"/>
+                          </a:solidFill>
+                          <a:latin typeface="Times New Roman" pitchFamily="34" charset="0"/>
+                          <a:ea typeface="Times New Roman" pitchFamily="34" charset="-122"/>
+                          <a:cs typeface="Times New Roman" pitchFamily="34" charset="-120"/>
+                        </a:rPr>
+                        <a:t>EEGNet, DCPM + Euclidean alignment, domain-adversarial training, generic MoE; leave-one-subject-out</a:t>
+                      </a:r>
+                      <a:endParaRPr lang="en-US" sz="1300" dirty="0">
+                        <a:latin typeface="Times New Roman" charset="0"/>
+                        <a:ea typeface="Times New Roman" charset="0"/>
+                        <a:cs typeface="Times New Roman" charset="0"/>
+                      </a:endParaRPr>
+                    </a:p>
+                  </a:txBody>
+                  <a:tcPr marL="101600" marR="101600" marT="38100" marB="38100" anchor="ctr">
+                    <a:lnL w="0" cap="flat" cmpd="sng" algn="ctr">
+                      <a:noFill/>
+                    </a:lnL>
+                    <a:lnR w="0" cap="flat" cmpd="sng" algn="ctr">
+                      <a:noFill/>
+                    </a:lnR>
+                    <a:lnT w="0" cap="flat" cmpd="sng" algn="ctr">
+                      <a:noFill/>
+                    </a:lnT>
+                    <a:lnB w="0" cap="flat" cmpd="sng" algn="ctr">
+                      <a:noFill/>
+                    </a:lnB>
+                  </a:tcPr>
+                </a:tc>
+              </a:tr>
+              <a:tr h="676656">
+                <a:tc>
+                  <a:txBody>
+                    <a:bodyPr/>
+                    <a:lstStyle/>
+                    <a:p>
+                      <a:pPr algn="l" indent="0" marL="0">
+                        <a:buNone/>
+                      </a:pPr>
+                      <a:r>
+                        <a:rPr lang="en-US" sz="1300" b="1" dirty="0">
+                          <a:solidFill>
+                            <a:srgbClr val="000000"/>
+                          </a:solidFill>
+                          <a:latin typeface="Times New Roman" pitchFamily="34" charset="0"/>
+                          <a:ea typeface="Times New Roman" pitchFamily="34" charset="-122"/>
+                          <a:cs typeface="Times New Roman" pitchFamily="34" charset="-120"/>
+                        </a:rPr>
+                        <a:t>Ablation studies</a:t>
+                      </a:r>
+                      <a:endParaRPr lang="en-US" sz="1300" dirty="0">
+                        <a:latin typeface="Times New Roman" charset="0"/>
+                        <a:ea typeface="Times New Roman" charset="0"/>
+                        <a:cs typeface="Times New Roman" charset="0"/>
+                      </a:endParaRPr>
+                    </a:p>
+                  </a:txBody>
+                  <a:tcPr marL="101600" marR="101600" marT="38100" marB="38100" anchor="ctr">
+                    <a:lnL w="0" cap="flat" cmpd="sng" algn="ctr">
+                      <a:noFill/>
+                    </a:lnL>
+                    <a:lnR w="0" cap="flat" cmpd="sng" algn="ctr">
+                      <a:noFill/>
+                    </a:lnR>
+                    <a:lnT w="0" cap="flat" cmpd="sng" algn="ctr">
+                      <a:noFill/>
+                    </a:lnT>
+                    <a:lnB w="0" cap="flat" cmpd="sng" algn="ctr">
+                      <a:noFill/>
+                    </a:lnB>
+                  </a:tcPr>
+                </a:tc>
+                <a:tc>
+                  <a:txBody>
+                    <a:bodyPr/>
+                    <a:lstStyle/>
+                    <a:p>
+                      <a:pPr algn="l" indent="0" marL="0">
+                        <a:buNone/>
+                      </a:pPr>
+                      <a:r>
+                        <a:rPr lang="en-US" sz="1300" dirty="0">
+                          <a:solidFill>
+                            <a:srgbClr val="000000"/>
+                          </a:solidFill>
+                          <a:latin typeface="Times New Roman" pitchFamily="34" charset="0"/>
+                          <a:ea typeface="Times New Roman" pitchFamily="34" charset="-122"/>
+                          <a:cs typeface="Times New Roman" pitchFamily="34" charset="-120"/>
+                        </a:rPr>
+                        <a:t>Each loss term; k ∈ {2, 3, 6}; context-matched vs. class-mean target; naive distillation</a:t>
+                      </a:r>
+                      <a:endParaRPr lang="en-US" sz="1300" dirty="0">
+                        <a:latin typeface="Times New Roman" charset="0"/>
+                        <a:ea typeface="Times New Roman" charset="0"/>
+                        <a:cs typeface="Times New Roman" charset="0"/>
+                      </a:endParaRPr>
+                    </a:p>
+                  </a:txBody>
+                  <a:tcPr marL="101600" marR="101600" marT="38100" marB="38100" anchor="ctr">
+                    <a:lnL w="0" cap="flat" cmpd="sng" algn="ctr">
+                      <a:noFill/>
+                    </a:lnL>
+                    <a:lnR w="0" cap="flat" cmpd="sng" algn="ctr">
+                      <a:noFill/>
+                    </a:lnR>
+                    <a:lnT w="0" cap="flat" cmpd="sng" algn="ctr">
+                      <a:noFill/>
+                    </a:lnT>
+                    <a:lnB w="0" cap="flat" cmpd="sng" algn="ctr">
+                      <a:noFill/>
+                    </a:lnB>
+                  </a:tcPr>
+                </a:tc>
+                <a:tc>
+                  <a:txBody>
+                    <a:bodyPr/>
+                    <a:lstStyle/>
+                    <a:p>
+                      <a:pPr algn="l" indent="0" marL="0">
+                        <a:buNone/>
+                      </a:pPr>
+                      <a:r>
+                        <a:rPr lang="en-US" sz="1300" dirty="0">
+                          <a:solidFill>
+                            <a:srgbClr val="000000"/>
+                          </a:solidFill>
+                          <a:latin typeface="Times New Roman" pitchFamily="34" charset="0"/>
+                          <a:ea typeface="Times New Roman" pitchFamily="34" charset="-122"/>
+                          <a:cs typeface="Times New Roman" pitchFamily="34" charset="-120"/>
+                        </a:rPr>
+                        <a:t>No decomposition; single expert family; no latency variants; learned vs. physiological router</a:t>
+                      </a:r>
+                      <a:endParaRPr lang="en-US" sz="1300" dirty="0">
+                        <a:latin typeface="Times New Roman" charset="0"/>
+                        <a:ea typeface="Times New Roman" charset="0"/>
+                        <a:cs typeface="Times New Roman" charset="0"/>
+                      </a:endParaRPr>
+                    </a:p>
+                  </a:txBody>
+                  <a:tcPr marL="101600" marR="101600" marT="38100" marB="38100" anchor="ctr">
+                    <a:lnL w="0" cap="flat" cmpd="sng" algn="ctr">
+                      <a:noFill/>
+                    </a:lnL>
+                    <a:lnR w="0" cap="flat" cmpd="sng" algn="ctr">
+                      <a:noFill/>
+                    </a:lnR>
+                    <a:lnT w="0" cap="flat" cmpd="sng" algn="ctr">
+                      <a:noFill/>
+                    </a:lnT>
+                    <a:lnB w="0" cap="flat" cmpd="sng" algn="ctr">
+                      <a:noFill/>
+                    </a:lnB>
+                  </a:tcPr>
+                </a:tc>
+              </a:tr>
+              <a:tr h="676656">
+                <a:tc>
+                  <a:txBody>
+                    <a:bodyPr/>
+                    <a:lstStyle/>
+                    <a:p>
+                      <a:pPr algn="l" indent="0" marL="0">
+                        <a:buNone/>
+                      </a:pPr>
+                      <a:r>
+                        <a:rPr lang="en-US" sz="1300" b="1" dirty="0">
+                          <a:solidFill>
+                            <a:srgbClr val="000000"/>
+                          </a:solidFill>
+                          <a:latin typeface="Times New Roman" pitchFamily="34" charset="0"/>
+                          <a:ea typeface="Times New Roman" pitchFamily="34" charset="-122"/>
+                          <a:cs typeface="Times New Roman" pitchFamily="34" charset="-120"/>
+                        </a:rPr>
+                        <a:t>Generalization</a:t>
+                      </a:r>
+                      <a:endParaRPr lang="en-US" sz="1300" dirty="0">
+                        <a:latin typeface="Times New Roman" charset="0"/>
+                        <a:ea typeface="Times New Roman" charset="0"/>
+                        <a:cs typeface="Times New Roman" charset="0"/>
+                      </a:endParaRPr>
+                    </a:p>
+                  </a:txBody>
+                  <a:tcPr marL="101600" marR="101600" marT="38100" marB="38100" anchor="ctr">
+                    <a:lnL w="0" cap="flat" cmpd="sng" algn="ctr">
+                      <a:noFill/>
+                    </a:lnL>
+                    <a:lnR w="0" cap="flat" cmpd="sng" algn="ctr">
+                      <a:noFill/>
+                    </a:lnR>
+                    <a:lnT w="0" cap="flat" cmpd="sng" algn="ctr">
+                      <a:noFill/>
+                    </a:lnT>
+                    <a:lnB w="0" cap="flat" cmpd="sng" algn="ctr">
+                      <a:noFill/>
+                    </a:lnB>
+                  </a:tcPr>
+                </a:tc>
+                <a:tc>
+                  <a:txBody>
+                    <a:bodyPr/>
+                    <a:lstStyle/>
+                    <a:p>
+                      <a:pPr algn="l" indent="0" marL="0">
+                        <a:buNone/>
+                      </a:pPr>
+                      <a:r>
+                        <a:rPr lang="en-US" sz="1300" dirty="0">
+                          <a:solidFill>
+                            <a:srgbClr val="000000"/>
+                          </a:solidFill>
+                          <a:latin typeface="Times New Roman" pitchFamily="34" charset="0"/>
+                          <a:ea typeface="Times New Roman" pitchFamily="34" charset="-122"/>
+                          <a:cs typeface="Times New Roman" pitchFamily="34" charset="-120"/>
+                        </a:rPr>
+                        <a:t>All three protocols; several random seeds; Wilcoxon signed-rank tests with FDR correction</a:t>
+                      </a:r>
+                      <a:endParaRPr lang="en-US" sz="1300" dirty="0">
+                        <a:latin typeface="Times New Roman" charset="0"/>
+                        <a:ea typeface="Times New Roman" charset="0"/>
+                        <a:cs typeface="Times New Roman" charset="0"/>
+                      </a:endParaRPr>
+                    </a:p>
+                  </a:txBody>
+                  <a:tcPr marL="101600" marR="101600" marT="38100" marB="38100" anchor="ctr">
+                    <a:lnL w="0" cap="flat" cmpd="sng" algn="ctr">
+                      <a:noFill/>
+                    </a:lnL>
+                    <a:lnR w="0" cap="flat" cmpd="sng" algn="ctr">
+                      <a:noFill/>
+                    </a:lnR>
+                    <a:lnT w="0" cap="flat" cmpd="sng" algn="ctr">
+                      <a:noFill/>
+                    </a:lnT>
+                    <a:lnB w="0" cap="flat" cmpd="sng" algn="ctr">
+                      <a:noFill/>
+                    </a:lnB>
+                  </a:tcPr>
+                </a:tc>
+                <a:tc>
+                  <a:txBody>
+                    <a:bodyPr/>
+                    <a:lstStyle/>
+                    <a:p>
+                      <a:pPr algn="l" indent="0" marL="0">
+                        <a:buNone/>
+                      </a:pPr>
+                      <a:r>
+                        <a:rPr lang="en-US" sz="1300" dirty="0">
+                          <a:solidFill>
+                            <a:srgbClr val="000000"/>
+                          </a:solidFill>
+                          <a:latin typeface="Times New Roman" pitchFamily="34" charset="0"/>
+                          <a:ea typeface="Times New Roman" pitchFamily="34" charset="-122"/>
+                          <a:cs typeface="Times New Roman" pitchFamily="34" charset="-120"/>
+                        </a:rPr>
+                        <a:t>28 unseen subjects; unlabelled router adaptation; few-shot calibration curves</a:t>
+                      </a:r>
+                      <a:endParaRPr lang="en-US" sz="1300" dirty="0">
+                        <a:latin typeface="Times New Roman" charset="0"/>
+                        <a:ea typeface="Times New Roman" charset="0"/>
+                        <a:cs typeface="Times New Roman" charset="0"/>
+                      </a:endParaRPr>
+                    </a:p>
+                  </a:txBody>
+                  <a:tcPr marL="101600" marR="101600" marT="38100" marB="38100" anchor="ctr">
+                    <a:lnL w="0" cap="flat" cmpd="sng" algn="ctr">
+                      <a:noFill/>
+                    </a:lnL>
+                    <a:lnR w="0" cap="flat" cmpd="sng" algn="ctr">
+                      <a:noFill/>
+                    </a:lnR>
+                    <a:lnT w="0" cap="flat" cmpd="sng" algn="ctr">
+                      <a:noFill/>
+                    </a:lnT>
+                    <a:lnB w="0" cap="flat" cmpd="sng" algn="ctr">
+                      <a:noFill/>
+                    </a:lnB>
+                  </a:tcPr>
+                </a:tc>
+              </a:tr>
+              <a:tr h="676656">
+                <a:tc>
+                  <a:txBody>
+                    <a:bodyPr/>
+                    <a:lstStyle/>
+                    <a:p>
+                      <a:pPr algn="l" indent="0" marL="0">
+                        <a:buNone/>
+                      </a:pPr>
+                      <a:r>
+                        <a:rPr lang="en-US" sz="1300" b="1" dirty="0">
+                          <a:solidFill>
+                            <a:srgbClr val="000000"/>
+                          </a:solidFill>
+                          <a:latin typeface="Times New Roman" pitchFamily="34" charset="0"/>
+                          <a:ea typeface="Times New Roman" pitchFamily="34" charset="-122"/>
+                          <a:cs typeface="Times New Roman" pitchFamily="34" charset="-120"/>
+                        </a:rPr>
+                        <a:t>Robustness</a:t>
+                      </a:r>
+                      <a:endParaRPr lang="en-US" sz="1300" dirty="0">
+                        <a:latin typeface="Times New Roman" charset="0"/>
+                        <a:ea typeface="Times New Roman" charset="0"/>
+                        <a:cs typeface="Times New Roman" charset="0"/>
+                      </a:endParaRPr>
+                    </a:p>
+                  </a:txBody>
+                  <a:tcPr marL="101600" marR="101600" marT="38100" marB="38100" anchor="ctr">
+                    <a:lnL w="0" cap="flat" cmpd="sng" algn="ctr">
+                      <a:noFill/>
+                    </a:lnL>
+                    <a:lnR w="0" cap="flat" cmpd="sng" algn="ctr">
+                      <a:noFill/>
+                    </a:lnR>
+                    <a:lnT w="0" cap="flat" cmpd="sng" algn="ctr">
+                      <a:noFill/>
+                    </a:lnT>
+                    <a:lnB w="0" cap="flat" cmpd="sng" algn="ctr">
+                      <a:noFill/>
+                    </a:lnB>
+                  </a:tcPr>
+                </a:tc>
+                <a:tc>
+                  <a:txBody>
+                    <a:bodyPr/>
+                    <a:lstStyle/>
+                    <a:p>
+                      <a:pPr algn="l" indent="0" marL="0">
+                        <a:buNone/>
+                      </a:pPr>
+                      <a:r>
+                        <a:rPr lang="en-US" sz="1300" dirty="0">
+                          <a:solidFill>
+                            <a:srgbClr val="000000"/>
+                          </a:solidFill>
+                          <a:latin typeface="Times New Roman" pitchFamily="34" charset="0"/>
+                          <a:ea typeface="Times New Roman" pitchFamily="34" charset="-122"/>
+                          <a:cs typeface="Times New Roman" pitchFamily="34" charset="-120"/>
+                        </a:rPr>
+                        <a:t>Fewer training trials (learning curves); channel dropout; session-to-session shift</a:t>
+                      </a:r>
+                      <a:endParaRPr lang="en-US" sz="1300" dirty="0">
+                        <a:latin typeface="Times New Roman" charset="0"/>
+                        <a:ea typeface="Times New Roman" charset="0"/>
+                        <a:cs typeface="Times New Roman" charset="0"/>
+                      </a:endParaRPr>
+                    </a:p>
+                  </a:txBody>
+                  <a:tcPr marL="101600" marR="101600" marT="38100" marB="38100" anchor="ctr">
+                    <a:lnL w="0" cap="flat" cmpd="sng" algn="ctr">
+                      <a:noFill/>
+                    </a:lnL>
+                    <a:lnR w="0" cap="flat" cmpd="sng" algn="ctr">
+                      <a:noFill/>
+                    </a:lnR>
+                    <a:lnT w="0" cap="flat" cmpd="sng" algn="ctr">
+                      <a:noFill/>
+                    </a:lnT>
+                    <a:lnB w="0" cap="flat" cmpd="sng" algn="ctr">
+                      <a:noFill/>
+                    </a:lnB>
+                  </a:tcPr>
+                </a:tc>
+                <a:tc>
+                  <a:txBody>
+                    <a:bodyPr/>
+                    <a:lstStyle/>
+                    <a:p>
+                      <a:pPr algn="l" indent="0" marL="0">
+                        <a:buNone/>
+                      </a:pPr>
+                      <a:r>
+                        <a:rPr lang="en-US" sz="1300" dirty="0">
+                          <a:solidFill>
+                            <a:srgbClr val="000000"/>
+                          </a:solidFill>
+                          <a:latin typeface="Times New Roman" pitchFamily="34" charset="0"/>
+                          <a:ea typeface="Times New Roman" pitchFamily="34" charset="-122"/>
+                          <a:cs typeface="Times New Roman" pitchFamily="34" charset="-120"/>
+                        </a:rPr>
+                        <a:t>Atypical subjects (low mirror r); reduced channel sets; short calibration</a:t>
+                      </a:r>
+                      <a:endParaRPr lang="en-US" sz="1300" dirty="0">
+                        <a:latin typeface="Times New Roman" charset="0"/>
+                        <a:ea typeface="Times New Roman" charset="0"/>
+                        <a:cs typeface="Times New Roman" charset="0"/>
+                      </a:endParaRPr>
+                    </a:p>
+                  </a:txBody>
+                  <a:tcPr marL="101600" marR="101600" marT="38100" marB="38100" anchor="ctr">
+                    <a:lnL w="0" cap="flat" cmpd="sng" algn="ctr">
+                      <a:noFill/>
+                    </a:lnL>
+                    <a:lnR w="0" cap="flat" cmpd="sng" algn="ctr">
+                      <a:noFill/>
+                    </a:lnR>
+                    <a:lnT w="0" cap="flat" cmpd="sng" algn="ctr">
+                      <a:noFill/>
+                    </a:lnT>
+                    <a:lnB w="0" cap="flat" cmpd="sng" algn="ctr">
+                      <a:noFill/>
+                    </a:lnB>
+                  </a:tcPr>
+                </a:tc>
+              </a:tr>
+              <a:tr h="676656">
+                <a:tc>
+                  <a:txBody>
+                    <a:bodyPr/>
+                    <a:lstStyle/>
+                    <a:p>
+                      <a:pPr algn="l" indent="0" marL="0">
+                        <a:buNone/>
+                      </a:pPr>
+                      <a:r>
+                        <a:rPr lang="en-US" sz="1300" b="1" dirty="0">
+                          <a:solidFill>
+                            <a:srgbClr val="000000"/>
+                          </a:solidFill>
+                          <a:latin typeface="Times New Roman" pitchFamily="34" charset="0"/>
+                          <a:ea typeface="Times New Roman" pitchFamily="34" charset="-122"/>
+                          <a:cs typeface="Times New Roman" pitchFamily="34" charset="-120"/>
+                        </a:rPr>
+                        <a:t>Optimization</a:t>
+                      </a:r>
+                      <a:endParaRPr lang="en-US" sz="1300" dirty="0">
+                        <a:latin typeface="Times New Roman" charset="0"/>
+                        <a:ea typeface="Times New Roman" charset="0"/>
+                        <a:cs typeface="Times New Roman" charset="0"/>
+                      </a:endParaRPr>
+                    </a:p>
+                  </a:txBody>
+                  <a:tcPr marL="101600" marR="101600" marT="38100" marB="38100" anchor="ctr">
+                    <a:lnL w="0" cap="flat" cmpd="sng" algn="ctr">
+                      <a:noFill/>
+                    </a:lnL>
+                    <a:lnR w="0" cap="flat" cmpd="sng" algn="ctr">
+                      <a:noFill/>
+                    </a:lnR>
+                    <a:lnT w="0" cap="flat" cmpd="sng" algn="ctr">
+                      <a:noFill/>
+                    </a:lnT>
+                    <a:lnB w="19050" cap="flat" cmpd="sng" algn="ctr">
+                      <a:solidFill>
+                        <a:srgbClr val="000000"/>
+                      </a:solidFill>
+                      <a:prstDash val="solid"/>
+                      <a:round/>
+                      <a:headEnd type="none" w="med" len="med"/>
+                      <a:tailEnd type="none" w="med" len="med"/>
+                    </a:lnB>
+                  </a:tcPr>
+                </a:tc>
+                <a:tc>
+                  <a:txBody>
+                    <a:bodyPr/>
+                    <a:lstStyle/>
+                    <a:p>
+                      <a:pPr algn="l" indent="0" marL="0">
+                        <a:buNone/>
+                      </a:pPr>
+                      <a:r>
+                        <a:rPr lang="en-US" sz="1300" dirty="0">
+                          <a:solidFill>
+                            <a:srgbClr val="000000"/>
+                          </a:solidFill>
+                          <a:latin typeface="Times New Roman" pitchFamily="34" charset="0"/>
+                          <a:ea typeface="Times New Roman" pitchFamily="34" charset="-122"/>
+                          <a:cs typeface="Times New Roman" pitchFamily="34" charset="-120"/>
+                        </a:rPr>
+                        <a:t>Non-linear decoder; teacher ensembles; training cost</a:t>
+                      </a:r>
+                      <a:endParaRPr lang="en-US" sz="1300" dirty="0">
+                        <a:latin typeface="Times New Roman" charset="0"/>
+                        <a:ea typeface="Times New Roman" charset="0"/>
+                        <a:cs typeface="Times New Roman" charset="0"/>
+                      </a:endParaRPr>
+                    </a:p>
+                  </a:txBody>
+                  <a:tcPr marL="101600" marR="101600" marT="38100" marB="38100" anchor="ctr">
+                    <a:lnL w="0" cap="flat" cmpd="sng" algn="ctr">
+                      <a:noFill/>
+                    </a:lnL>
+                    <a:lnR w="0" cap="flat" cmpd="sng" algn="ctr">
+                      <a:noFill/>
+                    </a:lnR>
+                    <a:lnT w="0" cap="flat" cmpd="sng" algn="ctr">
+                      <a:noFill/>
+                    </a:lnT>
+                    <a:lnB w="19050" cap="flat" cmpd="sng" algn="ctr">
+                      <a:solidFill>
+                        <a:srgbClr val="000000"/>
+                      </a:solidFill>
+                      <a:prstDash val="solid"/>
+                      <a:round/>
+                      <a:headEnd type="none" w="med" len="med"/>
+                      <a:tailEnd type="none" w="med" len="med"/>
+                    </a:lnB>
+                  </a:tcPr>
+                </a:tc>
+                <a:tc>
+                  <a:txBody>
+                    <a:bodyPr/>
+                    <a:lstStyle/>
+                    <a:p>
+                      <a:pPr algn="l" indent="0" marL="0">
+                        <a:buNone/>
+                      </a:pPr>
+                      <a:r>
+                        <a:rPr lang="en-US" sz="1300" dirty="0">
+                          <a:solidFill>
+                            <a:srgbClr val="000000"/>
+                          </a:solidFill>
+                          <a:latin typeface="Times New Roman" pitchFamily="34" charset="0"/>
+                          <a:ea typeface="Times New Roman" pitchFamily="34" charset="-122"/>
+                          <a:cs typeface="Times New Roman" pitchFamily="34" charset="-120"/>
+                        </a:rPr>
+                        <a:t>Lightweight experts for real-time use; checking router choices against measured r and latency</a:t>
+                      </a:r>
+                      <a:endParaRPr lang="en-US" sz="1300" dirty="0">
+                        <a:latin typeface="Times New Roman" charset="0"/>
+                        <a:ea typeface="Times New Roman" charset="0"/>
+                        <a:cs typeface="Times New Roman" charset="0"/>
+                      </a:endParaRPr>
+                    </a:p>
+                  </a:txBody>
+                  <a:tcPr marL="101600" marR="101600" marT="38100" marB="38100" anchor="ctr">
+                    <a:lnL w="0" cap="flat" cmpd="sng" algn="ctr">
+                      <a:noFill/>
+                    </a:lnL>
+                    <a:lnR w="0" cap="flat" cmpd="sng" algn="ctr">
+                      <a:noFill/>
+                    </a:lnR>
+                    <a:lnT w="0" cap="flat" cmpd="sng" algn="ctr">
+                      <a:noFill/>
+                    </a:lnT>
+                    <a:lnB w="19050" cap="flat" cmpd="sng" algn="ctr">
+                      <a:solidFill>
+                        <a:srgbClr val="000000"/>
+                      </a:solidFill>
+                      <a:prstDash val="solid"/>
+                      <a:round/>
+                      <a:headEnd type="none" w="med" len="med"/>
+                      <a:tailEnd type="none" w="med" len="med"/>
+                    </a:lnB>
+                  </a:tcPr>
+                </a:tc>
+              </a:tr>
+            </a:tbl>
+          </a:graphicData>
+        </a:graphic>
+      </p:graphicFrame>
+      <p:sp>
+        <p:nvSpPr>
+          <p:cNvPr id="5" name="Outcome"/>
+          <p:cNvSpPr txBox="1"/>
+          <p:nvPr/>
+        </p:nvSpPr>
+        <p:spPr>
+          <a:xfrm>
+            <a:off x="548640" y="5532120"/>
+            <a:ext cx="11064240" cy="411480"/>
+          </a:xfrm>
+          <a:prstGeom prst="rect">
+            <a:avLst/>
+          </a:prstGeom>
+          <a:noFill/>
+          <a:ln/>
+        </p:spPr>
+        <p:txBody>
+          <a:bodyPr wrap="square" lIns="0" tIns="0" rIns="0" bIns="0" rtlCol="0" anchor="ctr"/>
+          <a:lstStyle/>
+          <a:p>
+            <a:pPr algn="ctr" indent="0" marL="0">
+              <a:buNone/>
+            </a:pPr>
+            <a:r>
+              <a:rPr lang="en-US" sz="1700" b="1" dirty="0">
+                <a:solidFill>
+                  <a:schemeClr val="accent1"/>
+                </a:solidFill>
+              </a:rPr>
+              <a:t>Goal: each chapter validated on 28 subjects with statistical tests, ready for one paper per chapter</a:t>
+            </a:r>
+            <a:endParaRPr lang="en-US" sz="1700" dirty="0"/>
+          </a:p>
+        </p:txBody>
+      </p:sp>
+      <p:sp>
+        <p:nvSpPr>
+          <p:cNvPr id="25" name="Slide Number Placeholder 0"/>
+          <p:cNvSpPr>
+            <a:spLocks noGrp="1"/>
+          </p:cNvSpPr>
+          <p:nvPr>
+            <p:ph type="sldNum" sz="quarter" idx="4294967295"/>
+          </p:nvPr>
+        </p:nvSpPr>
+        <p:spPr>
+          <a:xfrm>
+            <a:off x="11292840" y="6382512"/>
+            <a:ext cx="594360" cy="320040"/>
+          </a:xfrm>
+          <a:prstGeom prst="rect">
+            <a:avLst/>
+          </a:prstGeom>
+          <a:extLst>
+            <a:ext uri="{C572A759-6A51-4108-AA02-DFA0A04FC94B}">
+              <ma14:wrappingTextBoxFlag xmlns:ma14="http://schemas.microsoft.com/office/mac/drawingml/2011/main" val="0"/>
+            </a:ext>
+          </a:extLst>
+        </p:spPr>
+        <p:txBody>
+          <a:bodyPr/>
+          <a:lstStyle>
+            <a:lvl1pPr>
+              <a:defRPr sz="1400">
+                <a:solidFill>
+                  <a:schemeClr val="tx1"/>
+                </a:solidFill>
+              </a:defRPr>
+            </a:lvl1pPr>
+          </a:lstStyle>
+          <a:p>
+            <a:pPr algn="r"/>
+            <a:fld id="{F7021451-1387-4CA6-816F-3879F97B5CBC}" type="slidenum">
+              <a:rPr b="0" lang="en-US"/>
+              <a:t>13</a:t>
+            </a:fld>
+            <a:endParaRPr lang="en-US"/>
+          </a:p>
+        </p:txBody>
+      </p:sp>
+    </p:spTree>
+  </p:cSld>
+  <p:clrMapOvr>
+    <a:masterClrMapping/>
+  </p:clrMapOvr>
+</p:sld>
+</file>
+
+<file path=ppt/slides/slide14.xml><?xml version="1.0" encoding="utf-8"?>
+<p:sld xmlns:a="http://schemas.openxmlformats.org/drawingml/2006/main" xmlns:r="http://schemas.openxmlformats.org/officeDocument/2006/relationships" xmlns:p="http://schemas.openxmlformats.org/presentationml/2006/main">
+  <p:cSld name="Slide 14">
+    <p:spTree>
+      <p:nvGrpSpPr>
+        <p:cNvPr id="1" name=""/>
+        <p:cNvGrpSpPr/>
+        <p:nvPr/>
+      </p:nvGrpSpPr>
+      <p:grpSpPr>
+        <a:xfrm>
+          <a:off x="0" y="0"/>
+          <a:ext cx="0" cy="0"/>
+          <a:chOff x="0" y="0"/>
+          <a:chExt cx="0" cy="0"/>
+        </a:xfrm>
+      </p:grpSpPr>
+      <p:sp>
+        <p:nvSpPr>
+          <p:cNvPr id="2" name="Text 4"/>
+          <p:cNvSpPr/>
+          <p:nvPr>
+            <p:ph idx="104" type="title" hasCustomPrompt="1"/>
+          </p:nvPr>
+        </p:nvSpPr>
+        <p:spPr>
+          <a:xfrm>
+            <a:off x="457200" y="274320"/>
+            <a:ext cx="8001000" cy="749808"/>
+          </a:xfrm>
+          <a:prstGeom prst="rect">
+            <a:avLst/>
+          </a:prstGeom>
+          <a:noFill/>
+          <a:ln/>
+        </p:spPr>
+        <p:txBody>
+          <a:bodyPr wrap="square" lIns="0" tIns="0" rIns="0" bIns="0" rtlCol="0" anchor="ctr"/>
+          <a:lstStyle/>
+          <a:p>
+            <a:pPr algn="l" indent="0" marL="0">
+              <a:buNone/>
+            </a:pPr>
+            <a:r>
+              <a:rPr lang="en-US" sz="2800" b="1" dirty="0">
+                <a:solidFill>
+                  <a:schemeClr val="bg1"/>
+                </a:solidFill>
+              </a:rPr>
+              <a:t>3 Next-stage Research Plan</a:t>
+            </a:r>
+            <a:endParaRPr lang="en-US" sz="2800" dirty="0"/>
+          </a:p>
+        </p:txBody>
+      </p:sp>
+      <p:sp>
+        <p:nvSpPr>
+          <p:cNvPr id="3" name="Lead"/>
+          <p:cNvSpPr txBox="1"/>
+          <p:nvPr/>
+        </p:nvSpPr>
+        <p:spPr>
+          <a:xfrm>
+            <a:off x="548640" y="1161288"/>
+            <a:ext cx="11338560" cy="365760"/>
+          </a:xfrm>
+          <a:prstGeom prst="rect">
+            <a:avLst/>
+          </a:prstGeom>
+          <a:noFill/>
+          <a:ln/>
+        </p:spPr>
+        <p:txBody>
+          <a:bodyPr wrap="square" lIns="0" tIns="0" rIns="0" bIns="0" rtlCol="0" anchor="ctr"/>
+          <a:lstStyle/>
+          <a:p>
+            <a:pPr indent="0" marL="0">
+              <a:buNone/>
+            </a:pPr>
+            <a:r>
+              <a:rPr lang="en-US" sz="1700" dirty="0">
+                <a:solidFill>
+                  <a:schemeClr val="tx1"/>
+                </a:solidFill>
+              </a:rPr>
+              <a:t>Chapter 3: online aVEP-based brain-controlled robotic arm with continuous control</a:t>
+            </a:r>
+            <a:endParaRPr lang="en-US" sz="1700" dirty="0"/>
+          </a:p>
+        </p:txBody>
+      </p:sp>
+      <p:sp>
+        <p:nvSpPr>
+          <p:cNvPr id="4" name="Loop panel"/>
+          <p:cNvSpPr/>
+          <p:nvPr/>
+        </p:nvSpPr>
+        <p:spPr>
+          <a:xfrm>
+            <a:off x="411480" y="1600200"/>
+            <a:ext cx="7772400" cy="4343400"/>
+          </a:xfrm>
+          <a:prstGeom prst="rect">
+            <a:avLst/>
+          </a:prstGeom>
+          <a:solidFill>
+            <a:srgbClr val="F2F2F2"/>
+          </a:solidFill>
+          <a:ln/>
+        </p:spPr>
+      </p:sp>
+      <p:pic>
+        <p:nvPicPr>
+          <p:cNvPr id="5" name="aVEP screen" descr="aVEP interface showing the workspace with miniature stimuli beside commands">    </p:cNvPr>
+          <p:cNvPicPr>
+            <a:picLocks noChangeAspect="1"/>
+          </p:cNvPicPr>
+          <p:nvPr/>
+        </p:nvPicPr>
+        <p:blipFill>
+          <a:blip r:embed="rId1"/>
+          <a:stretch>
+            <a:fillRect/>
+          </a:stretch>
+        </p:blipFill>
+        <p:spPr>
+          <a:xfrm>
+            <a:off x="762000" y="1828800"/>
+            <a:ext cx="1036320" cy="777240"/>
+          </a:xfrm>
+          <a:prstGeom prst="rect">
+            <a:avLst/>
+          </a:prstGeom>
+        </p:spPr>
+      </p:pic>
+      <p:pic>
+        <p:nvPicPr>
+          <p:cNvPr id="6" name="Amplifier" descr="EEG amplifier streaming channels">    </p:cNvPr>
+          <p:cNvPicPr>
+            <a:picLocks noChangeAspect="1"/>
+          </p:cNvPicPr>
+          <p:nvPr/>
+        </p:nvPicPr>
+        <p:blipFill>
+          <a:blip r:embed="rId2"/>
+          <a:stretch>
+            <a:fillRect/>
+          </a:stretch>
+        </p:blipFill>
+        <p:spPr>
+          <a:xfrm>
+            <a:off x="2716184" y="1874520"/>
+            <a:ext cx="1059873" cy="685800"/>
+          </a:xfrm>
+          <a:prstGeom prst="rect">
+            <a:avLst/>
+          </a:prstGeom>
+        </p:spPr>
+      </p:pic>
+      <p:sp>
+        <p:nvSpPr>
+          <p:cNvPr id="7" name="Processing"/>
+          <p:cNvSpPr/>
+          <p:nvPr/>
+        </p:nvSpPr>
+        <p:spPr>
+          <a:xfrm>
+            <a:off x="4526280" y="1874520"/>
+            <a:ext cx="1600200" cy="685800"/>
+          </a:xfrm>
+          <a:prstGeom prst="rect">
+            <a:avLst/>
+          </a:prstGeom>
+          <a:solidFill>
+            <a:srgbClr val="FFFFFF"/>
+          </a:solidFill>
+          <a:ln w="12700">
+            <a:solidFill>
+              <a:srgbClr val="000000"/>
+            </a:solidFill>
+            <a:prstDash val="solid"/>
+          </a:ln>
+        </p:spPr>
+        <p:txBody>
+          <a:bodyPr wrap="square" lIns="25400" tIns="25400" rIns="25400" bIns="25400" rtlCol="0" anchor="ctr"/>
+          <a:lstStyle/>
+          <a:p>
+            <a:pPr algn="ctr" indent="0" marL="0">
+              <a:buNone/>
+            </a:pPr>
+            <a:r>
+              <a:rPr lang="en-US" sz="1200" b="1" dirty="0">
+                <a:solidFill>
+                  <a:srgbClr val="000000"/>
+                </a:solidFill>
+              </a:rPr>
+              <a:t>Real-time processing</a:t>
+            </a:r>
+            <a:endParaRPr lang="en-US" sz="1200" dirty="0"/>
+          </a:p>
+          <a:p>
+            <a:pPr algn="ctr" indent="0" marL="0">
+              <a:buNone/>
+            </a:pPr>
+            <a:r>
+              <a:rPr lang="en-US" sz="1050" dirty="0">
+                <a:solidFill>
+                  <a:srgbClr val="262626"/>
+                </a:solidFill>
+              </a:rPr>
+              <a:t>causal 1–30 Hz filter;</a:t>
+            </a:r>
+            <a:endParaRPr lang="en-US" sz="1200" dirty="0"/>
+          </a:p>
+          <a:p>
+            <a:pPr algn="ctr" indent="0" marL="0">
+              <a:buNone/>
+            </a:pPr>
+            <a:r>
+              <a:rPr lang="en-US" sz="1050" dirty="0">
+                <a:solidFill>
+                  <a:srgbClr val="262626"/>
+                </a:solidFill>
+              </a:rPr>
+              <a:t>200 ms epoch per pair</a:t>
+            </a:r>
+            <a:endParaRPr lang="en-US" sz="1200" dirty="0"/>
+          </a:p>
+        </p:txBody>
+      </p:sp>
+      <p:pic>
+        <p:nvPicPr>
+          <p:cNvPr id="8" name="Decoder" descr="Proposed decoder network">    </p:cNvPr>
+          <p:cNvPicPr>
+            <a:picLocks noChangeAspect="1"/>
+          </p:cNvPicPr>
+          <p:nvPr/>
+        </p:nvPicPr>
+        <p:blipFill>
+          <a:blip r:embed="rId3"/>
+          <a:stretch>
+            <a:fillRect/>
+          </a:stretch>
+        </p:blipFill>
+        <p:spPr>
+          <a:xfrm>
+            <a:off x="6450676" y="1901952"/>
+            <a:ext cx="1454727" cy="640080"/>
+          </a:xfrm>
+          <a:prstGeom prst="rect">
+            <a:avLst/>
+          </a:prstGeom>
+        </p:spPr>
+      </p:pic>
+      <p:sp>
+        <p:nvSpPr>
+          <p:cNvPr id="9" name="Screen cap"/>
+          <p:cNvSpPr txBox="1"/>
+          <p:nvPr/>
+        </p:nvSpPr>
+        <p:spPr>
+          <a:xfrm>
+            <a:off x="640080" y="2670048"/>
+            <a:ext cx="1645920" cy="384048"/>
+          </a:xfrm>
+          <a:prstGeom prst="rect">
+            <a:avLst/>
+          </a:prstGeom>
+          <a:noFill/>
+          <a:ln/>
+        </p:spPr>
+        <p:txBody>
+          <a:bodyPr wrap="square" lIns="0" tIns="0" rIns="0" bIns="0" rtlCol="0" anchor="t"/>
+          <a:lstStyle/>
+          <a:p>
+            <a:pPr algn="ctr" indent="0" marL="0">
+              <a:buNone/>
+            </a:pPr>
+            <a:r>
+              <a:rPr lang="en-US" sz="1200" b="1" dirty="0">
+                <a:solidFill>
+                  <a:srgbClr val="000000"/>
+                </a:solidFill>
+              </a:rPr>
+              <a:t>aVEP interface</a:t>
+            </a:r>
+            <a:endParaRPr lang="en-US" sz="1200" dirty="0"/>
+          </a:p>
+          <a:p>
+            <a:pPr algn="ctr" indent="0" marL="0">
+              <a:buNone/>
+            </a:pPr>
+            <a:r>
+              <a:rPr lang="en-US" sz="1050" dirty="0">
+                <a:solidFill>
+                  <a:srgbClr val="262626"/>
+                </a:solidFill>
+              </a:rPr>
+              <a:t>tiny stimuli beside commands</a:t>
+            </a:r>
+            <a:endParaRPr lang="en-US" sz="1200" dirty="0"/>
+          </a:p>
+        </p:txBody>
+      </p:sp>
+      <p:sp>
+        <p:nvSpPr>
+          <p:cNvPr id="10" name="Amp cap"/>
+          <p:cNvSpPr txBox="1"/>
+          <p:nvPr/>
+        </p:nvSpPr>
+        <p:spPr>
+          <a:xfrm>
+            <a:off x="2468880" y="2670048"/>
+            <a:ext cx="1554480" cy="384048"/>
+          </a:xfrm>
+          <a:prstGeom prst="rect">
+            <a:avLst/>
+          </a:prstGeom>
+          <a:noFill/>
+          <a:ln/>
+        </p:spPr>
+        <p:txBody>
+          <a:bodyPr wrap="square" lIns="0" tIns="0" rIns="0" bIns="0" rtlCol="0" anchor="t"/>
+          <a:lstStyle/>
+          <a:p>
+            <a:pPr algn="ctr" indent="0" marL="0">
+              <a:buNone/>
+            </a:pPr>
+            <a:r>
+              <a:rPr lang="en-US" sz="1200" b="1" dirty="0">
+                <a:solidFill>
+                  <a:srgbClr val="000000"/>
+                </a:solidFill>
+              </a:rPr>
+              <a:t>EEG acquisition</a:t>
+            </a:r>
+            <a:endParaRPr lang="en-US" sz="1200" dirty="0"/>
+          </a:p>
+          <a:p>
+            <a:pPr algn="ctr" indent="0" marL="0">
+              <a:buNone/>
+            </a:pPr>
+            <a:r>
+              <a:rPr lang="en-US" sz="1050" dirty="0">
+                <a:solidFill>
+                  <a:srgbClr val="262626"/>
+                </a:solidFill>
+              </a:rPr>
+              <a:t>21 channels, streamed</a:t>
+            </a:r>
+            <a:endParaRPr lang="en-US" sz="1200" dirty="0"/>
+          </a:p>
+        </p:txBody>
+      </p:sp>
+      <p:sp>
+        <p:nvSpPr>
+          <p:cNvPr id="11" name="Decoder cap"/>
+          <p:cNvSpPr txBox="1"/>
+          <p:nvPr/>
+        </p:nvSpPr>
+        <p:spPr>
+          <a:xfrm>
+            <a:off x="6217920" y="2670048"/>
+            <a:ext cx="1920240" cy="384048"/>
+          </a:xfrm>
+          <a:prstGeom prst="rect">
+            <a:avLst/>
+          </a:prstGeom>
+          <a:noFill/>
+          <a:ln/>
+        </p:spPr>
+        <p:txBody>
+          <a:bodyPr wrap="square" lIns="0" tIns="0" rIns="0" bIns="0" rtlCol="0" anchor="t"/>
+          <a:lstStyle/>
+          <a:p>
+            <a:pPr algn="ctr" indent="0" marL="0">
+              <a:buNone/>
+            </a:pPr>
+            <a:r>
+              <a:rPr lang="en-US" sz="1200" b="1" dirty="0">
+                <a:solidFill>
+                  <a:srgbClr val="000000"/>
+                </a:solidFill>
+              </a:rPr>
+              <a:t>Proposed decoders</a:t>
+            </a:r>
+            <a:endParaRPr lang="en-US" sz="1200" dirty="0"/>
+          </a:p>
+          <a:p>
+            <a:pPr algn="ctr" indent="0" marL="0">
+              <a:buNone/>
+            </a:pPr>
+            <a:r>
+              <a:rPr lang="en-US" sz="1050" dirty="0">
+                <a:solidFill>
+                  <a:srgbClr val="262626"/>
+                </a:solidFill>
+              </a:rPr>
+              <a:t>RED / LR-MoE</a:t>
+            </a:r>
+            <a:endParaRPr lang="en-US" sz="1200" dirty="0"/>
+          </a:p>
+        </p:txBody>
+      </p:sp>
+      <p:sp>
+        <p:nvSpPr>
+          <p:cNvPr id="12" name="scr-amp"/>
+          <p:cNvSpPr/>
+          <p:nvPr/>
+        </p:nvSpPr>
+        <p:spPr>
+          <a:xfrm>
+            <a:off x="1871472" y="2217420"/>
+            <a:ext cx="771560" cy="0"/>
+          </a:xfrm>
+          <a:prstGeom prst="line">
+            <a:avLst/>
+          </a:prstGeom>
+          <a:noFill/>
+          <a:ln w="15875">
+            <a:solidFill>
+              <a:srgbClr val="000000"/>
+            </a:solidFill>
+            <a:prstDash val="solid"/>
+            <a:tailEnd type="triangle"/>
+          </a:ln>
+        </p:spPr>
+      </p:sp>
+      <p:sp>
+        <p:nvSpPr>
+          <p:cNvPr id="13" name="amp-proc"/>
+          <p:cNvSpPr/>
+          <p:nvPr/>
+        </p:nvSpPr>
+        <p:spPr>
+          <a:xfrm>
+            <a:off x="3849208" y="2217420"/>
+            <a:ext cx="677072" cy="0"/>
+          </a:xfrm>
+          <a:prstGeom prst="line">
+            <a:avLst/>
+          </a:prstGeom>
+          <a:noFill/>
+          <a:ln w="15875">
+            <a:solidFill>
+              <a:srgbClr val="000000"/>
+            </a:solidFill>
+            <a:prstDash val="solid"/>
+            <a:tailEnd type="triangle"/>
+          </a:ln>
+        </p:spPr>
+      </p:sp>
+      <p:sp>
+        <p:nvSpPr>
+          <p:cNvPr id="14" name="proc-dec"/>
+          <p:cNvSpPr/>
+          <p:nvPr/>
+        </p:nvSpPr>
+        <p:spPr>
+          <a:xfrm>
+            <a:off x="6126480" y="2217420"/>
+            <a:ext cx="251044" cy="0"/>
+          </a:xfrm>
+          <a:prstGeom prst="line">
+            <a:avLst/>
+          </a:prstGeom>
+          <a:noFill/>
+          <a:ln w="15875">
+            <a:solidFill>
+              <a:srgbClr val="000000"/>
+            </a:solidFill>
+            <a:prstDash val="solid"/>
+            <a:tailEnd type="triangle"/>
+          </a:ln>
+        </p:spPr>
+      </p:sp>
+      <p:pic>
+        <p:nvPicPr>
+          <p:cNvPr id="15" name="Velocity" descr="Smoothed velocity commands toward a target">    </p:cNvPr>
+          <p:cNvPicPr>
+            <a:picLocks noChangeAspect="1"/>
+          </p:cNvPicPr>
+          <p:nvPr/>
+        </p:nvPicPr>
+        <p:blipFill>
+          <a:blip r:embed="rId4"/>
+          <a:stretch>
+            <a:fillRect/>
+          </a:stretch>
+        </p:blipFill>
+        <p:spPr>
+          <a:xfrm>
+            <a:off x="6606540" y="3520440"/>
+            <a:ext cx="1143000" cy="914400"/>
+          </a:xfrm>
+          <a:prstGeom prst="rect">
+            <a:avLst/>
+          </a:prstGeom>
+        </p:spPr>
+      </p:pic>
+      <p:sp>
+        <p:nvSpPr>
+          <p:cNvPr id="16" name="Controller"/>
+          <p:cNvSpPr/>
+          <p:nvPr/>
+        </p:nvSpPr>
+        <p:spPr>
+          <a:xfrm>
+            <a:off x="4206240" y="3657600"/>
+            <a:ext cx="1783080" cy="685800"/>
+          </a:xfrm>
+          <a:prstGeom prst="rect">
+            <a:avLst/>
+          </a:prstGeom>
+          <a:solidFill>
+            <a:srgbClr val="FFFFFF"/>
+          </a:solidFill>
+          <a:ln w="12700">
+            <a:solidFill>
+              <a:srgbClr val="000000"/>
+            </a:solidFill>
+            <a:prstDash val="solid"/>
+          </a:ln>
+        </p:spPr>
+        <p:txBody>
+          <a:bodyPr wrap="square" lIns="25400" tIns="25400" rIns="25400" bIns="25400" rtlCol="0" anchor="ctr"/>
+          <a:lstStyle/>
+          <a:p>
+            <a:pPr algn="ctr" indent="0" marL="0">
+              <a:buNone/>
+            </a:pPr>
+            <a:r>
+              <a:rPr lang="en-US" sz="1200" b="1" dirty="0">
+                <a:solidFill>
+                  <a:srgbClr val="000000"/>
+                </a:solidFill>
+              </a:rPr>
+              <a:t>Robot controller</a:t>
+            </a:r>
+            <a:endParaRPr lang="en-US" sz="1200" dirty="0"/>
+          </a:p>
+          <a:p>
+            <a:pPr algn="ctr" indent="0" marL="0">
+              <a:buNone/>
+            </a:pPr>
+            <a:r>
+              <a:rPr lang="en-US" sz="1050" dirty="0">
+                <a:solidFill>
+                  <a:srgbClr val="262626"/>
+                </a:solidFill>
+              </a:rPr>
+              <a:t>Cartesian velocity;</a:t>
+            </a:r>
+            <a:endParaRPr lang="en-US" sz="1200" dirty="0"/>
+          </a:p>
+          <a:p>
+            <a:pPr algn="ctr" indent="0" marL="0">
+              <a:buNone/>
+            </a:pPr>
+            <a:r>
+              <a:rPr lang="en-US" sz="1050" dirty="0">
+                <a:solidFill>
+                  <a:srgbClr val="262626"/>
+                </a:solidFill>
+              </a:rPr>
+              <a:t>workspace and speed limits</a:t>
+            </a:r>
+            <a:endParaRPr lang="en-US" sz="1200" dirty="0"/>
+          </a:p>
+        </p:txBody>
+      </p:sp>
+      <p:pic>
+        <p:nvPicPr>
+          <p:cNvPr id="17" name="Robot arm" descr="Robotic arm reaching for an object">    </p:cNvPr>
+          <p:cNvPicPr>
+            <a:picLocks noChangeAspect="1"/>
+          </p:cNvPicPr>
+          <p:nvPr/>
+        </p:nvPicPr>
+        <p:blipFill>
+          <a:blip r:embed="rId5"/>
+          <a:stretch>
+            <a:fillRect/>
+          </a:stretch>
+        </p:blipFill>
+        <p:spPr>
+          <a:xfrm>
+            <a:off x="758952" y="3566160"/>
+            <a:ext cx="1042416" cy="868680"/>
+          </a:xfrm>
+          <a:prstGeom prst="rect">
+            <a:avLst/>
+          </a:prstGeom>
+        </p:spPr>
+      </p:pic>
+      <p:sp>
+        <p:nvSpPr>
+          <p:cNvPr id="18" name="Vel cap"/>
+          <p:cNvSpPr txBox="1"/>
+          <p:nvPr/>
+        </p:nvSpPr>
+        <p:spPr>
+          <a:xfrm>
+            <a:off x="6126480" y="4453128"/>
+            <a:ext cx="2103120" cy="384048"/>
+          </a:xfrm>
+          <a:prstGeom prst="rect">
+            <a:avLst/>
+          </a:prstGeom>
+          <a:noFill/>
+          <a:ln/>
+        </p:spPr>
+        <p:txBody>
+          <a:bodyPr wrap="square" lIns="0" tIns="0" rIns="0" bIns="0" rtlCol="0" anchor="t"/>
+          <a:lstStyle/>
+          <a:p>
+            <a:pPr algn="ctr" indent="0" marL="0">
+              <a:buNone/>
+            </a:pPr>
+            <a:r>
+              <a:rPr lang="en-US" sz="1200" b="1" dirty="0">
+                <a:solidFill>
+                  <a:srgbClr val="000000"/>
+                </a:solidFill>
+              </a:rPr>
+              <a:t>Continuous control</a:t>
+            </a:r>
+            <a:endParaRPr lang="en-US" sz="1200" dirty="0"/>
+          </a:p>
+          <a:p>
+            <a:pPr algn="ctr" indent="0" marL="0">
+              <a:buNone/>
+            </a:pPr>
+            <a:r>
+              <a:rPr lang="en-US" sz="1050" dirty="0">
+                <a:solidFill>
+                  <a:srgbClr val="262626"/>
+                </a:solidFill>
+              </a:rPr>
+              <a:t>posterior every 200 ms → velocity</a:t>
+            </a:r>
+            <a:endParaRPr lang="en-US" sz="1200" dirty="0"/>
+          </a:p>
+          <a:p>
+            <a:pPr algn="ctr" indent="0" marL="0">
+              <a:buNone/>
+            </a:pPr>
+            <a:r>
+              <a:rPr lang="en-US" sz="1050" dirty="0">
+                <a:solidFill>
+                  <a:srgbClr val="262626"/>
+                </a:solidFill>
+              </a:rPr>
+              <a:t>∝ confidence, smoothed</a:t>
+            </a:r>
+            <a:endParaRPr lang="en-US" sz="1200" dirty="0"/>
+          </a:p>
+        </p:txBody>
+      </p:sp>
+      <p:sp>
+        <p:nvSpPr>
+          <p:cNvPr id="19" name="Arm cap"/>
+          <p:cNvSpPr txBox="1"/>
+          <p:nvPr/>
+        </p:nvSpPr>
+        <p:spPr>
+          <a:xfrm>
+            <a:off x="411480" y="4498848"/>
+            <a:ext cx="1737360" cy="384048"/>
+          </a:xfrm>
+          <a:prstGeom prst="rect">
+            <a:avLst/>
+          </a:prstGeom>
+          <a:noFill/>
+          <a:ln/>
+        </p:spPr>
+        <p:txBody>
+          <a:bodyPr wrap="square" lIns="0" tIns="0" rIns="0" bIns="0" rtlCol="0" anchor="t"/>
+          <a:lstStyle/>
+          <a:p>
+            <a:pPr algn="ctr" indent="0" marL="0">
+              <a:buNone/>
+            </a:pPr>
+            <a:r>
+              <a:rPr lang="en-US" sz="1200" b="1" dirty="0">
+                <a:solidFill>
+                  <a:srgbClr val="000000"/>
+                </a:solidFill>
+              </a:rPr>
+              <a:t>Robotic arm</a:t>
+            </a:r>
+            <a:endParaRPr lang="en-US" sz="1200" dirty="0"/>
+          </a:p>
+          <a:p>
+            <a:pPr algn="ctr" indent="0" marL="0">
+              <a:buNone/>
+            </a:pPr>
+            <a:r>
+              <a:rPr lang="en-US" sz="1050" dirty="0">
+                <a:solidFill>
+                  <a:srgbClr val="262626"/>
+                </a:solidFill>
+              </a:rPr>
+              <a:t>user watches it directly</a:t>
+            </a:r>
+            <a:endParaRPr lang="en-US" sz="1200" dirty="0"/>
+          </a:p>
+        </p:txBody>
+      </p:sp>
+      <p:sp>
+        <p:nvSpPr>
+          <p:cNvPr id="20" name="dec-vel"/>
+          <p:cNvSpPr/>
+          <p:nvPr/>
+        </p:nvSpPr>
+        <p:spPr>
+          <a:xfrm>
+            <a:off x="7178040" y="3081528"/>
+            <a:ext cx="0" cy="502920"/>
+          </a:xfrm>
+          <a:prstGeom prst="line">
+            <a:avLst/>
+          </a:prstGeom>
+          <a:noFill/>
+          <a:ln w="15875">
+            <a:solidFill>
+              <a:srgbClr val="000000"/>
+            </a:solidFill>
+            <a:prstDash val="solid"/>
+            <a:tailEnd type="triangle"/>
+          </a:ln>
+        </p:spPr>
+      </p:sp>
+      <p:sp>
+        <p:nvSpPr>
+          <p:cNvPr id="21" name="vel-ctrl"/>
+          <p:cNvSpPr/>
+          <p:nvPr/>
+        </p:nvSpPr>
+        <p:spPr>
+          <a:xfrm flipH="1">
+            <a:off x="5989320" y="3977640"/>
+            <a:ext cx="544068" cy="0"/>
+          </a:xfrm>
+          <a:prstGeom prst="line">
+            <a:avLst/>
+          </a:prstGeom>
+          <a:noFill/>
+          <a:ln w="15875">
+            <a:solidFill>
+              <a:srgbClr val="000000"/>
+            </a:solidFill>
+            <a:prstDash val="solid"/>
+            <a:tailEnd type="triangle"/>
+          </a:ln>
+        </p:spPr>
+      </p:sp>
+      <p:sp>
+        <p:nvSpPr>
+          <p:cNvPr id="22" name="ctrl-arm"/>
+          <p:cNvSpPr/>
+          <p:nvPr/>
+        </p:nvSpPr>
+        <p:spPr>
+          <a:xfrm flipH="1">
+            <a:off x="1874520" y="3977640"/>
+            <a:ext cx="2331720" cy="0"/>
+          </a:xfrm>
+          <a:prstGeom prst="line">
+            <a:avLst/>
+          </a:prstGeom>
+          <a:noFill/>
+          <a:ln w="15875">
+            <a:solidFill>
+              <a:srgbClr val="000000"/>
+            </a:solidFill>
+            <a:prstDash val="solid"/>
+            <a:tailEnd type="triangle"/>
+          </a:ln>
+        </p:spPr>
+      </p:sp>
+      <p:sp>
+        <p:nvSpPr>
+          <p:cNvPr id="23" name="feedback"/>
+          <p:cNvSpPr/>
+          <p:nvPr/>
+        </p:nvSpPr>
+        <p:spPr>
+          <a:xfrm flipV="1">
+            <a:off x="548640" y="2217420"/>
+            <a:ext cx="0" cy="1783080"/>
+          </a:xfrm>
+          <a:prstGeom prst="line">
+            <a:avLst/>
+          </a:prstGeom>
+          <a:noFill/>
+          <a:ln w="15875">
+            <a:solidFill>
+              <a:srgbClr val="A00000"/>
+            </a:solidFill>
+            <a:prstDash val="dash"/>
+          </a:ln>
+        </p:spPr>
+      </p:sp>
+      <p:sp>
+        <p:nvSpPr>
+          <p:cNvPr id="24" name="feedback-h1"/>
+          <p:cNvSpPr/>
+          <p:nvPr/>
+        </p:nvSpPr>
+        <p:spPr>
+          <a:xfrm>
+            <a:off x="548640" y="4000500"/>
+            <a:ext cx="192024" cy="0"/>
+          </a:xfrm>
+          <a:prstGeom prst="line">
+            <a:avLst/>
+          </a:prstGeom>
+          <a:noFill/>
+          <a:ln w="15875">
+            <a:solidFill>
+              <a:srgbClr val="A00000"/>
+            </a:solidFill>
+            <a:prstDash val="dash"/>
+          </a:ln>
+        </p:spPr>
+      </p:sp>
+      <p:sp>
+        <p:nvSpPr>
+          <p:cNvPr id="25" name="feedback-h2"/>
+          <p:cNvSpPr/>
+          <p:nvPr/>
+        </p:nvSpPr>
+        <p:spPr>
+          <a:xfrm>
+            <a:off x="548640" y="2217420"/>
+            <a:ext cx="185928" cy="0"/>
+          </a:xfrm>
+          <a:prstGeom prst="line">
+            <a:avLst/>
+          </a:prstGeom>
+          <a:noFill/>
+          <a:ln w="15875">
+            <a:solidFill>
+              <a:srgbClr val="A00000"/>
+            </a:solidFill>
+            <a:prstDash val="solid"/>
+            <a:tailEnd type="triangle"/>
+          </a:ln>
+        </p:spPr>
+      </p:sp>
+      <p:sp>
+        <p:nvSpPr>
+          <p:cNvPr id="26" name="Feedback label"/>
+          <p:cNvSpPr txBox="1"/>
+          <p:nvPr/>
+        </p:nvSpPr>
+        <p:spPr>
+          <a:xfrm>
+            <a:off x="621792" y="3200400"/>
+            <a:ext cx="1188720" cy="274320"/>
+          </a:xfrm>
+          <a:prstGeom prst="rect">
+            <a:avLst/>
+          </a:prstGeom>
+          <a:noFill/>
+          <a:ln/>
+        </p:spPr>
+        <p:txBody>
+          <a:bodyPr wrap="square" lIns="0" tIns="0" rIns="0" bIns="0" rtlCol="0" anchor="ctr"/>
+          <a:lstStyle/>
+          <a:p>
+            <a:pPr indent="0" marL="0">
+              <a:buNone/>
+            </a:pPr>
+            <a:r>
+              <a:rPr lang="en-US" sz="1100" i="1" dirty="0">
+                <a:solidFill>
+                  <a:schemeClr val="accent1"/>
+                </a:solidFill>
+              </a:rPr>
+              <a:t>visual feedback</a:t>
+            </a:r>
+            <a:endParaRPr lang="en-US" sz="1100" dirty="0"/>
+          </a:p>
+        </p:txBody>
+      </p:sp>
+      <p:sp>
+        <p:nvSpPr>
+          <p:cNvPr id="27" name="Metrics"/>
+          <p:cNvSpPr txBox="1"/>
+          <p:nvPr/>
+        </p:nvSpPr>
+        <p:spPr>
+          <a:xfrm>
+            <a:off x="548640" y="5257800"/>
+            <a:ext cx="7498080" cy="548640"/>
+          </a:xfrm>
+          <a:prstGeom prst="rect">
+            <a:avLst/>
+          </a:prstGeom>
+          <a:noFill/>
+          <a:ln/>
+        </p:spPr>
+        <p:txBody>
+          <a:bodyPr wrap="square" lIns="0" tIns="0" rIns="0" bIns="0" rtlCol="0" anchor="ctr"/>
+          <a:lstStyle/>
+          <a:p>
+            <a:pPr indent="0" marL="0">
+              <a:buNone/>
+            </a:pPr>
+            <a:r>
+              <a:rPr lang="en-US" sz="1300" b="1" dirty="0">
+                <a:solidFill>
+                  <a:schemeClr val="tx1"/>
+                </a:solidFill>
+              </a:rPr>
+              <a:t>Online evaluation: </a:t>
+            </a:r>
+            <a:pPr indent="0" marL="0">
+              <a:buNone/>
+            </a:pPr>
+            <a:r>
+              <a:rPr lang="en-US" sz="1300" dirty="0">
+                <a:solidFill>
+                  <a:schemeClr val="tx1"/>
+                </a:solidFill>
+              </a:rPr>
+              <a:t>accuracy · ITR · command latency · task success and completion time · path efficiency · workload (NASA-TLX)</a:t>
+            </a:r>
+            <a:endParaRPr lang="en-US" sz="1300" dirty="0"/>
+          </a:p>
+        </p:txBody>
+      </p:sp>
+      <p:sp>
+        <p:nvSpPr>
+          <p:cNvPr id="28" name="Foundation head"/>
+          <p:cNvSpPr txBox="1"/>
+          <p:nvPr/>
+        </p:nvSpPr>
+        <p:spPr>
+          <a:xfrm>
+            <a:off x="8412480" y="1600200"/>
+            <a:ext cx="3429000" cy="320040"/>
+          </a:xfrm>
+          <a:prstGeom prst="rect">
+            <a:avLst/>
+          </a:prstGeom>
+          <a:noFill/>
+          <a:ln/>
+        </p:spPr>
+        <p:txBody>
+          <a:bodyPr wrap="square" lIns="0" tIns="0" rIns="0" bIns="0" rtlCol="0" anchor="ctr"/>
+          <a:lstStyle/>
+          <a:p>
+            <a:pPr indent="0" marL="0">
+              <a:buNone/>
+            </a:pPr>
+            <a:r>
+              <a:rPr lang="en-US" sz="1500" b="1" dirty="0">
+                <a:solidFill>
+                  <a:schemeClr val="accent1"/>
+                </a:solidFill>
+              </a:rPr>
+              <a:t>Foundation: preliminary system</a:t>
+            </a:r>
+            <a:endParaRPr lang="en-US" sz="1500" dirty="0"/>
+          </a:p>
+        </p:txBody>
+      </p:sp>
+      <p:sp>
+        <p:nvSpPr>
+          <p:cNvPr id="29" name="Photo slot"/>
+          <p:cNvSpPr/>
+          <p:nvPr/>
+        </p:nvSpPr>
+        <p:spPr>
+          <a:xfrm>
+            <a:off x="8412480" y="1965960"/>
+            <a:ext cx="3429000" cy="1920240"/>
+          </a:xfrm>
+          <a:prstGeom prst="rect">
+            <a:avLst/>
+          </a:prstGeom>
+          <a:solidFill>
+            <a:srgbClr val="F2F2F2"/>
+          </a:solidFill>
+          <a:ln w="9525">
+            <a:solidFill>
+              <a:srgbClr val="BFBFBF"/>
+            </a:solidFill>
+            <a:prstDash val="dash"/>
+          </a:ln>
+        </p:spPr>
+      </p:sp>
+      <p:sp>
+        <p:nvSpPr>
+          <p:cNvPr id="30" name="Photo slot text"/>
+          <p:cNvSpPr txBox="1"/>
+          <p:nvPr/>
+        </p:nvSpPr>
+        <p:spPr>
+          <a:xfrm>
+            <a:off x="8595360" y="1965960"/>
+            <a:ext cx="3063240" cy="1920240"/>
+          </a:xfrm>
+          <a:prstGeom prst="rect">
+            <a:avLst/>
+          </a:prstGeom>
+          <a:noFill/>
+          <a:ln/>
+        </p:spPr>
+        <p:txBody>
+          <a:bodyPr wrap="square" lIns="0" tIns="0" rIns="0" bIns="0" rtlCol="0" anchor="ctr"/>
+          <a:lstStyle/>
+          <a:p>
+            <a:pPr algn="ctr" indent="0" marL="0">
+              <a:buNone/>
+            </a:pPr>
+            <a:r>
+              <a:rPr lang="en-US" sz="1200" dirty="0">
+                <a:solidFill>
+                  <a:schemeClr val="accent3"/>
+                </a:solidFill>
+              </a:rPr>
+              <a:t>[Photo of the preliminary brain-controlled robotic arm system]</a:t>
+            </a:r>
+            <a:endParaRPr lang="en-US" sz="1200" dirty="0"/>
+          </a:p>
+        </p:txBody>
+      </p:sp>
+      <p:sp>
+        <p:nvSpPr>
+          <p:cNvPr id="31" name="Award"/>
+          <p:cNvSpPr txBox="1"/>
+          <p:nvPr/>
+        </p:nvSpPr>
+        <p:spPr>
+          <a:xfrm>
+            <a:off x="8412480" y="3950208"/>
+            <a:ext cx="3429000" cy="320040"/>
+          </a:xfrm>
+          <a:prstGeom prst="rect">
+            <a:avLst/>
+          </a:prstGeom>
+          <a:noFill/>
+          <a:ln/>
+        </p:spPr>
+        <p:txBody>
+          <a:bodyPr wrap="square" lIns="0" tIns="0" rIns="0" bIns="0" rtlCol="0" anchor="ctr"/>
+          <a:lstStyle/>
+          <a:p>
+            <a:pPr algn="ctr" indent="0" marL="0">
+              <a:buNone/>
+            </a:pPr>
+            <a:r>
+              <a:rPr lang="en-US" sz="1400" b="1" dirty="0">
+                <a:solidFill>
+                  <a:schemeClr val="tx1"/>
+                </a:solidFill>
+              </a:rPr>
+              <a:t>[Competition name] · [Award] · [Year]</a:t>
+            </a:r>
+            <a:endParaRPr lang="en-US" sz="1400" dirty="0"/>
+          </a:p>
+        </p:txBody>
+      </p:sp>
+      <p:sp>
+        <p:nvSpPr>
+          <p:cNvPr id="32" name="Foundation points"/>
+          <p:cNvSpPr txBox="1"/>
+          <p:nvPr/>
+        </p:nvSpPr>
+        <p:spPr>
+          <a:xfrm>
+            <a:off x="8412480" y="4343400"/>
+            <a:ext cx="3429000" cy="1554480"/>
+          </a:xfrm>
+          <a:prstGeom prst="rect">
+            <a:avLst/>
+          </a:prstGeom>
+          <a:noFill/>
+          <a:ln/>
+        </p:spPr>
+        <p:txBody>
+          <a:bodyPr wrap="square" lIns="0" tIns="0" rIns="0" bIns="0" rtlCol="0" anchor="t"/>
+          <a:lstStyle/>
+          <a:p>
+            <a:pPr marL="342900" indent="-342900">
+              <a:spcAft>
+                <a:spcPts val="400"/>
+              </a:spcAft>
+              <a:buSzPct val="100000"/>
+              <a:buChar char="•"/>
+            </a:pPr>
+            <a:r>
+              <a:rPr lang="en-US" sz="1350" dirty="0">
+                <a:solidFill>
+                  <a:schemeClr val="tx1"/>
+                </a:solidFill>
+              </a:rPr>
+              <a:t>Existing pipeline: stimulation, EEG acquisition, decoding and robot control</a:t>
+            </a:r>
+            <a:endParaRPr lang="en-US" sz="1350" dirty="0"/>
+          </a:p>
+          <a:p>
+            <a:pPr marL="342900" indent="-342900">
+              <a:spcAft>
+                <a:spcPts val="400"/>
+              </a:spcAft>
+              <a:buSzPct val="100000"/>
+              <a:buChar char="•"/>
+            </a:pPr>
+            <a:r>
+              <a:rPr lang="en-US" sz="1350" dirty="0">
+                <a:solidFill>
+                  <a:schemeClr val="tx1"/>
+                </a:solidFill>
+              </a:rPr>
+              <a:t>Chapter 3 adds: aVEP interface, the proposed decoders, continuous control</a:t>
+            </a:r>
+            <a:endParaRPr lang="en-US" sz="1350" dirty="0"/>
+          </a:p>
+        </p:txBody>
+      </p:sp>
+      <p:sp>
+        <p:nvSpPr>
+          <p:cNvPr id="25" name="Slide Number Placeholder 0"/>
+          <p:cNvSpPr>
+            <a:spLocks noGrp="1"/>
+          </p:cNvSpPr>
+          <p:nvPr>
+            <p:ph type="sldNum" sz="quarter" idx="4294967295"/>
+          </p:nvPr>
+        </p:nvSpPr>
+        <p:spPr>
+          <a:xfrm>
+            <a:off x="11292840" y="6382512"/>
+            <a:ext cx="594360" cy="320040"/>
+          </a:xfrm>
+          <a:prstGeom prst="rect">
+            <a:avLst/>
+          </a:prstGeom>
+          <a:extLst>
+            <a:ext uri="{C572A759-6A51-4108-AA02-DFA0A04FC94B}">
+              <ma14:wrappingTextBoxFlag xmlns:ma14="http://schemas.microsoft.com/office/mac/drawingml/2011/main" val="0"/>
+            </a:ext>
+          </a:extLst>
+        </p:spPr>
+        <p:txBody>
+          <a:bodyPr/>
+          <a:lstStyle>
+            <a:lvl1pPr>
+              <a:defRPr sz="1400">
+                <a:solidFill>
+                  <a:schemeClr val="tx1"/>
+                </a:solidFill>
+              </a:defRPr>
+            </a:lvl1pPr>
+          </a:lstStyle>
+          <a:p>
+            <a:pPr algn="r"/>
+            <a:fld id="{F7021451-1387-4CA6-816F-3879F97B5CBC}" type="slidenum">
+              <a:rPr b="0" lang="en-US"/>
+              <a:t>14</a:t>
             </a:fld>
             <a:endParaRPr lang="en-US"/>
           </a:p>

</xml_diff>

<commit_message>
Add project schedule: Gantt chart Nov 2026 - May 2027 with milestones
Outline slide for part 4 and a Gantt chart covering the remaining work on
Chapters 1-2, the online robotic arm system (incl. ethics approval), papers,
thesis writing, revision and the final defense, with six milestones.

Co-Authored-By: Claude Opus 5.5 <noreply@anthropic.com>
Claude-Session: https://claude.ai/code/session_01M2N1FL6JrZz8kTbkaY5rZ8
</commit_message>
<xml_diff>
--- a/presentation/midterm_defense_sample.pptx
+++ b/presentation/midterm_defense_sample.pptx
@@ -19,9 +19,11 @@
     <p:sldId id="267" r:id="rId13"/>
     <p:sldId id="268" r:id="rId14"/>
     <p:sldId id="269" r:id="rId15"/>
+    <p:sldId id="270" r:id="rId16"/>
+    <p:sldId id="271" r:id="rId17"/>
   </p:sldIdLst>
   <p:notesMasterIdLst>
-    <p:notesMasterId r:id="rId16"/>
+    <p:notesMasterId r:id="rId18"/>
   </p:notesMasterIdLst>
   <p:sldSz cx="12192000" cy="6858000"/>
   <p:notesSz cx="6858000" cy="12192000"/>
@@ -120,12 +122,12 @@
   <p:extLst>
     <p:ext uri="{521415D9-36F7-43E2-AB2F-B90AF26B5E84}">
       <p14:sectionLst xmlns:p14="http://schemas.microsoft.com/office/powerpoint/2010/main">
-        <p14:section name="Opening" id="{f65439e6-c17b-005b-3be4-4fe3f2e82916}">
+        <p14:section name="Opening" id="{19c6040d-ee94-5a27-88fd-954da3f96632}">
           <p14:sldIdLst>
             <p14:sldId id="256"/>
           </p14:sldIdLst>
         </p14:section>
-        <p14:section name="Research Background and Objectives" id="{d5c9c9e0-8dfe-257a-2598-948dfa2d426f}">
+        <p14:section name="Research Background and Objectives" id="{f097e6b9-d896-241a-f688-1790bbebdfb3}">
           <p14:sldIdLst>
             <p14:sldId id="257"/>
             <p14:sldId id="258"/>
@@ -133,7 +135,7 @@
             <p14:sldId id="260"/>
           </p14:sldIdLst>
         </p14:section>
-        <p14:section name="Research Progress and Stage Achievements" id="{ae354c8e-1fcd-48f0-f3e2-0d9bd0f25fae}">
+        <p14:section name="Research Progress and Stage Achievements" id="{546ea5b7-bf41-a385-f1ed-33863a2c6844}">
           <p14:sldIdLst>
             <p14:sldId id="261"/>
             <p14:sldId id="262"/>
@@ -143,11 +145,17 @@
             <p14:sldId id="266"/>
           </p14:sldIdLst>
         </p14:section>
-        <p14:section name="Next-stage Research Plan" id="{a6249486-14aa-1818-b1b6-1ae12c56094a}">
+        <p14:section name="Next-stage Research Plan" id="{7e0867ce-9098-ed14-5041-2ba682b7734a}">
           <p14:sldIdLst>
             <p14:sldId id="267"/>
             <p14:sldId id="268"/>
             <p14:sldId id="269"/>
+          </p14:sldIdLst>
+        </p14:section>
+        <p14:section name="Project Schedule" id="{bca9f9ee-c6be-75aa-16eb-b564a98a92bb}">
+          <p14:sldIdLst>
+            <p14:sldId id="270"/>
+            <p14:sldId id="271"/>
           </p14:sldIdLst>
         </p14:section>
       </p14:sectionLst>
@@ -1018,6 +1026,182 @@
             <a:fld id="{F7021451-1387-4CA6-816F-3879F97B5CBC}" type="slidenum">
               <a:rPr lang="en-US"/>
               <a:t>14</a:t>
+            </a:fld>
+            <a:endParaRPr lang="en-US"/>
+          </a:p>
+        </p:txBody>
+      </p:sp>
+    </p:spTree>
+    <p:extLst>
+      <p:ext uri="{BB962C8B-B14F-4D97-AF65-F5344CB8AC3E}">
+        <p14:creationId xmlns:p14="http://schemas.microsoft.com/office/powerpoint/2010/main" val="1024086991"/>
+      </p:ext>
+    </p:extLst>
+  </p:cSld>
+  <p:clrMapOvr>
+    <a:masterClrMapping/>
+  </p:clrMapOvr>
+</p:notes>
+</file>
+
+<file path=ppt/notesSlides/notesSlide15.xml><?xml version="1.0" encoding="utf-8"?>
+<p:notes xmlns:a="http://schemas.openxmlformats.org/drawingml/2006/main" xmlns:r="http://schemas.openxmlformats.org/officeDocument/2006/relationships" xmlns:p="http://schemas.openxmlformats.org/presentationml/2006/main">
+  <p:cSld>
+    <p:spTree>
+      <p:nvGrpSpPr>
+        <p:cNvPr id="1" name=""/>
+        <p:cNvGrpSpPr/>
+        <p:nvPr/>
+      </p:nvGrpSpPr>
+      <p:grpSpPr>
+        <a:xfrm>
+          <a:off x="0" y="0"/>
+          <a:ext cx="0" cy="0"/>
+          <a:chOff x="0" y="0"/>
+          <a:chExt cx="0" cy="0"/>
+        </a:xfrm>
+      </p:grpSpPr>
+      <p:sp>
+        <p:nvSpPr>
+          <p:cNvPr id="2" name="Slide Image Placeholder 1"/>
+          <p:cNvSpPr>
+            <a:spLocks noGrp="1" noRot="1" noChangeAspect="1"/>
+          </p:cNvSpPr>
+          <p:nvPr>
+            <p:ph type="sldImg"/>
+          </p:nvPr>
+        </p:nvSpPr>
+        <p:spPr/>
+      </p:sp>
+      <p:sp>
+        <p:nvSpPr>
+          <p:cNvPr id="3" name="Notes Placeholder 2"/>
+          <p:cNvSpPr>
+            <a:spLocks noGrp="1"/>
+          </p:cNvSpPr>
+          <p:nvPr>
+            <p:ph type="body" idx="1"/>
+          </p:nvPr>
+        </p:nvSpPr>
+        <p:spPr/>
+        <p:txBody>
+          <a:bodyPr/>
+          <a:lstStyle/>
+          <a:p>
+            <a:r>
+              <a:rPr lang="en-US" dirty="0"/>
+              <a:t>~3 s.</a:t>
+            </a:r>
+            <a:endParaRPr lang="en-US" dirty="0"/>
+          </a:p>
+        </p:txBody>
+      </p:sp>
+      <p:sp>
+        <p:nvSpPr>
+          <p:cNvPr id="4" name="Slide Number Placeholder 3"/>
+          <p:cNvSpPr>
+            <a:spLocks noGrp="1"/>
+          </p:cNvSpPr>
+          <p:nvPr>
+            <p:ph type="sldNum" sz="quarter" idx="10"/>
+          </p:nvPr>
+        </p:nvSpPr>
+        <p:spPr/>
+        <p:txBody>
+          <a:bodyPr/>
+          <a:lstStyle/>
+          <a:p>
+            <a:fld id="{F7021451-1387-4CA6-816F-3879F97B5CBC}" type="slidenum">
+              <a:rPr lang="en-US"/>
+              <a:t>15</a:t>
+            </a:fld>
+            <a:endParaRPr lang="en-US"/>
+          </a:p>
+        </p:txBody>
+      </p:sp>
+    </p:spTree>
+    <p:extLst>
+      <p:ext uri="{BB962C8B-B14F-4D97-AF65-F5344CB8AC3E}">
+        <p14:creationId xmlns:p14="http://schemas.microsoft.com/office/powerpoint/2010/main" val="1024086991"/>
+      </p:ext>
+    </p:extLst>
+  </p:cSld>
+  <p:clrMapOvr>
+    <a:masterClrMapping/>
+  </p:clrMapOvr>
+</p:notes>
+</file>
+
+<file path=ppt/notesSlides/notesSlide16.xml><?xml version="1.0" encoding="utf-8"?>
+<p:notes xmlns:a="http://schemas.openxmlformats.org/drawingml/2006/main" xmlns:r="http://schemas.openxmlformats.org/officeDocument/2006/relationships" xmlns:p="http://schemas.openxmlformats.org/presentationml/2006/main">
+  <p:cSld>
+    <p:spTree>
+      <p:nvGrpSpPr>
+        <p:cNvPr id="1" name=""/>
+        <p:cNvGrpSpPr/>
+        <p:nvPr/>
+      </p:nvGrpSpPr>
+      <p:grpSpPr>
+        <a:xfrm>
+          <a:off x="0" y="0"/>
+          <a:ext cx="0" cy="0"/>
+          <a:chOff x="0" y="0"/>
+          <a:chExt cx="0" cy="0"/>
+        </a:xfrm>
+      </p:grpSpPr>
+      <p:sp>
+        <p:nvSpPr>
+          <p:cNvPr id="2" name="Slide Image Placeholder 1"/>
+          <p:cNvSpPr>
+            <a:spLocks noGrp="1" noRot="1" noChangeAspect="1"/>
+          </p:cNvSpPr>
+          <p:nvPr>
+            <p:ph type="sldImg"/>
+          </p:nvPr>
+        </p:nvSpPr>
+        <p:spPr/>
+      </p:sp>
+      <p:sp>
+        <p:nvSpPr>
+          <p:cNvPr id="3" name="Notes Placeholder 2"/>
+          <p:cNvSpPr>
+            <a:spLocks noGrp="1"/>
+          </p:cNvSpPr>
+          <p:nvPr>
+            <p:ph type="body" idx="1"/>
+          </p:nvPr>
+        </p:nvSpPr>
+        <p:spPr/>
+        <p:txBody>
+          <a:bodyPr/>
+          <a:lstStyle/>
+          <a:p>
+            <a:r>
+              <a:rPr lang="en-US" dirty="0"/>
+              <a:t>~30 s. Until mid-February: finish Chapter 1 experiments and implement Chapter 2. In parallel, from December, ethics approval and integration of the online system. Chapter 2 results by the end of February, an online demo in mid-March, online experiments until mid-April. Papers are written from mid-January, the thesis from mid-March, with the draft to my supervisor on April 20, then revision and the final defense at the end of May.</a:t>
+            </a:r>
+            <a:endParaRPr lang="en-US" dirty="0"/>
+          </a:p>
+        </p:txBody>
+      </p:sp>
+      <p:sp>
+        <p:nvSpPr>
+          <p:cNvPr id="4" name="Slide Number Placeholder 3"/>
+          <p:cNvSpPr>
+            <a:spLocks noGrp="1"/>
+          </p:cNvSpPr>
+          <p:nvPr>
+            <p:ph type="sldNum" sz="quarter" idx="10"/>
+          </p:nvPr>
+        </p:nvSpPr>
+        <p:spPr/>
+        <p:txBody>
+          <a:bodyPr/>
+          <a:lstStyle/>
+          <a:p>
+            <a:fld id="{F7021451-1387-4CA6-816F-3879F97B5CBC}" type="slidenum">
+              <a:rPr lang="en-US"/>
+              <a:t>16</a:t>
             </a:fld>
             <a:endParaRPr lang="en-US"/>
           </a:p>
@@ -7587,6 +7771,2165 @@
 </p:sld>
 </file>
 
+<file path=ppt/slides/slide15.xml><?xml version="1.0" encoding="utf-8"?>
+<p:sld xmlns:a="http://schemas.openxmlformats.org/drawingml/2006/main" xmlns:r="http://schemas.openxmlformats.org/officeDocument/2006/relationships" xmlns:p="http://schemas.openxmlformats.org/presentationml/2006/main">
+  <p:cSld name="Slide 15">
+    <p:spTree>
+      <p:nvGrpSpPr>
+        <p:cNvPr id="1" name=""/>
+        <p:cNvGrpSpPr/>
+        <p:nvPr/>
+      </p:nvGrpSpPr>
+      <p:grpSpPr>
+        <a:xfrm>
+          <a:off x="0" y="0"/>
+          <a:ext cx="0" cy="0"/>
+          <a:chOff x="0" y="0"/>
+          <a:chExt cx="0" cy="0"/>
+        </a:xfrm>
+      </p:grpSpPr>
+      <p:sp>
+        <p:nvSpPr>
+          <p:cNvPr id="2" name="Outline list"/>
+          <p:cNvSpPr txBox="1"/>
+          <p:nvPr/>
+        </p:nvSpPr>
+        <p:spPr>
+          <a:xfrm>
+            <a:off x="4389120" y="1920240"/>
+            <a:ext cx="7132320" cy="2926080"/>
+          </a:xfrm>
+          <a:prstGeom prst="rect">
+            <a:avLst/>
+          </a:prstGeom>
+          <a:noFill/>
+          <a:ln/>
+        </p:spPr>
+        <p:txBody>
+          <a:bodyPr wrap="square" lIns="0" tIns="0" rIns="0" bIns="0" rtlCol="0" anchor="ctr"/>
+          <a:lstStyle/>
+          <a:p>
+            <a:pPr marL="342900" indent="-342900">
+              <a:spcAft>
+                <a:spcPts val="1800"/>
+              </a:spcAft>
+              <a:buSzPct val="100000"/>
+              <a:buChar char="•"/>
+            </a:pPr>
+            <a:r>
+              <a:rPr lang="en-US" sz="2600" dirty="0">
+                <a:solidFill>
+                  <a:srgbClr val="000000"/>
+                </a:solidFill>
+              </a:rPr>
+              <a:t>Research Background and Objectives</a:t>
+            </a:r>
+            <a:endParaRPr lang="en-US" sz="2600" dirty="0"/>
+          </a:p>
+          <a:p>
+            <a:pPr marL="342900" indent="-342900">
+              <a:spcAft>
+                <a:spcPts val="1800"/>
+              </a:spcAft>
+              <a:buSzPct val="100000"/>
+              <a:buChar char="•"/>
+            </a:pPr>
+            <a:r>
+              <a:rPr lang="en-US" sz="2600" dirty="0">
+                <a:solidFill>
+                  <a:srgbClr val="000000"/>
+                </a:solidFill>
+              </a:rPr>
+              <a:t>Research Progress and Stage Achievements</a:t>
+            </a:r>
+            <a:endParaRPr lang="en-US" sz="2600" dirty="0"/>
+          </a:p>
+          <a:p>
+            <a:pPr marL="342900" indent="-342900">
+              <a:spcAft>
+                <a:spcPts val="1800"/>
+              </a:spcAft>
+              <a:buSzPct val="100000"/>
+              <a:buChar char="•"/>
+            </a:pPr>
+            <a:r>
+              <a:rPr lang="en-US" sz="2600" dirty="0">
+                <a:solidFill>
+                  <a:srgbClr val="000000"/>
+                </a:solidFill>
+              </a:rPr>
+              <a:t>Next-stage Research Plan</a:t>
+            </a:r>
+            <a:endParaRPr lang="en-US" sz="2600" dirty="0"/>
+          </a:p>
+          <a:p>
+            <a:pPr marL="342900" indent="-342900">
+              <a:spcAft>
+                <a:spcPts val="1800"/>
+              </a:spcAft>
+              <a:buSzPct val="100000"/>
+              <a:buChar char="•"/>
+            </a:pPr>
+            <a:r>
+              <a:rPr lang="en-US" sz="2600" dirty="0">
+                <a:solidFill>
+                  <a:srgbClr val="A00000"/>
+                </a:solidFill>
+              </a:rPr>
+              <a:t>Project Schedule</a:t>
+            </a:r>
+            <a:endParaRPr lang="en-US" sz="2600" dirty="0"/>
+          </a:p>
+        </p:txBody>
+      </p:sp>
+      <p:sp>
+        <p:nvSpPr>
+          <p:cNvPr id="25" name="Slide Number Placeholder 0"/>
+          <p:cNvSpPr>
+            <a:spLocks noGrp="1"/>
+          </p:cNvSpPr>
+          <p:nvPr>
+            <p:ph type="sldNum" sz="quarter" idx="4294967295"/>
+          </p:nvPr>
+        </p:nvSpPr>
+        <p:spPr>
+          <a:xfrm>
+            <a:off x="11292840" y="6382512"/>
+            <a:ext cx="594360" cy="320040"/>
+          </a:xfrm>
+          <a:prstGeom prst="rect">
+            <a:avLst/>
+          </a:prstGeom>
+          <a:extLst>
+            <a:ext uri="{C572A759-6A51-4108-AA02-DFA0A04FC94B}">
+              <ma14:wrappingTextBoxFlag xmlns:ma14="http://schemas.microsoft.com/office/mac/drawingml/2011/main" val="0"/>
+            </a:ext>
+          </a:extLst>
+        </p:spPr>
+        <p:txBody>
+          <a:bodyPr/>
+          <a:lstStyle>
+            <a:lvl1pPr>
+              <a:defRPr sz="1400">
+                <a:solidFill>
+                  <a:schemeClr val="tx1"/>
+                </a:solidFill>
+              </a:defRPr>
+            </a:lvl1pPr>
+          </a:lstStyle>
+          <a:p>
+            <a:pPr algn="r"/>
+            <a:fld id="{F7021451-1387-4CA6-816F-3879F97B5CBC}" type="slidenum">
+              <a:rPr b="0" lang="en-US"/>
+              <a:t>15</a:t>
+            </a:fld>
+            <a:endParaRPr lang="en-US"/>
+          </a:p>
+        </p:txBody>
+      </p:sp>
+    </p:spTree>
+  </p:cSld>
+  <p:clrMapOvr>
+    <a:masterClrMapping/>
+  </p:clrMapOvr>
+</p:sld>
+</file>
+
+<file path=ppt/slides/slide16.xml><?xml version="1.0" encoding="utf-8"?>
+<p:sld xmlns:a="http://schemas.openxmlformats.org/drawingml/2006/main" xmlns:r="http://schemas.openxmlformats.org/officeDocument/2006/relationships" xmlns:p="http://schemas.openxmlformats.org/presentationml/2006/main">
+  <p:cSld name="Slide 16">
+    <p:spTree>
+      <p:nvGrpSpPr>
+        <p:cNvPr id="1" name=""/>
+        <p:cNvGrpSpPr/>
+        <p:nvPr/>
+      </p:nvGrpSpPr>
+      <p:grpSpPr>
+        <a:xfrm>
+          <a:off x="0" y="0"/>
+          <a:ext cx="0" cy="0"/>
+          <a:chOff x="0" y="0"/>
+          <a:chExt cx="0" cy="0"/>
+        </a:xfrm>
+      </p:grpSpPr>
+      <p:sp>
+        <p:nvSpPr>
+          <p:cNvPr id="2" name="Text 4"/>
+          <p:cNvSpPr/>
+          <p:nvPr>
+            <p:ph idx="104" type="title" hasCustomPrompt="1"/>
+          </p:nvPr>
+        </p:nvSpPr>
+        <p:spPr>
+          <a:xfrm>
+            <a:off x="457200" y="274320"/>
+            <a:ext cx="8001000" cy="749808"/>
+          </a:xfrm>
+          <a:prstGeom prst="rect">
+            <a:avLst/>
+          </a:prstGeom>
+          <a:noFill/>
+          <a:ln/>
+        </p:spPr>
+        <p:txBody>
+          <a:bodyPr wrap="square" lIns="0" tIns="0" rIns="0" bIns="0" rtlCol="0" anchor="ctr"/>
+          <a:lstStyle/>
+          <a:p>
+            <a:pPr algn="l" indent="0" marL="0">
+              <a:buNone/>
+            </a:pPr>
+            <a:r>
+              <a:rPr lang="en-US" sz="2800" b="1" dirty="0">
+                <a:solidFill>
+                  <a:schemeClr val="bg1"/>
+                </a:solidFill>
+              </a:rPr>
+              <a:t>4 Project Schedule</a:t>
+            </a:r>
+            <a:endParaRPr lang="en-US" sz="2800" dirty="0"/>
+          </a:p>
+        </p:txBody>
+      </p:sp>
+      <p:sp>
+        <p:nvSpPr>
+          <p:cNvPr id="3" name="Year 2026"/>
+          <p:cNvSpPr txBox="1"/>
+          <p:nvPr/>
+        </p:nvSpPr>
+        <p:spPr>
+          <a:xfrm>
+            <a:off x="4343400" y="1298448"/>
+            <a:ext cx="2090057" cy="274320"/>
+          </a:xfrm>
+          <a:prstGeom prst="rect">
+            <a:avLst/>
+          </a:prstGeom>
+          <a:noFill/>
+          <a:ln/>
+        </p:spPr>
+        <p:txBody>
+          <a:bodyPr wrap="square" lIns="0" tIns="0" rIns="0" bIns="0" rtlCol="0" anchor="ctr"/>
+          <a:lstStyle/>
+          <a:p>
+            <a:pPr algn="ctr" indent="0" marL="0">
+              <a:buNone/>
+            </a:pPr>
+            <a:r>
+              <a:rPr lang="en-US" sz="1300" b="1" dirty="0">
+                <a:solidFill>
+                  <a:schemeClr val="tx1"/>
+                </a:solidFill>
+              </a:rPr>
+              <a:t>2026</a:t>
+            </a:r>
+            <a:endParaRPr lang="en-US" sz="1300" dirty="0"/>
+          </a:p>
+        </p:txBody>
+      </p:sp>
+      <p:sp>
+        <p:nvSpPr>
+          <p:cNvPr id="4" name="Year 2027"/>
+          <p:cNvSpPr txBox="1"/>
+          <p:nvPr/>
+        </p:nvSpPr>
+        <p:spPr>
+          <a:xfrm>
+            <a:off x="6433457" y="1298448"/>
+            <a:ext cx="5225143" cy="274320"/>
+          </a:xfrm>
+          <a:prstGeom prst="rect">
+            <a:avLst/>
+          </a:prstGeom>
+          <a:noFill/>
+          <a:ln/>
+        </p:spPr>
+        <p:txBody>
+          <a:bodyPr wrap="square" lIns="0" tIns="0" rIns="0" bIns="0" rtlCol="0" anchor="ctr"/>
+          <a:lstStyle/>
+          <a:p>
+            <a:pPr algn="ctr" indent="0" marL="0">
+              <a:buNone/>
+            </a:pPr>
+            <a:r>
+              <a:rPr lang="en-US" sz="1300" b="1" dirty="0">
+                <a:solidFill>
+                  <a:schemeClr val="tx1"/>
+                </a:solidFill>
+              </a:rPr>
+              <a:t>2027</a:t>
+            </a:r>
+            <a:endParaRPr lang="en-US" sz="1300" dirty="0"/>
+          </a:p>
+        </p:txBody>
+      </p:sp>
+      <p:sp>
+        <p:nvSpPr>
+          <p:cNvPr id="5" name="Month Nov"/>
+          <p:cNvSpPr txBox="1"/>
+          <p:nvPr/>
+        </p:nvSpPr>
+        <p:spPr>
+          <a:xfrm>
+            <a:off x="4343400" y="1591056"/>
+            <a:ext cx="1045029" cy="274320"/>
+          </a:xfrm>
+          <a:prstGeom prst="rect">
+            <a:avLst/>
+          </a:prstGeom>
+          <a:noFill/>
+          <a:ln/>
+        </p:spPr>
+        <p:txBody>
+          <a:bodyPr wrap="square" lIns="0" tIns="0" rIns="0" bIns="0" rtlCol="0" anchor="ctr"/>
+          <a:lstStyle/>
+          <a:p>
+            <a:pPr algn="ctr" indent="0" marL="0">
+              <a:buNone/>
+            </a:pPr>
+            <a:r>
+              <a:rPr lang="en-US" sz="1300" dirty="0">
+                <a:solidFill>
+                  <a:schemeClr val="tx1"/>
+                </a:solidFill>
+              </a:rPr>
+              <a:t>Nov</a:t>
+            </a:r>
+            <a:endParaRPr lang="en-US" sz="1300" dirty="0"/>
+          </a:p>
+        </p:txBody>
+      </p:sp>
+      <p:sp>
+        <p:nvSpPr>
+          <p:cNvPr id="6" name="Month Dec"/>
+          <p:cNvSpPr txBox="1"/>
+          <p:nvPr/>
+        </p:nvSpPr>
+        <p:spPr>
+          <a:xfrm>
+            <a:off x="5388429" y="1591056"/>
+            <a:ext cx="1045029" cy="274320"/>
+          </a:xfrm>
+          <a:prstGeom prst="rect">
+            <a:avLst/>
+          </a:prstGeom>
+          <a:noFill/>
+          <a:ln/>
+        </p:spPr>
+        <p:txBody>
+          <a:bodyPr wrap="square" lIns="0" tIns="0" rIns="0" bIns="0" rtlCol="0" anchor="ctr"/>
+          <a:lstStyle/>
+          <a:p>
+            <a:pPr algn="ctr" indent="0" marL="0">
+              <a:buNone/>
+            </a:pPr>
+            <a:r>
+              <a:rPr lang="en-US" sz="1300" dirty="0">
+                <a:solidFill>
+                  <a:schemeClr val="tx1"/>
+                </a:solidFill>
+              </a:rPr>
+              <a:t>Dec</a:t>
+            </a:r>
+            <a:endParaRPr lang="en-US" sz="1300" dirty="0"/>
+          </a:p>
+        </p:txBody>
+      </p:sp>
+      <p:sp>
+        <p:nvSpPr>
+          <p:cNvPr id="7" name="Month Jan"/>
+          <p:cNvSpPr txBox="1"/>
+          <p:nvPr/>
+        </p:nvSpPr>
+        <p:spPr>
+          <a:xfrm>
+            <a:off x="6433457" y="1591056"/>
+            <a:ext cx="1045029" cy="274320"/>
+          </a:xfrm>
+          <a:prstGeom prst="rect">
+            <a:avLst/>
+          </a:prstGeom>
+          <a:noFill/>
+          <a:ln/>
+        </p:spPr>
+        <p:txBody>
+          <a:bodyPr wrap="square" lIns="0" tIns="0" rIns="0" bIns="0" rtlCol="0" anchor="ctr"/>
+          <a:lstStyle/>
+          <a:p>
+            <a:pPr algn="ctr" indent="0" marL="0">
+              <a:buNone/>
+            </a:pPr>
+            <a:r>
+              <a:rPr lang="en-US" sz="1300" dirty="0">
+                <a:solidFill>
+                  <a:schemeClr val="tx1"/>
+                </a:solidFill>
+              </a:rPr>
+              <a:t>Jan</a:t>
+            </a:r>
+            <a:endParaRPr lang="en-US" sz="1300" dirty="0"/>
+          </a:p>
+        </p:txBody>
+      </p:sp>
+      <p:sp>
+        <p:nvSpPr>
+          <p:cNvPr id="8" name="Month Feb"/>
+          <p:cNvSpPr txBox="1"/>
+          <p:nvPr/>
+        </p:nvSpPr>
+        <p:spPr>
+          <a:xfrm>
+            <a:off x="7478486" y="1591056"/>
+            <a:ext cx="1045029" cy="274320"/>
+          </a:xfrm>
+          <a:prstGeom prst="rect">
+            <a:avLst/>
+          </a:prstGeom>
+          <a:noFill/>
+          <a:ln/>
+        </p:spPr>
+        <p:txBody>
+          <a:bodyPr wrap="square" lIns="0" tIns="0" rIns="0" bIns="0" rtlCol="0" anchor="ctr"/>
+          <a:lstStyle/>
+          <a:p>
+            <a:pPr algn="ctr" indent="0" marL="0">
+              <a:buNone/>
+            </a:pPr>
+            <a:r>
+              <a:rPr lang="en-US" sz="1300" dirty="0">
+                <a:solidFill>
+                  <a:schemeClr val="tx1"/>
+                </a:solidFill>
+              </a:rPr>
+              <a:t>Feb</a:t>
+            </a:r>
+            <a:endParaRPr lang="en-US" sz="1300" dirty="0"/>
+          </a:p>
+        </p:txBody>
+      </p:sp>
+      <p:sp>
+        <p:nvSpPr>
+          <p:cNvPr id="9" name="Month Mar"/>
+          <p:cNvSpPr txBox="1"/>
+          <p:nvPr/>
+        </p:nvSpPr>
+        <p:spPr>
+          <a:xfrm>
+            <a:off x="8523514" y="1591056"/>
+            <a:ext cx="1045029" cy="274320"/>
+          </a:xfrm>
+          <a:prstGeom prst="rect">
+            <a:avLst/>
+          </a:prstGeom>
+          <a:noFill/>
+          <a:ln/>
+        </p:spPr>
+        <p:txBody>
+          <a:bodyPr wrap="square" lIns="0" tIns="0" rIns="0" bIns="0" rtlCol="0" anchor="ctr"/>
+          <a:lstStyle/>
+          <a:p>
+            <a:pPr algn="ctr" indent="0" marL="0">
+              <a:buNone/>
+            </a:pPr>
+            <a:r>
+              <a:rPr lang="en-US" sz="1300" dirty="0">
+                <a:solidFill>
+                  <a:schemeClr val="tx1"/>
+                </a:solidFill>
+              </a:rPr>
+              <a:t>Mar</a:t>
+            </a:r>
+            <a:endParaRPr lang="en-US" sz="1300" dirty="0"/>
+          </a:p>
+        </p:txBody>
+      </p:sp>
+      <p:sp>
+        <p:nvSpPr>
+          <p:cNvPr id="10" name="Month Apr"/>
+          <p:cNvSpPr txBox="1"/>
+          <p:nvPr/>
+        </p:nvSpPr>
+        <p:spPr>
+          <a:xfrm>
+            <a:off x="9568543" y="1591056"/>
+            <a:ext cx="1045029" cy="274320"/>
+          </a:xfrm>
+          <a:prstGeom prst="rect">
+            <a:avLst/>
+          </a:prstGeom>
+          <a:noFill/>
+          <a:ln/>
+        </p:spPr>
+        <p:txBody>
+          <a:bodyPr wrap="square" lIns="0" tIns="0" rIns="0" bIns="0" rtlCol="0" anchor="ctr"/>
+          <a:lstStyle/>
+          <a:p>
+            <a:pPr algn="ctr" indent="0" marL="0">
+              <a:buNone/>
+            </a:pPr>
+            <a:r>
+              <a:rPr lang="en-US" sz="1300" dirty="0">
+                <a:solidFill>
+                  <a:schemeClr val="tx1"/>
+                </a:solidFill>
+              </a:rPr>
+              <a:t>Apr</a:t>
+            </a:r>
+            <a:endParaRPr lang="en-US" sz="1300" dirty="0"/>
+          </a:p>
+        </p:txBody>
+      </p:sp>
+      <p:sp>
+        <p:nvSpPr>
+          <p:cNvPr id="11" name="Month May"/>
+          <p:cNvSpPr txBox="1"/>
+          <p:nvPr/>
+        </p:nvSpPr>
+        <p:spPr>
+          <a:xfrm>
+            <a:off x="10613571" y="1591056"/>
+            <a:ext cx="1045029" cy="274320"/>
+          </a:xfrm>
+          <a:prstGeom prst="rect">
+            <a:avLst/>
+          </a:prstGeom>
+          <a:noFill/>
+          <a:ln/>
+        </p:spPr>
+        <p:txBody>
+          <a:bodyPr wrap="square" lIns="0" tIns="0" rIns="0" bIns="0" rtlCol="0" anchor="ctr"/>
+          <a:lstStyle/>
+          <a:p>
+            <a:pPr algn="ctr" indent="0" marL="0">
+              <a:buNone/>
+            </a:pPr>
+            <a:r>
+              <a:rPr lang="en-US" sz="1300" dirty="0">
+                <a:solidFill>
+                  <a:schemeClr val="tx1"/>
+                </a:solidFill>
+              </a:rPr>
+              <a:t>May</a:t>
+            </a:r>
+            <a:endParaRPr lang="en-US" sz="1300" dirty="0"/>
+          </a:p>
+        </p:txBody>
+      </p:sp>
+      <p:sp>
+        <p:nvSpPr>
+          <p:cNvPr id="12" name="Header rule"/>
+          <p:cNvSpPr/>
+          <p:nvPr/>
+        </p:nvSpPr>
+        <p:spPr>
+          <a:xfrm>
+            <a:off x="548640" y="1883664"/>
+            <a:ext cx="11109960" cy="0"/>
+          </a:xfrm>
+          <a:prstGeom prst="line">
+            <a:avLst/>
+          </a:prstGeom>
+          <a:noFill/>
+          <a:ln w="19050">
+            <a:solidFill>
+              <a:srgbClr val="000000"/>
+            </a:solidFill>
+            <a:prstDash val="solid"/>
+          </a:ln>
+        </p:spPr>
+      </p:sp>
+      <p:sp>
+        <p:nvSpPr>
+          <p:cNvPr id="13" name="Group 1 band"/>
+          <p:cNvSpPr/>
+          <p:nvPr/>
+        </p:nvSpPr>
+        <p:spPr>
+          <a:xfrm>
+            <a:off x="548640" y="1938528"/>
+            <a:ext cx="11109960" cy="649224"/>
+          </a:xfrm>
+          <a:prstGeom prst="rect">
+            <a:avLst/>
+          </a:prstGeom>
+          <a:solidFill>
+            <a:srgbClr val="F2F2F2"/>
+          </a:solidFill>
+          <a:ln/>
+        </p:spPr>
+      </p:sp>
+      <p:sp>
+        <p:nvSpPr>
+          <p:cNvPr id="14" name="Group 1 name"/>
+          <p:cNvSpPr txBox="1"/>
+          <p:nvPr/>
+        </p:nvSpPr>
+        <p:spPr>
+          <a:xfrm>
+            <a:off x="594360" y="1938528"/>
+            <a:ext cx="1188720" cy="649224"/>
+          </a:xfrm>
+          <a:prstGeom prst="rect">
+            <a:avLst/>
+          </a:prstGeom>
+          <a:noFill/>
+          <a:ln/>
+        </p:spPr>
+        <p:txBody>
+          <a:bodyPr wrap="square" lIns="0" tIns="0" rIns="0" bIns="0" rtlCol="0" anchor="ctr"/>
+          <a:lstStyle/>
+          <a:p>
+            <a:pPr indent="0" marL="0">
+              <a:buNone/>
+            </a:pPr>
+            <a:r>
+              <a:rPr lang="en-US" sz="1250" b="1" dirty="0">
+                <a:solidFill>
+                  <a:schemeClr val="accent1"/>
+                </a:solidFill>
+              </a:rPr>
+              <a:t>Chapter 1</a:t>
+            </a:r>
+            <a:endParaRPr lang="en-US" sz="1250" dirty="0"/>
+          </a:p>
+          <a:p>
+            <a:pPr indent="0" marL="0">
+              <a:buNone/>
+            </a:pPr>
+            <a:r>
+              <a:rPr lang="en-US" sz="1250" b="1" dirty="0">
+                <a:solidFill>
+                  <a:schemeClr val="accent1"/>
+                </a:solidFill>
+              </a:rPr>
+              <a:t>RED</a:t>
+            </a:r>
+            <a:endParaRPr lang="en-US" sz="1250" dirty="0"/>
+          </a:p>
+        </p:txBody>
+      </p:sp>
+      <p:sp>
+        <p:nvSpPr>
+          <p:cNvPr id="15" name="Task 1 name"/>
+          <p:cNvSpPr txBox="1"/>
+          <p:nvPr/>
+        </p:nvSpPr>
+        <p:spPr>
+          <a:xfrm>
+            <a:off x="1783080" y="1938528"/>
+            <a:ext cx="2514600" cy="324612"/>
+          </a:xfrm>
+          <a:prstGeom prst="rect">
+            <a:avLst/>
+          </a:prstGeom>
+          <a:noFill/>
+          <a:ln/>
+        </p:spPr>
+        <p:txBody>
+          <a:bodyPr wrap="square" lIns="0" tIns="0" rIns="0" bIns="0" rtlCol="0" anchor="ctr"/>
+          <a:lstStyle/>
+          <a:p>
+            <a:pPr indent="0" marL="0">
+              <a:buNone/>
+            </a:pPr>
+            <a:r>
+              <a:rPr lang="en-US" sz="1200" dirty="0">
+                <a:solidFill>
+                  <a:schemeClr val="tx1"/>
+                </a:solidFill>
+              </a:rPr>
+              <a:t>Full comparisons on all protocols</a:t>
+            </a:r>
+            <a:endParaRPr lang="en-US" sz="1200" dirty="0"/>
+          </a:p>
+        </p:txBody>
+      </p:sp>
+      <p:sp>
+        <p:nvSpPr>
+          <p:cNvPr id="16" name="Task 1 bar"/>
+          <p:cNvSpPr/>
+          <p:nvPr/>
+        </p:nvSpPr>
+        <p:spPr>
+          <a:xfrm>
+            <a:off x="4343400" y="2002536"/>
+            <a:ext cx="1567543" cy="196596"/>
+          </a:xfrm>
+          <a:prstGeom prst="rect">
+            <a:avLst/>
+          </a:prstGeom>
+          <a:solidFill>
+            <a:srgbClr val="A00000"/>
+          </a:solidFill>
+          <a:ln/>
+        </p:spPr>
+      </p:sp>
+      <p:sp>
+        <p:nvSpPr>
+          <p:cNvPr id="17" name="Task 2 name"/>
+          <p:cNvSpPr txBox="1"/>
+          <p:nvPr/>
+        </p:nvSpPr>
+        <p:spPr>
+          <a:xfrm>
+            <a:off x="1783080" y="2263140"/>
+            <a:ext cx="2514600" cy="324612"/>
+          </a:xfrm>
+          <a:prstGeom prst="rect">
+            <a:avLst/>
+          </a:prstGeom>
+          <a:noFill/>
+          <a:ln/>
+        </p:spPr>
+        <p:txBody>
+          <a:bodyPr wrap="square" lIns="0" tIns="0" rIns="0" bIns="0" rtlCol="0" anchor="ctr"/>
+          <a:lstStyle/>
+          <a:p>
+            <a:pPr indent="0" marL="0">
+              <a:buNone/>
+            </a:pPr>
+            <a:r>
+              <a:rPr lang="en-US" sz="1200" dirty="0">
+                <a:solidFill>
+                  <a:schemeClr val="tx1"/>
+                </a:solidFill>
+              </a:rPr>
+              <a:t>Ablation, robustness, statistics</a:t>
+            </a:r>
+            <a:endParaRPr lang="en-US" sz="1200" dirty="0"/>
+          </a:p>
+        </p:txBody>
+      </p:sp>
+      <p:sp>
+        <p:nvSpPr>
+          <p:cNvPr id="18" name="Task 2 bar"/>
+          <p:cNvSpPr/>
+          <p:nvPr/>
+        </p:nvSpPr>
+        <p:spPr>
+          <a:xfrm>
+            <a:off x="5388429" y="2327148"/>
+            <a:ext cx="1567543" cy="196596"/>
+          </a:xfrm>
+          <a:prstGeom prst="rect">
+            <a:avLst/>
+          </a:prstGeom>
+          <a:solidFill>
+            <a:srgbClr val="A00000"/>
+          </a:solidFill>
+          <a:ln/>
+        </p:spPr>
+      </p:sp>
+      <p:sp>
+        <p:nvSpPr>
+          <p:cNvPr id="19" name="Group 2 name"/>
+          <p:cNvSpPr txBox="1"/>
+          <p:nvPr/>
+        </p:nvSpPr>
+        <p:spPr>
+          <a:xfrm>
+            <a:off x="594360" y="2587752"/>
+            <a:ext cx="1188720" cy="649224"/>
+          </a:xfrm>
+          <a:prstGeom prst="rect">
+            <a:avLst/>
+          </a:prstGeom>
+          <a:noFill/>
+          <a:ln/>
+        </p:spPr>
+        <p:txBody>
+          <a:bodyPr wrap="square" lIns="0" tIns="0" rIns="0" bIns="0" rtlCol="0" anchor="ctr"/>
+          <a:lstStyle/>
+          <a:p>
+            <a:pPr indent="0" marL="0">
+              <a:buNone/>
+            </a:pPr>
+            <a:r>
+              <a:rPr lang="en-US" sz="1250" b="1" dirty="0">
+                <a:solidFill>
+                  <a:schemeClr val="tx1"/>
+                </a:solidFill>
+              </a:rPr>
+              <a:t>Chapter 2</a:t>
+            </a:r>
+            <a:endParaRPr lang="en-US" sz="1250" dirty="0"/>
+          </a:p>
+          <a:p>
+            <a:pPr indent="0" marL="0">
+              <a:buNone/>
+            </a:pPr>
+            <a:r>
+              <a:rPr lang="en-US" sz="1250" b="1" dirty="0">
+                <a:solidFill>
+                  <a:schemeClr val="tx1"/>
+                </a:solidFill>
+              </a:rPr>
+              <a:t>LR-MoE</a:t>
+            </a:r>
+            <a:endParaRPr lang="en-US" sz="1250" dirty="0"/>
+          </a:p>
+        </p:txBody>
+      </p:sp>
+      <p:sp>
+        <p:nvSpPr>
+          <p:cNvPr id="20" name="Task 3 name"/>
+          <p:cNvSpPr txBox="1"/>
+          <p:nvPr/>
+        </p:nvSpPr>
+        <p:spPr>
+          <a:xfrm>
+            <a:off x="1783080" y="2587752"/>
+            <a:ext cx="2514600" cy="324612"/>
+          </a:xfrm>
+          <a:prstGeom prst="rect">
+            <a:avLst/>
+          </a:prstGeom>
+          <a:noFill/>
+          <a:ln/>
+        </p:spPr>
+        <p:txBody>
+          <a:bodyPr wrap="square" lIns="0" tIns="0" rIns="0" bIns="0" rtlCol="0" anchor="ctr"/>
+          <a:lstStyle/>
+          <a:p>
+            <a:pPr indent="0" marL="0">
+              <a:buNone/>
+            </a:pPr>
+            <a:r>
+              <a:rPr lang="en-US" sz="1200" dirty="0">
+                <a:solidFill>
+                  <a:schemeClr val="tx1"/>
+                </a:solidFill>
+              </a:rPr>
+              <a:t>Implementation and LOSO experiments</a:t>
+            </a:r>
+            <a:endParaRPr lang="en-US" sz="1200" dirty="0"/>
+          </a:p>
+        </p:txBody>
+      </p:sp>
+      <p:sp>
+        <p:nvSpPr>
+          <p:cNvPr id="21" name="Task 3 bar"/>
+          <p:cNvSpPr/>
+          <p:nvPr/>
+        </p:nvSpPr>
+        <p:spPr>
+          <a:xfrm>
+            <a:off x="4831080" y="2651760"/>
+            <a:ext cx="2647406" cy="196596"/>
+          </a:xfrm>
+          <a:prstGeom prst="rect">
+            <a:avLst/>
+          </a:prstGeom>
+          <a:solidFill>
+            <a:srgbClr val="C55A5A"/>
+          </a:solidFill>
+          <a:ln/>
+        </p:spPr>
+      </p:sp>
+      <p:sp>
+        <p:nvSpPr>
+          <p:cNvPr id="22" name="Task 4 name"/>
+          <p:cNvSpPr txBox="1"/>
+          <p:nvPr/>
+        </p:nvSpPr>
+        <p:spPr>
+          <a:xfrm>
+            <a:off x="1783080" y="2912364"/>
+            <a:ext cx="2514600" cy="324612"/>
+          </a:xfrm>
+          <a:prstGeom prst="rect">
+            <a:avLst/>
+          </a:prstGeom>
+          <a:noFill/>
+          <a:ln/>
+        </p:spPr>
+        <p:txBody>
+          <a:bodyPr wrap="square" lIns="0" tIns="0" rIns="0" bIns="0" rtlCol="0" anchor="ctr"/>
+          <a:lstStyle/>
+          <a:p>
+            <a:pPr indent="0" marL="0">
+              <a:buNone/>
+            </a:pPr>
+            <a:r>
+              <a:rPr lang="en-US" sz="1200" dirty="0">
+                <a:solidFill>
+                  <a:schemeClr val="tx1"/>
+                </a:solidFill>
+              </a:rPr>
+              <a:t>Ablation, few-shot, routing analysis</a:t>
+            </a:r>
+            <a:endParaRPr lang="en-US" sz="1200" dirty="0"/>
+          </a:p>
+        </p:txBody>
+      </p:sp>
+      <p:sp>
+        <p:nvSpPr>
+          <p:cNvPr id="23" name="Task 4 bar"/>
+          <p:cNvSpPr/>
+          <p:nvPr/>
+        </p:nvSpPr>
+        <p:spPr>
+          <a:xfrm>
+            <a:off x="6433457" y="2976372"/>
+            <a:ext cx="2020389" cy="196596"/>
+          </a:xfrm>
+          <a:prstGeom prst="rect">
+            <a:avLst/>
+          </a:prstGeom>
+          <a:solidFill>
+            <a:srgbClr val="C55A5A"/>
+          </a:solidFill>
+          <a:ln/>
+        </p:spPr>
+      </p:sp>
+      <p:sp>
+        <p:nvSpPr>
+          <p:cNvPr id="24" name="Group 3 band"/>
+          <p:cNvSpPr/>
+          <p:nvPr/>
+        </p:nvSpPr>
+        <p:spPr>
+          <a:xfrm>
+            <a:off x="548640" y="3236976"/>
+            <a:ext cx="11109960" cy="1298448"/>
+          </a:xfrm>
+          <a:prstGeom prst="rect">
+            <a:avLst/>
+          </a:prstGeom>
+          <a:solidFill>
+            <a:srgbClr val="F2F2F2"/>
+          </a:solidFill>
+          <a:ln/>
+        </p:spPr>
+      </p:sp>
+      <p:sp>
+        <p:nvSpPr>
+          <p:cNvPr id="25" name="Group 3 name"/>
+          <p:cNvSpPr txBox="1"/>
+          <p:nvPr/>
+        </p:nvSpPr>
+        <p:spPr>
+          <a:xfrm>
+            <a:off x="594360" y="3236976"/>
+            <a:ext cx="1188720" cy="1298448"/>
+          </a:xfrm>
+          <a:prstGeom prst="rect">
+            <a:avLst/>
+          </a:prstGeom>
+          <a:noFill/>
+          <a:ln/>
+        </p:spPr>
+        <p:txBody>
+          <a:bodyPr wrap="square" lIns="0" tIns="0" rIns="0" bIns="0" rtlCol="0" anchor="ctr"/>
+          <a:lstStyle/>
+          <a:p>
+            <a:pPr indent="0" marL="0">
+              <a:buNone/>
+            </a:pPr>
+            <a:r>
+              <a:rPr lang="en-US" sz="1250" b="1" dirty="0">
+                <a:solidFill>
+                  <a:schemeClr val="tx1"/>
+                </a:solidFill>
+              </a:rPr>
+              <a:t>Chapter 3</a:t>
+            </a:r>
+            <a:endParaRPr lang="en-US" sz="1250" dirty="0"/>
+          </a:p>
+          <a:p>
+            <a:pPr indent="0" marL="0">
+              <a:buNone/>
+            </a:pPr>
+            <a:r>
+              <a:rPr lang="en-US" sz="1250" b="1" dirty="0">
+                <a:solidFill>
+                  <a:schemeClr val="tx1"/>
+                </a:solidFill>
+              </a:rPr>
+              <a:t>Online system</a:t>
+            </a:r>
+            <a:endParaRPr lang="en-US" sz="1250" dirty="0"/>
+          </a:p>
+        </p:txBody>
+      </p:sp>
+      <p:sp>
+        <p:nvSpPr>
+          <p:cNvPr id="26" name="Task 5 name"/>
+          <p:cNvSpPr txBox="1"/>
+          <p:nvPr/>
+        </p:nvSpPr>
+        <p:spPr>
+          <a:xfrm>
+            <a:off x="1783080" y="3236976"/>
+            <a:ext cx="2514600" cy="324612"/>
+          </a:xfrm>
+          <a:prstGeom prst="rect">
+            <a:avLst/>
+          </a:prstGeom>
+          <a:noFill/>
+          <a:ln/>
+        </p:spPr>
+        <p:txBody>
+          <a:bodyPr wrap="square" lIns="0" tIns="0" rIns="0" bIns="0" rtlCol="0" anchor="ctr"/>
+          <a:lstStyle/>
+          <a:p>
+            <a:pPr indent="0" marL="0">
+              <a:buNone/>
+            </a:pPr>
+            <a:r>
+              <a:rPr lang="en-US" sz="1200" dirty="0">
+                <a:solidFill>
+                  <a:schemeClr val="tx1"/>
+                </a:solidFill>
+              </a:rPr>
+              <a:t>Ethics approval, subject recruitment</a:t>
+            </a:r>
+            <a:endParaRPr lang="en-US" sz="1200" dirty="0"/>
+          </a:p>
+        </p:txBody>
+      </p:sp>
+      <p:sp>
+        <p:nvSpPr>
+          <p:cNvPr id="27" name="Task 5 bar"/>
+          <p:cNvSpPr/>
+          <p:nvPr/>
+        </p:nvSpPr>
+        <p:spPr>
+          <a:xfrm>
+            <a:off x="5388429" y="3300984"/>
+            <a:ext cx="2090057" cy="196596"/>
+          </a:xfrm>
+          <a:prstGeom prst="rect">
+            <a:avLst/>
+          </a:prstGeom>
+          <a:solidFill>
+            <a:srgbClr val="404040"/>
+          </a:solidFill>
+          <a:ln/>
+        </p:spPr>
+      </p:sp>
+      <p:sp>
+        <p:nvSpPr>
+          <p:cNvPr id="28" name="Task 6 name"/>
+          <p:cNvSpPr txBox="1"/>
+          <p:nvPr/>
+        </p:nvSpPr>
+        <p:spPr>
+          <a:xfrm>
+            <a:off x="1783080" y="3561588"/>
+            <a:ext cx="2514600" cy="324612"/>
+          </a:xfrm>
+          <a:prstGeom prst="rect">
+            <a:avLst/>
+          </a:prstGeom>
+          <a:noFill/>
+          <a:ln/>
+        </p:spPr>
+        <p:txBody>
+          <a:bodyPr wrap="square" lIns="0" tIns="0" rIns="0" bIns="0" rtlCol="0" anchor="ctr"/>
+          <a:lstStyle/>
+          <a:p>
+            <a:pPr indent="0" marL="0">
+              <a:buNone/>
+            </a:pPr>
+            <a:r>
+              <a:rPr lang="en-US" sz="1200" dirty="0">
+                <a:solidFill>
+                  <a:schemeClr val="tx1"/>
+                </a:solidFill>
+              </a:rPr>
+              <a:t>Real-time system integration</a:t>
+            </a:r>
+            <a:endParaRPr lang="en-US" sz="1200" dirty="0"/>
+          </a:p>
+        </p:txBody>
+      </p:sp>
+      <p:sp>
+        <p:nvSpPr>
+          <p:cNvPr id="29" name="Task 6 bar"/>
+          <p:cNvSpPr/>
+          <p:nvPr/>
+        </p:nvSpPr>
+        <p:spPr>
+          <a:xfrm>
+            <a:off x="5388429" y="3625596"/>
+            <a:ext cx="2612571" cy="196596"/>
+          </a:xfrm>
+          <a:prstGeom prst="rect">
+            <a:avLst/>
+          </a:prstGeom>
+          <a:solidFill>
+            <a:srgbClr val="404040"/>
+          </a:solidFill>
+          <a:ln/>
+        </p:spPr>
+      </p:sp>
+      <p:sp>
+        <p:nvSpPr>
+          <p:cNvPr id="30" name="Task 7 name"/>
+          <p:cNvSpPr txBox="1"/>
+          <p:nvPr/>
+        </p:nvSpPr>
+        <p:spPr>
+          <a:xfrm>
+            <a:off x="1783080" y="3886200"/>
+            <a:ext cx="2514600" cy="324612"/>
+          </a:xfrm>
+          <a:prstGeom prst="rect">
+            <a:avLst/>
+          </a:prstGeom>
+          <a:noFill/>
+          <a:ln/>
+        </p:spPr>
+        <p:txBody>
+          <a:bodyPr wrap="square" lIns="0" tIns="0" rIns="0" bIns="0" rtlCol="0" anchor="ctr"/>
+          <a:lstStyle/>
+          <a:p>
+            <a:pPr indent="0" marL="0">
+              <a:buNone/>
+            </a:pPr>
+            <a:r>
+              <a:rPr lang="en-US" sz="1200" dirty="0">
+                <a:solidFill>
+                  <a:schemeClr val="tx1"/>
+                </a:solidFill>
+              </a:rPr>
+              <a:t>Continuous control, pilot tests</a:t>
+            </a:r>
+            <a:endParaRPr lang="en-US" sz="1200" dirty="0"/>
+          </a:p>
+        </p:txBody>
+      </p:sp>
+      <p:sp>
+        <p:nvSpPr>
+          <p:cNvPr id="31" name="Task 7 bar"/>
+          <p:cNvSpPr/>
+          <p:nvPr/>
+        </p:nvSpPr>
+        <p:spPr>
+          <a:xfrm>
+            <a:off x="7478486" y="3950208"/>
+            <a:ext cx="1567543" cy="196596"/>
+          </a:xfrm>
+          <a:prstGeom prst="rect">
+            <a:avLst/>
+          </a:prstGeom>
+          <a:solidFill>
+            <a:srgbClr val="404040"/>
+          </a:solidFill>
+          <a:ln/>
+        </p:spPr>
+      </p:sp>
+      <p:sp>
+        <p:nvSpPr>
+          <p:cNvPr id="32" name="Task 8 name"/>
+          <p:cNvSpPr txBox="1"/>
+          <p:nvPr/>
+        </p:nvSpPr>
+        <p:spPr>
+          <a:xfrm>
+            <a:off x="1783080" y="4210812"/>
+            <a:ext cx="2514600" cy="324612"/>
+          </a:xfrm>
+          <a:prstGeom prst="rect">
+            <a:avLst/>
+          </a:prstGeom>
+          <a:noFill/>
+          <a:ln/>
+        </p:spPr>
+        <p:txBody>
+          <a:bodyPr wrap="square" lIns="0" tIns="0" rIns="0" bIns="0" rtlCol="0" anchor="ctr"/>
+          <a:lstStyle/>
+          <a:p>
+            <a:pPr indent="0" marL="0">
+              <a:buNone/>
+            </a:pPr>
+            <a:r>
+              <a:rPr lang="en-US" sz="1200" dirty="0">
+                <a:solidFill>
+                  <a:schemeClr val="tx1"/>
+                </a:solidFill>
+              </a:rPr>
+              <a:t>Online experiments and evaluation</a:t>
+            </a:r>
+            <a:endParaRPr lang="en-US" sz="1200" dirty="0"/>
+          </a:p>
+        </p:txBody>
+      </p:sp>
+      <p:sp>
+        <p:nvSpPr>
+          <p:cNvPr id="33" name="Task 8 bar"/>
+          <p:cNvSpPr/>
+          <p:nvPr/>
+        </p:nvSpPr>
+        <p:spPr>
+          <a:xfrm>
+            <a:off x="8523514" y="4274820"/>
+            <a:ext cx="1567543" cy="196596"/>
+          </a:xfrm>
+          <a:prstGeom prst="rect">
+            <a:avLst/>
+          </a:prstGeom>
+          <a:solidFill>
+            <a:srgbClr val="404040"/>
+          </a:solidFill>
+          <a:ln/>
+        </p:spPr>
+      </p:sp>
+      <p:sp>
+        <p:nvSpPr>
+          <p:cNvPr id="34" name="Group 4 name"/>
+          <p:cNvSpPr txBox="1"/>
+          <p:nvPr/>
+        </p:nvSpPr>
+        <p:spPr>
+          <a:xfrm>
+            <a:off x="594360" y="4535424"/>
+            <a:ext cx="1188720" cy="973836"/>
+          </a:xfrm>
+          <a:prstGeom prst="rect">
+            <a:avLst/>
+          </a:prstGeom>
+          <a:noFill/>
+          <a:ln/>
+        </p:spPr>
+        <p:txBody>
+          <a:bodyPr wrap="square" lIns="0" tIns="0" rIns="0" bIns="0" rtlCol="0" anchor="ctr"/>
+          <a:lstStyle/>
+          <a:p>
+            <a:pPr indent="0" marL="0">
+              <a:buNone/>
+            </a:pPr>
+            <a:r>
+              <a:rPr lang="en-US" sz="1250" b="1" dirty="0">
+                <a:solidFill>
+                  <a:schemeClr val="tx1"/>
+                </a:solidFill>
+              </a:rPr>
+              <a:t>Thesis</a:t>
+            </a:r>
+            <a:endParaRPr lang="en-US" sz="1250" dirty="0"/>
+          </a:p>
+        </p:txBody>
+      </p:sp>
+      <p:sp>
+        <p:nvSpPr>
+          <p:cNvPr id="35" name="Task 9 name"/>
+          <p:cNvSpPr txBox="1"/>
+          <p:nvPr/>
+        </p:nvSpPr>
+        <p:spPr>
+          <a:xfrm>
+            <a:off x="1783080" y="4535424"/>
+            <a:ext cx="2514600" cy="324612"/>
+          </a:xfrm>
+          <a:prstGeom prst="rect">
+            <a:avLst/>
+          </a:prstGeom>
+          <a:noFill/>
+          <a:ln/>
+        </p:spPr>
+        <p:txBody>
+          <a:bodyPr wrap="square" lIns="0" tIns="0" rIns="0" bIns="0" rtlCol="0" anchor="ctr"/>
+          <a:lstStyle/>
+          <a:p>
+            <a:pPr indent="0" marL="0">
+              <a:buNone/>
+            </a:pPr>
+            <a:r>
+              <a:rPr lang="en-US" sz="1200" dirty="0">
+                <a:solidFill>
+                  <a:schemeClr val="tx1"/>
+                </a:solidFill>
+              </a:rPr>
+              <a:t>Papers for Chapters 1 and 2</a:t>
+            </a:r>
+            <a:endParaRPr lang="en-US" sz="1200" dirty="0"/>
+          </a:p>
+        </p:txBody>
+      </p:sp>
+      <p:sp>
+        <p:nvSpPr>
+          <p:cNvPr id="36" name="Task 9 bar"/>
+          <p:cNvSpPr/>
+          <p:nvPr/>
+        </p:nvSpPr>
+        <p:spPr>
+          <a:xfrm>
+            <a:off x="6921137" y="4599432"/>
+            <a:ext cx="2647406" cy="196596"/>
+          </a:xfrm>
+          <a:prstGeom prst="rect">
+            <a:avLst/>
+          </a:prstGeom>
+          <a:solidFill>
+            <a:srgbClr val="A6A6A6"/>
+          </a:solidFill>
+          <a:ln/>
+        </p:spPr>
+      </p:sp>
+      <p:sp>
+        <p:nvSpPr>
+          <p:cNvPr id="37" name="Task 10 name"/>
+          <p:cNvSpPr txBox="1"/>
+          <p:nvPr/>
+        </p:nvSpPr>
+        <p:spPr>
+          <a:xfrm>
+            <a:off x="1783080" y="4860036"/>
+            <a:ext cx="2514600" cy="324612"/>
+          </a:xfrm>
+          <a:prstGeom prst="rect">
+            <a:avLst/>
+          </a:prstGeom>
+          <a:noFill/>
+          <a:ln/>
+        </p:spPr>
+        <p:txBody>
+          <a:bodyPr wrap="square" lIns="0" tIns="0" rIns="0" bIns="0" rtlCol="0" anchor="ctr"/>
+          <a:lstStyle/>
+          <a:p>
+            <a:pPr indent="0" marL="0">
+              <a:buNone/>
+            </a:pPr>
+            <a:r>
+              <a:rPr lang="en-US" sz="1200" dirty="0">
+                <a:solidFill>
+                  <a:schemeClr val="tx1"/>
+                </a:solidFill>
+              </a:rPr>
+              <a:t>Thesis writing</a:t>
+            </a:r>
+            <a:endParaRPr lang="en-US" sz="1200" dirty="0"/>
+          </a:p>
+        </p:txBody>
+      </p:sp>
+      <p:sp>
+        <p:nvSpPr>
+          <p:cNvPr id="38" name="Task 10 bar"/>
+          <p:cNvSpPr/>
+          <p:nvPr/>
+        </p:nvSpPr>
+        <p:spPr>
+          <a:xfrm>
+            <a:off x="7966166" y="4924044"/>
+            <a:ext cx="2299063" cy="196596"/>
+          </a:xfrm>
+          <a:prstGeom prst="rect">
+            <a:avLst/>
+          </a:prstGeom>
+          <a:solidFill>
+            <a:srgbClr val="A6A6A6"/>
+          </a:solidFill>
+          <a:ln/>
+        </p:spPr>
+      </p:sp>
+      <p:sp>
+        <p:nvSpPr>
+          <p:cNvPr id="39" name="Task 11 name"/>
+          <p:cNvSpPr txBox="1"/>
+          <p:nvPr/>
+        </p:nvSpPr>
+        <p:spPr>
+          <a:xfrm>
+            <a:off x="1783080" y="5184648"/>
+            <a:ext cx="2514600" cy="324612"/>
+          </a:xfrm>
+          <a:prstGeom prst="rect">
+            <a:avLst/>
+          </a:prstGeom>
+          <a:noFill/>
+          <a:ln/>
+        </p:spPr>
+        <p:txBody>
+          <a:bodyPr wrap="square" lIns="0" tIns="0" rIns="0" bIns="0" rtlCol="0" anchor="ctr"/>
+          <a:lstStyle/>
+          <a:p>
+            <a:pPr indent="0" marL="0">
+              <a:buNone/>
+            </a:pPr>
+            <a:r>
+              <a:rPr lang="en-US" sz="1200" dirty="0">
+                <a:solidFill>
+                  <a:schemeClr val="tx1"/>
+                </a:solidFill>
+              </a:rPr>
+              <a:t>Revision and defense preparation</a:t>
+            </a:r>
+            <a:endParaRPr lang="en-US" sz="1200" dirty="0"/>
+          </a:p>
+        </p:txBody>
+      </p:sp>
+      <p:sp>
+        <p:nvSpPr>
+          <p:cNvPr id="40" name="Task 11 bar"/>
+          <p:cNvSpPr/>
+          <p:nvPr/>
+        </p:nvSpPr>
+        <p:spPr>
+          <a:xfrm>
+            <a:off x="10056223" y="5248656"/>
+            <a:ext cx="1602377" cy="196596"/>
+          </a:xfrm>
+          <a:prstGeom prst="rect">
+            <a:avLst/>
+          </a:prstGeom>
+          <a:solidFill>
+            <a:srgbClr val="A6A6A6"/>
+          </a:solidFill>
+          <a:ln/>
+        </p:spPr>
+      </p:sp>
+      <p:sp>
+        <p:nvSpPr>
+          <p:cNvPr id="41" name="Month line 1"/>
+          <p:cNvSpPr/>
+          <p:nvPr/>
+        </p:nvSpPr>
+        <p:spPr>
+          <a:xfrm>
+            <a:off x="5388429" y="1883664"/>
+            <a:ext cx="0" cy="3625596"/>
+          </a:xfrm>
+          <a:prstGeom prst="line">
+            <a:avLst/>
+          </a:prstGeom>
+          <a:noFill/>
+          <a:ln w="6350">
+            <a:solidFill>
+              <a:srgbClr val="BFBFBF"/>
+            </a:solidFill>
+            <a:prstDash val="dash"/>
+          </a:ln>
+        </p:spPr>
+      </p:sp>
+      <p:sp>
+        <p:nvSpPr>
+          <p:cNvPr id="42" name="Month line 2"/>
+          <p:cNvSpPr/>
+          <p:nvPr/>
+        </p:nvSpPr>
+        <p:spPr>
+          <a:xfrm>
+            <a:off x="6433457" y="1883664"/>
+            <a:ext cx="0" cy="3625596"/>
+          </a:xfrm>
+          <a:prstGeom prst="line">
+            <a:avLst/>
+          </a:prstGeom>
+          <a:noFill/>
+          <a:ln w="6350">
+            <a:solidFill>
+              <a:srgbClr val="BFBFBF"/>
+            </a:solidFill>
+            <a:prstDash val="dash"/>
+          </a:ln>
+        </p:spPr>
+      </p:sp>
+      <p:sp>
+        <p:nvSpPr>
+          <p:cNvPr id="43" name="Month line 3"/>
+          <p:cNvSpPr/>
+          <p:nvPr/>
+        </p:nvSpPr>
+        <p:spPr>
+          <a:xfrm>
+            <a:off x="7478486" y="1883664"/>
+            <a:ext cx="0" cy="3625596"/>
+          </a:xfrm>
+          <a:prstGeom prst="line">
+            <a:avLst/>
+          </a:prstGeom>
+          <a:noFill/>
+          <a:ln w="6350">
+            <a:solidFill>
+              <a:srgbClr val="BFBFBF"/>
+            </a:solidFill>
+            <a:prstDash val="dash"/>
+          </a:ln>
+        </p:spPr>
+      </p:sp>
+      <p:sp>
+        <p:nvSpPr>
+          <p:cNvPr id="44" name="Month line 4"/>
+          <p:cNvSpPr/>
+          <p:nvPr/>
+        </p:nvSpPr>
+        <p:spPr>
+          <a:xfrm>
+            <a:off x="8523514" y="1883664"/>
+            <a:ext cx="0" cy="3625596"/>
+          </a:xfrm>
+          <a:prstGeom prst="line">
+            <a:avLst/>
+          </a:prstGeom>
+          <a:noFill/>
+          <a:ln w="6350">
+            <a:solidFill>
+              <a:srgbClr val="BFBFBF"/>
+            </a:solidFill>
+            <a:prstDash val="dash"/>
+          </a:ln>
+        </p:spPr>
+      </p:sp>
+      <p:sp>
+        <p:nvSpPr>
+          <p:cNvPr id="45" name="Month line 5"/>
+          <p:cNvSpPr/>
+          <p:nvPr/>
+        </p:nvSpPr>
+        <p:spPr>
+          <a:xfrm>
+            <a:off x="9568543" y="1883664"/>
+            <a:ext cx="0" cy="3625596"/>
+          </a:xfrm>
+          <a:prstGeom prst="line">
+            <a:avLst/>
+          </a:prstGeom>
+          <a:noFill/>
+          <a:ln w="6350">
+            <a:solidFill>
+              <a:srgbClr val="BFBFBF"/>
+            </a:solidFill>
+            <a:prstDash val="dash"/>
+          </a:ln>
+        </p:spPr>
+      </p:sp>
+      <p:sp>
+        <p:nvSpPr>
+          <p:cNvPr id="46" name="Month line 6"/>
+          <p:cNvSpPr/>
+          <p:nvPr/>
+        </p:nvSpPr>
+        <p:spPr>
+          <a:xfrm>
+            <a:off x="10613571" y="1883664"/>
+            <a:ext cx="0" cy="3625596"/>
+          </a:xfrm>
+          <a:prstGeom prst="line">
+            <a:avLst/>
+          </a:prstGeom>
+          <a:noFill/>
+          <a:ln w="6350">
+            <a:solidFill>
+              <a:srgbClr val="BFBFBF"/>
+            </a:solidFill>
+            <a:prstDash val="dash"/>
+          </a:ln>
+        </p:spPr>
+      </p:sp>
+      <p:sp>
+        <p:nvSpPr>
+          <p:cNvPr id="47" name="Bottom rule"/>
+          <p:cNvSpPr/>
+          <p:nvPr/>
+        </p:nvSpPr>
+        <p:spPr>
+          <a:xfrm>
+            <a:off x="548640" y="5527548"/>
+            <a:ext cx="11109960" cy="0"/>
+          </a:xfrm>
+          <a:prstGeom prst="line">
+            <a:avLst/>
+          </a:prstGeom>
+          <a:noFill/>
+          <a:ln w="19050">
+            <a:solidFill>
+              <a:srgbClr val="000000"/>
+            </a:solidFill>
+            <a:prstDash val="solid"/>
+          </a:ln>
+        </p:spPr>
+      </p:sp>
+      <p:sp>
+        <p:nvSpPr>
+          <p:cNvPr id="48" name="M1 diamond"/>
+          <p:cNvSpPr/>
+          <p:nvPr/>
+        </p:nvSpPr>
+        <p:spPr>
+          <a:xfrm>
+            <a:off x="6846243" y="2315718"/>
+            <a:ext cx="219456" cy="219456"/>
+          </a:xfrm>
+          <a:prstGeom prst="diamond">
+            <a:avLst/>
+          </a:prstGeom>
+          <a:solidFill>
+            <a:srgbClr val="A00000"/>
+          </a:solidFill>
+          <a:ln w="12700">
+            <a:solidFill>
+              <a:srgbClr val="FFFFFF"/>
+            </a:solidFill>
+            <a:prstDash val="solid"/>
+          </a:ln>
+        </p:spPr>
+      </p:sp>
+      <p:sp>
+        <p:nvSpPr>
+          <p:cNvPr id="49" name="M1 label"/>
+          <p:cNvSpPr txBox="1"/>
+          <p:nvPr/>
+        </p:nvSpPr>
+        <p:spPr>
+          <a:xfrm>
+            <a:off x="7074843" y="2279142"/>
+            <a:ext cx="365760" cy="292608"/>
+          </a:xfrm>
+          <a:prstGeom prst="rect">
+            <a:avLst/>
+          </a:prstGeom>
+          <a:noFill/>
+          <a:ln/>
+        </p:spPr>
+        <p:txBody>
+          <a:bodyPr wrap="square" lIns="0" tIns="0" rIns="0" bIns="0" rtlCol="0" anchor="ctr"/>
+          <a:lstStyle/>
+          <a:p>
+            <a:pPr algn="l" indent="0" marL="0">
+              <a:buNone/>
+            </a:pPr>
+            <a:r>
+              <a:rPr lang="en-US" sz="1100" b="1" dirty="0">
+                <a:solidFill>
+                  <a:schemeClr val="accent1"/>
+                </a:solidFill>
+              </a:rPr>
+              <a:t>M1</a:t>
+            </a:r>
+            <a:endParaRPr lang="en-US" sz="1100" dirty="0"/>
+          </a:p>
+        </p:txBody>
+      </p:sp>
+      <p:sp>
+        <p:nvSpPr>
+          <p:cNvPr id="50" name="M2 diamond"/>
+          <p:cNvSpPr/>
+          <p:nvPr/>
+        </p:nvSpPr>
+        <p:spPr>
+          <a:xfrm>
+            <a:off x="8344118" y="2964942"/>
+            <a:ext cx="219456" cy="219456"/>
+          </a:xfrm>
+          <a:prstGeom prst="diamond">
+            <a:avLst/>
+          </a:prstGeom>
+          <a:solidFill>
+            <a:srgbClr val="A00000"/>
+          </a:solidFill>
+          <a:ln w="12700">
+            <a:solidFill>
+              <a:srgbClr val="FFFFFF"/>
+            </a:solidFill>
+            <a:prstDash val="solid"/>
+          </a:ln>
+        </p:spPr>
+      </p:sp>
+      <p:sp>
+        <p:nvSpPr>
+          <p:cNvPr id="51" name="M2 label"/>
+          <p:cNvSpPr txBox="1"/>
+          <p:nvPr/>
+        </p:nvSpPr>
+        <p:spPr>
+          <a:xfrm>
+            <a:off x="8572718" y="2928366"/>
+            <a:ext cx="365760" cy="292608"/>
+          </a:xfrm>
+          <a:prstGeom prst="rect">
+            <a:avLst/>
+          </a:prstGeom>
+          <a:noFill/>
+          <a:ln/>
+        </p:spPr>
+        <p:txBody>
+          <a:bodyPr wrap="square" lIns="0" tIns="0" rIns="0" bIns="0" rtlCol="0" anchor="ctr"/>
+          <a:lstStyle/>
+          <a:p>
+            <a:pPr algn="l" indent="0" marL="0">
+              <a:buNone/>
+            </a:pPr>
+            <a:r>
+              <a:rPr lang="en-US" sz="1100" b="1" dirty="0">
+                <a:solidFill>
+                  <a:schemeClr val="accent1"/>
+                </a:solidFill>
+              </a:rPr>
+              <a:t>M2</a:t>
+            </a:r>
+            <a:endParaRPr lang="en-US" sz="1100" dirty="0"/>
+          </a:p>
+        </p:txBody>
+      </p:sp>
+      <p:sp>
+        <p:nvSpPr>
+          <p:cNvPr id="52" name="M3 diamond"/>
+          <p:cNvSpPr/>
+          <p:nvPr/>
+        </p:nvSpPr>
+        <p:spPr>
+          <a:xfrm>
+            <a:off x="8936301" y="3938778"/>
+            <a:ext cx="219456" cy="219456"/>
+          </a:xfrm>
+          <a:prstGeom prst="diamond">
+            <a:avLst/>
+          </a:prstGeom>
+          <a:solidFill>
+            <a:srgbClr val="A00000"/>
+          </a:solidFill>
+          <a:ln w="12700">
+            <a:solidFill>
+              <a:srgbClr val="FFFFFF"/>
+            </a:solidFill>
+            <a:prstDash val="solid"/>
+          </a:ln>
+        </p:spPr>
+      </p:sp>
+      <p:sp>
+        <p:nvSpPr>
+          <p:cNvPr id="53" name="M3 label"/>
+          <p:cNvSpPr txBox="1"/>
+          <p:nvPr/>
+        </p:nvSpPr>
+        <p:spPr>
+          <a:xfrm>
+            <a:off x="9164901" y="3902202"/>
+            <a:ext cx="365760" cy="292608"/>
+          </a:xfrm>
+          <a:prstGeom prst="rect">
+            <a:avLst/>
+          </a:prstGeom>
+          <a:noFill/>
+          <a:ln/>
+        </p:spPr>
+        <p:txBody>
+          <a:bodyPr wrap="square" lIns="0" tIns="0" rIns="0" bIns="0" rtlCol="0" anchor="ctr"/>
+          <a:lstStyle/>
+          <a:p>
+            <a:pPr algn="l" indent="0" marL="0">
+              <a:buNone/>
+            </a:pPr>
+            <a:r>
+              <a:rPr lang="en-US" sz="1100" b="1" dirty="0">
+                <a:solidFill>
+                  <a:schemeClr val="accent1"/>
+                </a:solidFill>
+              </a:rPr>
+              <a:t>M3</a:t>
+            </a:r>
+            <a:endParaRPr lang="en-US" sz="1100" dirty="0"/>
+          </a:p>
+        </p:txBody>
+      </p:sp>
+      <p:sp>
+        <p:nvSpPr>
+          <p:cNvPr id="54" name="M4 diamond"/>
+          <p:cNvSpPr/>
+          <p:nvPr/>
+        </p:nvSpPr>
+        <p:spPr>
+          <a:xfrm>
+            <a:off x="9981329" y="4263390"/>
+            <a:ext cx="219456" cy="219456"/>
+          </a:xfrm>
+          <a:prstGeom prst="diamond">
+            <a:avLst/>
+          </a:prstGeom>
+          <a:solidFill>
+            <a:srgbClr val="A00000"/>
+          </a:solidFill>
+          <a:ln w="12700">
+            <a:solidFill>
+              <a:srgbClr val="FFFFFF"/>
+            </a:solidFill>
+            <a:prstDash val="solid"/>
+          </a:ln>
+        </p:spPr>
+      </p:sp>
+      <p:sp>
+        <p:nvSpPr>
+          <p:cNvPr id="55" name="M4 label"/>
+          <p:cNvSpPr txBox="1"/>
+          <p:nvPr/>
+        </p:nvSpPr>
+        <p:spPr>
+          <a:xfrm>
+            <a:off x="10209929" y="4226814"/>
+            <a:ext cx="365760" cy="292608"/>
+          </a:xfrm>
+          <a:prstGeom prst="rect">
+            <a:avLst/>
+          </a:prstGeom>
+          <a:noFill/>
+          <a:ln/>
+        </p:spPr>
+        <p:txBody>
+          <a:bodyPr wrap="square" lIns="0" tIns="0" rIns="0" bIns="0" rtlCol="0" anchor="ctr"/>
+          <a:lstStyle/>
+          <a:p>
+            <a:pPr algn="l" indent="0" marL="0">
+              <a:buNone/>
+            </a:pPr>
+            <a:r>
+              <a:rPr lang="en-US" sz="1100" b="1" dirty="0">
+                <a:solidFill>
+                  <a:schemeClr val="accent1"/>
+                </a:solidFill>
+              </a:rPr>
+              <a:t>M4</a:t>
+            </a:r>
+            <a:endParaRPr lang="en-US" sz="1100" dirty="0"/>
+          </a:p>
+        </p:txBody>
+      </p:sp>
+      <p:sp>
+        <p:nvSpPr>
+          <p:cNvPr id="56" name="M5 diamond"/>
+          <p:cNvSpPr/>
+          <p:nvPr/>
+        </p:nvSpPr>
+        <p:spPr>
+          <a:xfrm>
+            <a:off x="10155501" y="4912614"/>
+            <a:ext cx="219456" cy="219456"/>
+          </a:xfrm>
+          <a:prstGeom prst="diamond">
+            <a:avLst/>
+          </a:prstGeom>
+          <a:solidFill>
+            <a:srgbClr val="A00000"/>
+          </a:solidFill>
+          <a:ln w="12700">
+            <a:solidFill>
+              <a:srgbClr val="FFFFFF"/>
+            </a:solidFill>
+            <a:prstDash val="solid"/>
+          </a:ln>
+        </p:spPr>
+      </p:sp>
+      <p:sp>
+        <p:nvSpPr>
+          <p:cNvPr id="57" name="M5 label"/>
+          <p:cNvSpPr txBox="1"/>
+          <p:nvPr/>
+        </p:nvSpPr>
+        <p:spPr>
+          <a:xfrm>
+            <a:off x="10384101" y="4876038"/>
+            <a:ext cx="365760" cy="292608"/>
+          </a:xfrm>
+          <a:prstGeom prst="rect">
+            <a:avLst/>
+          </a:prstGeom>
+          <a:noFill/>
+          <a:ln/>
+        </p:spPr>
+        <p:txBody>
+          <a:bodyPr wrap="square" lIns="0" tIns="0" rIns="0" bIns="0" rtlCol="0" anchor="ctr"/>
+          <a:lstStyle/>
+          <a:p>
+            <a:pPr algn="l" indent="0" marL="0">
+              <a:buNone/>
+            </a:pPr>
+            <a:r>
+              <a:rPr lang="en-US" sz="1100" b="1" dirty="0">
+                <a:solidFill>
+                  <a:schemeClr val="accent1"/>
+                </a:solidFill>
+              </a:rPr>
+              <a:t>M5</a:t>
+            </a:r>
+            <a:endParaRPr lang="en-US" sz="1100" dirty="0"/>
+          </a:p>
+        </p:txBody>
+      </p:sp>
+      <p:sp>
+        <p:nvSpPr>
+          <p:cNvPr id="58" name="M6 diamond"/>
+          <p:cNvSpPr/>
+          <p:nvPr/>
+        </p:nvSpPr>
+        <p:spPr>
+          <a:xfrm>
+            <a:off x="11479203" y="5237226"/>
+            <a:ext cx="219456" cy="219456"/>
+          </a:xfrm>
+          <a:prstGeom prst="diamond">
+            <a:avLst/>
+          </a:prstGeom>
+          <a:solidFill>
+            <a:srgbClr val="A00000"/>
+          </a:solidFill>
+          <a:ln w="12700">
+            <a:solidFill>
+              <a:srgbClr val="FFFFFF"/>
+            </a:solidFill>
+            <a:prstDash val="solid"/>
+          </a:ln>
+        </p:spPr>
+      </p:sp>
+      <p:sp>
+        <p:nvSpPr>
+          <p:cNvPr id="59" name="M6 label"/>
+          <p:cNvSpPr txBox="1"/>
+          <p:nvPr/>
+        </p:nvSpPr>
+        <p:spPr>
+          <a:xfrm>
+            <a:off x="11104299" y="5200650"/>
+            <a:ext cx="365760" cy="292608"/>
+          </a:xfrm>
+          <a:prstGeom prst="rect">
+            <a:avLst/>
+          </a:prstGeom>
+          <a:noFill/>
+          <a:ln/>
+        </p:spPr>
+        <p:txBody>
+          <a:bodyPr wrap="square" lIns="0" tIns="0" rIns="0" bIns="0" rtlCol="0" anchor="ctr"/>
+          <a:lstStyle/>
+          <a:p>
+            <a:pPr algn="r" indent="0" marL="0">
+              <a:buNone/>
+            </a:pPr>
+            <a:r>
+              <a:rPr lang="en-US" sz="1100" b="1" dirty="0">
+                <a:solidFill>
+                  <a:srgbClr val="FFFFFF"/>
+                </a:solidFill>
+              </a:rPr>
+              <a:t>M6</a:t>
+            </a:r>
+            <a:endParaRPr lang="en-US" sz="1100" dirty="0"/>
+          </a:p>
+        </p:txBody>
+      </p:sp>
+      <p:sp>
+        <p:nvSpPr>
+          <p:cNvPr id="60" name="Milestone legend"/>
+          <p:cNvSpPr txBox="1"/>
+          <p:nvPr/>
+        </p:nvSpPr>
+        <p:spPr>
+          <a:xfrm>
+            <a:off x="548640" y="5618988"/>
+            <a:ext cx="11109960" cy="566928"/>
+          </a:xfrm>
+          <a:prstGeom prst="rect">
+            <a:avLst/>
+          </a:prstGeom>
+          <a:noFill/>
+          <a:ln/>
+        </p:spPr>
+        <p:txBody>
+          <a:bodyPr wrap="square" lIns="0" tIns="0" rIns="0" bIns="0" rtlCol="0" anchor="ctr"/>
+          <a:lstStyle/>
+          <a:p>
+            <a:pPr indent="0" marL="0">
+              <a:buNone/>
+            </a:pPr>
+            <a:r>
+              <a:rPr lang="en-US" sz="1250" b="1" dirty="0">
+                <a:solidFill>
+                  <a:srgbClr val="A00000"/>
+                </a:solidFill>
+              </a:rPr>
+              <a:t>◆ Milestones:  </a:t>
+            </a:r>
+            <a:pPr indent="0" marL="0">
+              <a:buNone/>
+            </a:pPr>
+            <a:r>
+              <a:rPr lang="en-US" sz="1250" b="1" dirty="0">
+                <a:solidFill>
+                  <a:schemeClr val="tx1"/>
+                </a:solidFill>
+              </a:rPr>
+              <a:t>M1 </a:t>
+            </a:r>
+            <a:pPr indent="0" marL="0">
+              <a:buNone/>
+            </a:pPr>
+            <a:r>
+              <a:rPr lang="en-US" sz="1250" dirty="0">
+                <a:solidFill>
+                  <a:schemeClr val="tx1"/>
+                </a:solidFill>
+              </a:rPr>
+              <a:t>Chapter 1 results complete (Jan 15)   </a:t>
+            </a:r>
+            <a:pPr indent="0" marL="0">
+              <a:buNone/>
+            </a:pPr>
+            <a:r>
+              <a:rPr lang="en-US" sz="1250" b="1" dirty="0">
+                <a:solidFill>
+                  <a:schemeClr val="tx1"/>
+                </a:solidFill>
+              </a:rPr>
+              <a:t>M2 </a:t>
+            </a:r>
+            <a:pPr indent="0" marL="0">
+              <a:buNone/>
+            </a:pPr>
+            <a:r>
+              <a:rPr lang="en-US" sz="1250" dirty="0">
+                <a:solidFill>
+                  <a:schemeClr val="tx1"/>
+                </a:solidFill>
+              </a:rPr>
+              <a:t>Chapter 2 results complete (Feb 28)   </a:t>
+            </a:r>
+            <a:pPr indent="0" marL="0">
+              <a:buNone/>
+            </a:pPr>
+            <a:r>
+              <a:rPr lang="en-US" sz="1250" b="1" dirty="0">
+                <a:solidFill>
+                  <a:schemeClr val="tx1"/>
+                </a:solidFill>
+              </a:rPr>
+              <a:t>M3 </a:t>
+            </a:r>
+            <a:pPr indent="0" marL="0">
+              <a:buNone/>
+            </a:pPr>
+            <a:r>
+              <a:rPr lang="en-US" sz="1250" dirty="0">
+                <a:solidFill>
+                  <a:schemeClr val="tx1"/>
+                </a:solidFill>
+              </a:rPr>
+              <a:t>online system demo (Mar 15)   </a:t>
+            </a:r>
+            <a:endParaRPr lang="en-US" sz="1250" dirty="0"/>
+          </a:p>
+          <a:p>
+            <a:pPr indent="0" marL="0">
+              <a:buNone/>
+            </a:pPr>
+            <a:r>
+              <a:rPr lang="en-US" sz="1250" b="1" dirty="0">
+                <a:solidFill>
+                  <a:schemeClr val="tx1"/>
+                </a:solidFill>
+              </a:rPr>
+              <a:t>M4 </a:t>
+            </a:r>
+            <a:pPr indent="0" marL="0">
+              <a:buNone/>
+            </a:pPr>
+            <a:r>
+              <a:rPr lang="en-US" sz="1250" dirty="0">
+                <a:solidFill>
+                  <a:schemeClr val="tx1"/>
+                </a:solidFill>
+              </a:rPr>
+              <a:t>online experiments complete (Apr 15)   </a:t>
+            </a:r>
+            <a:pPr indent="0" marL="0">
+              <a:buNone/>
+            </a:pPr>
+            <a:r>
+              <a:rPr lang="en-US" sz="1250" b="1" dirty="0">
+                <a:solidFill>
+                  <a:schemeClr val="tx1"/>
+                </a:solidFill>
+              </a:rPr>
+              <a:t>M5 </a:t>
+            </a:r>
+            <a:pPr indent="0" marL="0">
+              <a:buNone/>
+            </a:pPr>
+            <a:r>
+              <a:rPr lang="en-US" sz="1250" dirty="0">
+                <a:solidFill>
+                  <a:schemeClr val="tx1"/>
+                </a:solidFill>
+              </a:rPr>
+              <a:t>thesis draft to supervisor (Apr 20)   </a:t>
+            </a:r>
+            <a:pPr indent="0" marL="0">
+              <a:buNone/>
+            </a:pPr>
+            <a:r>
+              <a:rPr lang="en-US" sz="1250" b="1" dirty="0">
+                <a:solidFill>
+                  <a:schemeClr val="tx1"/>
+                </a:solidFill>
+              </a:rPr>
+              <a:t>M6 </a:t>
+            </a:r>
+            <a:pPr indent="0" marL="0">
+              <a:buNone/>
+            </a:pPr>
+            <a:r>
+              <a:rPr lang="en-US" sz="1250" dirty="0">
+                <a:solidFill>
+                  <a:schemeClr val="tx1"/>
+                </a:solidFill>
+              </a:rPr>
+              <a:t>final defense (end of May)</a:t>
+            </a:r>
+            <a:endParaRPr lang="en-US" sz="1250" dirty="0"/>
+          </a:p>
+        </p:txBody>
+      </p:sp>
+      <p:sp>
+        <p:nvSpPr>
+          <p:cNvPr id="25" name="Slide Number Placeholder 0"/>
+          <p:cNvSpPr>
+            <a:spLocks noGrp="1"/>
+          </p:cNvSpPr>
+          <p:nvPr>
+            <p:ph type="sldNum" sz="quarter" idx="4294967295"/>
+          </p:nvPr>
+        </p:nvSpPr>
+        <p:spPr>
+          <a:xfrm>
+            <a:off x="11292840" y="6382512"/>
+            <a:ext cx="594360" cy="320040"/>
+          </a:xfrm>
+          <a:prstGeom prst="rect">
+            <a:avLst/>
+          </a:prstGeom>
+          <a:extLst>
+            <a:ext uri="{C572A759-6A51-4108-AA02-DFA0A04FC94B}">
+              <ma14:wrappingTextBoxFlag xmlns:ma14="http://schemas.microsoft.com/office/mac/drawingml/2011/main" val="0"/>
+            </a:ext>
+          </a:extLst>
+        </p:spPr>
+        <p:txBody>
+          <a:bodyPr/>
+          <a:lstStyle>
+            <a:lvl1pPr>
+              <a:defRPr sz="1400">
+                <a:solidFill>
+                  <a:schemeClr val="tx1"/>
+                </a:solidFill>
+              </a:defRPr>
+            </a:lvl1pPr>
+          </a:lstStyle>
+          <a:p>
+            <a:pPr algn="r"/>
+            <a:fld id="{F7021451-1387-4CA6-816F-3879F97B5CBC}" type="slidenum">
+              <a:rPr b="0" lang="en-US"/>
+              <a:t>16</a:t>
+            </a:fld>
+            <a:endParaRPr lang="en-US"/>
+          </a:p>
+        </p:txBody>
+      </p:sp>
+    </p:spTree>
+  </p:cSld>
+  <p:clrMapOvr>
+    <a:masterClrMapping/>
+  </p:clrMapOvr>
+</p:sld>
+</file>
+
 <file path=ppt/slides/slide2.xml><?xml version="1.0" encoding="utf-8"?>
 <p:sld xmlns:a="http://schemas.openxmlformats.org/drawingml/2006/main" xmlns:r="http://schemas.openxmlformats.org/officeDocument/2006/relationships" xmlns:p="http://schemas.openxmlformats.org/presentationml/2006/main">
   <p:cSld name="Slide 2">

</xml_diff>

<commit_message>
Slide 13: four research tasks for Chapters 1-2; align Gantt chart
Replace the per-algorithm table with four tasks: joint ablation of RED and
LR-MoE, generalization on public ERP datasets, a unified rigorous benchmark
and neurophysiological interpretability. Update the Gantt rows and
milestones M1/M2 to match.

Co-Authored-By: Claude Opus 5.5 <noreply@anthropic.com>
Claude-Session: https://claude.ai/code/session_01M2N1FL6JrZz8kTbkaY5rZ8
</commit_message>
<xml_diff>
--- a/presentation/midterm_defense_sample.pptx
+++ b/presentation/midterm_defense_sample.pptx
@@ -122,12 +122,12 @@
   <p:extLst>
     <p:ext uri="{521415D9-36F7-43E2-AB2F-B90AF26B5E84}">
       <p14:sectionLst xmlns:p14="http://schemas.microsoft.com/office/powerpoint/2010/main">
-        <p14:section name="Opening" id="{19c6040d-ee94-5a27-88fd-954da3f96632}">
+        <p14:section name="Opening" id="{55f11969-8f74-cabe-675d-255b938f4fe0}">
           <p14:sldIdLst>
             <p14:sldId id="256"/>
           </p14:sldIdLst>
         </p14:section>
-        <p14:section name="Research Background and Objectives" id="{f097e6b9-d896-241a-f688-1790bbebdfb3}">
+        <p14:section name="Research Background and Objectives" id="{768e580d-17b4-fa90-0f48-e8fe24d2250f}">
           <p14:sldIdLst>
             <p14:sldId id="257"/>
             <p14:sldId id="258"/>
@@ -135,7 +135,7 @@
             <p14:sldId id="260"/>
           </p14:sldIdLst>
         </p14:section>
-        <p14:section name="Research Progress and Stage Achievements" id="{546ea5b7-bf41-a385-f1ed-33863a2c6844}">
+        <p14:section name="Research Progress and Stage Achievements" id="{bc0b3977-e94d-5581-34e8-01c9272a69fb}">
           <p14:sldIdLst>
             <p14:sldId id="261"/>
             <p14:sldId id="262"/>
@@ -145,14 +145,14 @@
             <p14:sldId id="266"/>
           </p14:sldIdLst>
         </p14:section>
-        <p14:section name="Next-stage Research Plan" id="{7e0867ce-9098-ed14-5041-2ba682b7734a}">
+        <p14:section name="Next-stage Research Plan" id="{53c11c5b-eb26-2c57-1489-06cc6ee6d82f}">
           <p14:sldIdLst>
             <p14:sldId id="267"/>
             <p14:sldId id="268"/>
             <p14:sldId id="269"/>
           </p14:sldIdLst>
         </p14:section>
-        <p14:section name="Project Schedule" id="{bca9f9ee-c6be-75aa-16eb-b564a98a92bb}">
+        <p14:section name="Project Schedule" id="{278813d2-337e-77c1-9a8e-56820b745737}">
           <p14:sldIdLst>
             <p14:sldId id="270"/>
             <p14:sldId id="271"/>
@@ -914,7 +914,7 @@
           <a:p>
             <a:r>
               <a:rPr lang="en-US" dirty="0"/>
-              <a:t>~35 s. Both methods still need full validation. Comparisons add standard ERP decoders and recent deep models for Chapter 1, and alignment and domain-adaptation methods for Chapter 2. Ablations remove one component at a time. All results are reported over 28 subjects and several seeds with signed-rank tests. Robustness covers less training data, fewer channels and atypical subjects. Optimization prepares the models for real-time use.</a:t>
+              <a:t>~40 s. Four tasks remain for the two algorithms. First, a joint ablation: RED and LR-MoE address different problems, so a two-by-two design shows what each contributes and whether they add up when combined. Second, generalization: public ERP datasets with other devices and paradigms show the methods are not specific to this dataset. Third, a unified benchmark: the same leakage-free splits for every method, several seeds and proper statistics. Fourth, interpretability: the learned filters, reconstructions and routing should match aVEP physiology. Together they deliver one validated decoder for the online system.</a:t>
             </a:r>
             <a:endParaRPr lang="en-US" dirty="0"/>
           </a:p>
@@ -1178,7 +1178,7 @@
           <a:p>
             <a:r>
               <a:rPr lang="en-US" dirty="0"/>
-              <a:t>~30 s. Until mid-February: finish Chapter 1 experiments and implement Chapter 2. In parallel, from December, ethics approval and integration of the online system. Chapter 2 results by the end of February, an online demo in mid-March, online experiments until mid-April. Papers are written from mid-January, the thesis from mid-March, with the draft to my supervisor on April 20, then revision and the final defense at the end of May.</a:t>
+              <a:t>~30 s. Until January: implement LR-MoE and run the unified benchmark; joint ablation by the end of January; public-dataset validation and interpretability in February. In parallel, from December, ethics approval and integration of the online system. Algorithm results by the end of February, an online demo in mid-March, online experiments until mid-April. Papers are written from mid-January, the thesis from mid-March, with the draft to my supervisor on April 20, then revision and the final defense at the end of May.</a:t>
             </a:r>
             <a:endParaRPr lang="en-US" dirty="0"/>
           </a:p>
@@ -5674,846 +5674,80 @@
                   <a:schemeClr val="tx1"/>
                 </a:solidFill>
               </a:rPr>
-              <a:t>Chapters 1–2: from algorithm design to validated, complete methods</a:t>
+              <a:t>Chapters 1–2: four research tasks to complete and validate the two algorithms</a:t>
             </a:r>
             <a:endParaRPr lang="en-US" sz="1700" dirty="0"/>
           </a:p>
         </p:txBody>
       </p:sp>
-      <p:graphicFrame>
-        <p:nvGraphicFramePr>
-          <p:cNvPr id="14" name="Plan table"/>
-          <p:cNvGraphicFramePr>
-            <a:graphicFrameLocks noGrp="1"/>
-          </p:cNvGraphicFramePr>
-          <p:nvPr>
-            <p:extLst>
-              <p:ext uri="{D42A27DB-BD31-4B8C-83A1-F6EECF244321}">
-                <p14:modId xmlns:p14="http://schemas.microsoft.com/office/powerpoint/2010/main" val="1579011935"/>
-              </p:ext>
-            </p:extLst>
-          </p:nvPr>
-        </p:nvGraphicFramePr>
-        <p:xfrm>
-          <a:off x="548640" y="1645920"/>
-          <a:ext cx="11064240" cy="914400"/>
-        </p:xfrm>
-        <a:graphic>
-          <a:graphicData uri="http://schemas.openxmlformats.org/drawingml/2006/table">
-            <a:tbl>
-              <a:tblPr/>
-              <a:tblGrid>
-                <a:gridCol w="2103120"/>
-                <a:gridCol w="4480560"/>
-                <a:gridCol w="4480560"/>
-              </a:tblGrid>
-              <a:tr h="411480">
-                <a:tc>
-                  <a:txBody>
-                    <a:bodyPr/>
-                    <a:lstStyle/>
-                    <a:p>
-                      <a:pPr algn="l" indent="0" marL="0">
-                        <a:buNone/>
-                      </a:pPr>
-                      <a:endParaRPr lang="en-US" sz="1500" dirty="0">
-                        <a:latin typeface="Times New Roman" charset="0"/>
-                        <a:ea typeface="Times New Roman" charset="0"/>
-                        <a:cs typeface="Times New Roman" charset="0"/>
-                      </a:endParaRPr>
-                    </a:p>
-                  </a:txBody>
-                  <a:tcPr marL="101600" marR="101600" marT="38100" marB="38100" anchor="ctr">
-                    <a:lnL w="0" cap="flat" cmpd="sng" algn="ctr">
-                      <a:noFill/>
-                    </a:lnL>
-                    <a:lnR w="0" cap="flat" cmpd="sng" algn="ctr">
-                      <a:noFill/>
-                    </a:lnR>
-                    <a:lnT w="19050" cap="flat" cmpd="sng" algn="ctr">
-                      <a:solidFill>
-                        <a:srgbClr val="000000"/>
-                      </a:solidFill>
-                      <a:prstDash val="solid"/>
-                      <a:round/>
-                      <a:headEnd type="none" w="med" len="med"/>
-                      <a:tailEnd type="none" w="med" len="med"/>
-                    </a:lnT>
-                    <a:lnB w="12700" cap="flat" cmpd="sng" algn="ctr">
-                      <a:solidFill>
-                        <a:srgbClr val="000000"/>
-                      </a:solidFill>
-                      <a:prstDash val="solid"/>
-                      <a:round/>
-                      <a:headEnd type="none" w="med" len="med"/>
-                      <a:tailEnd type="none" w="med" len="med"/>
-                    </a:lnB>
-                  </a:tcPr>
-                </a:tc>
-                <a:tc>
-                  <a:txBody>
-                    <a:bodyPr/>
-                    <a:lstStyle/>
-                    <a:p>
-                      <a:pPr algn="l" indent="0" marL="0">
-                        <a:buNone/>
-                      </a:pPr>
-                      <a:r>
-                        <a:rPr lang="en-US" sz="1500" b="1" dirty="0">
-                          <a:solidFill>
-                            <a:srgbClr val="000000"/>
-                          </a:solidFill>
-                          <a:latin typeface="Times New Roman" pitchFamily="34" charset="0"/>
-                          <a:ea typeface="Times New Roman" pitchFamily="34" charset="-122"/>
-                          <a:cs typeface="Times New Roman" pitchFamily="34" charset="-120"/>
-                        </a:rPr>
-                        <a:t>Chapter 1 · RED (within-subject SNR)</a:t>
-                      </a:r>
-                      <a:endParaRPr lang="en-US" sz="1500" dirty="0">
-                        <a:latin typeface="Times New Roman" charset="0"/>
-                        <a:ea typeface="Times New Roman" charset="0"/>
-                        <a:cs typeface="Times New Roman" charset="0"/>
-                      </a:endParaRPr>
-                    </a:p>
-                  </a:txBody>
-                  <a:tcPr marL="101600" marR="101600" marT="38100" marB="38100" anchor="ctr">
-                    <a:lnL w="0" cap="flat" cmpd="sng" algn="ctr">
-                      <a:noFill/>
-                    </a:lnL>
-                    <a:lnR w="0" cap="flat" cmpd="sng" algn="ctr">
-                      <a:noFill/>
-                    </a:lnR>
-                    <a:lnT w="19050" cap="flat" cmpd="sng" algn="ctr">
-                      <a:solidFill>
-                        <a:srgbClr val="000000"/>
-                      </a:solidFill>
-                      <a:prstDash val="solid"/>
-                      <a:round/>
-                      <a:headEnd type="none" w="med" len="med"/>
-                      <a:tailEnd type="none" w="med" len="med"/>
-                    </a:lnT>
-                    <a:lnB w="12700" cap="flat" cmpd="sng" algn="ctr">
-                      <a:solidFill>
-                        <a:srgbClr val="000000"/>
-                      </a:solidFill>
-                      <a:prstDash val="solid"/>
-                      <a:round/>
-                      <a:headEnd type="none" w="med" len="med"/>
-                      <a:tailEnd type="none" w="med" len="med"/>
-                    </a:lnB>
-                  </a:tcPr>
-                </a:tc>
-                <a:tc>
-                  <a:txBody>
-                    <a:bodyPr/>
-                    <a:lstStyle/>
-                    <a:p>
-                      <a:pPr algn="l" indent="0" marL="0">
-                        <a:buNone/>
-                      </a:pPr>
-                      <a:r>
-                        <a:rPr lang="en-US" sz="1500" b="1" dirty="0">
-                          <a:solidFill>
-                            <a:srgbClr val="000000"/>
-                          </a:solidFill>
-                          <a:latin typeface="Times New Roman" pitchFamily="34" charset="0"/>
-                          <a:ea typeface="Times New Roman" pitchFamily="34" charset="-122"/>
-                          <a:cs typeface="Times New Roman" pitchFamily="34" charset="-120"/>
-                        </a:rPr>
-                        <a:t>Chapter 2 · LR-MoE (cross-subject)</a:t>
-                      </a:r>
-                      <a:endParaRPr lang="en-US" sz="1500" dirty="0">
-                        <a:latin typeface="Times New Roman" charset="0"/>
-                        <a:ea typeface="Times New Roman" charset="0"/>
-                        <a:cs typeface="Times New Roman" charset="0"/>
-                      </a:endParaRPr>
-                    </a:p>
-                  </a:txBody>
-                  <a:tcPr marL="101600" marR="101600" marT="38100" marB="38100" anchor="ctr">
-                    <a:lnL w="0" cap="flat" cmpd="sng" algn="ctr">
-                      <a:noFill/>
-                    </a:lnL>
-                    <a:lnR w="0" cap="flat" cmpd="sng" algn="ctr">
-                      <a:noFill/>
-                    </a:lnR>
-                    <a:lnT w="19050" cap="flat" cmpd="sng" algn="ctr">
-                      <a:solidFill>
-                        <a:srgbClr val="000000"/>
-                      </a:solidFill>
-                      <a:prstDash val="solid"/>
-                      <a:round/>
-                      <a:headEnd type="none" w="med" len="med"/>
-                      <a:tailEnd type="none" w="med" len="med"/>
-                    </a:lnT>
-                    <a:lnB w="12700" cap="flat" cmpd="sng" algn="ctr">
-                      <a:solidFill>
-                        <a:srgbClr val="000000"/>
-                      </a:solidFill>
-                      <a:prstDash val="solid"/>
-                      <a:round/>
-                      <a:headEnd type="none" w="med" len="med"/>
-                      <a:tailEnd type="none" w="med" len="med"/>
-                    </a:lnB>
-                  </a:tcPr>
-                </a:tc>
-              </a:tr>
-              <a:tr h="676656">
-                <a:tc>
-                  <a:txBody>
-                    <a:bodyPr/>
-                    <a:lstStyle/>
-                    <a:p>
-                      <a:pPr algn="l" indent="0" marL="0">
-                        <a:buNone/>
-                      </a:pPr>
-                      <a:r>
-                        <a:rPr lang="en-US" sz="1300" b="1" dirty="0">
-                          <a:solidFill>
-                            <a:srgbClr val="000000"/>
-                          </a:solidFill>
-                          <a:latin typeface="Times New Roman" pitchFamily="34" charset="0"/>
-                          <a:ea typeface="Times New Roman" pitchFamily="34" charset="-122"/>
-                          <a:cs typeface="Times New Roman" pitchFamily="34" charset="-120"/>
-                        </a:rPr>
-                        <a:t>Comparative experiments</a:t>
-                      </a:r>
-                      <a:endParaRPr lang="en-US" sz="1300" dirty="0">
-                        <a:latin typeface="Times New Roman" charset="0"/>
-                        <a:ea typeface="Times New Roman" charset="0"/>
-                        <a:cs typeface="Times New Roman" charset="0"/>
-                      </a:endParaRPr>
-                    </a:p>
-                  </a:txBody>
-                  <a:tcPr marL="101600" marR="101600" marT="38100" marB="38100" anchor="ctr">
-                    <a:lnL w="0" cap="flat" cmpd="sng" algn="ctr">
-                      <a:noFill/>
-                    </a:lnL>
-                    <a:lnR w="0" cap="flat" cmpd="sng" algn="ctr">
-                      <a:noFill/>
-                    </a:lnR>
-                    <a:lnT w="0" cap="flat" cmpd="sng" algn="ctr">
-                      <a:noFill/>
-                    </a:lnT>
-                    <a:lnB w="0" cap="flat" cmpd="sng" algn="ctr">
-                      <a:noFill/>
-                    </a:lnB>
-                  </a:tcPr>
-                </a:tc>
-                <a:tc>
-                  <a:txBody>
-                    <a:bodyPr/>
-                    <a:lstStyle/>
-                    <a:p>
-                      <a:pPr algn="l" indent="0" marL="0">
-                        <a:buNone/>
-                      </a:pPr>
-                      <a:r>
-                        <a:rPr lang="en-US" sz="1300" dirty="0">
-                          <a:solidFill>
-                            <a:srgbClr val="000000"/>
-                          </a:solidFill>
-                          <a:latin typeface="Times New Roman" pitchFamily="34" charset="0"/>
-                          <a:ea typeface="Times New Roman" pitchFamily="34" charset="-122"/>
-                          <a:cs typeface="Times New Roman" pitchFamily="34" charset="-120"/>
-                        </a:rPr>
-                        <a:t>EEGNet, DCPM + xDAWN-LDA, ShallowConvNet, EEG-Conformer; within-subject and pooled</a:t>
-                      </a:r>
-                      <a:endParaRPr lang="en-US" sz="1300" dirty="0">
-                        <a:latin typeface="Times New Roman" charset="0"/>
-                        <a:ea typeface="Times New Roman" charset="0"/>
-                        <a:cs typeface="Times New Roman" charset="0"/>
-                      </a:endParaRPr>
-                    </a:p>
-                  </a:txBody>
-                  <a:tcPr marL="101600" marR="101600" marT="38100" marB="38100" anchor="ctr">
-                    <a:lnL w="0" cap="flat" cmpd="sng" algn="ctr">
-                      <a:noFill/>
-                    </a:lnL>
-                    <a:lnR w="0" cap="flat" cmpd="sng" algn="ctr">
-                      <a:noFill/>
-                    </a:lnR>
-                    <a:lnT w="0" cap="flat" cmpd="sng" algn="ctr">
-                      <a:noFill/>
-                    </a:lnT>
-                    <a:lnB w="0" cap="flat" cmpd="sng" algn="ctr">
-                      <a:noFill/>
-                    </a:lnB>
-                  </a:tcPr>
-                </a:tc>
-                <a:tc>
-                  <a:txBody>
-                    <a:bodyPr/>
-                    <a:lstStyle/>
-                    <a:p>
-                      <a:pPr algn="l" indent="0" marL="0">
-                        <a:buNone/>
-                      </a:pPr>
-                      <a:r>
-                        <a:rPr lang="en-US" sz="1300" dirty="0">
-                          <a:solidFill>
-                            <a:srgbClr val="000000"/>
-                          </a:solidFill>
-                          <a:latin typeface="Times New Roman" pitchFamily="34" charset="0"/>
-                          <a:ea typeface="Times New Roman" pitchFamily="34" charset="-122"/>
-                          <a:cs typeface="Times New Roman" pitchFamily="34" charset="-120"/>
-                        </a:rPr>
-                        <a:t>EEGNet, DCPM + Euclidean alignment, domain-adversarial training, generic MoE; leave-one-subject-out</a:t>
-                      </a:r>
-                      <a:endParaRPr lang="en-US" sz="1300" dirty="0">
-                        <a:latin typeface="Times New Roman" charset="0"/>
-                        <a:ea typeface="Times New Roman" charset="0"/>
-                        <a:cs typeface="Times New Roman" charset="0"/>
-                      </a:endParaRPr>
-                    </a:p>
-                  </a:txBody>
-                  <a:tcPr marL="101600" marR="101600" marT="38100" marB="38100" anchor="ctr">
-                    <a:lnL w="0" cap="flat" cmpd="sng" algn="ctr">
-                      <a:noFill/>
-                    </a:lnL>
-                    <a:lnR w="0" cap="flat" cmpd="sng" algn="ctr">
-                      <a:noFill/>
-                    </a:lnR>
-                    <a:lnT w="0" cap="flat" cmpd="sng" algn="ctr">
-                      <a:noFill/>
-                    </a:lnT>
-                    <a:lnB w="0" cap="flat" cmpd="sng" algn="ctr">
-                      <a:noFill/>
-                    </a:lnB>
-                  </a:tcPr>
-                </a:tc>
-              </a:tr>
-              <a:tr h="676656">
-                <a:tc>
-                  <a:txBody>
-                    <a:bodyPr/>
-                    <a:lstStyle/>
-                    <a:p>
-                      <a:pPr algn="l" indent="0" marL="0">
-                        <a:buNone/>
-                      </a:pPr>
-                      <a:r>
-                        <a:rPr lang="en-US" sz="1300" b="1" dirty="0">
-                          <a:solidFill>
-                            <a:srgbClr val="000000"/>
-                          </a:solidFill>
-                          <a:latin typeface="Times New Roman" pitchFamily="34" charset="0"/>
-                          <a:ea typeface="Times New Roman" pitchFamily="34" charset="-122"/>
-                          <a:cs typeface="Times New Roman" pitchFamily="34" charset="-120"/>
-                        </a:rPr>
-                        <a:t>Ablation studies</a:t>
-                      </a:r>
-                      <a:endParaRPr lang="en-US" sz="1300" dirty="0">
-                        <a:latin typeface="Times New Roman" charset="0"/>
-                        <a:ea typeface="Times New Roman" charset="0"/>
-                        <a:cs typeface="Times New Roman" charset="0"/>
-                      </a:endParaRPr>
-                    </a:p>
-                  </a:txBody>
-                  <a:tcPr marL="101600" marR="101600" marT="38100" marB="38100" anchor="ctr">
-                    <a:lnL w="0" cap="flat" cmpd="sng" algn="ctr">
-                      <a:noFill/>
-                    </a:lnL>
-                    <a:lnR w="0" cap="flat" cmpd="sng" algn="ctr">
-                      <a:noFill/>
-                    </a:lnR>
-                    <a:lnT w="0" cap="flat" cmpd="sng" algn="ctr">
-                      <a:noFill/>
-                    </a:lnT>
-                    <a:lnB w="0" cap="flat" cmpd="sng" algn="ctr">
-                      <a:noFill/>
-                    </a:lnB>
-                  </a:tcPr>
-                </a:tc>
-                <a:tc>
-                  <a:txBody>
-                    <a:bodyPr/>
-                    <a:lstStyle/>
-                    <a:p>
-                      <a:pPr algn="l" indent="0" marL="0">
-                        <a:buNone/>
-                      </a:pPr>
-                      <a:r>
-                        <a:rPr lang="en-US" sz="1300" dirty="0">
-                          <a:solidFill>
-                            <a:srgbClr val="000000"/>
-                          </a:solidFill>
-                          <a:latin typeface="Times New Roman" pitchFamily="34" charset="0"/>
-                          <a:ea typeface="Times New Roman" pitchFamily="34" charset="-122"/>
-                          <a:cs typeface="Times New Roman" pitchFamily="34" charset="-120"/>
-                        </a:rPr>
-                        <a:t>Each loss term; k ∈ {2, 3, 6}; context-matched vs. class-mean target; naive distillation</a:t>
-                      </a:r>
-                      <a:endParaRPr lang="en-US" sz="1300" dirty="0">
-                        <a:latin typeface="Times New Roman" charset="0"/>
-                        <a:ea typeface="Times New Roman" charset="0"/>
-                        <a:cs typeface="Times New Roman" charset="0"/>
-                      </a:endParaRPr>
-                    </a:p>
-                  </a:txBody>
-                  <a:tcPr marL="101600" marR="101600" marT="38100" marB="38100" anchor="ctr">
-                    <a:lnL w="0" cap="flat" cmpd="sng" algn="ctr">
-                      <a:noFill/>
-                    </a:lnL>
-                    <a:lnR w="0" cap="flat" cmpd="sng" algn="ctr">
-                      <a:noFill/>
-                    </a:lnR>
-                    <a:lnT w="0" cap="flat" cmpd="sng" algn="ctr">
-                      <a:noFill/>
-                    </a:lnT>
-                    <a:lnB w="0" cap="flat" cmpd="sng" algn="ctr">
-                      <a:noFill/>
-                    </a:lnB>
-                  </a:tcPr>
-                </a:tc>
-                <a:tc>
-                  <a:txBody>
-                    <a:bodyPr/>
-                    <a:lstStyle/>
-                    <a:p>
-                      <a:pPr algn="l" indent="0" marL="0">
-                        <a:buNone/>
-                      </a:pPr>
-                      <a:r>
-                        <a:rPr lang="en-US" sz="1300" dirty="0">
-                          <a:solidFill>
-                            <a:srgbClr val="000000"/>
-                          </a:solidFill>
-                          <a:latin typeface="Times New Roman" pitchFamily="34" charset="0"/>
-                          <a:ea typeface="Times New Roman" pitchFamily="34" charset="-122"/>
-                          <a:cs typeface="Times New Roman" pitchFamily="34" charset="-120"/>
-                        </a:rPr>
-                        <a:t>No decomposition; single expert family; no latency variants; learned vs. physiological router</a:t>
-                      </a:r>
-                      <a:endParaRPr lang="en-US" sz="1300" dirty="0">
-                        <a:latin typeface="Times New Roman" charset="0"/>
-                        <a:ea typeface="Times New Roman" charset="0"/>
-                        <a:cs typeface="Times New Roman" charset="0"/>
-                      </a:endParaRPr>
-                    </a:p>
-                  </a:txBody>
-                  <a:tcPr marL="101600" marR="101600" marT="38100" marB="38100" anchor="ctr">
-                    <a:lnL w="0" cap="flat" cmpd="sng" algn="ctr">
-                      <a:noFill/>
-                    </a:lnL>
-                    <a:lnR w="0" cap="flat" cmpd="sng" algn="ctr">
-                      <a:noFill/>
-                    </a:lnR>
-                    <a:lnT w="0" cap="flat" cmpd="sng" algn="ctr">
-                      <a:noFill/>
-                    </a:lnT>
-                    <a:lnB w="0" cap="flat" cmpd="sng" algn="ctr">
-                      <a:noFill/>
-                    </a:lnB>
-                  </a:tcPr>
-                </a:tc>
-              </a:tr>
-              <a:tr h="676656">
-                <a:tc>
-                  <a:txBody>
-                    <a:bodyPr/>
-                    <a:lstStyle/>
-                    <a:p>
-                      <a:pPr algn="l" indent="0" marL="0">
-                        <a:buNone/>
-                      </a:pPr>
-                      <a:r>
-                        <a:rPr lang="en-US" sz="1300" b="1" dirty="0">
-                          <a:solidFill>
-                            <a:srgbClr val="000000"/>
-                          </a:solidFill>
-                          <a:latin typeface="Times New Roman" pitchFamily="34" charset="0"/>
-                          <a:ea typeface="Times New Roman" pitchFamily="34" charset="-122"/>
-                          <a:cs typeface="Times New Roman" pitchFamily="34" charset="-120"/>
-                        </a:rPr>
-                        <a:t>Generalization</a:t>
-                      </a:r>
-                      <a:endParaRPr lang="en-US" sz="1300" dirty="0">
-                        <a:latin typeface="Times New Roman" charset="0"/>
-                        <a:ea typeface="Times New Roman" charset="0"/>
-                        <a:cs typeface="Times New Roman" charset="0"/>
-                      </a:endParaRPr>
-                    </a:p>
-                  </a:txBody>
-                  <a:tcPr marL="101600" marR="101600" marT="38100" marB="38100" anchor="ctr">
-                    <a:lnL w="0" cap="flat" cmpd="sng" algn="ctr">
-                      <a:noFill/>
-                    </a:lnL>
-                    <a:lnR w="0" cap="flat" cmpd="sng" algn="ctr">
-                      <a:noFill/>
-                    </a:lnR>
-                    <a:lnT w="0" cap="flat" cmpd="sng" algn="ctr">
-                      <a:noFill/>
-                    </a:lnT>
-                    <a:lnB w="0" cap="flat" cmpd="sng" algn="ctr">
-                      <a:noFill/>
-                    </a:lnB>
-                  </a:tcPr>
-                </a:tc>
-                <a:tc>
-                  <a:txBody>
-                    <a:bodyPr/>
-                    <a:lstStyle/>
-                    <a:p>
-                      <a:pPr algn="l" indent="0" marL="0">
-                        <a:buNone/>
-                      </a:pPr>
-                      <a:r>
-                        <a:rPr lang="en-US" sz="1300" dirty="0">
-                          <a:solidFill>
-                            <a:srgbClr val="000000"/>
-                          </a:solidFill>
-                          <a:latin typeface="Times New Roman" pitchFamily="34" charset="0"/>
-                          <a:ea typeface="Times New Roman" pitchFamily="34" charset="-122"/>
-                          <a:cs typeface="Times New Roman" pitchFamily="34" charset="-120"/>
-                        </a:rPr>
-                        <a:t>All three protocols; several random seeds; Wilcoxon signed-rank tests with FDR correction</a:t>
-                      </a:r>
-                      <a:endParaRPr lang="en-US" sz="1300" dirty="0">
-                        <a:latin typeface="Times New Roman" charset="0"/>
-                        <a:ea typeface="Times New Roman" charset="0"/>
-                        <a:cs typeface="Times New Roman" charset="0"/>
-                      </a:endParaRPr>
-                    </a:p>
-                  </a:txBody>
-                  <a:tcPr marL="101600" marR="101600" marT="38100" marB="38100" anchor="ctr">
-                    <a:lnL w="0" cap="flat" cmpd="sng" algn="ctr">
-                      <a:noFill/>
-                    </a:lnL>
-                    <a:lnR w="0" cap="flat" cmpd="sng" algn="ctr">
-                      <a:noFill/>
-                    </a:lnR>
-                    <a:lnT w="0" cap="flat" cmpd="sng" algn="ctr">
-                      <a:noFill/>
-                    </a:lnT>
-                    <a:lnB w="0" cap="flat" cmpd="sng" algn="ctr">
-                      <a:noFill/>
-                    </a:lnB>
-                  </a:tcPr>
-                </a:tc>
-                <a:tc>
-                  <a:txBody>
-                    <a:bodyPr/>
-                    <a:lstStyle/>
-                    <a:p>
-                      <a:pPr algn="l" indent="0" marL="0">
-                        <a:buNone/>
-                      </a:pPr>
-                      <a:r>
-                        <a:rPr lang="en-US" sz="1300" dirty="0">
-                          <a:solidFill>
-                            <a:srgbClr val="000000"/>
-                          </a:solidFill>
-                          <a:latin typeface="Times New Roman" pitchFamily="34" charset="0"/>
-                          <a:ea typeface="Times New Roman" pitchFamily="34" charset="-122"/>
-                          <a:cs typeface="Times New Roman" pitchFamily="34" charset="-120"/>
-                        </a:rPr>
-                        <a:t>28 unseen subjects; unlabelled router adaptation; few-shot calibration curves</a:t>
-                      </a:r>
-                      <a:endParaRPr lang="en-US" sz="1300" dirty="0">
-                        <a:latin typeface="Times New Roman" charset="0"/>
-                        <a:ea typeface="Times New Roman" charset="0"/>
-                        <a:cs typeface="Times New Roman" charset="0"/>
-                      </a:endParaRPr>
-                    </a:p>
-                  </a:txBody>
-                  <a:tcPr marL="101600" marR="101600" marT="38100" marB="38100" anchor="ctr">
-                    <a:lnL w="0" cap="flat" cmpd="sng" algn="ctr">
-                      <a:noFill/>
-                    </a:lnL>
-                    <a:lnR w="0" cap="flat" cmpd="sng" algn="ctr">
-                      <a:noFill/>
-                    </a:lnR>
-                    <a:lnT w="0" cap="flat" cmpd="sng" algn="ctr">
-                      <a:noFill/>
-                    </a:lnT>
-                    <a:lnB w="0" cap="flat" cmpd="sng" algn="ctr">
-                      <a:noFill/>
-                    </a:lnB>
-                  </a:tcPr>
-                </a:tc>
-              </a:tr>
-              <a:tr h="676656">
-                <a:tc>
-                  <a:txBody>
-                    <a:bodyPr/>
-                    <a:lstStyle/>
-                    <a:p>
-                      <a:pPr algn="l" indent="0" marL="0">
-                        <a:buNone/>
-                      </a:pPr>
-                      <a:r>
-                        <a:rPr lang="en-US" sz="1300" b="1" dirty="0">
-                          <a:solidFill>
-                            <a:srgbClr val="000000"/>
-                          </a:solidFill>
-                          <a:latin typeface="Times New Roman" pitchFamily="34" charset="0"/>
-                          <a:ea typeface="Times New Roman" pitchFamily="34" charset="-122"/>
-                          <a:cs typeface="Times New Roman" pitchFamily="34" charset="-120"/>
-                        </a:rPr>
-                        <a:t>Robustness</a:t>
-                      </a:r>
-                      <a:endParaRPr lang="en-US" sz="1300" dirty="0">
-                        <a:latin typeface="Times New Roman" charset="0"/>
-                        <a:ea typeface="Times New Roman" charset="0"/>
-                        <a:cs typeface="Times New Roman" charset="0"/>
-                      </a:endParaRPr>
-                    </a:p>
-                  </a:txBody>
-                  <a:tcPr marL="101600" marR="101600" marT="38100" marB="38100" anchor="ctr">
-                    <a:lnL w="0" cap="flat" cmpd="sng" algn="ctr">
-                      <a:noFill/>
-                    </a:lnL>
-                    <a:lnR w="0" cap="flat" cmpd="sng" algn="ctr">
-                      <a:noFill/>
-                    </a:lnR>
-                    <a:lnT w="0" cap="flat" cmpd="sng" algn="ctr">
-                      <a:noFill/>
-                    </a:lnT>
-                    <a:lnB w="0" cap="flat" cmpd="sng" algn="ctr">
-                      <a:noFill/>
-                    </a:lnB>
-                  </a:tcPr>
-                </a:tc>
-                <a:tc>
-                  <a:txBody>
-                    <a:bodyPr/>
-                    <a:lstStyle/>
-                    <a:p>
-                      <a:pPr algn="l" indent="0" marL="0">
-                        <a:buNone/>
-                      </a:pPr>
-                      <a:r>
-                        <a:rPr lang="en-US" sz="1300" dirty="0">
-                          <a:solidFill>
-                            <a:srgbClr val="000000"/>
-                          </a:solidFill>
-                          <a:latin typeface="Times New Roman" pitchFamily="34" charset="0"/>
-                          <a:ea typeface="Times New Roman" pitchFamily="34" charset="-122"/>
-                          <a:cs typeface="Times New Roman" pitchFamily="34" charset="-120"/>
-                        </a:rPr>
-                        <a:t>Fewer training trials (learning curves); channel dropout; session-to-session shift</a:t>
-                      </a:r>
-                      <a:endParaRPr lang="en-US" sz="1300" dirty="0">
-                        <a:latin typeface="Times New Roman" charset="0"/>
-                        <a:ea typeface="Times New Roman" charset="0"/>
-                        <a:cs typeface="Times New Roman" charset="0"/>
-                      </a:endParaRPr>
-                    </a:p>
-                  </a:txBody>
-                  <a:tcPr marL="101600" marR="101600" marT="38100" marB="38100" anchor="ctr">
-                    <a:lnL w="0" cap="flat" cmpd="sng" algn="ctr">
-                      <a:noFill/>
-                    </a:lnL>
-                    <a:lnR w="0" cap="flat" cmpd="sng" algn="ctr">
-                      <a:noFill/>
-                    </a:lnR>
-                    <a:lnT w="0" cap="flat" cmpd="sng" algn="ctr">
-                      <a:noFill/>
-                    </a:lnT>
-                    <a:lnB w="0" cap="flat" cmpd="sng" algn="ctr">
-                      <a:noFill/>
-                    </a:lnB>
-                  </a:tcPr>
-                </a:tc>
-                <a:tc>
-                  <a:txBody>
-                    <a:bodyPr/>
-                    <a:lstStyle/>
-                    <a:p>
-                      <a:pPr algn="l" indent="0" marL="0">
-                        <a:buNone/>
-                      </a:pPr>
-                      <a:r>
-                        <a:rPr lang="en-US" sz="1300" dirty="0">
-                          <a:solidFill>
-                            <a:srgbClr val="000000"/>
-                          </a:solidFill>
-                          <a:latin typeface="Times New Roman" pitchFamily="34" charset="0"/>
-                          <a:ea typeface="Times New Roman" pitchFamily="34" charset="-122"/>
-                          <a:cs typeface="Times New Roman" pitchFamily="34" charset="-120"/>
-                        </a:rPr>
-                        <a:t>Atypical subjects (low mirror r); reduced channel sets; short calibration</a:t>
-                      </a:r>
-                      <a:endParaRPr lang="en-US" sz="1300" dirty="0">
-                        <a:latin typeface="Times New Roman" charset="0"/>
-                        <a:ea typeface="Times New Roman" charset="0"/>
-                        <a:cs typeface="Times New Roman" charset="0"/>
-                      </a:endParaRPr>
-                    </a:p>
-                  </a:txBody>
-                  <a:tcPr marL="101600" marR="101600" marT="38100" marB="38100" anchor="ctr">
-                    <a:lnL w="0" cap="flat" cmpd="sng" algn="ctr">
-                      <a:noFill/>
-                    </a:lnL>
-                    <a:lnR w="0" cap="flat" cmpd="sng" algn="ctr">
-                      <a:noFill/>
-                    </a:lnR>
-                    <a:lnT w="0" cap="flat" cmpd="sng" algn="ctr">
-                      <a:noFill/>
-                    </a:lnT>
-                    <a:lnB w="0" cap="flat" cmpd="sng" algn="ctr">
-                      <a:noFill/>
-                    </a:lnB>
-                  </a:tcPr>
-                </a:tc>
-              </a:tr>
-              <a:tr h="676656">
-                <a:tc>
-                  <a:txBody>
-                    <a:bodyPr/>
-                    <a:lstStyle/>
-                    <a:p>
-                      <a:pPr algn="l" indent="0" marL="0">
-                        <a:buNone/>
-                      </a:pPr>
-                      <a:r>
-                        <a:rPr lang="en-US" sz="1300" b="1" dirty="0">
-                          <a:solidFill>
-                            <a:srgbClr val="000000"/>
-                          </a:solidFill>
-                          <a:latin typeface="Times New Roman" pitchFamily="34" charset="0"/>
-                          <a:ea typeface="Times New Roman" pitchFamily="34" charset="-122"/>
-                          <a:cs typeface="Times New Roman" pitchFamily="34" charset="-120"/>
-                        </a:rPr>
-                        <a:t>Optimization</a:t>
-                      </a:r>
-                      <a:endParaRPr lang="en-US" sz="1300" dirty="0">
-                        <a:latin typeface="Times New Roman" charset="0"/>
-                        <a:ea typeface="Times New Roman" charset="0"/>
-                        <a:cs typeface="Times New Roman" charset="0"/>
-                      </a:endParaRPr>
-                    </a:p>
-                  </a:txBody>
-                  <a:tcPr marL="101600" marR="101600" marT="38100" marB="38100" anchor="ctr">
-                    <a:lnL w="0" cap="flat" cmpd="sng" algn="ctr">
-                      <a:noFill/>
-                    </a:lnL>
-                    <a:lnR w="0" cap="flat" cmpd="sng" algn="ctr">
-                      <a:noFill/>
-                    </a:lnR>
-                    <a:lnT w="0" cap="flat" cmpd="sng" algn="ctr">
-                      <a:noFill/>
-                    </a:lnT>
-                    <a:lnB w="19050" cap="flat" cmpd="sng" algn="ctr">
-                      <a:solidFill>
-                        <a:srgbClr val="000000"/>
-                      </a:solidFill>
-                      <a:prstDash val="solid"/>
-                      <a:round/>
-                      <a:headEnd type="none" w="med" len="med"/>
-                      <a:tailEnd type="none" w="med" len="med"/>
-                    </a:lnB>
-                  </a:tcPr>
-                </a:tc>
-                <a:tc>
-                  <a:txBody>
-                    <a:bodyPr/>
-                    <a:lstStyle/>
-                    <a:p>
-                      <a:pPr algn="l" indent="0" marL="0">
-                        <a:buNone/>
-                      </a:pPr>
-                      <a:r>
-                        <a:rPr lang="en-US" sz="1300" dirty="0">
-                          <a:solidFill>
-                            <a:srgbClr val="000000"/>
-                          </a:solidFill>
-                          <a:latin typeface="Times New Roman" pitchFamily="34" charset="0"/>
-                          <a:ea typeface="Times New Roman" pitchFamily="34" charset="-122"/>
-                          <a:cs typeface="Times New Roman" pitchFamily="34" charset="-120"/>
-                        </a:rPr>
-                        <a:t>Non-linear decoder; teacher ensembles; training cost</a:t>
-                      </a:r>
-                      <a:endParaRPr lang="en-US" sz="1300" dirty="0">
-                        <a:latin typeface="Times New Roman" charset="0"/>
-                        <a:ea typeface="Times New Roman" charset="0"/>
-                        <a:cs typeface="Times New Roman" charset="0"/>
-                      </a:endParaRPr>
-                    </a:p>
-                  </a:txBody>
-                  <a:tcPr marL="101600" marR="101600" marT="38100" marB="38100" anchor="ctr">
-                    <a:lnL w="0" cap="flat" cmpd="sng" algn="ctr">
-                      <a:noFill/>
-                    </a:lnL>
-                    <a:lnR w="0" cap="flat" cmpd="sng" algn="ctr">
-                      <a:noFill/>
-                    </a:lnR>
-                    <a:lnT w="0" cap="flat" cmpd="sng" algn="ctr">
-                      <a:noFill/>
-                    </a:lnT>
-                    <a:lnB w="19050" cap="flat" cmpd="sng" algn="ctr">
-                      <a:solidFill>
-                        <a:srgbClr val="000000"/>
-                      </a:solidFill>
-                      <a:prstDash val="solid"/>
-                      <a:round/>
-                      <a:headEnd type="none" w="med" len="med"/>
-                      <a:tailEnd type="none" w="med" len="med"/>
-                    </a:lnB>
-                  </a:tcPr>
-                </a:tc>
-                <a:tc>
-                  <a:txBody>
-                    <a:bodyPr/>
-                    <a:lstStyle/>
-                    <a:p>
-                      <a:pPr algn="l" indent="0" marL="0">
-                        <a:buNone/>
-                      </a:pPr>
-                      <a:r>
-                        <a:rPr lang="en-US" sz="1300" dirty="0">
-                          <a:solidFill>
-                            <a:srgbClr val="000000"/>
-                          </a:solidFill>
-                          <a:latin typeface="Times New Roman" pitchFamily="34" charset="0"/>
-                          <a:ea typeface="Times New Roman" pitchFamily="34" charset="-122"/>
-                          <a:cs typeface="Times New Roman" pitchFamily="34" charset="-120"/>
-                        </a:rPr>
-                        <a:t>Lightweight experts for real-time use; checking router choices against measured r and latency</a:t>
-                      </a:r>
-                      <a:endParaRPr lang="en-US" sz="1300" dirty="0">
-                        <a:latin typeface="Times New Roman" charset="0"/>
-                        <a:ea typeface="Times New Roman" charset="0"/>
-                        <a:cs typeface="Times New Roman" charset="0"/>
-                      </a:endParaRPr>
-                    </a:p>
-                  </a:txBody>
-                  <a:tcPr marL="101600" marR="101600" marT="38100" marB="38100" anchor="ctr">
-                    <a:lnL w="0" cap="flat" cmpd="sng" algn="ctr">
-                      <a:noFill/>
-                    </a:lnL>
-                    <a:lnR w="0" cap="flat" cmpd="sng" algn="ctr">
-                      <a:noFill/>
-                    </a:lnR>
-                    <a:lnT w="0" cap="flat" cmpd="sng" algn="ctr">
-                      <a:noFill/>
-                    </a:lnT>
-                    <a:lnB w="19050" cap="flat" cmpd="sng" algn="ctr">
-                      <a:solidFill>
-                        <a:srgbClr val="000000"/>
-                      </a:solidFill>
-                      <a:prstDash val="solid"/>
-                      <a:round/>
-                      <a:headEnd type="none" w="med" len="med"/>
-                      <a:tailEnd type="none" w="med" len="med"/>
-                    </a:lnB>
-                  </a:tcPr>
-                </a:tc>
-              </a:tr>
-            </a:tbl>
-          </a:graphicData>
-        </a:graphic>
-      </p:graphicFrame>
-      <p:sp>
-        <p:nvSpPr>
-          <p:cNvPr id="5" name="Outcome"/>
+      <p:sp>
+        <p:nvSpPr>
+          <p:cNvPr id="4" name="Task 1 card"/>
+          <p:cNvSpPr/>
+          <p:nvPr/>
+        </p:nvSpPr>
+        <p:spPr>
+          <a:xfrm>
+            <a:off x="548640" y="1664208"/>
+            <a:ext cx="5440680" cy="1847088"/>
+          </a:xfrm>
+          <a:prstGeom prst="rect">
+            <a:avLst/>
+          </a:prstGeom>
+          <a:solidFill>
+            <a:srgbClr val="F2F2F2"/>
+          </a:solidFill>
+          <a:ln/>
+        </p:spPr>
+      </p:sp>
+      <p:sp>
+        <p:nvSpPr>
+          <p:cNvPr id="5" name="Task 1 number"/>
+          <p:cNvSpPr/>
+          <p:nvPr/>
+        </p:nvSpPr>
+        <p:spPr>
+          <a:xfrm>
+            <a:off x="731520" y="1828800"/>
+            <a:ext cx="438912" cy="438912"/>
+          </a:xfrm>
+          <a:prstGeom prst="ellipse">
+            <a:avLst/>
+          </a:prstGeom>
+          <a:solidFill>
+            <a:srgbClr val="A00000"/>
+          </a:solidFill>
+          <a:ln/>
+        </p:spPr>
+        <p:txBody>
+          <a:bodyPr wrap="square" lIns="0" tIns="0" rIns="0" bIns="0" rtlCol="0" anchor="ctr"/>
+          <a:lstStyle/>
+          <a:p>
+            <a:pPr algn="ctr" indent="0" marL="0">
+              <a:buNone/>
+            </a:pPr>
+            <a:r>
+              <a:rPr lang="en-US" sz="1800" b="1" dirty="0">
+                <a:solidFill>
+                  <a:schemeClr val="bg1"/>
+                </a:solidFill>
+              </a:rPr>
+              <a:t>1</a:t>
+            </a:r>
+            <a:endParaRPr lang="en-US" sz="1800" dirty="0"/>
+          </a:p>
+        </p:txBody>
+      </p:sp>
+      <p:sp>
+        <p:nvSpPr>
+          <p:cNvPr id="6" name="Task 1 title"/>
           <p:cNvSpPr txBox="1"/>
           <p:nvPr/>
         </p:nvSpPr>
         <p:spPr>
           <a:xfrm>
-            <a:off x="548640" y="5532120"/>
-            <a:ext cx="11064240" cy="411480"/>
+            <a:off x="1298448" y="1828800"/>
+            <a:ext cx="4526280" cy="438912"/>
           </a:xfrm>
           <a:prstGeom prst="rect">
             <a:avLst/>
@@ -6525,18 +5759,672 @@
           <a:bodyPr wrap="square" lIns="0" tIns="0" rIns="0" bIns="0" rtlCol="0" anchor="ctr"/>
           <a:lstStyle/>
           <a:p>
+            <a:pPr indent="0" marL="0">
+              <a:buNone/>
+            </a:pPr>
+            <a:r>
+              <a:rPr lang="en-US" sz="1700" b="1" dirty="0">
+                <a:solidFill>
+                  <a:schemeClr val="tx1"/>
+                </a:solidFill>
+              </a:rPr>
+              <a:t>Joint ablation of RED and LR-MoE</a:t>
+            </a:r>
+            <a:endParaRPr lang="en-US" sz="1700" dirty="0"/>
+          </a:p>
+        </p:txBody>
+      </p:sp>
+      <p:sp>
+        <p:nvSpPr>
+          <p:cNvPr id="7" name="Task 1 body"/>
+          <p:cNvSpPr txBox="1"/>
+          <p:nvPr/>
+        </p:nvSpPr>
+        <p:spPr>
+          <a:xfrm>
+            <a:off x="777240" y="2377440"/>
+            <a:ext cx="5029200" cy="1042416"/>
+          </a:xfrm>
+          <a:prstGeom prst="rect">
+            <a:avLst/>
+          </a:prstGeom>
+          <a:noFill/>
+          <a:ln/>
+        </p:spPr>
+        <p:txBody>
+          <a:bodyPr wrap="square" lIns="0" tIns="0" rIns="0" bIns="0" rtlCol="0" anchor="t"/>
+          <a:lstStyle/>
+          <a:p>
+            <a:pPr indent="0" marL="0">
+              <a:spcAft>
+                <a:spcPts val="500"/>
+              </a:spcAft>
+              <a:buNone/>
+            </a:pPr>
+            <a:r>
+              <a:rPr lang="en-US" sz="1350" b="1" dirty="0">
+                <a:solidFill>
+                  <a:srgbClr val="A00000"/>
+                </a:solidFill>
+              </a:rPr>
+              <a:t>Goal: </a:t>
+            </a:r>
+            <a:pPr indent="0" marL="0">
+              <a:spcAft>
+                <a:spcPts val="500"/>
+              </a:spcAft>
+              <a:buNone/>
+            </a:pPr>
+            <a:r>
+              <a:rPr lang="en-US" sz="1350" dirty="0">
+                <a:solidFill>
+                  <a:schemeClr val="tx1"/>
+                </a:solidFill>
+              </a:rPr>
+              <a:t>Quantify each algorithm's contribution, their interaction and complementarity</a:t>
+            </a:r>
+            <a:endParaRPr lang="en-US" sz="1350" dirty="0"/>
+          </a:p>
+          <a:p>
+            <a:pPr indent="0" marL="0">
+              <a:spcAft>
+                <a:spcPts val="500"/>
+              </a:spcAft>
+              <a:buNone/>
+            </a:pPr>
+            <a:r>
+              <a:rPr lang="en-US" sz="1350" b="1" dirty="0">
+                <a:solidFill>
+                  <a:srgbClr val="A00000"/>
+                </a:solidFill>
+              </a:rPr>
+              <a:t>Method: </a:t>
+            </a:r>
+            <a:pPr indent="0" marL="0">
+              <a:spcAft>
+                <a:spcPts val="500"/>
+              </a:spcAft>
+              <a:buNone/>
+            </a:pPr>
+            <a:r>
+              <a:rPr lang="en-US" sz="1350" dirty="0">
+                <a:solidFill>
+                  <a:schemeClr val="tx1"/>
+                </a:solidFill>
+              </a:rPr>
+              <a:t>2 × 2 design (with / without RED training × with / without LR-MoE) on within-subject, pooled and LOSO protocols</a:t>
+            </a:r>
+            <a:endParaRPr lang="en-US" sz="1350" dirty="0"/>
+          </a:p>
+        </p:txBody>
+      </p:sp>
+      <p:sp>
+        <p:nvSpPr>
+          <p:cNvPr id="8" name="Task 2 card"/>
+          <p:cNvSpPr/>
+          <p:nvPr/>
+        </p:nvSpPr>
+        <p:spPr>
+          <a:xfrm>
+            <a:off x="6172200" y="1664208"/>
+            <a:ext cx="5440680" cy="1847088"/>
+          </a:xfrm>
+          <a:prstGeom prst="rect">
+            <a:avLst/>
+          </a:prstGeom>
+          <a:solidFill>
+            <a:srgbClr val="F2F2F2"/>
+          </a:solidFill>
+          <a:ln/>
+        </p:spPr>
+      </p:sp>
+      <p:sp>
+        <p:nvSpPr>
+          <p:cNvPr id="9" name="Task 2 number"/>
+          <p:cNvSpPr/>
+          <p:nvPr/>
+        </p:nvSpPr>
+        <p:spPr>
+          <a:xfrm>
+            <a:off x="6355080" y="1828800"/>
+            <a:ext cx="438912" cy="438912"/>
+          </a:xfrm>
+          <a:prstGeom prst="ellipse">
+            <a:avLst/>
+          </a:prstGeom>
+          <a:solidFill>
+            <a:srgbClr val="A00000"/>
+          </a:solidFill>
+          <a:ln/>
+        </p:spPr>
+        <p:txBody>
+          <a:bodyPr wrap="square" lIns="0" tIns="0" rIns="0" bIns="0" rtlCol="0" anchor="ctr"/>
+          <a:lstStyle/>
+          <a:p>
             <a:pPr algn="ctr" indent="0" marL="0">
               <a:buNone/>
             </a:pPr>
             <a:r>
+              <a:rPr lang="en-US" sz="1800" b="1" dirty="0">
+                <a:solidFill>
+                  <a:schemeClr val="bg1"/>
+                </a:solidFill>
+              </a:rPr>
+              <a:t>2</a:t>
+            </a:r>
+            <a:endParaRPr lang="en-US" sz="1800" dirty="0"/>
+          </a:p>
+        </p:txBody>
+      </p:sp>
+      <p:sp>
+        <p:nvSpPr>
+          <p:cNvPr id="10" name="Task 2 title"/>
+          <p:cNvSpPr txBox="1"/>
+          <p:nvPr/>
+        </p:nvSpPr>
+        <p:spPr>
+          <a:xfrm>
+            <a:off x="6922008" y="1828800"/>
+            <a:ext cx="4526280" cy="438912"/>
+          </a:xfrm>
+          <a:prstGeom prst="rect">
+            <a:avLst/>
+          </a:prstGeom>
+          <a:noFill/>
+          <a:ln/>
+        </p:spPr>
+        <p:txBody>
+          <a:bodyPr wrap="square" lIns="0" tIns="0" rIns="0" bIns="0" rtlCol="0" anchor="ctr"/>
+          <a:lstStyle/>
+          <a:p>
+            <a:pPr indent="0" marL="0">
+              <a:buNone/>
+            </a:pPr>
+            <a:r>
               <a:rPr lang="en-US" sz="1700" b="1" dirty="0">
                 <a:solidFill>
+                  <a:schemeClr val="tx1"/>
+                </a:solidFill>
+              </a:rPr>
+              <a:t>Generalization on public ERP datasets</a:t>
+            </a:r>
+            <a:endParaRPr lang="en-US" sz="1700" dirty="0"/>
+          </a:p>
+        </p:txBody>
+      </p:sp>
+      <p:sp>
+        <p:nvSpPr>
+          <p:cNvPr id="11" name="Task 2 body"/>
+          <p:cNvSpPr txBox="1"/>
+          <p:nvPr/>
+        </p:nvSpPr>
+        <p:spPr>
+          <a:xfrm>
+            <a:off x="6400800" y="2377440"/>
+            <a:ext cx="5029200" cy="1042416"/>
+          </a:xfrm>
+          <a:prstGeom prst="rect">
+            <a:avLst/>
+          </a:prstGeom>
+          <a:noFill/>
+          <a:ln/>
+        </p:spPr>
+        <p:txBody>
+          <a:bodyPr wrap="square" lIns="0" tIns="0" rIns="0" bIns="0" rtlCol="0" anchor="t"/>
+          <a:lstStyle/>
+          <a:p>
+            <a:pPr indent="0" marL="0">
+              <a:spcAft>
+                <a:spcPts val="500"/>
+              </a:spcAft>
+              <a:buNone/>
+            </a:pPr>
+            <a:r>
+              <a:rPr lang="en-US" sz="1350" b="1" dirty="0">
+                <a:solidFill>
+                  <a:srgbClr val="A00000"/>
+                </a:solidFill>
+              </a:rPr>
+              <a:t>Goal: </a:t>
+            </a:r>
+            <a:pPr indent="0" marL="0">
+              <a:spcAft>
+                <a:spcPts val="500"/>
+              </a:spcAft>
+              <a:buNone/>
+            </a:pPr>
+            <a:r>
+              <a:rPr lang="en-US" sz="1350" dirty="0">
+                <a:solidFill>
+                  <a:schemeClr val="tx1"/>
+                </a:solidFill>
+              </a:rPr>
+              <a:t>Show the methods are not tied to one dataset, paradigm or recording setup</a:t>
+            </a:r>
+            <a:endParaRPr lang="en-US" sz="1350" dirty="0"/>
+          </a:p>
+          <a:p>
+            <a:pPr indent="0" marL="0">
+              <a:spcAft>
+                <a:spcPts val="500"/>
+              </a:spcAft>
+              <a:buNone/>
+            </a:pPr>
+            <a:r>
+              <a:rPr lang="en-US" sz="1350" b="1" dirty="0">
+                <a:solidFill>
+                  <a:srgbClr val="A00000"/>
+                </a:solidFill>
+              </a:rPr>
+              <a:t>Method: </a:t>
+            </a:r>
+            <a:pPr indent="0" marL="0">
+              <a:spcAft>
+                <a:spcPts val="500"/>
+              </a:spcAft>
+              <a:buNone/>
+            </a:pPr>
+            <a:r>
+              <a:rPr lang="en-US" sz="1350" dirty="0">
+                <a:solidFill>
+                  <a:schemeClr val="tx1"/>
+                </a:solidFill>
+              </a:rPr>
+              <a:t>Public ERP / P300 datasets (e.g. MOABB, BCI Competition III) with other devices; adapt the mirror split where needed</a:t>
+            </a:r>
+            <a:endParaRPr lang="en-US" sz="1350" dirty="0"/>
+          </a:p>
+        </p:txBody>
+      </p:sp>
+      <p:sp>
+        <p:nvSpPr>
+          <p:cNvPr id="12" name="Task 3 card"/>
+          <p:cNvSpPr/>
+          <p:nvPr/>
+        </p:nvSpPr>
+        <p:spPr>
+          <a:xfrm>
+            <a:off x="548640" y="3639312"/>
+            <a:ext cx="5440680" cy="1847088"/>
+          </a:xfrm>
+          <a:prstGeom prst="rect">
+            <a:avLst/>
+          </a:prstGeom>
+          <a:solidFill>
+            <a:srgbClr val="F2F2F2"/>
+          </a:solidFill>
+          <a:ln/>
+        </p:spPr>
+      </p:sp>
+      <p:sp>
+        <p:nvSpPr>
+          <p:cNvPr id="13" name="Task 3 number"/>
+          <p:cNvSpPr/>
+          <p:nvPr/>
+        </p:nvSpPr>
+        <p:spPr>
+          <a:xfrm>
+            <a:off x="731520" y="3803904"/>
+            <a:ext cx="438912" cy="438912"/>
+          </a:xfrm>
+          <a:prstGeom prst="ellipse">
+            <a:avLst/>
+          </a:prstGeom>
+          <a:solidFill>
+            <a:srgbClr val="A00000"/>
+          </a:solidFill>
+          <a:ln/>
+        </p:spPr>
+        <p:txBody>
+          <a:bodyPr wrap="square" lIns="0" tIns="0" rIns="0" bIns="0" rtlCol="0" anchor="ctr"/>
+          <a:lstStyle/>
+          <a:p>
+            <a:pPr algn="ctr" indent="0" marL="0">
+              <a:buNone/>
+            </a:pPr>
+            <a:r>
+              <a:rPr lang="en-US" sz="1800" b="1" dirty="0">
+                <a:solidFill>
+                  <a:schemeClr val="bg1"/>
+                </a:solidFill>
+              </a:rPr>
+              <a:t>3</a:t>
+            </a:r>
+            <a:endParaRPr lang="en-US" sz="1800" dirty="0"/>
+          </a:p>
+        </p:txBody>
+      </p:sp>
+      <p:sp>
+        <p:nvSpPr>
+          <p:cNvPr id="14" name="Task 3 title"/>
+          <p:cNvSpPr txBox="1"/>
+          <p:nvPr/>
+        </p:nvSpPr>
+        <p:spPr>
+          <a:xfrm>
+            <a:off x="1298448" y="3803904"/>
+            <a:ext cx="4526280" cy="438912"/>
+          </a:xfrm>
+          <a:prstGeom prst="rect">
+            <a:avLst/>
+          </a:prstGeom>
+          <a:noFill/>
+          <a:ln/>
+        </p:spPr>
+        <p:txBody>
+          <a:bodyPr wrap="square" lIns="0" tIns="0" rIns="0" bIns="0" rtlCol="0" anchor="ctr"/>
+          <a:lstStyle/>
+          <a:p>
+            <a:pPr indent="0" marL="0">
+              <a:buNone/>
+            </a:pPr>
+            <a:r>
+              <a:rPr lang="en-US" sz="1700" b="1" dirty="0">
+                <a:solidFill>
+                  <a:schemeClr val="tx1"/>
+                </a:solidFill>
+              </a:rPr>
+              <a:t>Unified, rigorous benchmark</a:t>
+            </a:r>
+            <a:endParaRPr lang="en-US" sz="1700" dirty="0"/>
+          </a:p>
+        </p:txBody>
+      </p:sp>
+      <p:sp>
+        <p:nvSpPr>
+          <p:cNvPr id="15" name="Task 3 body"/>
+          <p:cNvSpPr txBox="1"/>
+          <p:nvPr/>
+        </p:nvSpPr>
+        <p:spPr>
+          <a:xfrm>
+            <a:off x="777240" y="4352544"/>
+            <a:ext cx="5029200" cy="1042416"/>
+          </a:xfrm>
+          <a:prstGeom prst="rect">
+            <a:avLst/>
+          </a:prstGeom>
+          <a:noFill/>
+          <a:ln/>
+        </p:spPr>
+        <p:txBody>
+          <a:bodyPr wrap="square" lIns="0" tIns="0" rIns="0" bIns="0" rtlCol="0" anchor="t"/>
+          <a:lstStyle/>
+          <a:p>
+            <a:pPr indent="0" marL="0">
+              <a:spcAft>
+                <a:spcPts val="500"/>
+              </a:spcAft>
+              <a:buNone/>
+            </a:pPr>
+            <a:r>
+              <a:rPr lang="en-US" sz="1350" b="1" dirty="0">
+                <a:solidFill>
+                  <a:srgbClr val="A00000"/>
+                </a:solidFill>
+              </a:rPr>
+              <a:t>Goal: </a:t>
+            </a:r>
+            <a:pPr indent="0" marL="0">
+              <a:spcAft>
+                <a:spcPts val="500"/>
+              </a:spcAft>
+              <a:buNone/>
+            </a:pPr>
+            <a:r>
+              <a:rPr lang="en-US" sz="1350" dirty="0">
+                <a:solidFill>
+                  <a:schemeClr val="tx1"/>
+                </a:solidFill>
+              </a:rPr>
+              <a:t>Fair comparison with state-of-the-art ERP decoders and cross-subject methods</a:t>
+            </a:r>
+            <a:endParaRPr lang="en-US" sz="1350" dirty="0"/>
+          </a:p>
+          <a:p>
+            <a:pPr indent="0" marL="0">
+              <a:spcAft>
+                <a:spcPts val="500"/>
+              </a:spcAft>
+              <a:buNone/>
+            </a:pPr>
+            <a:r>
+              <a:rPr lang="en-US" sz="1350" b="1" dirty="0">
+                <a:solidFill>
+                  <a:srgbClr val="A00000"/>
+                </a:solidFill>
+              </a:rPr>
+              <a:t>Method: </a:t>
+            </a:r>
+            <a:pPr indent="0" marL="0">
+              <a:spcAft>
+                <a:spcPts val="500"/>
+              </a:spcAft>
+              <a:buNone/>
+            </a:pPr>
+            <a:r>
+              <a:rPr lang="en-US" sz="1350" dirty="0">
+                <a:solidFill>
+                  <a:schemeClr val="tx1"/>
+                </a:solidFill>
+              </a:rPr>
+              <a:t>Identical leakage-free splits; several seeds; Wilcoxon signed-rank tests with FDR correction, effect sizes; open-source code</a:t>
+            </a:r>
+            <a:endParaRPr lang="en-US" sz="1350" dirty="0"/>
+          </a:p>
+        </p:txBody>
+      </p:sp>
+      <p:sp>
+        <p:nvSpPr>
+          <p:cNvPr id="16" name="Task 4 card"/>
+          <p:cNvSpPr/>
+          <p:nvPr/>
+        </p:nvSpPr>
+        <p:spPr>
+          <a:xfrm>
+            <a:off x="6172200" y="3639312"/>
+            <a:ext cx="5440680" cy="1847088"/>
+          </a:xfrm>
+          <a:prstGeom prst="rect">
+            <a:avLst/>
+          </a:prstGeom>
+          <a:solidFill>
+            <a:srgbClr val="F2F2F2"/>
+          </a:solidFill>
+          <a:ln/>
+        </p:spPr>
+      </p:sp>
+      <p:sp>
+        <p:nvSpPr>
+          <p:cNvPr id="17" name="Task 4 number"/>
+          <p:cNvSpPr/>
+          <p:nvPr/>
+        </p:nvSpPr>
+        <p:spPr>
+          <a:xfrm>
+            <a:off x="6355080" y="3803904"/>
+            <a:ext cx="438912" cy="438912"/>
+          </a:xfrm>
+          <a:prstGeom prst="ellipse">
+            <a:avLst/>
+          </a:prstGeom>
+          <a:solidFill>
+            <a:srgbClr val="A00000"/>
+          </a:solidFill>
+          <a:ln/>
+        </p:spPr>
+        <p:txBody>
+          <a:bodyPr wrap="square" lIns="0" tIns="0" rIns="0" bIns="0" rtlCol="0" anchor="ctr"/>
+          <a:lstStyle/>
+          <a:p>
+            <a:pPr algn="ctr" indent="0" marL="0">
+              <a:buNone/>
+            </a:pPr>
+            <a:r>
+              <a:rPr lang="en-US" sz="1800" b="1" dirty="0">
+                <a:solidFill>
+                  <a:schemeClr val="bg1"/>
+                </a:solidFill>
+              </a:rPr>
+              <a:t>4</a:t>
+            </a:r>
+            <a:endParaRPr lang="en-US" sz="1800" dirty="0"/>
+          </a:p>
+        </p:txBody>
+      </p:sp>
+      <p:sp>
+        <p:nvSpPr>
+          <p:cNvPr id="18" name="Task 4 title"/>
+          <p:cNvSpPr txBox="1"/>
+          <p:nvPr/>
+        </p:nvSpPr>
+        <p:spPr>
+          <a:xfrm>
+            <a:off x="6922008" y="3803904"/>
+            <a:ext cx="4526280" cy="438912"/>
+          </a:xfrm>
+          <a:prstGeom prst="rect">
+            <a:avLst/>
+          </a:prstGeom>
+          <a:noFill/>
+          <a:ln/>
+        </p:spPr>
+        <p:txBody>
+          <a:bodyPr wrap="square" lIns="0" tIns="0" rIns="0" bIns="0" rtlCol="0" anchor="ctr"/>
+          <a:lstStyle/>
+          <a:p>
+            <a:pPr indent="0" marL="0">
+              <a:buNone/>
+            </a:pPr>
+            <a:r>
+              <a:rPr lang="en-US" sz="1700" b="1" dirty="0">
+                <a:solidFill>
+                  <a:schemeClr val="tx1"/>
+                </a:solidFill>
+              </a:rPr>
+              <a:t>Neurophysiological interpretability</a:t>
+            </a:r>
+            <a:endParaRPr lang="en-US" sz="1700" dirty="0"/>
+          </a:p>
+        </p:txBody>
+      </p:sp>
+      <p:sp>
+        <p:nvSpPr>
+          <p:cNvPr id="19" name="Task 4 body"/>
+          <p:cNvSpPr txBox="1"/>
+          <p:nvPr/>
+        </p:nvSpPr>
+        <p:spPr>
+          <a:xfrm>
+            <a:off x="6400800" y="4352544"/>
+            <a:ext cx="5029200" cy="1042416"/>
+          </a:xfrm>
+          <a:prstGeom prst="rect">
+            <a:avLst/>
+          </a:prstGeom>
+          <a:noFill/>
+          <a:ln/>
+        </p:spPr>
+        <p:txBody>
+          <a:bodyPr wrap="square" lIns="0" tIns="0" rIns="0" bIns="0" rtlCol="0" anchor="t"/>
+          <a:lstStyle/>
+          <a:p>
+            <a:pPr indent="0" marL="0">
+              <a:spcAft>
+                <a:spcPts val="500"/>
+              </a:spcAft>
+              <a:buNone/>
+            </a:pPr>
+            <a:r>
+              <a:rPr lang="en-US" sz="1350" b="1" dirty="0">
+                <a:solidFill>
+                  <a:srgbClr val="A00000"/>
+                </a:solidFill>
+              </a:rPr>
+              <a:t>Goal: </a:t>
+            </a:r>
+            <a:pPr indent="0" marL="0">
+              <a:spcAft>
+                <a:spcPts val="500"/>
+              </a:spcAft>
+              <a:buNone/>
+            </a:pPr>
+            <a:r>
+              <a:rPr lang="en-US" sz="1350" dirty="0">
+                <a:solidFill>
+                  <a:schemeClr val="tx1"/>
+                </a:solidFill>
+              </a:rPr>
+              <a:t>Confirm that the gains come from aVEP physiology, not from artifacts</a:t>
+            </a:r>
+            <a:endParaRPr lang="en-US" sz="1350" dirty="0"/>
+          </a:p>
+          <a:p>
+            <a:pPr indent="0" marL="0">
+              <a:spcAft>
+                <a:spcPts val="500"/>
+              </a:spcAft>
+              <a:buNone/>
+            </a:pPr>
+            <a:r>
+              <a:rPr lang="en-US" sz="1350" b="1" dirty="0">
+                <a:solidFill>
+                  <a:srgbClr val="A00000"/>
+                </a:solidFill>
+              </a:rPr>
+              <a:t>Method: </a:t>
+            </a:r>
+            <a:pPr indent="0" marL="0">
+              <a:spcAft>
+                <a:spcPts val="500"/>
+              </a:spcAft>
+              <a:buNone/>
+            </a:pPr>
+            <a:r>
+              <a:rPr lang="en-US" sz="1350" dirty="0">
+                <a:solidFill>
+                  <a:schemeClr val="tx1"/>
+                </a:solidFill>
+              </a:rPr>
+              <a:t>Spatial patterns of learned filters; RED reconstructions vs. averaged ERPs; LR-MoE routing vs. each subject's mirror r and latency</a:t>
+            </a:r>
+            <a:endParaRPr lang="en-US" sz="1350" dirty="0"/>
+          </a:p>
+        </p:txBody>
+      </p:sp>
+      <p:sp>
+        <p:nvSpPr>
+          <p:cNvPr id="20" name="Outcome"/>
+          <p:cNvSpPr txBox="1"/>
+          <p:nvPr/>
+        </p:nvSpPr>
+        <p:spPr>
+          <a:xfrm>
+            <a:off x="548640" y="5577840"/>
+            <a:ext cx="11064240" cy="384048"/>
+          </a:xfrm>
+          <a:prstGeom prst="rect">
+            <a:avLst/>
+          </a:prstGeom>
+          <a:noFill/>
+          <a:ln/>
+        </p:spPr>
+        <p:txBody>
+          <a:bodyPr wrap="square" lIns="0" tIns="0" rIns="0" bIns="0" rtlCol="0" anchor="ctr"/>
+          <a:lstStyle/>
+          <a:p>
+            <a:pPr algn="ctr" indent="0" marL="0">
+              <a:buNone/>
+            </a:pPr>
+            <a:r>
+              <a:rPr lang="en-US" sz="1600" b="1" dirty="0">
+                <a:solidFill>
                   <a:schemeClr val="accent1"/>
                 </a:solidFill>
               </a:rPr>
-              <a:t>Goal: each chapter validated on 28 subjects with statistical tests, ready for one paper per chapter</a:t>
-            </a:r>
-            <a:endParaRPr lang="en-US" sz="1700" dirty="0"/>
+              <a:t>Outcome: one validated, interpretable decoder (RED + LR-MoE) for the online system of Chapter 3</a:t>
+            </a:r>
+            <a:endParaRPr lang="en-US" sz="1600" dirty="0"/>
           </a:p>
         </p:txBody>
       </p:sp>
@@ -8346,7 +8234,7 @@
         <p:spPr>
           <a:xfrm>
             <a:off x="548640" y="1938528"/>
-            <a:ext cx="11109960" cy="649224"/>
+            <a:ext cx="11109960" cy="1298448"/>
           </a:xfrm>
           <a:prstGeom prst="rect">
             <a:avLst/>
@@ -8366,7 +8254,7 @@
         <p:spPr>
           <a:xfrm>
             <a:off x="594360" y="1938528"/>
-            <a:ext cx="1188720" cy="649224"/>
+            <a:ext cx="1188720" cy="1298448"/>
           </a:xfrm>
           <a:prstGeom prst="rect">
             <a:avLst/>
@@ -8387,7 +8275,7 @@
                   <a:schemeClr val="accent1"/>
                 </a:solidFill>
               </a:rPr>
-              <a:t>Chapter 1</a:t>
+              <a:t>Chapters 1–2</a:t>
             </a:r>
             <a:endParaRPr lang="en-US" sz="1250" dirty="0"/>
           </a:p>
@@ -8401,7 +8289,7 @@
                   <a:schemeClr val="accent1"/>
                 </a:solidFill>
               </a:rPr>
-              <a:t>RED</a:t>
+              <a:t>Algorithms</a:t>
             </a:r>
             <a:endParaRPr lang="en-US" sz="1250" dirty="0"/>
           </a:p>
@@ -8437,7 +8325,7 @@
                   <a:schemeClr val="tx1"/>
                 </a:solidFill>
               </a:rPr>
-              <a:t>Full comparisons on all protocols</a:t>
+              <a:t>LR-MoE implementation, benchmark</a:t>
             </a:r>
             <a:endParaRPr lang="en-US" sz="1200" dirty="0"/>
           </a:p>
@@ -8452,7 +8340,7 @@
         <p:spPr>
           <a:xfrm>
             <a:off x="4343400" y="2002536"/>
-            <a:ext cx="1567543" cy="196596"/>
+            <a:ext cx="2090057" cy="196596"/>
           </a:xfrm>
           <a:prstGeom prst="rect">
             <a:avLst/>
@@ -8493,7 +8381,7 @@
                   <a:schemeClr val="tx1"/>
                 </a:solidFill>
               </a:rPr>
-              <a:t>Ablation, robustness, statistics</a:t>
+              <a:t>Joint ablation (RED × LR-MoE)</a:t>
             </a:r>
             <a:endParaRPr lang="en-US" sz="1200" dirty="0"/>
           </a:p>
@@ -8507,8 +8395,8 @@
         </p:nvSpPr>
         <p:spPr>
           <a:xfrm>
-            <a:off x="5388429" y="2327148"/>
-            <a:ext cx="1567543" cy="196596"/>
+            <a:off x="5876109" y="2327148"/>
+            <a:ext cx="1602377" cy="196596"/>
           </a:xfrm>
           <a:prstGeom prst="rect">
             <a:avLst/>
@@ -8521,57 +8409,7 @@
       </p:sp>
       <p:sp>
         <p:nvSpPr>
-          <p:cNvPr id="19" name="Group 2 name"/>
-          <p:cNvSpPr txBox="1"/>
-          <p:nvPr/>
-        </p:nvSpPr>
-        <p:spPr>
-          <a:xfrm>
-            <a:off x="594360" y="2587752"/>
-            <a:ext cx="1188720" cy="649224"/>
-          </a:xfrm>
-          <a:prstGeom prst="rect">
-            <a:avLst/>
-          </a:prstGeom>
-          <a:noFill/>
-          <a:ln/>
-        </p:spPr>
-        <p:txBody>
-          <a:bodyPr wrap="square" lIns="0" tIns="0" rIns="0" bIns="0" rtlCol="0" anchor="ctr"/>
-          <a:lstStyle/>
-          <a:p>
-            <a:pPr indent="0" marL="0">
-              <a:buNone/>
-            </a:pPr>
-            <a:r>
-              <a:rPr lang="en-US" sz="1250" b="1" dirty="0">
-                <a:solidFill>
-                  <a:schemeClr val="tx1"/>
-                </a:solidFill>
-              </a:rPr>
-              <a:t>Chapter 2</a:t>
-            </a:r>
-            <a:endParaRPr lang="en-US" sz="1250" dirty="0"/>
-          </a:p>
-          <a:p>
-            <a:pPr indent="0" marL="0">
-              <a:buNone/>
-            </a:pPr>
-            <a:r>
-              <a:rPr lang="en-US" sz="1250" b="1" dirty="0">
-                <a:solidFill>
-                  <a:schemeClr val="tx1"/>
-                </a:solidFill>
-              </a:rPr>
-              <a:t>LR-MoE</a:t>
-            </a:r>
-            <a:endParaRPr lang="en-US" sz="1250" dirty="0"/>
-          </a:p>
-        </p:txBody>
-      </p:sp>
-      <p:sp>
-        <p:nvSpPr>
-          <p:cNvPr id="20" name="Task 3 name"/>
+          <p:cNvPr id="19" name="Task 3 name"/>
           <p:cNvSpPr txBox="1"/>
           <p:nvPr/>
         </p:nvSpPr>
@@ -8599,7 +8437,7 @@
                   <a:schemeClr val="tx1"/>
                 </a:solidFill>
               </a:rPr>
-              <a:t>Implementation and LOSO experiments</a:t>
+              <a:t>Public ERP dataset validation</a:t>
             </a:r>
             <a:endParaRPr lang="en-US" sz="1200" dirty="0"/>
           </a:p>
@@ -8607,27 +8445,27 @@
       </p:sp>
       <p:sp>
         <p:nvSpPr>
-          <p:cNvPr id="21" name="Task 3 bar"/>
+          <p:cNvPr id="20" name="Task 3 bar"/>
           <p:cNvSpPr/>
           <p:nvPr/>
         </p:nvSpPr>
         <p:spPr>
           <a:xfrm>
-            <a:off x="4831080" y="2651760"/>
-            <a:ext cx="2647406" cy="196596"/>
+            <a:off x="6433457" y="2651760"/>
+            <a:ext cx="2020389" cy="196596"/>
           </a:xfrm>
           <a:prstGeom prst="rect">
             <a:avLst/>
           </a:prstGeom>
           <a:solidFill>
-            <a:srgbClr val="C55A5A"/>
+            <a:srgbClr val="A00000"/>
           </a:solidFill>
           <a:ln/>
         </p:spPr>
       </p:sp>
       <p:sp>
         <p:nvSpPr>
-          <p:cNvPr id="22" name="Task 4 name"/>
+          <p:cNvPr id="21" name="Task 4 name"/>
           <p:cNvSpPr txBox="1"/>
           <p:nvPr/>
         </p:nvSpPr>
@@ -8655,7 +8493,7 @@
                   <a:schemeClr val="tx1"/>
                 </a:solidFill>
               </a:rPr>
-              <a:t>Ablation, few-shot, routing analysis</a:t>
+              <a:t>Interpretability analysis</a:t>
             </a:r>
             <a:endParaRPr lang="en-US" sz="1200" dirty="0"/>
           </a:p>
@@ -8663,34 +8501,308 @@
       </p:sp>
       <p:sp>
         <p:nvSpPr>
-          <p:cNvPr id="23" name="Task 4 bar"/>
+          <p:cNvPr id="22" name="Task 4 bar"/>
           <p:cNvSpPr/>
           <p:nvPr/>
         </p:nvSpPr>
         <p:spPr>
           <a:xfrm>
-            <a:off x="6433457" y="2976372"/>
-            <a:ext cx="2020389" cy="196596"/>
+            <a:off x="7478486" y="2976372"/>
+            <a:ext cx="975360" cy="196596"/>
           </a:xfrm>
           <a:prstGeom prst="rect">
             <a:avLst/>
           </a:prstGeom>
           <a:solidFill>
-            <a:srgbClr val="C55A5A"/>
+            <a:srgbClr val="A00000"/>
           </a:solidFill>
           <a:ln/>
         </p:spPr>
       </p:sp>
       <p:sp>
         <p:nvSpPr>
-          <p:cNvPr id="24" name="Group 3 band"/>
+          <p:cNvPr id="23" name="Group 2 name"/>
+          <p:cNvSpPr txBox="1"/>
+          <p:nvPr/>
+        </p:nvSpPr>
+        <p:spPr>
+          <a:xfrm>
+            <a:off x="594360" y="3236976"/>
+            <a:ext cx="1188720" cy="1298448"/>
+          </a:xfrm>
+          <a:prstGeom prst="rect">
+            <a:avLst/>
+          </a:prstGeom>
+          <a:noFill/>
+          <a:ln/>
+        </p:spPr>
+        <p:txBody>
+          <a:bodyPr wrap="square" lIns="0" tIns="0" rIns="0" bIns="0" rtlCol="0" anchor="ctr"/>
+          <a:lstStyle/>
+          <a:p>
+            <a:pPr indent="0" marL="0">
+              <a:buNone/>
+            </a:pPr>
+            <a:r>
+              <a:rPr lang="en-US" sz="1250" b="1" dirty="0">
+                <a:solidFill>
+                  <a:schemeClr val="tx1"/>
+                </a:solidFill>
+              </a:rPr>
+              <a:t>Chapter 3</a:t>
+            </a:r>
+            <a:endParaRPr lang="en-US" sz="1250" dirty="0"/>
+          </a:p>
+          <a:p>
+            <a:pPr indent="0" marL="0">
+              <a:buNone/>
+            </a:pPr>
+            <a:r>
+              <a:rPr lang="en-US" sz="1250" b="1" dirty="0">
+                <a:solidFill>
+                  <a:schemeClr val="tx1"/>
+                </a:solidFill>
+              </a:rPr>
+              <a:t>Online system</a:t>
+            </a:r>
+            <a:endParaRPr lang="en-US" sz="1250" dirty="0"/>
+          </a:p>
+        </p:txBody>
+      </p:sp>
+      <p:sp>
+        <p:nvSpPr>
+          <p:cNvPr id="24" name="Task 5 name"/>
+          <p:cNvSpPr txBox="1"/>
+          <p:nvPr/>
+        </p:nvSpPr>
+        <p:spPr>
+          <a:xfrm>
+            <a:off x="1783080" y="3236976"/>
+            <a:ext cx="2514600" cy="324612"/>
+          </a:xfrm>
+          <a:prstGeom prst="rect">
+            <a:avLst/>
+          </a:prstGeom>
+          <a:noFill/>
+          <a:ln/>
+        </p:spPr>
+        <p:txBody>
+          <a:bodyPr wrap="square" lIns="0" tIns="0" rIns="0" bIns="0" rtlCol="0" anchor="ctr"/>
+          <a:lstStyle/>
+          <a:p>
+            <a:pPr indent="0" marL="0">
+              <a:buNone/>
+            </a:pPr>
+            <a:r>
+              <a:rPr lang="en-US" sz="1200" dirty="0">
+                <a:solidFill>
+                  <a:schemeClr val="tx1"/>
+                </a:solidFill>
+              </a:rPr>
+              <a:t>Ethics approval, subject recruitment</a:t>
+            </a:r>
+            <a:endParaRPr lang="en-US" sz="1200" dirty="0"/>
+          </a:p>
+        </p:txBody>
+      </p:sp>
+      <p:sp>
+        <p:nvSpPr>
+          <p:cNvPr id="25" name="Task 5 bar"/>
           <p:cNvSpPr/>
           <p:nvPr/>
         </p:nvSpPr>
         <p:spPr>
           <a:xfrm>
-            <a:off x="548640" y="3236976"/>
-            <a:ext cx="11109960" cy="1298448"/>
+            <a:off x="5388429" y="3300984"/>
+            <a:ext cx="2090057" cy="196596"/>
+          </a:xfrm>
+          <a:prstGeom prst="rect">
+            <a:avLst/>
+          </a:prstGeom>
+          <a:solidFill>
+            <a:srgbClr val="404040"/>
+          </a:solidFill>
+          <a:ln/>
+        </p:spPr>
+      </p:sp>
+      <p:sp>
+        <p:nvSpPr>
+          <p:cNvPr id="26" name="Task 6 name"/>
+          <p:cNvSpPr txBox="1"/>
+          <p:nvPr/>
+        </p:nvSpPr>
+        <p:spPr>
+          <a:xfrm>
+            <a:off x="1783080" y="3561588"/>
+            <a:ext cx="2514600" cy="324612"/>
+          </a:xfrm>
+          <a:prstGeom prst="rect">
+            <a:avLst/>
+          </a:prstGeom>
+          <a:noFill/>
+          <a:ln/>
+        </p:spPr>
+        <p:txBody>
+          <a:bodyPr wrap="square" lIns="0" tIns="0" rIns="0" bIns="0" rtlCol="0" anchor="ctr"/>
+          <a:lstStyle/>
+          <a:p>
+            <a:pPr indent="0" marL="0">
+              <a:buNone/>
+            </a:pPr>
+            <a:r>
+              <a:rPr lang="en-US" sz="1200" dirty="0">
+                <a:solidFill>
+                  <a:schemeClr val="tx1"/>
+                </a:solidFill>
+              </a:rPr>
+              <a:t>Real-time system integration</a:t>
+            </a:r>
+            <a:endParaRPr lang="en-US" sz="1200" dirty="0"/>
+          </a:p>
+        </p:txBody>
+      </p:sp>
+      <p:sp>
+        <p:nvSpPr>
+          <p:cNvPr id="27" name="Task 6 bar"/>
+          <p:cNvSpPr/>
+          <p:nvPr/>
+        </p:nvSpPr>
+        <p:spPr>
+          <a:xfrm>
+            <a:off x="5388429" y="3625596"/>
+            <a:ext cx="2612571" cy="196596"/>
+          </a:xfrm>
+          <a:prstGeom prst="rect">
+            <a:avLst/>
+          </a:prstGeom>
+          <a:solidFill>
+            <a:srgbClr val="404040"/>
+          </a:solidFill>
+          <a:ln/>
+        </p:spPr>
+      </p:sp>
+      <p:sp>
+        <p:nvSpPr>
+          <p:cNvPr id="28" name="Task 7 name"/>
+          <p:cNvSpPr txBox="1"/>
+          <p:nvPr/>
+        </p:nvSpPr>
+        <p:spPr>
+          <a:xfrm>
+            <a:off x="1783080" y="3886200"/>
+            <a:ext cx="2514600" cy="324612"/>
+          </a:xfrm>
+          <a:prstGeom prst="rect">
+            <a:avLst/>
+          </a:prstGeom>
+          <a:noFill/>
+          <a:ln/>
+        </p:spPr>
+        <p:txBody>
+          <a:bodyPr wrap="square" lIns="0" tIns="0" rIns="0" bIns="0" rtlCol="0" anchor="ctr"/>
+          <a:lstStyle/>
+          <a:p>
+            <a:pPr indent="0" marL="0">
+              <a:buNone/>
+            </a:pPr>
+            <a:r>
+              <a:rPr lang="en-US" sz="1200" dirty="0">
+                <a:solidFill>
+                  <a:schemeClr val="tx1"/>
+                </a:solidFill>
+              </a:rPr>
+              <a:t>Continuous control, pilot tests</a:t>
+            </a:r>
+            <a:endParaRPr lang="en-US" sz="1200" dirty="0"/>
+          </a:p>
+        </p:txBody>
+      </p:sp>
+      <p:sp>
+        <p:nvSpPr>
+          <p:cNvPr id="29" name="Task 7 bar"/>
+          <p:cNvSpPr/>
+          <p:nvPr/>
+        </p:nvSpPr>
+        <p:spPr>
+          <a:xfrm>
+            <a:off x="7478486" y="3950208"/>
+            <a:ext cx="1567543" cy="196596"/>
+          </a:xfrm>
+          <a:prstGeom prst="rect">
+            <a:avLst/>
+          </a:prstGeom>
+          <a:solidFill>
+            <a:srgbClr val="404040"/>
+          </a:solidFill>
+          <a:ln/>
+        </p:spPr>
+      </p:sp>
+      <p:sp>
+        <p:nvSpPr>
+          <p:cNvPr id="30" name="Task 8 name"/>
+          <p:cNvSpPr txBox="1"/>
+          <p:nvPr/>
+        </p:nvSpPr>
+        <p:spPr>
+          <a:xfrm>
+            <a:off x="1783080" y="4210812"/>
+            <a:ext cx="2514600" cy="324612"/>
+          </a:xfrm>
+          <a:prstGeom prst="rect">
+            <a:avLst/>
+          </a:prstGeom>
+          <a:noFill/>
+          <a:ln/>
+        </p:spPr>
+        <p:txBody>
+          <a:bodyPr wrap="square" lIns="0" tIns="0" rIns="0" bIns="0" rtlCol="0" anchor="ctr"/>
+          <a:lstStyle/>
+          <a:p>
+            <a:pPr indent="0" marL="0">
+              <a:buNone/>
+            </a:pPr>
+            <a:r>
+              <a:rPr lang="en-US" sz="1200" dirty="0">
+                <a:solidFill>
+                  <a:schemeClr val="tx1"/>
+                </a:solidFill>
+              </a:rPr>
+              <a:t>Online experiments and evaluation</a:t>
+            </a:r>
+            <a:endParaRPr lang="en-US" sz="1200" dirty="0"/>
+          </a:p>
+        </p:txBody>
+      </p:sp>
+      <p:sp>
+        <p:nvSpPr>
+          <p:cNvPr id="31" name="Task 8 bar"/>
+          <p:cNvSpPr/>
+          <p:nvPr/>
+        </p:nvSpPr>
+        <p:spPr>
+          <a:xfrm>
+            <a:off x="8523514" y="4274820"/>
+            <a:ext cx="1567543" cy="196596"/>
+          </a:xfrm>
+          <a:prstGeom prst="rect">
+            <a:avLst/>
+          </a:prstGeom>
+          <a:solidFill>
+            <a:srgbClr val="404040"/>
+          </a:solidFill>
+          <a:ln/>
+        </p:spPr>
+      </p:sp>
+      <p:sp>
+        <p:nvSpPr>
+          <p:cNvPr id="32" name="Group 3 band"/>
+          <p:cNvSpPr/>
+          <p:nvPr/>
+        </p:nvSpPr>
+        <p:spPr>
+          <a:xfrm>
+            <a:off x="548640" y="4535424"/>
+            <a:ext cx="11109960" cy="973836"/>
           </a:xfrm>
           <a:prstGeom prst="rect">
             <a:avLst/>
@@ -8703,281 +8815,7 @@
       </p:sp>
       <p:sp>
         <p:nvSpPr>
-          <p:cNvPr id="25" name="Group 3 name"/>
-          <p:cNvSpPr txBox="1"/>
-          <p:nvPr/>
-        </p:nvSpPr>
-        <p:spPr>
-          <a:xfrm>
-            <a:off x="594360" y="3236976"/>
-            <a:ext cx="1188720" cy="1298448"/>
-          </a:xfrm>
-          <a:prstGeom prst="rect">
-            <a:avLst/>
-          </a:prstGeom>
-          <a:noFill/>
-          <a:ln/>
-        </p:spPr>
-        <p:txBody>
-          <a:bodyPr wrap="square" lIns="0" tIns="0" rIns="0" bIns="0" rtlCol="0" anchor="ctr"/>
-          <a:lstStyle/>
-          <a:p>
-            <a:pPr indent="0" marL="0">
-              <a:buNone/>
-            </a:pPr>
-            <a:r>
-              <a:rPr lang="en-US" sz="1250" b="1" dirty="0">
-                <a:solidFill>
-                  <a:schemeClr val="tx1"/>
-                </a:solidFill>
-              </a:rPr>
-              <a:t>Chapter 3</a:t>
-            </a:r>
-            <a:endParaRPr lang="en-US" sz="1250" dirty="0"/>
-          </a:p>
-          <a:p>
-            <a:pPr indent="0" marL="0">
-              <a:buNone/>
-            </a:pPr>
-            <a:r>
-              <a:rPr lang="en-US" sz="1250" b="1" dirty="0">
-                <a:solidFill>
-                  <a:schemeClr val="tx1"/>
-                </a:solidFill>
-              </a:rPr>
-              <a:t>Online system</a:t>
-            </a:r>
-            <a:endParaRPr lang="en-US" sz="1250" dirty="0"/>
-          </a:p>
-        </p:txBody>
-      </p:sp>
-      <p:sp>
-        <p:nvSpPr>
-          <p:cNvPr id="26" name="Task 5 name"/>
-          <p:cNvSpPr txBox="1"/>
-          <p:nvPr/>
-        </p:nvSpPr>
-        <p:spPr>
-          <a:xfrm>
-            <a:off x="1783080" y="3236976"/>
-            <a:ext cx="2514600" cy="324612"/>
-          </a:xfrm>
-          <a:prstGeom prst="rect">
-            <a:avLst/>
-          </a:prstGeom>
-          <a:noFill/>
-          <a:ln/>
-        </p:spPr>
-        <p:txBody>
-          <a:bodyPr wrap="square" lIns="0" tIns="0" rIns="0" bIns="0" rtlCol="0" anchor="ctr"/>
-          <a:lstStyle/>
-          <a:p>
-            <a:pPr indent="0" marL="0">
-              <a:buNone/>
-            </a:pPr>
-            <a:r>
-              <a:rPr lang="en-US" sz="1200" dirty="0">
-                <a:solidFill>
-                  <a:schemeClr val="tx1"/>
-                </a:solidFill>
-              </a:rPr>
-              <a:t>Ethics approval, subject recruitment</a:t>
-            </a:r>
-            <a:endParaRPr lang="en-US" sz="1200" dirty="0"/>
-          </a:p>
-        </p:txBody>
-      </p:sp>
-      <p:sp>
-        <p:nvSpPr>
-          <p:cNvPr id="27" name="Task 5 bar"/>
-          <p:cNvSpPr/>
-          <p:nvPr/>
-        </p:nvSpPr>
-        <p:spPr>
-          <a:xfrm>
-            <a:off x="5388429" y="3300984"/>
-            <a:ext cx="2090057" cy="196596"/>
-          </a:xfrm>
-          <a:prstGeom prst="rect">
-            <a:avLst/>
-          </a:prstGeom>
-          <a:solidFill>
-            <a:srgbClr val="404040"/>
-          </a:solidFill>
-          <a:ln/>
-        </p:spPr>
-      </p:sp>
-      <p:sp>
-        <p:nvSpPr>
-          <p:cNvPr id="28" name="Task 6 name"/>
-          <p:cNvSpPr txBox="1"/>
-          <p:nvPr/>
-        </p:nvSpPr>
-        <p:spPr>
-          <a:xfrm>
-            <a:off x="1783080" y="3561588"/>
-            <a:ext cx="2514600" cy="324612"/>
-          </a:xfrm>
-          <a:prstGeom prst="rect">
-            <a:avLst/>
-          </a:prstGeom>
-          <a:noFill/>
-          <a:ln/>
-        </p:spPr>
-        <p:txBody>
-          <a:bodyPr wrap="square" lIns="0" tIns="0" rIns="0" bIns="0" rtlCol="0" anchor="ctr"/>
-          <a:lstStyle/>
-          <a:p>
-            <a:pPr indent="0" marL="0">
-              <a:buNone/>
-            </a:pPr>
-            <a:r>
-              <a:rPr lang="en-US" sz="1200" dirty="0">
-                <a:solidFill>
-                  <a:schemeClr val="tx1"/>
-                </a:solidFill>
-              </a:rPr>
-              <a:t>Real-time system integration</a:t>
-            </a:r>
-            <a:endParaRPr lang="en-US" sz="1200" dirty="0"/>
-          </a:p>
-        </p:txBody>
-      </p:sp>
-      <p:sp>
-        <p:nvSpPr>
-          <p:cNvPr id="29" name="Task 6 bar"/>
-          <p:cNvSpPr/>
-          <p:nvPr/>
-        </p:nvSpPr>
-        <p:spPr>
-          <a:xfrm>
-            <a:off x="5388429" y="3625596"/>
-            <a:ext cx="2612571" cy="196596"/>
-          </a:xfrm>
-          <a:prstGeom prst="rect">
-            <a:avLst/>
-          </a:prstGeom>
-          <a:solidFill>
-            <a:srgbClr val="404040"/>
-          </a:solidFill>
-          <a:ln/>
-        </p:spPr>
-      </p:sp>
-      <p:sp>
-        <p:nvSpPr>
-          <p:cNvPr id="30" name="Task 7 name"/>
-          <p:cNvSpPr txBox="1"/>
-          <p:nvPr/>
-        </p:nvSpPr>
-        <p:spPr>
-          <a:xfrm>
-            <a:off x="1783080" y="3886200"/>
-            <a:ext cx="2514600" cy="324612"/>
-          </a:xfrm>
-          <a:prstGeom prst="rect">
-            <a:avLst/>
-          </a:prstGeom>
-          <a:noFill/>
-          <a:ln/>
-        </p:spPr>
-        <p:txBody>
-          <a:bodyPr wrap="square" lIns="0" tIns="0" rIns="0" bIns="0" rtlCol="0" anchor="ctr"/>
-          <a:lstStyle/>
-          <a:p>
-            <a:pPr indent="0" marL="0">
-              <a:buNone/>
-            </a:pPr>
-            <a:r>
-              <a:rPr lang="en-US" sz="1200" dirty="0">
-                <a:solidFill>
-                  <a:schemeClr val="tx1"/>
-                </a:solidFill>
-              </a:rPr>
-              <a:t>Continuous control, pilot tests</a:t>
-            </a:r>
-            <a:endParaRPr lang="en-US" sz="1200" dirty="0"/>
-          </a:p>
-        </p:txBody>
-      </p:sp>
-      <p:sp>
-        <p:nvSpPr>
-          <p:cNvPr id="31" name="Task 7 bar"/>
-          <p:cNvSpPr/>
-          <p:nvPr/>
-        </p:nvSpPr>
-        <p:spPr>
-          <a:xfrm>
-            <a:off x="7478486" y="3950208"/>
-            <a:ext cx="1567543" cy="196596"/>
-          </a:xfrm>
-          <a:prstGeom prst="rect">
-            <a:avLst/>
-          </a:prstGeom>
-          <a:solidFill>
-            <a:srgbClr val="404040"/>
-          </a:solidFill>
-          <a:ln/>
-        </p:spPr>
-      </p:sp>
-      <p:sp>
-        <p:nvSpPr>
-          <p:cNvPr id="32" name="Task 8 name"/>
-          <p:cNvSpPr txBox="1"/>
-          <p:nvPr/>
-        </p:nvSpPr>
-        <p:spPr>
-          <a:xfrm>
-            <a:off x="1783080" y="4210812"/>
-            <a:ext cx="2514600" cy="324612"/>
-          </a:xfrm>
-          <a:prstGeom prst="rect">
-            <a:avLst/>
-          </a:prstGeom>
-          <a:noFill/>
-          <a:ln/>
-        </p:spPr>
-        <p:txBody>
-          <a:bodyPr wrap="square" lIns="0" tIns="0" rIns="0" bIns="0" rtlCol="0" anchor="ctr"/>
-          <a:lstStyle/>
-          <a:p>
-            <a:pPr indent="0" marL="0">
-              <a:buNone/>
-            </a:pPr>
-            <a:r>
-              <a:rPr lang="en-US" sz="1200" dirty="0">
-                <a:solidFill>
-                  <a:schemeClr val="tx1"/>
-                </a:solidFill>
-              </a:rPr>
-              <a:t>Online experiments and evaluation</a:t>
-            </a:r>
-            <a:endParaRPr lang="en-US" sz="1200" dirty="0"/>
-          </a:p>
-        </p:txBody>
-      </p:sp>
-      <p:sp>
-        <p:nvSpPr>
-          <p:cNvPr id="33" name="Task 8 bar"/>
-          <p:cNvSpPr/>
-          <p:nvPr/>
-        </p:nvSpPr>
-        <p:spPr>
-          <a:xfrm>
-            <a:off x="8523514" y="4274820"/>
-            <a:ext cx="1567543" cy="196596"/>
-          </a:xfrm>
-          <a:prstGeom prst="rect">
-            <a:avLst/>
-          </a:prstGeom>
-          <a:solidFill>
-            <a:srgbClr val="404040"/>
-          </a:solidFill>
-          <a:ln/>
-        </p:spPr>
-      </p:sp>
-      <p:sp>
-        <p:nvSpPr>
-          <p:cNvPr id="34" name="Group 4 name"/>
+          <p:cNvPr id="33" name="Group 3 name"/>
           <p:cNvSpPr txBox="1"/>
           <p:nvPr/>
         </p:nvSpPr>
@@ -9013,7 +8851,7 @@
       </p:sp>
       <p:sp>
         <p:nvSpPr>
-          <p:cNvPr id="35" name="Task 9 name"/>
+          <p:cNvPr id="34" name="Task 9 name"/>
           <p:cNvSpPr txBox="1"/>
           <p:nvPr/>
         </p:nvSpPr>
@@ -9049,7 +8887,7 @@
       </p:sp>
       <p:sp>
         <p:nvSpPr>
-          <p:cNvPr id="36" name="Task 9 bar"/>
+          <p:cNvPr id="35" name="Task 9 bar"/>
           <p:cNvSpPr/>
           <p:nvPr/>
         </p:nvSpPr>
@@ -9069,7 +8907,7 @@
       </p:sp>
       <p:sp>
         <p:nvSpPr>
-          <p:cNvPr id="37" name="Task 10 name"/>
+          <p:cNvPr id="36" name="Task 10 name"/>
           <p:cNvSpPr txBox="1"/>
           <p:nvPr/>
         </p:nvSpPr>
@@ -9105,7 +8943,7 @@
       </p:sp>
       <p:sp>
         <p:nvSpPr>
-          <p:cNvPr id="38" name="Task 10 bar"/>
+          <p:cNvPr id="37" name="Task 10 bar"/>
           <p:cNvSpPr/>
           <p:nvPr/>
         </p:nvSpPr>
@@ -9125,7 +8963,7 @@
       </p:sp>
       <p:sp>
         <p:nvSpPr>
-          <p:cNvPr id="39" name="Task 11 name"/>
+          <p:cNvPr id="38" name="Task 11 name"/>
           <p:cNvSpPr txBox="1"/>
           <p:nvPr/>
         </p:nvSpPr>
@@ -9161,7 +8999,7 @@
       </p:sp>
       <p:sp>
         <p:nvSpPr>
-          <p:cNvPr id="40" name="Task 11 bar"/>
+          <p:cNvPr id="39" name="Task 11 bar"/>
           <p:cNvSpPr/>
           <p:nvPr/>
         </p:nvSpPr>
@@ -9181,7 +9019,7 @@
       </p:sp>
       <p:sp>
         <p:nvSpPr>
-          <p:cNvPr id="41" name="Month line 1"/>
+          <p:cNvPr id="40" name="Month line 1"/>
           <p:cNvSpPr/>
           <p:nvPr/>
         </p:nvSpPr>
@@ -9204,7 +9042,7 @@
       </p:sp>
       <p:sp>
         <p:nvSpPr>
-          <p:cNvPr id="42" name="Month line 2"/>
+          <p:cNvPr id="41" name="Month line 2"/>
           <p:cNvSpPr/>
           <p:nvPr/>
         </p:nvSpPr>
@@ -9227,7 +9065,7 @@
       </p:sp>
       <p:sp>
         <p:nvSpPr>
-          <p:cNvPr id="43" name="Month line 3"/>
+          <p:cNvPr id="42" name="Month line 3"/>
           <p:cNvSpPr/>
           <p:nvPr/>
         </p:nvSpPr>
@@ -9250,7 +9088,7 @@
       </p:sp>
       <p:sp>
         <p:nvSpPr>
-          <p:cNvPr id="44" name="Month line 4"/>
+          <p:cNvPr id="43" name="Month line 4"/>
           <p:cNvSpPr/>
           <p:nvPr/>
         </p:nvSpPr>
@@ -9273,7 +9111,7 @@
       </p:sp>
       <p:sp>
         <p:nvSpPr>
-          <p:cNvPr id="45" name="Month line 5"/>
+          <p:cNvPr id="44" name="Month line 5"/>
           <p:cNvSpPr/>
           <p:nvPr/>
         </p:nvSpPr>
@@ -9296,7 +9134,7 @@
       </p:sp>
       <p:sp>
         <p:nvSpPr>
-          <p:cNvPr id="46" name="Month line 6"/>
+          <p:cNvPr id="45" name="Month line 6"/>
           <p:cNvSpPr/>
           <p:nvPr/>
         </p:nvSpPr>
@@ -9319,7 +9157,7 @@
       </p:sp>
       <p:sp>
         <p:nvSpPr>
-          <p:cNvPr id="47" name="Bottom rule"/>
+          <p:cNvPr id="46" name="Bottom rule"/>
           <p:cNvSpPr/>
           <p:nvPr/>
         </p:nvSpPr>
@@ -9342,13 +9180,13 @@
       </p:sp>
       <p:sp>
         <p:nvSpPr>
-          <p:cNvPr id="48" name="M1 diamond"/>
+          <p:cNvPr id="47" name="M1 diamond"/>
           <p:cNvSpPr/>
           <p:nvPr/>
         </p:nvSpPr>
         <p:spPr>
           <a:xfrm>
-            <a:off x="6846243" y="2315718"/>
+            <a:off x="7368758" y="2315718"/>
             <a:ext cx="219456" cy="219456"/>
           </a:xfrm>
           <a:prstGeom prst="diamond">
@@ -9367,13 +9205,13 @@
       </p:sp>
       <p:sp>
         <p:nvSpPr>
-          <p:cNvPr id="49" name="M1 label"/>
+          <p:cNvPr id="48" name="M1 label"/>
           <p:cNvSpPr txBox="1"/>
           <p:nvPr/>
         </p:nvSpPr>
         <p:spPr>
           <a:xfrm>
-            <a:off x="7074843" y="2279142"/>
+            <a:off x="7597358" y="2279142"/>
             <a:ext cx="365760" cy="292608"/>
           </a:xfrm>
           <a:prstGeom prst="rect">
@@ -9403,7 +9241,7 @@
       </p:sp>
       <p:sp>
         <p:nvSpPr>
-          <p:cNvPr id="50" name="M2 diamond"/>
+          <p:cNvPr id="49" name="M2 diamond"/>
           <p:cNvSpPr/>
           <p:nvPr/>
         </p:nvSpPr>
@@ -9428,7 +9266,7 @@
       </p:sp>
       <p:sp>
         <p:nvSpPr>
-          <p:cNvPr id="51" name="M2 label"/>
+          <p:cNvPr id="50" name="M2 label"/>
           <p:cNvSpPr txBox="1"/>
           <p:nvPr/>
         </p:nvSpPr>
@@ -9464,7 +9302,7 @@
       </p:sp>
       <p:sp>
         <p:nvSpPr>
-          <p:cNvPr id="52" name="M3 diamond"/>
+          <p:cNvPr id="51" name="M3 diamond"/>
           <p:cNvSpPr/>
           <p:nvPr/>
         </p:nvSpPr>
@@ -9489,7 +9327,7 @@
       </p:sp>
       <p:sp>
         <p:nvSpPr>
-          <p:cNvPr id="53" name="M3 label"/>
+          <p:cNvPr id="52" name="M3 label"/>
           <p:cNvSpPr txBox="1"/>
           <p:nvPr/>
         </p:nvSpPr>
@@ -9525,7 +9363,7 @@
       </p:sp>
       <p:sp>
         <p:nvSpPr>
-          <p:cNvPr id="54" name="M4 diamond"/>
+          <p:cNvPr id="53" name="M4 diamond"/>
           <p:cNvSpPr/>
           <p:nvPr/>
         </p:nvSpPr>
@@ -9550,7 +9388,7 @@
       </p:sp>
       <p:sp>
         <p:nvSpPr>
-          <p:cNvPr id="55" name="M4 label"/>
+          <p:cNvPr id="54" name="M4 label"/>
           <p:cNvSpPr txBox="1"/>
           <p:nvPr/>
         </p:nvSpPr>
@@ -9586,7 +9424,7 @@
       </p:sp>
       <p:sp>
         <p:nvSpPr>
-          <p:cNvPr id="56" name="M5 diamond"/>
+          <p:cNvPr id="55" name="M5 diamond"/>
           <p:cNvSpPr/>
           <p:nvPr/>
         </p:nvSpPr>
@@ -9611,7 +9449,7 @@
       </p:sp>
       <p:sp>
         <p:nvSpPr>
-          <p:cNvPr id="57" name="M5 label"/>
+          <p:cNvPr id="56" name="M5 label"/>
           <p:cNvSpPr txBox="1"/>
           <p:nvPr/>
         </p:nvSpPr>
@@ -9647,7 +9485,7 @@
       </p:sp>
       <p:sp>
         <p:nvSpPr>
-          <p:cNvPr id="58" name="M6 diamond"/>
+          <p:cNvPr id="57" name="M6 diamond"/>
           <p:cNvSpPr/>
           <p:nvPr/>
         </p:nvSpPr>
@@ -9672,7 +9510,7 @@
       </p:sp>
       <p:sp>
         <p:nvSpPr>
-          <p:cNvPr id="59" name="M6 label"/>
+          <p:cNvPr id="58" name="M6 label"/>
           <p:cNvSpPr txBox="1"/>
           <p:nvPr/>
         </p:nvSpPr>
@@ -9708,7 +9546,7 @@
       </p:sp>
       <p:sp>
         <p:nvSpPr>
-          <p:cNvPr id="60" name="Milestone legend"/>
+          <p:cNvPr id="59" name="Milestone legend"/>
           <p:cNvSpPr txBox="1"/>
           <p:nvPr/>
         </p:nvSpPr>
@@ -9758,7 +9596,7 @@
                   <a:schemeClr val="tx1"/>
                 </a:solidFill>
               </a:rPr>
-              <a:t>Chapter 1 results complete (Jan 15)   </a:t>
+              <a:t>joint ablation complete (Jan 31)   </a:t>
             </a:r>
             <a:pPr indent="0" marL="0">
               <a:buNone/>
@@ -9780,7 +9618,7 @@
                   <a:schemeClr val="tx1"/>
                 </a:solidFill>
               </a:rPr>
-              <a:t>Chapter 2 results complete (Feb 28)   </a:t>
+              <a:t>Chapters 1–2 results complete (Feb 28)   </a:t>
             </a:r>
             <a:pPr indent="0" marL="0">
               <a:buNone/>

</xml_diff>